<commit_message>
update the read me file.
</commit_message>
<xml_diff>
--- a/doc/designDoc.pptx
+++ b/doc/designDoc.pptx
@@ -6,6 +6,7 @@
   </p:sldMasterIdLst>
   <p:sldIdLst>
     <p:sldId id="256" r:id="rId2"/>
+    <p:sldId id="257" r:id="rId3"/>
   </p:sldIdLst>
   <p:sldSz cx="12192000" cy="6858000"/>
   <p:notesSz cx="6858000" cy="9144000"/>
@@ -104,6 +105,11 @@
       </a:defRPr>
     </a:lvl9pPr>
   </p:defaultTextStyle>
+  <p:extLst>
+    <p:ext uri="{EFAFB233-063F-42B5-8137-9DF3F51BA10A}">
+      <p15:sldGuideLst xmlns:p15="http://schemas.microsoft.com/office/powerpoint/2012/main"/>
+    </p:ext>
+  </p:extLst>
 </p:presentation>
 </file>
 
@@ -256,7 +262,7 @@
           <a:p>
             <a:fld id="{E61142BF-0A62-477F-BD0D-B122876D5D2E}" type="datetimeFigureOut">
               <a:rPr lang="en-SG" smtClean="0"/>
-              <a:t>30/10/2025</a:t>
+              <a:t>3/11/2025</a:t>
             </a:fld>
             <a:endParaRPr lang="en-SG"/>
           </a:p>
@@ -456,7 +462,7 @@
           <a:p>
             <a:fld id="{E61142BF-0A62-477F-BD0D-B122876D5D2E}" type="datetimeFigureOut">
               <a:rPr lang="en-SG" smtClean="0"/>
-              <a:t>30/10/2025</a:t>
+              <a:t>3/11/2025</a:t>
             </a:fld>
             <a:endParaRPr lang="en-SG"/>
           </a:p>
@@ -666,7 +672,7 @@
           <a:p>
             <a:fld id="{E61142BF-0A62-477F-BD0D-B122876D5D2E}" type="datetimeFigureOut">
               <a:rPr lang="en-SG" smtClean="0"/>
-              <a:t>30/10/2025</a:t>
+              <a:t>3/11/2025</a:t>
             </a:fld>
             <a:endParaRPr lang="en-SG"/>
           </a:p>
@@ -866,7 +872,7 @@
           <a:p>
             <a:fld id="{E61142BF-0A62-477F-BD0D-B122876D5D2E}" type="datetimeFigureOut">
               <a:rPr lang="en-SG" smtClean="0"/>
-              <a:t>30/10/2025</a:t>
+              <a:t>3/11/2025</a:t>
             </a:fld>
             <a:endParaRPr lang="en-SG"/>
           </a:p>
@@ -1142,7 +1148,7 @@
           <a:p>
             <a:fld id="{E61142BF-0A62-477F-BD0D-B122876D5D2E}" type="datetimeFigureOut">
               <a:rPr lang="en-SG" smtClean="0"/>
-              <a:t>30/10/2025</a:t>
+              <a:t>3/11/2025</a:t>
             </a:fld>
             <a:endParaRPr lang="en-SG"/>
           </a:p>
@@ -1410,7 +1416,7 @@
           <a:p>
             <a:fld id="{E61142BF-0A62-477F-BD0D-B122876D5D2E}" type="datetimeFigureOut">
               <a:rPr lang="en-SG" smtClean="0"/>
-              <a:t>30/10/2025</a:t>
+              <a:t>3/11/2025</a:t>
             </a:fld>
             <a:endParaRPr lang="en-SG"/>
           </a:p>
@@ -1825,7 +1831,7 @@
           <a:p>
             <a:fld id="{E61142BF-0A62-477F-BD0D-B122876D5D2E}" type="datetimeFigureOut">
               <a:rPr lang="en-SG" smtClean="0"/>
-              <a:t>30/10/2025</a:t>
+              <a:t>3/11/2025</a:t>
             </a:fld>
             <a:endParaRPr lang="en-SG"/>
           </a:p>
@@ -1967,7 +1973,7 @@
           <a:p>
             <a:fld id="{E61142BF-0A62-477F-BD0D-B122876D5D2E}" type="datetimeFigureOut">
               <a:rPr lang="en-SG" smtClean="0"/>
-              <a:t>30/10/2025</a:t>
+              <a:t>3/11/2025</a:t>
             </a:fld>
             <a:endParaRPr lang="en-SG"/>
           </a:p>
@@ -2080,7 +2086,7 @@
           <a:p>
             <a:fld id="{E61142BF-0A62-477F-BD0D-B122876D5D2E}" type="datetimeFigureOut">
               <a:rPr lang="en-SG" smtClean="0"/>
-              <a:t>30/10/2025</a:t>
+              <a:t>3/11/2025</a:t>
             </a:fld>
             <a:endParaRPr lang="en-SG"/>
           </a:p>
@@ -2393,7 +2399,7 @@
           <a:p>
             <a:fld id="{E61142BF-0A62-477F-BD0D-B122876D5D2E}" type="datetimeFigureOut">
               <a:rPr lang="en-SG" smtClean="0"/>
-              <a:t>30/10/2025</a:t>
+              <a:t>3/11/2025</a:t>
             </a:fld>
             <a:endParaRPr lang="en-SG"/>
           </a:p>
@@ -2682,7 +2688,7 @@
           <a:p>
             <a:fld id="{E61142BF-0A62-477F-BD0D-B122876D5D2E}" type="datetimeFigureOut">
               <a:rPr lang="en-SG" smtClean="0"/>
-              <a:t>30/10/2025</a:t>
+              <a:t>3/11/2025</a:t>
             </a:fld>
             <a:endParaRPr lang="en-SG"/>
           </a:p>
@@ -2925,7 +2931,7 @@
           <a:p>
             <a:fld id="{E61142BF-0A62-477F-BD0D-B122876D5D2E}" type="datetimeFigureOut">
               <a:rPr lang="en-SG" smtClean="0"/>
-              <a:t>30/10/2025</a:t>
+              <a:t>3/11/2025</a:t>
             </a:fld>
             <a:endParaRPr lang="en-SG"/>
           </a:p>
@@ -4791,6 +4797,948 @@
     <p:extLst>
       <p:ext uri="{BB962C8B-B14F-4D97-AF65-F5344CB8AC3E}">
         <p14:creationId xmlns:p14="http://schemas.microsoft.com/office/powerpoint/2010/main" val="240756249"/>
+      </p:ext>
+    </p:extLst>
+  </p:cSld>
+  <p:clrMapOvr>
+    <a:masterClrMapping/>
+  </p:clrMapOvr>
+</p:sld>
+</file>
+
+<file path=ppt/slides/slide2.xml><?xml version="1.0" encoding="utf-8"?>
+<p:sld xmlns:a="http://schemas.openxmlformats.org/drawingml/2006/main" xmlns:r="http://schemas.openxmlformats.org/officeDocument/2006/relationships" xmlns:p="http://schemas.openxmlformats.org/presentationml/2006/main">
+  <p:cSld>
+    <p:spTree>
+      <p:nvGrpSpPr>
+        <p:cNvPr id="1" name=""/>
+        <p:cNvGrpSpPr/>
+        <p:nvPr/>
+      </p:nvGrpSpPr>
+      <p:grpSpPr>
+        <a:xfrm>
+          <a:off x="0" y="0"/>
+          <a:ext cx="0" cy="0"/>
+          <a:chOff x="0" y="0"/>
+          <a:chExt cx="0" cy="0"/>
+        </a:xfrm>
+      </p:grpSpPr>
+      <p:sp>
+        <p:nvSpPr>
+          <p:cNvPr id="5" name="Rectangle 4">
+            <a:extLst>
+              <a:ext uri="{FF2B5EF4-FFF2-40B4-BE49-F238E27FC236}">
+                <a16:creationId xmlns:a16="http://schemas.microsoft.com/office/drawing/2014/main" id="{795BEA1A-7ACE-A084-E97E-EAB31DF9CD09}"/>
+              </a:ext>
+            </a:extLst>
+          </p:cNvPr>
+          <p:cNvSpPr/>
+          <p:nvPr/>
+        </p:nvSpPr>
+        <p:spPr>
+          <a:xfrm>
+            <a:off x="4079281" y="1558456"/>
+            <a:ext cx="3045289" cy="2836563"/>
+          </a:xfrm>
+          <a:prstGeom prst="rect">
+            <a:avLst/>
+          </a:prstGeom>
+          <a:solidFill>
+            <a:schemeClr val="tx2">
+              <a:lumMod val="10000"/>
+              <a:lumOff val="90000"/>
+            </a:schemeClr>
+          </a:solidFill>
+        </p:spPr>
+        <p:style>
+          <a:lnRef idx="2">
+            <a:schemeClr val="accent1">
+              <a:shade val="15000"/>
+            </a:schemeClr>
+          </a:lnRef>
+          <a:fillRef idx="1">
+            <a:schemeClr val="accent1"/>
+          </a:fillRef>
+          <a:effectRef idx="0">
+            <a:schemeClr val="accent1"/>
+          </a:effectRef>
+          <a:fontRef idx="minor">
+            <a:schemeClr val="lt1"/>
+          </a:fontRef>
+        </p:style>
+        <p:txBody>
+          <a:bodyPr rtlCol="0" anchor="ctr"/>
+          <a:lstStyle/>
+          <a:p>
+            <a:pPr algn="ctr"/>
+            <a:endParaRPr lang="en-SG" dirty="0"/>
+          </a:p>
+        </p:txBody>
+      </p:sp>
+      <p:sp>
+        <p:nvSpPr>
+          <p:cNvPr id="4" name="Rectangle 3">
+            <a:extLst>
+              <a:ext uri="{FF2B5EF4-FFF2-40B4-BE49-F238E27FC236}">
+                <a16:creationId xmlns:a16="http://schemas.microsoft.com/office/drawing/2014/main" id="{9A640534-3FC6-9633-EF17-E19015883C71}"/>
+              </a:ext>
+            </a:extLst>
+          </p:cNvPr>
+          <p:cNvSpPr/>
+          <p:nvPr/>
+        </p:nvSpPr>
+        <p:spPr>
+          <a:xfrm>
+            <a:off x="5238976" y="2564996"/>
+            <a:ext cx="1714048" cy="501471"/>
+          </a:xfrm>
+          <a:prstGeom prst="rect">
+            <a:avLst/>
+          </a:prstGeom>
+          <a:solidFill>
+            <a:schemeClr val="tx2">
+              <a:lumMod val="75000"/>
+              <a:lumOff val="25000"/>
+            </a:schemeClr>
+          </a:solidFill>
+          <a:ln>
+            <a:solidFill>
+              <a:schemeClr val="tx1"/>
+            </a:solidFill>
+          </a:ln>
+        </p:spPr>
+        <p:style>
+          <a:lnRef idx="2">
+            <a:schemeClr val="accent1">
+              <a:shade val="50000"/>
+            </a:schemeClr>
+          </a:lnRef>
+          <a:fillRef idx="1">
+            <a:schemeClr val="accent1"/>
+          </a:fillRef>
+          <a:effectRef idx="0">
+            <a:schemeClr val="accent1"/>
+          </a:effectRef>
+          <a:fontRef idx="minor">
+            <a:schemeClr val="lt1"/>
+          </a:fontRef>
+        </p:style>
+        <p:txBody>
+          <a:bodyPr rtlCol="0" anchor="ctr"/>
+          <a:lstStyle/>
+          <a:p>
+            <a:r>
+              <a:rPr lang="en-SG" sz="1200" b="1" dirty="0"/>
+              <a:t>User and Access  Management Module </a:t>
+            </a:r>
+          </a:p>
+        </p:txBody>
+      </p:sp>
+      <p:sp>
+        <p:nvSpPr>
+          <p:cNvPr id="6" name="TextBox 5">
+            <a:extLst>
+              <a:ext uri="{FF2B5EF4-FFF2-40B4-BE49-F238E27FC236}">
+                <a16:creationId xmlns:a16="http://schemas.microsoft.com/office/drawing/2014/main" id="{7A70032D-F9A9-5DF3-348B-B60B4991CBC2}"/>
+              </a:ext>
+            </a:extLst>
+          </p:cNvPr>
+          <p:cNvSpPr txBox="1"/>
+          <p:nvPr/>
+        </p:nvSpPr>
+        <p:spPr>
+          <a:xfrm>
+            <a:off x="4048152" y="1622536"/>
+            <a:ext cx="2500148" cy="338554"/>
+          </a:xfrm>
+          <a:prstGeom prst="rect">
+            <a:avLst/>
+          </a:prstGeom>
+          <a:noFill/>
+        </p:spPr>
+        <p:txBody>
+          <a:bodyPr wrap="square" rtlCol="0">
+            <a:spAutoFit/>
+          </a:bodyPr>
+          <a:lstStyle/>
+          <a:p>
+            <a:r>
+              <a:rPr lang="en-US" sz="1600" b="1" dirty="0"/>
+              <a:t>Flask Camera Server</a:t>
+            </a:r>
+            <a:endParaRPr lang="en-SG" sz="1600" b="1" dirty="0"/>
+          </a:p>
+        </p:txBody>
+      </p:sp>
+      <p:sp>
+        <p:nvSpPr>
+          <p:cNvPr id="7" name="Cylinder 6">
+            <a:extLst>
+              <a:ext uri="{FF2B5EF4-FFF2-40B4-BE49-F238E27FC236}">
+                <a16:creationId xmlns:a16="http://schemas.microsoft.com/office/drawing/2014/main" id="{39FFC1E6-E8B7-E8F9-A757-519C2C7C8E73}"/>
+              </a:ext>
+            </a:extLst>
+          </p:cNvPr>
+          <p:cNvSpPr/>
+          <p:nvPr/>
+        </p:nvSpPr>
+        <p:spPr>
+          <a:xfrm>
+            <a:off x="6172651" y="1858119"/>
+            <a:ext cx="696191" cy="519546"/>
+          </a:xfrm>
+          <a:prstGeom prst="can">
+            <a:avLst/>
+          </a:prstGeom>
+          <a:solidFill>
+            <a:schemeClr val="accent6">
+              <a:lumMod val="50000"/>
+            </a:schemeClr>
+          </a:solidFill>
+        </p:spPr>
+        <p:style>
+          <a:lnRef idx="2">
+            <a:schemeClr val="accent1">
+              <a:shade val="15000"/>
+            </a:schemeClr>
+          </a:lnRef>
+          <a:fillRef idx="1">
+            <a:schemeClr val="accent1"/>
+          </a:fillRef>
+          <a:effectRef idx="0">
+            <a:schemeClr val="accent1"/>
+          </a:effectRef>
+          <a:fontRef idx="minor">
+            <a:schemeClr val="lt1"/>
+          </a:fontRef>
+        </p:style>
+        <p:txBody>
+          <a:bodyPr rtlCol="0" anchor="ctr"/>
+          <a:lstStyle/>
+          <a:p>
+            <a:pPr algn="ctr"/>
+            <a:r>
+              <a:rPr lang="en-SG" sz="1200" b="1" dirty="0"/>
+              <a:t>User BD</a:t>
+            </a:r>
+          </a:p>
+        </p:txBody>
+      </p:sp>
+      <p:cxnSp>
+        <p:nvCxnSpPr>
+          <p:cNvPr id="9" name="Straight Arrow Connector 8">
+            <a:extLst>
+              <a:ext uri="{FF2B5EF4-FFF2-40B4-BE49-F238E27FC236}">
+                <a16:creationId xmlns:a16="http://schemas.microsoft.com/office/drawing/2014/main" id="{8AEE00F4-22BE-6C96-27EF-66E6AD06243A}"/>
+              </a:ext>
+            </a:extLst>
+          </p:cNvPr>
+          <p:cNvCxnSpPr>
+            <a:cxnSpLocks/>
+          </p:cNvCxnSpPr>
+          <p:nvPr/>
+        </p:nvCxnSpPr>
+        <p:spPr>
+          <a:xfrm flipH="1">
+            <a:off x="6513077" y="2377665"/>
+            <a:ext cx="0" cy="188554"/>
+          </a:xfrm>
+          <a:prstGeom prst="straightConnector1">
+            <a:avLst/>
+          </a:prstGeom>
+          <a:ln>
+            <a:tailEnd type="triangle"/>
+          </a:ln>
+        </p:spPr>
+        <p:style>
+          <a:lnRef idx="2">
+            <a:schemeClr val="accent1"/>
+          </a:lnRef>
+          <a:fillRef idx="0">
+            <a:schemeClr val="accent1"/>
+          </a:fillRef>
+          <a:effectRef idx="1">
+            <a:schemeClr val="accent1"/>
+          </a:effectRef>
+          <a:fontRef idx="minor">
+            <a:schemeClr val="tx1"/>
+          </a:fontRef>
+        </p:style>
+      </p:cxnSp>
+      <p:sp>
+        <p:nvSpPr>
+          <p:cNvPr id="10" name="Rectangle 9">
+            <a:extLst>
+              <a:ext uri="{FF2B5EF4-FFF2-40B4-BE49-F238E27FC236}">
+                <a16:creationId xmlns:a16="http://schemas.microsoft.com/office/drawing/2014/main" id="{831EA590-ED1E-389D-C2EB-A578B654D40B}"/>
+              </a:ext>
+            </a:extLst>
+          </p:cNvPr>
+          <p:cNvSpPr/>
+          <p:nvPr/>
+        </p:nvSpPr>
+        <p:spPr>
+          <a:xfrm>
+            <a:off x="3869877" y="3838893"/>
+            <a:ext cx="1937698" cy="338554"/>
+          </a:xfrm>
+          <a:prstGeom prst="rect">
+            <a:avLst/>
+          </a:prstGeom>
+          <a:solidFill>
+            <a:schemeClr val="tx2">
+              <a:lumMod val="75000"/>
+              <a:lumOff val="25000"/>
+            </a:schemeClr>
+          </a:solidFill>
+          <a:ln>
+            <a:solidFill>
+              <a:schemeClr val="tx1"/>
+            </a:solidFill>
+          </a:ln>
+        </p:spPr>
+        <p:style>
+          <a:lnRef idx="2">
+            <a:schemeClr val="accent1">
+              <a:shade val="50000"/>
+            </a:schemeClr>
+          </a:lnRef>
+          <a:fillRef idx="1">
+            <a:schemeClr val="accent1"/>
+          </a:fillRef>
+          <a:effectRef idx="0">
+            <a:schemeClr val="accent1"/>
+          </a:effectRef>
+          <a:fontRef idx="minor">
+            <a:schemeClr val="lt1"/>
+          </a:fontRef>
+        </p:style>
+        <p:txBody>
+          <a:bodyPr rtlCol="0" anchor="ctr"/>
+          <a:lstStyle/>
+          <a:p>
+            <a:r>
+              <a:rPr lang="en-SG" sz="1200" b="1" dirty="0"/>
+              <a:t>Data Manager Module </a:t>
+            </a:r>
+          </a:p>
+        </p:txBody>
+      </p:sp>
+      <p:sp>
+        <p:nvSpPr>
+          <p:cNvPr id="11" name="Rectangle 10">
+            <a:extLst>
+              <a:ext uri="{FF2B5EF4-FFF2-40B4-BE49-F238E27FC236}">
+                <a16:creationId xmlns:a16="http://schemas.microsoft.com/office/drawing/2014/main" id="{43212530-F0D6-978A-DF0D-A3A8FB1D596F}"/>
+              </a:ext>
+            </a:extLst>
+          </p:cNvPr>
+          <p:cNvSpPr/>
+          <p:nvPr/>
+        </p:nvSpPr>
+        <p:spPr>
+          <a:xfrm>
+            <a:off x="4838727" y="3273881"/>
+            <a:ext cx="2387762" cy="338554"/>
+          </a:xfrm>
+          <a:prstGeom prst="rect">
+            <a:avLst/>
+          </a:prstGeom>
+          <a:solidFill>
+            <a:schemeClr val="tx2">
+              <a:lumMod val="75000"/>
+              <a:lumOff val="25000"/>
+            </a:schemeClr>
+          </a:solidFill>
+          <a:ln>
+            <a:solidFill>
+              <a:schemeClr val="tx1"/>
+            </a:solidFill>
+          </a:ln>
+        </p:spPr>
+        <p:style>
+          <a:lnRef idx="2">
+            <a:schemeClr val="accent1">
+              <a:shade val="50000"/>
+            </a:schemeClr>
+          </a:lnRef>
+          <a:fillRef idx="1">
+            <a:schemeClr val="accent1"/>
+          </a:fillRef>
+          <a:effectRef idx="0">
+            <a:schemeClr val="accent1"/>
+          </a:effectRef>
+          <a:fontRef idx="minor">
+            <a:schemeClr val="lt1"/>
+          </a:fontRef>
+        </p:style>
+        <p:txBody>
+          <a:bodyPr rtlCol="0" anchor="ctr"/>
+          <a:lstStyle/>
+          <a:p>
+            <a:r>
+              <a:rPr lang="en-SG" sz="1200" b="1" dirty="0"/>
+              <a:t>Flask Web Service Module </a:t>
+            </a:r>
+          </a:p>
+        </p:txBody>
+      </p:sp>
+      <p:sp>
+        <p:nvSpPr>
+          <p:cNvPr id="12" name="Rectangle 11">
+            <a:extLst>
+              <a:ext uri="{FF2B5EF4-FFF2-40B4-BE49-F238E27FC236}">
+                <a16:creationId xmlns:a16="http://schemas.microsoft.com/office/drawing/2014/main" id="{E167F503-53D7-03EF-F5BE-4400BC086F8F}"/>
+              </a:ext>
+            </a:extLst>
+          </p:cNvPr>
+          <p:cNvSpPr/>
+          <p:nvPr/>
+        </p:nvSpPr>
+        <p:spPr>
+          <a:xfrm>
+            <a:off x="3793526" y="2068441"/>
+            <a:ext cx="2225821" cy="338554"/>
+          </a:xfrm>
+          <a:prstGeom prst="rect">
+            <a:avLst/>
+          </a:prstGeom>
+          <a:solidFill>
+            <a:schemeClr val="tx2">
+              <a:lumMod val="75000"/>
+              <a:lumOff val="25000"/>
+            </a:schemeClr>
+          </a:solidFill>
+          <a:ln>
+            <a:solidFill>
+              <a:schemeClr val="tx1"/>
+            </a:solidFill>
+          </a:ln>
+        </p:spPr>
+        <p:style>
+          <a:lnRef idx="2">
+            <a:schemeClr val="accent1">
+              <a:shade val="50000"/>
+            </a:schemeClr>
+          </a:lnRef>
+          <a:fillRef idx="1">
+            <a:schemeClr val="accent1"/>
+          </a:fillRef>
+          <a:effectRef idx="0">
+            <a:schemeClr val="accent1"/>
+          </a:effectRef>
+          <a:fontRef idx="minor">
+            <a:schemeClr val="lt1"/>
+          </a:fontRef>
+        </p:style>
+        <p:txBody>
+          <a:bodyPr rtlCol="0" anchor="ctr"/>
+          <a:lstStyle/>
+          <a:p>
+            <a:r>
+              <a:rPr lang="en-SG" sz="1200" b="1" dirty="0"/>
+              <a:t>Video Source Manger Module </a:t>
+            </a:r>
+          </a:p>
+        </p:txBody>
+      </p:sp>
+      <p:cxnSp>
+        <p:nvCxnSpPr>
+          <p:cNvPr id="16" name="Straight Arrow Connector 15">
+            <a:extLst>
+              <a:ext uri="{FF2B5EF4-FFF2-40B4-BE49-F238E27FC236}">
+                <a16:creationId xmlns:a16="http://schemas.microsoft.com/office/drawing/2014/main" id="{4912AC03-8DA6-D8CA-0ED4-A562424A4FD8}"/>
+              </a:ext>
+            </a:extLst>
+          </p:cNvPr>
+          <p:cNvCxnSpPr>
+            <a:cxnSpLocks/>
+          </p:cNvCxnSpPr>
+          <p:nvPr/>
+        </p:nvCxnSpPr>
+        <p:spPr>
+          <a:xfrm>
+            <a:off x="4967636" y="2384955"/>
+            <a:ext cx="0" cy="888926"/>
+          </a:xfrm>
+          <a:prstGeom prst="straightConnector1">
+            <a:avLst/>
+          </a:prstGeom>
+          <a:ln>
+            <a:tailEnd type="triangle"/>
+          </a:ln>
+        </p:spPr>
+        <p:style>
+          <a:lnRef idx="2">
+            <a:schemeClr val="accent1"/>
+          </a:lnRef>
+          <a:fillRef idx="0">
+            <a:schemeClr val="accent1"/>
+          </a:fillRef>
+          <a:effectRef idx="1">
+            <a:schemeClr val="accent1"/>
+          </a:effectRef>
+          <a:fontRef idx="minor">
+            <a:schemeClr val="tx1"/>
+          </a:fontRef>
+        </p:style>
+      </p:cxnSp>
+      <p:cxnSp>
+        <p:nvCxnSpPr>
+          <p:cNvPr id="18" name="Straight Arrow Connector 17">
+            <a:extLst>
+              <a:ext uri="{FF2B5EF4-FFF2-40B4-BE49-F238E27FC236}">
+                <a16:creationId xmlns:a16="http://schemas.microsoft.com/office/drawing/2014/main" id="{2F6E7933-5D6D-5174-082D-DC4208989B30}"/>
+              </a:ext>
+            </a:extLst>
+          </p:cNvPr>
+          <p:cNvCxnSpPr>
+            <a:cxnSpLocks/>
+          </p:cNvCxnSpPr>
+          <p:nvPr/>
+        </p:nvCxnSpPr>
+        <p:spPr>
+          <a:xfrm flipV="1">
+            <a:off x="4965513" y="3612435"/>
+            <a:ext cx="0" cy="219055"/>
+          </a:xfrm>
+          <a:prstGeom prst="straightConnector1">
+            <a:avLst/>
+          </a:prstGeom>
+          <a:ln>
+            <a:tailEnd type="triangle"/>
+          </a:ln>
+        </p:spPr>
+        <p:style>
+          <a:lnRef idx="2">
+            <a:schemeClr val="accent1"/>
+          </a:lnRef>
+          <a:fillRef idx="0">
+            <a:schemeClr val="accent1"/>
+          </a:fillRef>
+          <a:effectRef idx="1">
+            <a:schemeClr val="accent1"/>
+          </a:effectRef>
+          <a:fontRef idx="minor">
+            <a:schemeClr val="tx1"/>
+          </a:fontRef>
+        </p:style>
+      </p:cxnSp>
+      <p:cxnSp>
+        <p:nvCxnSpPr>
+          <p:cNvPr id="26" name="Straight Arrow Connector 25">
+            <a:extLst>
+              <a:ext uri="{FF2B5EF4-FFF2-40B4-BE49-F238E27FC236}">
+                <a16:creationId xmlns:a16="http://schemas.microsoft.com/office/drawing/2014/main" id="{F679CB73-DBB5-9E76-3B51-8023C411BC91}"/>
+              </a:ext>
+            </a:extLst>
+          </p:cNvPr>
+          <p:cNvCxnSpPr>
+            <a:cxnSpLocks/>
+          </p:cNvCxnSpPr>
+          <p:nvPr/>
+        </p:nvCxnSpPr>
+        <p:spPr>
+          <a:xfrm>
+            <a:off x="3579684" y="4000155"/>
+            <a:ext cx="290193" cy="0"/>
+          </a:xfrm>
+          <a:prstGeom prst="straightConnector1">
+            <a:avLst/>
+          </a:prstGeom>
+          <a:ln>
+            <a:tailEnd type="triangle"/>
+          </a:ln>
+        </p:spPr>
+        <p:style>
+          <a:lnRef idx="2">
+            <a:schemeClr val="accent1"/>
+          </a:lnRef>
+          <a:fillRef idx="0">
+            <a:schemeClr val="accent1"/>
+          </a:fillRef>
+          <a:effectRef idx="1">
+            <a:schemeClr val="accent1"/>
+          </a:effectRef>
+          <a:fontRef idx="minor">
+            <a:schemeClr val="tx1"/>
+          </a:fontRef>
+        </p:style>
+      </p:cxnSp>
+      <p:pic>
+        <p:nvPicPr>
+          <p:cNvPr id="21" name="Picture 20" descr="A computer screen shot of a runway&#10;&#10;AI-generated content may be incorrect.">
+            <a:extLst>
+              <a:ext uri="{FF2B5EF4-FFF2-40B4-BE49-F238E27FC236}">
+                <a16:creationId xmlns:a16="http://schemas.microsoft.com/office/drawing/2014/main" id="{A5A68227-F3E4-A5D8-E5BE-F49D0AF99408}"/>
+              </a:ext>
+            </a:extLst>
+          </p:cNvPr>
+          <p:cNvPicPr>
+            <a:picLocks noChangeAspect="1"/>
+          </p:cNvPicPr>
+          <p:nvPr/>
+        </p:nvPicPr>
+        <p:blipFill>
+          <a:blip r:embed="rId2">
+            <a:extLst>
+              <a:ext uri="{28A0092B-C50C-407E-A947-70E740481C1C}">
+                <a14:useLocalDpi xmlns:a14="http://schemas.microsoft.com/office/drawing/2010/main" val="0"/>
+              </a:ext>
+            </a:extLst>
+          </a:blip>
+          <a:stretch>
+            <a:fillRect/>
+          </a:stretch>
+        </p:blipFill>
+        <p:spPr>
+          <a:xfrm>
+            <a:off x="396148" y="2685683"/>
+            <a:ext cx="3175137" cy="1739086"/>
+          </a:xfrm>
+          <a:prstGeom prst="rect">
+            <a:avLst/>
+          </a:prstGeom>
+          <a:ln w="9525">
+            <a:solidFill>
+              <a:schemeClr val="tx1"/>
+            </a:solidFill>
+          </a:ln>
+        </p:spPr>
+      </p:pic>
+      <p:sp>
+        <p:nvSpPr>
+          <p:cNvPr id="29" name="TextBox 28">
+            <a:extLst>
+              <a:ext uri="{FF2B5EF4-FFF2-40B4-BE49-F238E27FC236}">
+                <a16:creationId xmlns:a16="http://schemas.microsoft.com/office/drawing/2014/main" id="{2D6FEFEC-0A21-437D-3206-81C9C8C59D79}"/>
+              </a:ext>
+            </a:extLst>
+          </p:cNvPr>
+          <p:cNvSpPr txBox="1"/>
+          <p:nvPr/>
+        </p:nvSpPr>
+        <p:spPr>
+          <a:xfrm>
+            <a:off x="267695" y="2372513"/>
+            <a:ext cx="3339694" cy="307777"/>
+          </a:xfrm>
+          <a:prstGeom prst="rect">
+            <a:avLst/>
+          </a:prstGeom>
+          <a:noFill/>
+        </p:spPr>
+        <p:txBody>
+          <a:bodyPr wrap="square" rtlCol="0">
+            <a:spAutoFit/>
+          </a:bodyPr>
+          <a:lstStyle/>
+          <a:p>
+            <a:r>
+              <a:rPr lang="en-SG" sz="1400" b="1" dirty="0"/>
+              <a:t>Cyber Range Physical World Simulator </a:t>
+            </a:r>
+          </a:p>
+        </p:txBody>
+      </p:sp>
+      <p:pic>
+        <p:nvPicPr>
+          <p:cNvPr id="31" name="Picture 30">
+            <a:extLst>
+              <a:ext uri="{FF2B5EF4-FFF2-40B4-BE49-F238E27FC236}">
+                <a16:creationId xmlns:a16="http://schemas.microsoft.com/office/drawing/2014/main" id="{0127D3F8-A57E-20C1-8EF0-5AE80F4191B5}"/>
+              </a:ext>
+            </a:extLst>
+          </p:cNvPr>
+          <p:cNvPicPr>
+            <a:picLocks noChangeAspect="1"/>
+          </p:cNvPicPr>
+          <p:nvPr/>
+        </p:nvPicPr>
+        <p:blipFill>
+          <a:blip r:embed="rId3"/>
+          <a:stretch>
+            <a:fillRect/>
+          </a:stretch>
+        </p:blipFill>
+        <p:spPr>
+          <a:xfrm>
+            <a:off x="360046" y="1786598"/>
+            <a:ext cx="3247343" cy="478983"/>
+          </a:xfrm>
+          <a:prstGeom prst="rect">
+            <a:avLst/>
+          </a:prstGeom>
+        </p:spPr>
+      </p:pic>
+      <p:sp>
+        <p:nvSpPr>
+          <p:cNvPr id="32" name="TextBox 31">
+            <a:extLst>
+              <a:ext uri="{FF2B5EF4-FFF2-40B4-BE49-F238E27FC236}">
+                <a16:creationId xmlns:a16="http://schemas.microsoft.com/office/drawing/2014/main" id="{6AF2A4BE-9C38-88B7-208B-94F3BD0C9369}"/>
+              </a:ext>
+            </a:extLst>
+          </p:cNvPr>
+          <p:cNvSpPr txBox="1"/>
+          <p:nvPr/>
+        </p:nvSpPr>
+        <p:spPr>
+          <a:xfrm>
+            <a:off x="360046" y="1408370"/>
+            <a:ext cx="2023197" cy="307777"/>
+          </a:xfrm>
+          <a:prstGeom prst="rect">
+            <a:avLst/>
+          </a:prstGeom>
+          <a:noFill/>
+        </p:spPr>
+        <p:txBody>
+          <a:bodyPr wrap="square" rtlCol="0">
+            <a:spAutoFit/>
+          </a:bodyPr>
+          <a:lstStyle/>
+          <a:p>
+            <a:r>
+              <a:rPr lang="en-SG" sz="1400" b="1" dirty="0"/>
+              <a:t>Video Stream Source </a:t>
+            </a:r>
+          </a:p>
+        </p:txBody>
+      </p:sp>
+      <p:cxnSp>
+        <p:nvCxnSpPr>
+          <p:cNvPr id="33" name="Straight Arrow Connector 32">
+            <a:extLst>
+              <a:ext uri="{FF2B5EF4-FFF2-40B4-BE49-F238E27FC236}">
+                <a16:creationId xmlns:a16="http://schemas.microsoft.com/office/drawing/2014/main" id="{AEE6FBF7-A397-B5F6-8C2B-7BFB0872A311}"/>
+              </a:ext>
+            </a:extLst>
+          </p:cNvPr>
+          <p:cNvCxnSpPr>
+            <a:cxnSpLocks/>
+          </p:cNvCxnSpPr>
+          <p:nvPr/>
+        </p:nvCxnSpPr>
+        <p:spPr>
+          <a:xfrm>
+            <a:off x="3579684" y="2202315"/>
+            <a:ext cx="213842" cy="0"/>
+          </a:xfrm>
+          <a:prstGeom prst="straightConnector1">
+            <a:avLst/>
+          </a:prstGeom>
+          <a:ln>
+            <a:tailEnd type="triangle"/>
+          </a:ln>
+        </p:spPr>
+        <p:style>
+          <a:lnRef idx="2">
+            <a:schemeClr val="accent1"/>
+          </a:lnRef>
+          <a:fillRef idx="0">
+            <a:schemeClr val="accent1"/>
+          </a:fillRef>
+          <a:effectRef idx="1">
+            <a:schemeClr val="accent1"/>
+          </a:effectRef>
+          <a:fontRef idx="minor">
+            <a:schemeClr val="tx1"/>
+          </a:fontRef>
+        </p:style>
+      </p:cxnSp>
+      <p:cxnSp>
+        <p:nvCxnSpPr>
+          <p:cNvPr id="35" name="Straight Arrow Connector 34">
+            <a:extLst>
+              <a:ext uri="{FF2B5EF4-FFF2-40B4-BE49-F238E27FC236}">
+                <a16:creationId xmlns:a16="http://schemas.microsoft.com/office/drawing/2014/main" id="{C69B1288-537A-E9AB-1560-BAE1CB70103D}"/>
+              </a:ext>
+            </a:extLst>
+          </p:cNvPr>
+          <p:cNvCxnSpPr>
+            <a:cxnSpLocks/>
+            <a:stCxn id="11" idx="3"/>
+          </p:cNvCxnSpPr>
+          <p:nvPr/>
+        </p:nvCxnSpPr>
+        <p:spPr>
+          <a:xfrm>
+            <a:off x="7226489" y="3443158"/>
+            <a:ext cx="311348" cy="0"/>
+          </a:xfrm>
+          <a:prstGeom prst="straightConnector1">
+            <a:avLst/>
+          </a:prstGeom>
+          <a:ln>
+            <a:tailEnd type="triangle"/>
+          </a:ln>
+        </p:spPr>
+        <p:style>
+          <a:lnRef idx="2">
+            <a:schemeClr val="accent1"/>
+          </a:lnRef>
+          <a:fillRef idx="0">
+            <a:schemeClr val="accent1"/>
+          </a:fillRef>
+          <a:effectRef idx="1">
+            <a:schemeClr val="accent1"/>
+          </a:effectRef>
+          <a:fontRef idx="minor">
+            <a:schemeClr val="tx1"/>
+          </a:fontRef>
+        </p:style>
+      </p:cxnSp>
+      <p:pic>
+        <p:nvPicPr>
+          <p:cNvPr id="39" name="Picture 38">
+            <a:extLst>
+              <a:ext uri="{FF2B5EF4-FFF2-40B4-BE49-F238E27FC236}">
+                <a16:creationId xmlns:a16="http://schemas.microsoft.com/office/drawing/2014/main" id="{57E62C6C-7D80-AC36-A313-A707018E0058}"/>
+              </a:ext>
+            </a:extLst>
+          </p:cNvPr>
+          <p:cNvPicPr>
+            <a:picLocks noChangeAspect="1"/>
+          </p:cNvPicPr>
+          <p:nvPr/>
+        </p:nvPicPr>
+        <p:blipFill>
+          <a:blip r:embed="rId4"/>
+          <a:stretch>
+            <a:fillRect/>
+          </a:stretch>
+        </p:blipFill>
+        <p:spPr>
+          <a:xfrm>
+            <a:off x="7537837" y="1791813"/>
+            <a:ext cx="3882607" cy="2603206"/>
+          </a:xfrm>
+          <a:prstGeom prst="rect">
+            <a:avLst/>
+          </a:prstGeom>
+          <a:ln w="12700">
+            <a:solidFill>
+              <a:schemeClr val="tx1"/>
+            </a:solidFill>
+          </a:ln>
+        </p:spPr>
+      </p:pic>
+      <p:cxnSp>
+        <p:nvCxnSpPr>
+          <p:cNvPr id="44" name="Straight Arrow Connector 43">
+            <a:extLst>
+              <a:ext uri="{FF2B5EF4-FFF2-40B4-BE49-F238E27FC236}">
+                <a16:creationId xmlns:a16="http://schemas.microsoft.com/office/drawing/2014/main" id="{1C313551-14B2-8300-1EDF-9C31D34374FF}"/>
+              </a:ext>
+            </a:extLst>
+          </p:cNvPr>
+          <p:cNvCxnSpPr>
+            <a:cxnSpLocks/>
+          </p:cNvCxnSpPr>
+          <p:nvPr/>
+        </p:nvCxnSpPr>
+        <p:spPr>
+          <a:xfrm flipH="1">
+            <a:off x="6096000" y="3085327"/>
+            <a:ext cx="0" cy="188554"/>
+          </a:xfrm>
+          <a:prstGeom prst="straightConnector1">
+            <a:avLst/>
+          </a:prstGeom>
+          <a:ln>
+            <a:tailEnd type="triangle"/>
+          </a:ln>
+        </p:spPr>
+        <p:style>
+          <a:lnRef idx="2">
+            <a:schemeClr val="accent1"/>
+          </a:lnRef>
+          <a:fillRef idx="0">
+            <a:schemeClr val="accent1"/>
+          </a:fillRef>
+          <a:effectRef idx="1">
+            <a:schemeClr val="accent1"/>
+          </a:effectRef>
+          <a:fontRef idx="minor">
+            <a:schemeClr val="tx1"/>
+          </a:fontRef>
+        </p:style>
+      </p:cxnSp>
+      <p:pic>
+        <p:nvPicPr>
+          <p:cNvPr id="50" name="Picture 49">
+            <a:extLst>
+              <a:ext uri="{FF2B5EF4-FFF2-40B4-BE49-F238E27FC236}">
+                <a16:creationId xmlns:a16="http://schemas.microsoft.com/office/drawing/2014/main" id="{9A8651CE-65DD-B836-7E28-1CE96DDDD95B}"/>
+              </a:ext>
+            </a:extLst>
+          </p:cNvPr>
+          <p:cNvPicPr>
+            <a:picLocks noChangeAspect="1"/>
+          </p:cNvPicPr>
+          <p:nvPr/>
+        </p:nvPicPr>
+        <p:blipFill>
+          <a:blip r:embed="rId5"/>
+          <a:stretch>
+            <a:fillRect/>
+          </a:stretch>
+        </p:blipFill>
+        <p:spPr>
+          <a:xfrm>
+            <a:off x="7537837" y="1554709"/>
+            <a:ext cx="500932" cy="500932"/>
+          </a:xfrm>
+          <a:prstGeom prst="rect">
+            <a:avLst/>
+          </a:prstGeom>
+          <a:ln w="12700">
+            <a:solidFill>
+              <a:schemeClr val="tx1"/>
+            </a:solidFill>
+          </a:ln>
+        </p:spPr>
+      </p:pic>
+      <p:sp>
+        <p:nvSpPr>
+          <p:cNvPr id="51" name="TextBox 50">
+            <a:extLst>
+              <a:ext uri="{FF2B5EF4-FFF2-40B4-BE49-F238E27FC236}">
+                <a16:creationId xmlns:a16="http://schemas.microsoft.com/office/drawing/2014/main" id="{0A243121-01E1-4584-A4D1-C0D1180EA244}"/>
+              </a:ext>
+            </a:extLst>
+          </p:cNvPr>
+          <p:cNvSpPr txBox="1"/>
+          <p:nvPr/>
+        </p:nvSpPr>
+        <p:spPr>
+          <a:xfrm>
+            <a:off x="8017230" y="1519373"/>
+            <a:ext cx="1586698" cy="307777"/>
+          </a:xfrm>
+          <a:prstGeom prst="rect">
+            <a:avLst/>
+          </a:prstGeom>
+          <a:noFill/>
+        </p:spPr>
+        <p:txBody>
+          <a:bodyPr wrap="square" rtlCol="0">
+            <a:spAutoFit/>
+          </a:bodyPr>
+          <a:lstStyle/>
+          <a:p>
+            <a:r>
+              <a:rPr lang="en-SG" sz="1400" b="1" dirty="0"/>
+              <a:t>Web Browser </a:t>
+            </a:r>
+          </a:p>
+        </p:txBody>
+      </p:sp>
+    </p:spTree>
+    <p:extLst>
+      <p:ext uri="{BB962C8B-B14F-4D97-AF65-F5344CB8AC3E}">
+        <p14:creationId xmlns:p14="http://schemas.microsoft.com/office/powerpoint/2010/main" val="3681641428"/>
       </p:ext>
     </p:extLst>
   </p:cSld>

</xml_diff>

<commit_message>
update the readme configuration section.
</commit_message>
<xml_diff>
--- a/doc/designDoc.pptx
+++ b/doc/designDoc.pptx
@@ -263,7 +263,7 @@
           <a:p>
             <a:fld id="{E61142BF-0A62-477F-BD0D-B122876D5D2E}" type="datetimeFigureOut">
               <a:rPr lang="en-SG" smtClean="0"/>
-              <a:t>3/11/2025</a:t>
+              <a:t>4/11/2025</a:t>
             </a:fld>
             <a:endParaRPr lang="en-SG"/>
           </a:p>
@@ -463,7 +463,7 @@
           <a:p>
             <a:fld id="{E61142BF-0A62-477F-BD0D-B122876D5D2E}" type="datetimeFigureOut">
               <a:rPr lang="en-SG" smtClean="0"/>
-              <a:t>3/11/2025</a:t>
+              <a:t>4/11/2025</a:t>
             </a:fld>
             <a:endParaRPr lang="en-SG"/>
           </a:p>
@@ -673,7 +673,7 @@
           <a:p>
             <a:fld id="{E61142BF-0A62-477F-BD0D-B122876D5D2E}" type="datetimeFigureOut">
               <a:rPr lang="en-SG" smtClean="0"/>
-              <a:t>3/11/2025</a:t>
+              <a:t>4/11/2025</a:t>
             </a:fld>
             <a:endParaRPr lang="en-SG"/>
           </a:p>
@@ -873,7 +873,7 @@
           <a:p>
             <a:fld id="{E61142BF-0A62-477F-BD0D-B122876D5D2E}" type="datetimeFigureOut">
               <a:rPr lang="en-SG" smtClean="0"/>
-              <a:t>3/11/2025</a:t>
+              <a:t>4/11/2025</a:t>
             </a:fld>
             <a:endParaRPr lang="en-SG"/>
           </a:p>
@@ -1149,7 +1149,7 @@
           <a:p>
             <a:fld id="{E61142BF-0A62-477F-BD0D-B122876D5D2E}" type="datetimeFigureOut">
               <a:rPr lang="en-SG" smtClean="0"/>
-              <a:t>3/11/2025</a:t>
+              <a:t>4/11/2025</a:t>
             </a:fld>
             <a:endParaRPr lang="en-SG"/>
           </a:p>
@@ -1417,7 +1417,7 @@
           <a:p>
             <a:fld id="{E61142BF-0A62-477F-BD0D-B122876D5D2E}" type="datetimeFigureOut">
               <a:rPr lang="en-SG" smtClean="0"/>
-              <a:t>3/11/2025</a:t>
+              <a:t>4/11/2025</a:t>
             </a:fld>
             <a:endParaRPr lang="en-SG"/>
           </a:p>
@@ -1832,7 +1832,7 @@
           <a:p>
             <a:fld id="{E61142BF-0A62-477F-BD0D-B122876D5D2E}" type="datetimeFigureOut">
               <a:rPr lang="en-SG" smtClean="0"/>
-              <a:t>3/11/2025</a:t>
+              <a:t>4/11/2025</a:t>
             </a:fld>
             <a:endParaRPr lang="en-SG"/>
           </a:p>
@@ -1974,7 +1974,7 @@
           <a:p>
             <a:fld id="{E61142BF-0A62-477F-BD0D-B122876D5D2E}" type="datetimeFigureOut">
               <a:rPr lang="en-SG" smtClean="0"/>
-              <a:t>3/11/2025</a:t>
+              <a:t>4/11/2025</a:t>
             </a:fld>
             <a:endParaRPr lang="en-SG"/>
           </a:p>
@@ -2087,7 +2087,7 @@
           <a:p>
             <a:fld id="{E61142BF-0A62-477F-BD0D-B122876D5D2E}" type="datetimeFigureOut">
               <a:rPr lang="en-SG" smtClean="0"/>
-              <a:t>3/11/2025</a:t>
+              <a:t>4/11/2025</a:t>
             </a:fld>
             <a:endParaRPr lang="en-SG"/>
           </a:p>
@@ -2400,7 +2400,7 @@
           <a:p>
             <a:fld id="{E61142BF-0A62-477F-BD0D-B122876D5D2E}" type="datetimeFigureOut">
               <a:rPr lang="en-SG" smtClean="0"/>
-              <a:t>3/11/2025</a:t>
+              <a:t>4/11/2025</a:t>
             </a:fld>
             <a:endParaRPr lang="en-SG"/>
           </a:p>
@@ -2689,7 +2689,7 @@
           <a:p>
             <a:fld id="{E61142BF-0A62-477F-BD0D-B122876D5D2E}" type="datetimeFigureOut">
               <a:rPr lang="en-SG" smtClean="0"/>
-              <a:t>3/11/2025</a:t>
+              <a:t>4/11/2025</a:t>
             </a:fld>
             <a:endParaRPr lang="en-SG"/>
           </a:p>
@@ -2932,7 +2932,7 @@
           <a:p>
             <a:fld id="{E61142BF-0A62-477F-BD0D-B122876D5D2E}" type="datetimeFigureOut">
               <a:rPr lang="en-SG" smtClean="0"/>
-              <a:t>3/11/2025</a:t>
+              <a:t>4/11/2025</a:t>
             </a:fld>
             <a:endParaRPr lang="en-SG"/>
           </a:p>

</xml_diff>

<commit_message>
Added the logo and update the readme file.
</commit_message>
<xml_diff>
--- a/doc/designDoc.pptx
+++ b/doc/designDoc.pptx
@@ -5,9 +5,10 @@
     <p:sldMasterId id="2147483648" r:id="rId1"/>
   </p:sldMasterIdLst>
   <p:sldIdLst>
-    <p:sldId id="256" r:id="rId2"/>
-    <p:sldId id="257" r:id="rId3"/>
-    <p:sldId id="258" r:id="rId4"/>
+    <p:sldId id="259" r:id="rId2"/>
+    <p:sldId id="256" r:id="rId3"/>
+    <p:sldId id="257" r:id="rId4"/>
+    <p:sldId id="258" r:id="rId5"/>
   </p:sldIdLst>
   <p:sldSz cx="12192000" cy="6858000"/>
   <p:notesSz cx="6858000" cy="9144000"/>
@@ -263,7 +264,7 @@
           <a:p>
             <a:fld id="{E61142BF-0A62-477F-BD0D-B122876D5D2E}" type="datetimeFigureOut">
               <a:rPr lang="en-SG" smtClean="0"/>
-              <a:t>4/11/2025</a:t>
+              <a:t>5/11/2025</a:t>
             </a:fld>
             <a:endParaRPr lang="en-SG"/>
           </a:p>
@@ -463,7 +464,7 @@
           <a:p>
             <a:fld id="{E61142BF-0A62-477F-BD0D-B122876D5D2E}" type="datetimeFigureOut">
               <a:rPr lang="en-SG" smtClean="0"/>
-              <a:t>4/11/2025</a:t>
+              <a:t>5/11/2025</a:t>
             </a:fld>
             <a:endParaRPr lang="en-SG"/>
           </a:p>
@@ -673,7 +674,7 @@
           <a:p>
             <a:fld id="{E61142BF-0A62-477F-BD0D-B122876D5D2E}" type="datetimeFigureOut">
               <a:rPr lang="en-SG" smtClean="0"/>
-              <a:t>4/11/2025</a:t>
+              <a:t>5/11/2025</a:t>
             </a:fld>
             <a:endParaRPr lang="en-SG"/>
           </a:p>
@@ -873,7 +874,7 @@
           <a:p>
             <a:fld id="{E61142BF-0A62-477F-BD0D-B122876D5D2E}" type="datetimeFigureOut">
               <a:rPr lang="en-SG" smtClean="0"/>
-              <a:t>4/11/2025</a:t>
+              <a:t>5/11/2025</a:t>
             </a:fld>
             <a:endParaRPr lang="en-SG"/>
           </a:p>
@@ -1149,7 +1150,7 @@
           <a:p>
             <a:fld id="{E61142BF-0A62-477F-BD0D-B122876D5D2E}" type="datetimeFigureOut">
               <a:rPr lang="en-SG" smtClean="0"/>
-              <a:t>4/11/2025</a:t>
+              <a:t>5/11/2025</a:t>
             </a:fld>
             <a:endParaRPr lang="en-SG"/>
           </a:p>
@@ -1417,7 +1418,7 @@
           <a:p>
             <a:fld id="{E61142BF-0A62-477F-BD0D-B122876D5D2E}" type="datetimeFigureOut">
               <a:rPr lang="en-SG" smtClean="0"/>
-              <a:t>4/11/2025</a:t>
+              <a:t>5/11/2025</a:t>
             </a:fld>
             <a:endParaRPr lang="en-SG"/>
           </a:p>
@@ -1832,7 +1833,7 @@
           <a:p>
             <a:fld id="{E61142BF-0A62-477F-BD0D-B122876D5D2E}" type="datetimeFigureOut">
               <a:rPr lang="en-SG" smtClean="0"/>
-              <a:t>4/11/2025</a:t>
+              <a:t>5/11/2025</a:t>
             </a:fld>
             <a:endParaRPr lang="en-SG"/>
           </a:p>
@@ -1974,7 +1975,7 @@
           <a:p>
             <a:fld id="{E61142BF-0A62-477F-BD0D-B122876D5D2E}" type="datetimeFigureOut">
               <a:rPr lang="en-SG" smtClean="0"/>
-              <a:t>4/11/2025</a:t>
+              <a:t>5/11/2025</a:t>
             </a:fld>
             <a:endParaRPr lang="en-SG"/>
           </a:p>
@@ -2087,7 +2088,7 @@
           <a:p>
             <a:fld id="{E61142BF-0A62-477F-BD0D-B122876D5D2E}" type="datetimeFigureOut">
               <a:rPr lang="en-SG" smtClean="0"/>
-              <a:t>4/11/2025</a:t>
+              <a:t>5/11/2025</a:t>
             </a:fld>
             <a:endParaRPr lang="en-SG"/>
           </a:p>
@@ -2400,7 +2401,7 @@
           <a:p>
             <a:fld id="{E61142BF-0A62-477F-BD0D-B122876D5D2E}" type="datetimeFigureOut">
               <a:rPr lang="en-SG" smtClean="0"/>
-              <a:t>4/11/2025</a:t>
+              <a:t>5/11/2025</a:t>
             </a:fld>
             <a:endParaRPr lang="en-SG"/>
           </a:p>
@@ -2689,7 +2690,7 @@
           <a:p>
             <a:fld id="{E61142BF-0A62-477F-BD0D-B122876D5D2E}" type="datetimeFigureOut">
               <a:rPr lang="en-SG" smtClean="0"/>
-              <a:t>4/11/2025</a:t>
+              <a:t>5/11/2025</a:t>
             </a:fld>
             <a:endParaRPr lang="en-SG"/>
           </a:p>
@@ -2932,7 +2933,7 @@
           <a:p>
             <a:fld id="{E61142BF-0A62-477F-BD0D-B122876D5D2E}" type="datetimeFigureOut">
               <a:rPr lang="en-SG" smtClean="0"/>
-              <a:t>4/11/2025</a:t>
+              <a:t>5/11/2025</a:t>
             </a:fld>
             <a:endParaRPr lang="en-SG"/>
           </a:p>
@@ -3351,10 +3352,10 @@
       </p:grpSpPr>
       <p:sp>
         <p:nvSpPr>
-          <p:cNvPr id="1038" name="Rectangle 1037">
-            <a:extLst>
-              <a:ext uri="{FF2B5EF4-FFF2-40B4-BE49-F238E27FC236}">
-                <a16:creationId xmlns:a16="http://schemas.microsoft.com/office/drawing/2014/main" id="{7A72A1C1-40DB-34C3-B7B6-E74702CE1591}"/>
+          <p:cNvPr id="6" name="Rectangle 5">
+            <a:extLst>
+              <a:ext uri="{FF2B5EF4-FFF2-40B4-BE49-F238E27FC236}">
+                <a16:creationId xmlns:a16="http://schemas.microsoft.com/office/drawing/2014/main" id="{D3E1A6C1-A61B-783A-6637-41677D369EE3}"/>
               </a:ext>
             </a:extLst>
           </p:cNvPr>
@@ -3363,18 +3364,12 @@
         </p:nvSpPr>
         <p:spPr>
           <a:xfrm>
-            <a:off x="2742502" y="2422633"/>
-            <a:ext cx="2487368" cy="2950135"/>
+            <a:off x="2039112" y="1435608"/>
+            <a:ext cx="6245352" cy="3474720"/>
           </a:xfrm>
           <a:prstGeom prst="rect">
             <a:avLst/>
           </a:prstGeom>
-          <a:solidFill>
-            <a:schemeClr val="accent2">
-              <a:lumMod val="20000"/>
-              <a:lumOff val="80000"/>
-            </a:schemeClr>
-          </a:solidFill>
         </p:spPr>
         <p:style>
           <a:lnRef idx="2">
@@ -3397,1407 +3392,68 @@
           <a:lstStyle/>
           <a:p>
             <a:pPr algn="ctr"/>
-            <a:endParaRPr lang="en-SG" dirty="0"/>
-          </a:p>
-        </p:txBody>
-      </p:sp>
-      <p:sp>
-        <p:nvSpPr>
-          <p:cNvPr id="13" name="Rectangle 12">
-            <a:extLst>
-              <a:ext uri="{FF2B5EF4-FFF2-40B4-BE49-F238E27FC236}">
-                <a16:creationId xmlns:a16="http://schemas.microsoft.com/office/drawing/2014/main" id="{8759375A-3526-252C-A754-BE057854A791}"/>
-              </a:ext>
-            </a:extLst>
-          </p:cNvPr>
-          <p:cNvSpPr/>
-          <p:nvPr/>
-        </p:nvSpPr>
-        <p:spPr>
-          <a:xfrm>
-            <a:off x="1121383" y="627614"/>
-            <a:ext cx="9325191" cy="1244506"/>
-          </a:xfrm>
-          <a:prstGeom prst="rect">
-            <a:avLst/>
-          </a:prstGeom>
-          <a:solidFill>
-            <a:schemeClr val="accent6">
-              <a:lumMod val="20000"/>
-              <a:lumOff val="80000"/>
-            </a:schemeClr>
-          </a:solidFill>
-        </p:spPr>
-        <p:style>
-          <a:lnRef idx="2">
-            <a:schemeClr val="accent1">
-              <a:shade val="15000"/>
-            </a:schemeClr>
-          </a:lnRef>
-          <a:fillRef idx="1">
-            <a:schemeClr val="accent1"/>
-          </a:fillRef>
-          <a:effectRef idx="0">
-            <a:schemeClr val="accent1"/>
-          </a:effectRef>
-          <a:fontRef idx="minor">
-            <a:schemeClr val="lt1"/>
-          </a:fontRef>
-        </p:style>
-        <p:txBody>
-          <a:bodyPr rtlCol="0" anchor="ctr"/>
-          <a:lstStyle/>
-          <a:p>
-            <a:pPr algn="ctr"/>
-            <a:endParaRPr lang="en-SG" dirty="0"/>
+            <a:endParaRPr lang="en-SG"/>
           </a:p>
         </p:txBody>
       </p:sp>
       <p:pic>
         <p:nvPicPr>
-          <p:cNvPr id="1026" name="Picture 2" descr="Webcam - Free computer icons">
-            <a:extLst>
-              <a:ext uri="{FF2B5EF4-FFF2-40B4-BE49-F238E27FC236}">
-                <a16:creationId xmlns:a16="http://schemas.microsoft.com/office/drawing/2014/main" id="{1893017E-457B-DA61-73CD-5AF1C2D8E18B}"/>
+          <p:cNvPr id="5" name="Picture 4">
+            <a:extLst>
+              <a:ext uri="{FF2B5EF4-FFF2-40B4-BE49-F238E27FC236}">
+                <a16:creationId xmlns:a16="http://schemas.microsoft.com/office/drawing/2014/main" id="{27A63351-E557-EB05-5D47-B65CAF63DBB5}"/>
               </a:ext>
             </a:extLst>
           </p:cNvPr>
           <p:cNvPicPr>
-            <a:picLocks noChangeAspect="1" noChangeArrowheads="1"/>
+            <a:picLocks noChangeAspect="1"/>
           </p:cNvPicPr>
           <p:nvPr/>
         </p:nvPicPr>
         <p:blipFill>
-          <a:blip r:embed="rId2">
-            <a:extLst>
-              <a:ext uri="{28A0092B-C50C-407E-A947-70E740481C1C}">
-                <a14:useLocalDpi xmlns:a14="http://schemas.microsoft.com/office/drawing/2010/main" val="0"/>
-              </a:ext>
-            </a:extLst>
-          </a:blip>
-          <a:srcRect/>
+          <a:blip r:embed="rId2"/>
           <a:stretch>
             <a:fillRect/>
           </a:stretch>
         </p:blipFill>
-        <p:spPr bwMode="auto">
-          <a:xfrm>
-            <a:off x="1375875" y="1038236"/>
-            <a:ext cx="763929" cy="763929"/>
-          </a:xfrm>
-          <a:prstGeom prst="rect">
-            <a:avLst/>
-          </a:prstGeom>
-          <a:noFill/>
-          <a:extLst>
-            <a:ext uri="{909E8E84-426E-40DD-AFC4-6F175D3DCCD1}">
-              <a14:hiddenFill xmlns:a14="http://schemas.microsoft.com/office/drawing/2010/main">
-                <a:solidFill>
-                  <a:srgbClr val="FFFFFF"/>
-                </a:solidFill>
-              </a14:hiddenFill>
-            </a:ext>
-          </a:extLst>
+        <p:spPr>
+          <a:xfrm>
+            <a:off x="2181082" y="1316736"/>
+            <a:ext cx="5760244" cy="3255264"/>
+          </a:xfrm>
+          <a:prstGeom prst="roundRect">
+            <a:avLst>
+              <a:gd name="adj" fmla="val 16667"/>
+            </a:avLst>
+          </a:prstGeom>
+          <a:ln>
+            <a:noFill/>
+          </a:ln>
+          <a:effectLst>
+            <a:outerShdw blurRad="152400" dist="12000" dir="900000" sy="98000" kx="110000" ky="200000" algn="tl" rotWithShape="0">
+              <a:srgbClr val="000000">
+                <a:alpha val="30000"/>
+              </a:srgbClr>
+            </a:outerShdw>
+          </a:effectLst>
+          <a:scene3d>
+            <a:camera prst="perspectiveRelaxed">
+              <a:rot lat="19800000" lon="1200000" rev="20820000"/>
+            </a:camera>
+            <a:lightRig rig="threePt" dir="t"/>
+          </a:scene3d>
+          <a:sp3d contourW="6350" prstMaterial="matte">
+            <a:bevelT w="101600" h="101600"/>
+            <a:contourClr>
+              <a:srgbClr val="969696"/>
+            </a:contourClr>
+          </a:sp3d>
         </p:spPr>
       </p:pic>
-      <p:sp>
-        <p:nvSpPr>
-          <p:cNvPr id="4" name="TextBox 3">
-            <a:extLst>
-              <a:ext uri="{FF2B5EF4-FFF2-40B4-BE49-F238E27FC236}">
-                <a16:creationId xmlns:a16="http://schemas.microsoft.com/office/drawing/2014/main" id="{CE539FF7-AF70-F40A-4FA9-5BE1ED00A1BF}"/>
-              </a:ext>
-            </a:extLst>
-          </p:cNvPr>
-          <p:cNvSpPr txBox="1"/>
-          <p:nvPr/>
-        </p:nvSpPr>
-        <p:spPr>
-          <a:xfrm>
-            <a:off x="1310816" y="694939"/>
-            <a:ext cx="1232810" cy="307777"/>
-          </a:xfrm>
-          <a:prstGeom prst="rect">
-            <a:avLst/>
-          </a:prstGeom>
-          <a:noFill/>
-        </p:spPr>
-        <p:txBody>
-          <a:bodyPr wrap="square">
-            <a:spAutoFit/>
-          </a:bodyPr>
-          <a:lstStyle/>
-          <a:p>
-            <a:r>
-              <a:rPr lang="en-US" sz="1400" b="1" dirty="0">
-                <a:solidFill>
-                  <a:schemeClr val="tx1">
-                    <a:lumMod val="75000"/>
-                    <a:lumOff val="25000"/>
-                  </a:schemeClr>
-                </a:solidFill>
-              </a:rPr>
-              <a:t>Real Camrea</a:t>
-            </a:r>
-            <a:endParaRPr lang="en-SG" sz="1400" b="1" dirty="0">
-              <a:solidFill>
-                <a:schemeClr val="tx1">
-                  <a:lumMod val="75000"/>
-                  <a:lumOff val="25000"/>
-                </a:schemeClr>
-              </a:solidFill>
-            </a:endParaRPr>
-          </a:p>
-        </p:txBody>
-      </p:sp>
-      <p:pic>
-        <p:nvPicPr>
-          <p:cNvPr id="6" name="Picture 5">
-            <a:extLst>
-              <a:ext uri="{FF2B5EF4-FFF2-40B4-BE49-F238E27FC236}">
-                <a16:creationId xmlns:a16="http://schemas.microsoft.com/office/drawing/2014/main" id="{D51FB2D0-AFF9-CDEF-7567-C197B48D4C90}"/>
-              </a:ext>
-            </a:extLst>
-          </p:cNvPr>
-          <p:cNvPicPr>
-            <a:picLocks noChangeAspect="1"/>
-          </p:cNvPicPr>
-          <p:nvPr/>
-        </p:nvPicPr>
-        <p:blipFill>
-          <a:blip r:embed="rId3"/>
-          <a:stretch>
-            <a:fillRect/>
-          </a:stretch>
-        </p:blipFill>
-        <p:spPr>
-          <a:xfrm>
-            <a:off x="3023900" y="1114405"/>
-            <a:ext cx="664252" cy="631449"/>
-          </a:xfrm>
-          <a:prstGeom prst="rect">
-            <a:avLst/>
-          </a:prstGeom>
-        </p:spPr>
-      </p:pic>
-      <p:sp>
-        <p:nvSpPr>
-          <p:cNvPr id="7" name="TextBox 6">
-            <a:extLst>
-              <a:ext uri="{FF2B5EF4-FFF2-40B4-BE49-F238E27FC236}">
-                <a16:creationId xmlns:a16="http://schemas.microsoft.com/office/drawing/2014/main" id="{B0C26ADD-BCF5-082F-67C0-8BC556475408}"/>
-              </a:ext>
-            </a:extLst>
-          </p:cNvPr>
-          <p:cNvSpPr txBox="1"/>
-          <p:nvPr/>
-        </p:nvSpPr>
-        <p:spPr>
-          <a:xfrm>
-            <a:off x="2733058" y="678099"/>
-            <a:ext cx="1668004" cy="307777"/>
-          </a:xfrm>
-          <a:prstGeom prst="rect">
-            <a:avLst/>
-          </a:prstGeom>
-          <a:noFill/>
-        </p:spPr>
-        <p:txBody>
-          <a:bodyPr wrap="square">
-            <a:spAutoFit/>
-          </a:bodyPr>
-          <a:lstStyle/>
-          <a:p>
-            <a:r>
-              <a:rPr lang="en-US" sz="1400" b="1" dirty="0">
-                <a:solidFill>
-                  <a:schemeClr val="tx1">
-                    <a:lumMod val="75000"/>
-                    <a:lumOff val="25000"/>
-                  </a:schemeClr>
-                </a:solidFill>
-              </a:rPr>
-              <a:t>RTSP Video server</a:t>
-            </a:r>
-            <a:endParaRPr lang="en-SG" sz="1400" b="1" dirty="0">
-              <a:solidFill>
-                <a:schemeClr val="tx1">
-                  <a:lumMod val="75000"/>
-                  <a:lumOff val="25000"/>
-                </a:schemeClr>
-              </a:solidFill>
-            </a:endParaRPr>
-          </a:p>
-        </p:txBody>
-      </p:sp>
-      <p:pic>
-        <p:nvPicPr>
-          <p:cNvPr id="1028" name="Picture 4" descr="Folder images Icon | Free Folder Iconpack | Iconshock">
-            <a:extLst>
-              <a:ext uri="{FF2B5EF4-FFF2-40B4-BE49-F238E27FC236}">
-                <a16:creationId xmlns:a16="http://schemas.microsoft.com/office/drawing/2014/main" id="{4F5F0147-7AAC-0DB1-F1A8-62C15B8B7ECA}"/>
-              </a:ext>
-            </a:extLst>
-          </p:cNvPr>
-          <p:cNvPicPr>
-            <a:picLocks noChangeAspect="1" noChangeArrowheads="1"/>
-          </p:cNvPicPr>
-          <p:nvPr/>
-        </p:nvPicPr>
-        <p:blipFill>
-          <a:blip r:embed="rId4">
-            <a:extLst>
-              <a:ext uri="{28A0092B-C50C-407E-A947-70E740481C1C}">
-                <a14:useLocalDpi xmlns:a14="http://schemas.microsoft.com/office/drawing/2010/main" val="0"/>
-              </a:ext>
-            </a:extLst>
-          </a:blip>
-          <a:srcRect/>
-          <a:stretch>
-            <a:fillRect/>
-          </a:stretch>
-        </p:blipFill>
-        <p:spPr bwMode="auto">
-          <a:xfrm>
-            <a:off x="4769026" y="1043421"/>
-            <a:ext cx="726204" cy="726204"/>
-          </a:xfrm>
-          <a:prstGeom prst="rect">
-            <a:avLst/>
-          </a:prstGeom>
-          <a:noFill/>
-          <a:extLst>
-            <a:ext uri="{909E8E84-426E-40DD-AFC4-6F175D3DCCD1}">
-              <a14:hiddenFill xmlns:a14="http://schemas.microsoft.com/office/drawing/2010/main">
-                <a:solidFill>
-                  <a:srgbClr val="FFFFFF"/>
-                </a:solidFill>
-              </a14:hiddenFill>
-            </a:ext>
-          </a:extLst>
-        </p:spPr>
-      </p:pic>
-      <p:sp>
-        <p:nvSpPr>
-          <p:cNvPr id="8" name="TextBox 7">
-            <a:extLst>
-              <a:ext uri="{FF2B5EF4-FFF2-40B4-BE49-F238E27FC236}">
-                <a16:creationId xmlns:a16="http://schemas.microsoft.com/office/drawing/2014/main" id="{9E24AF49-FC8A-1870-DC15-72F43AF37E84}"/>
-              </a:ext>
-            </a:extLst>
-          </p:cNvPr>
-          <p:cNvSpPr txBox="1"/>
-          <p:nvPr/>
-        </p:nvSpPr>
-        <p:spPr>
-          <a:xfrm>
-            <a:off x="4401062" y="698259"/>
-            <a:ext cx="1822486" cy="307777"/>
-          </a:xfrm>
-          <a:prstGeom prst="rect">
-            <a:avLst/>
-          </a:prstGeom>
-          <a:noFill/>
-        </p:spPr>
-        <p:txBody>
-          <a:bodyPr wrap="square">
-            <a:spAutoFit/>
-          </a:bodyPr>
-          <a:lstStyle/>
-          <a:p>
-            <a:r>
-              <a:rPr lang="en-US" sz="1400" b="1" dirty="0">
-                <a:solidFill>
-                  <a:schemeClr val="tx1">
-                    <a:lumMod val="75000"/>
-                    <a:lumOff val="25000"/>
-                  </a:schemeClr>
-                </a:solidFill>
-              </a:rPr>
-              <a:t>Pictures Data Set</a:t>
-            </a:r>
-            <a:endParaRPr lang="en-SG" sz="1400" b="1" dirty="0">
-              <a:solidFill>
-                <a:schemeClr val="tx1">
-                  <a:lumMod val="75000"/>
-                  <a:lumOff val="25000"/>
-                </a:schemeClr>
-              </a:solidFill>
-            </a:endParaRPr>
-          </a:p>
-        </p:txBody>
-      </p:sp>
-      <p:pic>
-        <p:nvPicPr>
-          <p:cNvPr id="10" name="Picture 9">
-            <a:extLst>
-              <a:ext uri="{FF2B5EF4-FFF2-40B4-BE49-F238E27FC236}">
-                <a16:creationId xmlns:a16="http://schemas.microsoft.com/office/drawing/2014/main" id="{EF14CECB-8E08-231D-2A36-E998D7F1FFA4}"/>
-              </a:ext>
-            </a:extLst>
-          </p:cNvPr>
-          <p:cNvPicPr>
-            <a:picLocks noChangeAspect="1"/>
-          </p:cNvPicPr>
-          <p:nvPr/>
-        </p:nvPicPr>
-        <p:blipFill>
-          <a:blip r:embed="rId5"/>
-          <a:stretch>
-            <a:fillRect/>
-          </a:stretch>
-        </p:blipFill>
-        <p:spPr>
-          <a:xfrm>
-            <a:off x="6576104" y="1118522"/>
-            <a:ext cx="789144" cy="627332"/>
-          </a:xfrm>
-          <a:prstGeom prst="rect">
-            <a:avLst/>
-          </a:prstGeom>
-        </p:spPr>
-      </p:pic>
-      <p:sp>
-        <p:nvSpPr>
-          <p:cNvPr id="11" name="TextBox 10">
-            <a:extLst>
-              <a:ext uri="{FF2B5EF4-FFF2-40B4-BE49-F238E27FC236}">
-                <a16:creationId xmlns:a16="http://schemas.microsoft.com/office/drawing/2014/main" id="{90DF4BB7-8192-D0A1-5917-163BBE054545}"/>
-              </a:ext>
-            </a:extLst>
-          </p:cNvPr>
-          <p:cNvSpPr txBox="1"/>
-          <p:nvPr/>
-        </p:nvSpPr>
-        <p:spPr>
-          <a:xfrm>
-            <a:off x="6093853" y="694939"/>
-            <a:ext cx="1942092" cy="307777"/>
-          </a:xfrm>
-          <a:prstGeom prst="rect">
-            <a:avLst/>
-          </a:prstGeom>
-          <a:noFill/>
-        </p:spPr>
-        <p:txBody>
-          <a:bodyPr wrap="square">
-            <a:spAutoFit/>
-          </a:bodyPr>
-          <a:lstStyle/>
-          <a:p>
-            <a:r>
-              <a:rPr lang="en-US" sz="1400" b="1" dirty="0">
-                <a:solidFill>
-                  <a:schemeClr val="tx1">
-                    <a:lumMod val="75000"/>
-                    <a:lumOff val="25000"/>
-                  </a:schemeClr>
-                </a:solidFill>
-              </a:rPr>
-              <a:t>Screen Recording</a:t>
-            </a:r>
-            <a:endParaRPr lang="en-SG" sz="1400" b="1" dirty="0">
-              <a:solidFill>
-                <a:schemeClr val="tx1">
-                  <a:lumMod val="75000"/>
-                  <a:lumOff val="25000"/>
-                </a:schemeClr>
-              </a:solidFill>
-            </a:endParaRPr>
-          </a:p>
-        </p:txBody>
-      </p:sp>
-      <p:pic>
-        <p:nvPicPr>
-          <p:cNvPr id="1030" name="Picture 6" descr="Application Flaticons Lineal Color icon | Freepik">
-            <a:extLst>
-              <a:ext uri="{FF2B5EF4-FFF2-40B4-BE49-F238E27FC236}">
-                <a16:creationId xmlns:a16="http://schemas.microsoft.com/office/drawing/2014/main" id="{D680763A-B9AE-32E3-9CDA-1D12A0EB1172}"/>
-              </a:ext>
-            </a:extLst>
-          </p:cNvPr>
-          <p:cNvPicPr>
-            <a:picLocks noChangeAspect="1" noChangeArrowheads="1"/>
-          </p:cNvPicPr>
-          <p:nvPr/>
-        </p:nvPicPr>
-        <p:blipFill>
-          <a:blip r:embed="rId6">
-            <a:extLst>
-              <a:ext uri="{28A0092B-C50C-407E-A947-70E740481C1C}">
-                <a14:useLocalDpi xmlns:a14="http://schemas.microsoft.com/office/drawing/2010/main" val="0"/>
-              </a:ext>
-            </a:extLst>
-          </a:blip>
-          <a:srcRect/>
-          <a:stretch>
-            <a:fillRect/>
-          </a:stretch>
-        </p:blipFill>
-        <p:spPr bwMode="auto">
-          <a:xfrm>
-            <a:off x="8313493" y="1161892"/>
-            <a:ext cx="629368" cy="629368"/>
-          </a:xfrm>
-          <a:prstGeom prst="rect">
-            <a:avLst/>
-          </a:prstGeom>
-          <a:noFill/>
-          <a:extLst>
-            <a:ext uri="{909E8E84-426E-40DD-AFC4-6F175D3DCCD1}">
-              <a14:hiddenFill xmlns:a14="http://schemas.microsoft.com/office/drawing/2010/main">
-                <a:solidFill>
-                  <a:srgbClr val="FFFFFF"/>
-                </a:solidFill>
-              </a14:hiddenFill>
-            </a:ext>
-          </a:extLst>
-        </p:spPr>
-      </p:pic>
-      <p:sp>
-        <p:nvSpPr>
-          <p:cNvPr id="12" name="TextBox 11">
-            <a:extLst>
-              <a:ext uri="{FF2B5EF4-FFF2-40B4-BE49-F238E27FC236}">
-                <a16:creationId xmlns:a16="http://schemas.microsoft.com/office/drawing/2014/main" id="{DAB31FAC-8E0F-A0CF-FC80-8934A7E4E9D2}"/>
-              </a:ext>
-            </a:extLst>
-          </p:cNvPr>
-          <p:cNvSpPr txBox="1"/>
-          <p:nvPr/>
-        </p:nvSpPr>
-        <p:spPr>
-          <a:xfrm>
-            <a:off x="7924440" y="678099"/>
-            <a:ext cx="1942092" cy="523220"/>
-          </a:xfrm>
-          <a:prstGeom prst="rect">
-            <a:avLst/>
-          </a:prstGeom>
-          <a:noFill/>
-        </p:spPr>
-        <p:txBody>
-          <a:bodyPr wrap="square">
-            <a:spAutoFit/>
-          </a:bodyPr>
-          <a:lstStyle/>
-          <a:p>
-            <a:r>
-              <a:rPr lang="en-US" sz="1400" b="1" dirty="0">
-                <a:solidFill>
-                  <a:schemeClr val="tx1">
-                    <a:lumMod val="75000"/>
-                    <a:lumOff val="25000"/>
-                  </a:schemeClr>
-                </a:solidFill>
-              </a:rPr>
-              <a:t>Application Window  Screen shot </a:t>
-            </a:r>
-            <a:endParaRPr lang="en-SG" sz="1400" b="1" dirty="0">
-              <a:solidFill>
-                <a:schemeClr val="tx1">
-                  <a:lumMod val="75000"/>
-                  <a:lumOff val="25000"/>
-                </a:schemeClr>
-              </a:solidFill>
-            </a:endParaRPr>
-          </a:p>
-        </p:txBody>
-      </p:sp>
-      <p:sp>
-        <p:nvSpPr>
-          <p:cNvPr id="14" name="TextBox 13">
-            <a:extLst>
-              <a:ext uri="{FF2B5EF4-FFF2-40B4-BE49-F238E27FC236}">
-                <a16:creationId xmlns:a16="http://schemas.microsoft.com/office/drawing/2014/main" id="{42228077-B29A-6297-80F2-58FCD95ADD78}"/>
-              </a:ext>
-            </a:extLst>
-          </p:cNvPr>
-          <p:cNvSpPr txBox="1"/>
-          <p:nvPr/>
-        </p:nvSpPr>
-        <p:spPr>
-          <a:xfrm>
-            <a:off x="9071264" y="1241413"/>
-            <a:ext cx="1553984" cy="584775"/>
-          </a:xfrm>
-          <a:prstGeom prst="rect">
-            <a:avLst/>
-          </a:prstGeom>
-          <a:noFill/>
-        </p:spPr>
-        <p:txBody>
-          <a:bodyPr wrap="square">
-            <a:spAutoFit/>
-          </a:bodyPr>
-          <a:lstStyle/>
-          <a:p>
-            <a:r>
-              <a:rPr lang="en-US" sz="1600" b="1" dirty="0">
-                <a:solidFill>
-                  <a:schemeClr val="accent6">
-                    <a:lumMod val="75000"/>
-                  </a:schemeClr>
-                </a:solidFill>
-              </a:rPr>
-              <a:t>5 Different Video Source</a:t>
-            </a:r>
-            <a:endParaRPr lang="en-SG" sz="1600" b="1" dirty="0">
-              <a:solidFill>
-                <a:schemeClr val="accent6">
-                  <a:lumMod val="75000"/>
-                </a:schemeClr>
-              </a:solidFill>
-            </a:endParaRPr>
-          </a:p>
-        </p:txBody>
-      </p:sp>
-      <p:pic>
-        <p:nvPicPr>
-          <p:cNvPr id="18" name="Graphic 17" descr="Web design with solid fill">
-            <a:extLst>
-              <a:ext uri="{FF2B5EF4-FFF2-40B4-BE49-F238E27FC236}">
-                <a16:creationId xmlns:a16="http://schemas.microsoft.com/office/drawing/2014/main" id="{77E0C4C9-D36F-C627-1554-3B240DB8A9AB}"/>
-              </a:ext>
-            </a:extLst>
-          </p:cNvPr>
-          <p:cNvPicPr>
-            <a:picLocks noChangeAspect="1"/>
-          </p:cNvPicPr>
-          <p:nvPr/>
-        </p:nvPicPr>
-        <p:blipFill>
-          <a:blip r:embed="rId7">
-            <a:extLst>
-              <a:ext uri="{96DAC541-7B7A-43D3-8B79-37D633B846F1}">
-                <asvg:svgBlip xmlns:asvg="http://schemas.microsoft.com/office/drawing/2016/SVG/main" r:embed="rId8"/>
-              </a:ext>
-            </a:extLst>
-          </a:blip>
-          <a:stretch>
-            <a:fillRect/>
-          </a:stretch>
-        </p:blipFill>
-        <p:spPr>
-          <a:xfrm>
-            <a:off x="1609952" y="2422633"/>
-            <a:ext cx="845350" cy="845350"/>
-          </a:xfrm>
-          <a:prstGeom prst="rect">
-            <a:avLst/>
-          </a:prstGeom>
-        </p:spPr>
-      </p:pic>
-      <p:cxnSp>
-        <p:nvCxnSpPr>
-          <p:cNvPr id="21" name="Straight Connector 20">
-            <a:extLst>
-              <a:ext uri="{FF2B5EF4-FFF2-40B4-BE49-F238E27FC236}">
-                <a16:creationId xmlns:a16="http://schemas.microsoft.com/office/drawing/2014/main" id="{271E2D5E-E190-237F-B206-6226603CF68D}"/>
-              </a:ext>
-            </a:extLst>
-          </p:cNvPr>
-          <p:cNvCxnSpPr>
-            <a:cxnSpLocks/>
-          </p:cNvCxnSpPr>
-          <p:nvPr/>
-        </p:nvCxnSpPr>
-        <p:spPr>
-          <a:xfrm flipV="1">
-            <a:off x="1745426" y="2182091"/>
-            <a:ext cx="6882751" cy="3"/>
-          </a:xfrm>
-          <a:prstGeom prst="line">
-            <a:avLst/>
-          </a:prstGeom>
-          <a:ln w="28575"/>
-        </p:spPr>
-        <p:style>
-          <a:lnRef idx="2">
-            <a:schemeClr val="accent1"/>
-          </a:lnRef>
-          <a:fillRef idx="0">
-            <a:schemeClr val="accent1"/>
-          </a:fillRef>
-          <a:effectRef idx="1">
-            <a:schemeClr val="accent1"/>
-          </a:effectRef>
-          <a:fontRef idx="minor">
-            <a:schemeClr val="tx1"/>
-          </a:fontRef>
-        </p:style>
-      </p:cxnSp>
-      <p:sp>
-        <p:nvSpPr>
-          <p:cNvPr id="37" name="TextBox 36">
-            <a:extLst>
-              <a:ext uri="{FF2B5EF4-FFF2-40B4-BE49-F238E27FC236}">
-                <a16:creationId xmlns:a16="http://schemas.microsoft.com/office/drawing/2014/main" id="{258E1831-CD12-30A2-D4B1-4CAA16AAF7E9}"/>
-              </a:ext>
-            </a:extLst>
-          </p:cNvPr>
-          <p:cNvSpPr txBox="1"/>
-          <p:nvPr/>
-        </p:nvSpPr>
-        <p:spPr>
-          <a:xfrm>
-            <a:off x="901983" y="2834918"/>
-            <a:ext cx="1368324" cy="830997"/>
-          </a:xfrm>
-          <a:prstGeom prst="rect">
-            <a:avLst/>
-          </a:prstGeom>
-          <a:noFill/>
-        </p:spPr>
-        <p:txBody>
-          <a:bodyPr wrap="square">
-            <a:spAutoFit/>
-          </a:bodyPr>
-          <a:lstStyle/>
-          <a:p>
-            <a:r>
-              <a:rPr lang="en-US" sz="1600" b="1" dirty="0"/>
-              <a:t>Virtual Camera Client Lib</a:t>
-            </a:r>
-            <a:endParaRPr lang="en-SG" sz="1600" b="1" dirty="0"/>
-          </a:p>
-        </p:txBody>
-      </p:sp>
-      <p:cxnSp>
-        <p:nvCxnSpPr>
-          <p:cNvPr id="38" name="Straight Arrow Connector 37">
-            <a:extLst>
-              <a:ext uri="{FF2B5EF4-FFF2-40B4-BE49-F238E27FC236}">
-                <a16:creationId xmlns:a16="http://schemas.microsoft.com/office/drawing/2014/main" id="{CD5C236A-5CBF-28A4-41E7-8B5167AFAC53}"/>
-              </a:ext>
-            </a:extLst>
-          </p:cNvPr>
-          <p:cNvCxnSpPr>
-            <a:cxnSpLocks/>
-            <a:stCxn id="1026" idx="2"/>
-          </p:cNvCxnSpPr>
-          <p:nvPr/>
-        </p:nvCxnSpPr>
-        <p:spPr>
-          <a:xfrm flipH="1">
-            <a:off x="1745426" y="1802165"/>
-            <a:ext cx="0" cy="379929"/>
-          </a:xfrm>
-          <a:prstGeom prst="straightConnector1">
-            <a:avLst/>
-          </a:prstGeom>
-          <a:ln>
-            <a:tailEnd type="triangle"/>
-          </a:ln>
-        </p:spPr>
-        <p:style>
-          <a:lnRef idx="2">
-            <a:schemeClr val="accent1"/>
-          </a:lnRef>
-          <a:fillRef idx="0">
-            <a:schemeClr val="accent1"/>
-          </a:fillRef>
-          <a:effectRef idx="1">
-            <a:schemeClr val="accent1"/>
-          </a:effectRef>
-          <a:fontRef idx="minor">
-            <a:schemeClr val="tx1"/>
-          </a:fontRef>
-        </p:style>
-      </p:cxnSp>
-      <p:pic>
-        <p:nvPicPr>
-          <p:cNvPr id="42" name="Picture 41" descr="A screenshot of a computer&#10;&#10;AI-generated content may be incorrect.">
-            <a:extLst>
-              <a:ext uri="{FF2B5EF4-FFF2-40B4-BE49-F238E27FC236}">
-                <a16:creationId xmlns:a16="http://schemas.microsoft.com/office/drawing/2014/main" id="{74329011-E43B-FF29-1A3E-D3C3484885C4}"/>
-              </a:ext>
-            </a:extLst>
-          </p:cNvPr>
-          <p:cNvPicPr>
-            <a:picLocks noChangeAspect="1"/>
-          </p:cNvPicPr>
-          <p:nvPr/>
-        </p:nvPicPr>
-        <p:blipFill>
-          <a:blip r:embed="rId9">
-            <a:extLst>
-              <a:ext uri="{28A0092B-C50C-407E-A947-70E740481C1C}">
-                <a14:useLocalDpi xmlns:a14="http://schemas.microsoft.com/office/drawing/2010/main" val="0"/>
-              </a:ext>
-            </a:extLst>
-          </a:blip>
-          <a:stretch>
-            <a:fillRect/>
-          </a:stretch>
-        </p:blipFill>
-        <p:spPr>
-          <a:xfrm>
-            <a:off x="5541572" y="2662385"/>
-            <a:ext cx="4825680" cy="2710384"/>
-          </a:xfrm>
-          <a:prstGeom prst="rect">
-            <a:avLst/>
-          </a:prstGeom>
-          <a:ln w="9525">
-            <a:solidFill>
-              <a:schemeClr val="tx1"/>
-            </a:solidFill>
-          </a:ln>
-        </p:spPr>
-      </p:pic>
-      <p:pic>
-        <p:nvPicPr>
-          <p:cNvPr id="49" name="Graphic 48" descr="Web design with solid fill">
-            <a:extLst>
-              <a:ext uri="{FF2B5EF4-FFF2-40B4-BE49-F238E27FC236}">
-                <a16:creationId xmlns:a16="http://schemas.microsoft.com/office/drawing/2014/main" id="{9373EFF3-C3CA-A8EC-F712-1E08228526A1}"/>
-              </a:ext>
-            </a:extLst>
-          </p:cNvPr>
-          <p:cNvPicPr>
-            <a:picLocks noChangeAspect="1"/>
-          </p:cNvPicPr>
-          <p:nvPr/>
-        </p:nvPicPr>
-        <p:blipFill>
-          <a:blip r:embed="rId7">
-            <a:extLst>
-              <a:ext uri="{96DAC541-7B7A-43D3-8B79-37D633B846F1}">
-                <asvg:svgBlip xmlns:asvg="http://schemas.microsoft.com/office/drawing/2016/SVG/main" r:embed="rId8"/>
-              </a:ext>
-            </a:extLst>
-          </a:blip>
-          <a:stretch>
-            <a:fillRect/>
-          </a:stretch>
-        </p:blipFill>
-        <p:spPr>
-          <a:xfrm>
-            <a:off x="1575427" y="3731053"/>
-            <a:ext cx="914400" cy="914400"/>
-          </a:xfrm>
-          <a:prstGeom prst="rect">
-            <a:avLst/>
-          </a:prstGeom>
-        </p:spPr>
-      </p:pic>
-      <p:cxnSp>
-        <p:nvCxnSpPr>
-          <p:cNvPr id="53" name="Straight Arrow Connector 52">
-            <a:extLst>
-              <a:ext uri="{FF2B5EF4-FFF2-40B4-BE49-F238E27FC236}">
-                <a16:creationId xmlns:a16="http://schemas.microsoft.com/office/drawing/2014/main" id="{C4EDD6BF-B996-C23E-95B9-A4031B65D19B}"/>
-              </a:ext>
-            </a:extLst>
-          </p:cNvPr>
-          <p:cNvCxnSpPr>
-            <a:cxnSpLocks/>
-          </p:cNvCxnSpPr>
-          <p:nvPr/>
-        </p:nvCxnSpPr>
-        <p:spPr>
-          <a:xfrm>
-            <a:off x="3279817" y="1769625"/>
-            <a:ext cx="0" cy="412469"/>
-          </a:xfrm>
-          <a:prstGeom prst="straightConnector1">
-            <a:avLst/>
-          </a:prstGeom>
-          <a:ln w="28575">
-            <a:tailEnd type="triangle"/>
-          </a:ln>
-        </p:spPr>
-        <p:style>
-          <a:lnRef idx="2">
-            <a:schemeClr val="accent1"/>
-          </a:lnRef>
-          <a:fillRef idx="0">
-            <a:schemeClr val="accent1"/>
-          </a:fillRef>
-          <a:effectRef idx="1">
-            <a:schemeClr val="accent1"/>
-          </a:effectRef>
-          <a:fontRef idx="minor">
-            <a:schemeClr val="tx1"/>
-          </a:fontRef>
-        </p:style>
-      </p:cxnSp>
-      <p:cxnSp>
-        <p:nvCxnSpPr>
-          <p:cNvPr id="59" name="Straight Arrow Connector 58">
-            <a:extLst>
-              <a:ext uri="{FF2B5EF4-FFF2-40B4-BE49-F238E27FC236}">
-                <a16:creationId xmlns:a16="http://schemas.microsoft.com/office/drawing/2014/main" id="{00B639C0-0151-BA37-B97B-3AA51DAC9CE2}"/>
-              </a:ext>
-            </a:extLst>
-          </p:cNvPr>
-          <p:cNvCxnSpPr>
-            <a:cxnSpLocks/>
-          </p:cNvCxnSpPr>
-          <p:nvPr/>
-        </p:nvCxnSpPr>
-        <p:spPr>
-          <a:xfrm>
-            <a:off x="1745426" y="1814634"/>
-            <a:ext cx="0" cy="367457"/>
-          </a:xfrm>
-          <a:prstGeom prst="straightConnector1">
-            <a:avLst/>
-          </a:prstGeom>
-          <a:ln w="28575">
-            <a:tailEnd type="triangle"/>
-          </a:ln>
-        </p:spPr>
-        <p:style>
-          <a:lnRef idx="2">
-            <a:schemeClr val="accent1"/>
-          </a:lnRef>
-          <a:fillRef idx="0">
-            <a:schemeClr val="accent1"/>
-          </a:fillRef>
-          <a:effectRef idx="1">
-            <a:schemeClr val="accent1"/>
-          </a:effectRef>
-          <a:fontRef idx="minor">
-            <a:schemeClr val="tx1"/>
-          </a:fontRef>
-        </p:style>
-      </p:cxnSp>
-      <p:cxnSp>
-        <p:nvCxnSpPr>
-          <p:cNvPr id="60" name="Straight Arrow Connector 59">
-            <a:extLst>
-              <a:ext uri="{FF2B5EF4-FFF2-40B4-BE49-F238E27FC236}">
-                <a16:creationId xmlns:a16="http://schemas.microsoft.com/office/drawing/2014/main" id="{D40D7555-136F-1B8A-5BE0-CFEEE888D221}"/>
-              </a:ext>
-            </a:extLst>
-          </p:cNvPr>
-          <p:cNvCxnSpPr>
-            <a:cxnSpLocks/>
-          </p:cNvCxnSpPr>
-          <p:nvPr/>
-        </p:nvCxnSpPr>
-        <p:spPr>
-          <a:xfrm>
-            <a:off x="5084372" y="1769625"/>
-            <a:ext cx="0" cy="412469"/>
-          </a:xfrm>
-          <a:prstGeom prst="straightConnector1">
-            <a:avLst/>
-          </a:prstGeom>
-          <a:ln w="28575">
-            <a:tailEnd type="triangle"/>
-          </a:ln>
-        </p:spPr>
-        <p:style>
-          <a:lnRef idx="2">
-            <a:schemeClr val="accent1"/>
-          </a:lnRef>
-          <a:fillRef idx="0">
-            <a:schemeClr val="accent1"/>
-          </a:fillRef>
-          <a:effectRef idx="1">
-            <a:schemeClr val="accent1"/>
-          </a:effectRef>
-          <a:fontRef idx="minor">
-            <a:schemeClr val="tx1"/>
-          </a:fontRef>
-        </p:style>
-      </p:cxnSp>
-      <p:cxnSp>
-        <p:nvCxnSpPr>
-          <p:cNvPr id="61" name="Straight Arrow Connector 60">
-            <a:extLst>
-              <a:ext uri="{FF2B5EF4-FFF2-40B4-BE49-F238E27FC236}">
-                <a16:creationId xmlns:a16="http://schemas.microsoft.com/office/drawing/2014/main" id="{5F0E1DAD-9B25-C0D2-5F4D-DDCC4FC7014E}"/>
-              </a:ext>
-            </a:extLst>
-          </p:cNvPr>
-          <p:cNvCxnSpPr>
-            <a:cxnSpLocks/>
-          </p:cNvCxnSpPr>
-          <p:nvPr/>
-        </p:nvCxnSpPr>
-        <p:spPr>
-          <a:xfrm>
-            <a:off x="6975517" y="1745854"/>
-            <a:ext cx="0" cy="412469"/>
-          </a:xfrm>
-          <a:prstGeom prst="straightConnector1">
-            <a:avLst/>
-          </a:prstGeom>
-          <a:ln w="28575">
-            <a:tailEnd type="triangle"/>
-          </a:ln>
-        </p:spPr>
-        <p:style>
-          <a:lnRef idx="2">
-            <a:schemeClr val="accent1"/>
-          </a:lnRef>
-          <a:fillRef idx="0">
-            <a:schemeClr val="accent1"/>
-          </a:fillRef>
-          <a:effectRef idx="1">
-            <a:schemeClr val="accent1"/>
-          </a:effectRef>
-          <a:fontRef idx="minor">
-            <a:schemeClr val="tx1"/>
-          </a:fontRef>
-        </p:style>
-      </p:cxnSp>
-      <p:cxnSp>
-        <p:nvCxnSpPr>
-          <p:cNvPr id="62" name="Straight Arrow Connector 61">
-            <a:extLst>
-              <a:ext uri="{FF2B5EF4-FFF2-40B4-BE49-F238E27FC236}">
-                <a16:creationId xmlns:a16="http://schemas.microsoft.com/office/drawing/2014/main" id="{C9C4C224-A813-99AB-6416-F0F0D647E5A4}"/>
-              </a:ext>
-            </a:extLst>
-          </p:cNvPr>
-          <p:cNvCxnSpPr>
-            <a:cxnSpLocks/>
-          </p:cNvCxnSpPr>
-          <p:nvPr/>
-        </p:nvCxnSpPr>
-        <p:spPr>
-          <a:xfrm>
-            <a:off x="8597005" y="1802165"/>
-            <a:ext cx="0" cy="412469"/>
-          </a:xfrm>
-          <a:prstGeom prst="straightConnector1">
-            <a:avLst/>
-          </a:prstGeom>
-          <a:ln w="28575">
-            <a:tailEnd type="triangle"/>
-          </a:ln>
-        </p:spPr>
-        <p:style>
-          <a:lnRef idx="2">
-            <a:schemeClr val="accent1"/>
-          </a:lnRef>
-          <a:fillRef idx="0">
-            <a:schemeClr val="accent1"/>
-          </a:fillRef>
-          <a:effectRef idx="1">
-            <a:schemeClr val="accent1"/>
-          </a:effectRef>
-          <a:fontRef idx="minor">
-            <a:schemeClr val="tx1"/>
-          </a:fontRef>
-        </p:style>
-      </p:cxnSp>
-      <p:cxnSp>
-        <p:nvCxnSpPr>
-          <p:cNvPr id="63" name="Straight Arrow Connector 62">
-            <a:extLst>
-              <a:ext uri="{FF2B5EF4-FFF2-40B4-BE49-F238E27FC236}">
-                <a16:creationId xmlns:a16="http://schemas.microsoft.com/office/drawing/2014/main" id="{939080D0-CEEF-9EF3-C1DA-2A9AFCA741E5}"/>
-              </a:ext>
-            </a:extLst>
-          </p:cNvPr>
-          <p:cNvCxnSpPr>
-            <a:cxnSpLocks/>
-          </p:cNvCxnSpPr>
-          <p:nvPr/>
-        </p:nvCxnSpPr>
-        <p:spPr>
-          <a:xfrm>
-            <a:off x="2032627" y="2182091"/>
-            <a:ext cx="0" cy="384464"/>
-          </a:xfrm>
-          <a:prstGeom prst="straightConnector1">
-            <a:avLst/>
-          </a:prstGeom>
-          <a:ln w="28575">
-            <a:tailEnd type="triangle"/>
-          </a:ln>
-        </p:spPr>
-        <p:style>
-          <a:lnRef idx="2">
-            <a:schemeClr val="accent1"/>
-          </a:lnRef>
-          <a:fillRef idx="0">
-            <a:schemeClr val="accent1"/>
-          </a:fillRef>
-          <a:effectRef idx="1">
-            <a:schemeClr val="accent1"/>
-          </a:effectRef>
-          <a:fontRef idx="minor">
-            <a:schemeClr val="tx1"/>
-          </a:fontRef>
-        </p:style>
-      </p:cxnSp>
-      <p:cxnSp>
-        <p:nvCxnSpPr>
-          <p:cNvPr id="1029" name="Straight Arrow Connector 1028">
-            <a:extLst>
-              <a:ext uri="{FF2B5EF4-FFF2-40B4-BE49-F238E27FC236}">
-                <a16:creationId xmlns:a16="http://schemas.microsoft.com/office/drawing/2014/main" id="{BC68FBBA-31E1-9472-5CD3-64E06949420B}"/>
-              </a:ext>
-            </a:extLst>
-          </p:cNvPr>
-          <p:cNvCxnSpPr>
-            <a:cxnSpLocks/>
-          </p:cNvCxnSpPr>
-          <p:nvPr/>
-        </p:nvCxnSpPr>
-        <p:spPr>
-          <a:xfrm>
-            <a:off x="2032627" y="3160026"/>
-            <a:ext cx="0" cy="736621"/>
-          </a:xfrm>
-          <a:prstGeom prst="straightConnector1">
-            <a:avLst/>
-          </a:prstGeom>
-          <a:ln w="28575">
-            <a:tailEnd type="triangle"/>
-          </a:ln>
-        </p:spPr>
-        <p:style>
-          <a:lnRef idx="2">
-            <a:schemeClr val="accent1"/>
-          </a:lnRef>
-          <a:fillRef idx="0">
-            <a:schemeClr val="accent1"/>
-          </a:fillRef>
-          <a:effectRef idx="1">
-            <a:schemeClr val="accent1"/>
-          </a:effectRef>
-          <a:fontRef idx="minor">
-            <a:schemeClr val="tx1"/>
-          </a:fontRef>
-        </p:style>
-      </p:cxnSp>
-      <p:sp>
-        <p:nvSpPr>
-          <p:cNvPr id="1033" name="TextBox 1032">
-            <a:extLst>
-              <a:ext uri="{FF2B5EF4-FFF2-40B4-BE49-F238E27FC236}">
-                <a16:creationId xmlns:a16="http://schemas.microsoft.com/office/drawing/2014/main" id="{5CEA3A56-428C-DFC3-3B44-1D49A8CDBFCE}"/>
-              </a:ext>
-            </a:extLst>
-          </p:cNvPr>
-          <p:cNvSpPr txBox="1"/>
-          <p:nvPr/>
-        </p:nvSpPr>
-        <p:spPr>
-          <a:xfrm>
-            <a:off x="1001241" y="4203185"/>
-            <a:ext cx="1340967" cy="830997"/>
-          </a:xfrm>
-          <a:prstGeom prst="rect">
-            <a:avLst/>
-          </a:prstGeom>
-          <a:noFill/>
-        </p:spPr>
-        <p:txBody>
-          <a:bodyPr wrap="square">
-            <a:spAutoFit/>
-          </a:bodyPr>
-          <a:lstStyle/>
-          <a:p>
-            <a:r>
-              <a:rPr lang="en-US" sz="1600" b="1" dirty="0"/>
-              <a:t>Flask Camera Web server</a:t>
-            </a:r>
-            <a:endParaRPr lang="en-SG" sz="1600" b="1" dirty="0"/>
-          </a:p>
-        </p:txBody>
-      </p:sp>
-      <p:pic>
-        <p:nvPicPr>
-          <p:cNvPr id="1035" name="Picture 1034" descr="A screenshot of a computer&#10;&#10;AI-generated content may be incorrect.">
-            <a:extLst>
-              <a:ext uri="{FF2B5EF4-FFF2-40B4-BE49-F238E27FC236}">
-                <a16:creationId xmlns:a16="http://schemas.microsoft.com/office/drawing/2014/main" id="{3F5ED33D-F215-496B-BD0A-08EBE4475A64}"/>
-              </a:ext>
-            </a:extLst>
-          </p:cNvPr>
-          <p:cNvPicPr>
-            <a:picLocks noChangeAspect="1"/>
-          </p:cNvPicPr>
-          <p:nvPr/>
-        </p:nvPicPr>
-        <p:blipFill>
-          <a:blip r:embed="rId10">
-            <a:extLst>
-              <a:ext uri="{28A0092B-C50C-407E-A947-70E740481C1C}">
-                <a14:useLocalDpi xmlns:a14="http://schemas.microsoft.com/office/drawing/2010/main" val="0"/>
-              </a:ext>
-            </a:extLst>
-          </a:blip>
-          <a:stretch>
-            <a:fillRect/>
-          </a:stretch>
-        </p:blipFill>
-        <p:spPr>
-          <a:xfrm>
-            <a:off x="2928505" y="2837786"/>
-            <a:ext cx="1942092" cy="1138227"/>
-          </a:xfrm>
-          <a:prstGeom prst="rect">
-            <a:avLst/>
-          </a:prstGeom>
-          <a:ln w="6350">
-            <a:solidFill>
-              <a:schemeClr val="tx1"/>
-            </a:solidFill>
-          </a:ln>
-        </p:spPr>
-      </p:pic>
-      <p:pic>
-        <p:nvPicPr>
-          <p:cNvPr id="1037" name="Picture 1036" descr="A screenshot of a video camera&#10;&#10;AI-generated content may be incorrect.">
-            <a:extLst>
-              <a:ext uri="{FF2B5EF4-FFF2-40B4-BE49-F238E27FC236}">
-                <a16:creationId xmlns:a16="http://schemas.microsoft.com/office/drawing/2014/main" id="{64210A98-AB0B-E091-A800-AC202E578395}"/>
-              </a:ext>
-            </a:extLst>
-          </p:cNvPr>
-          <p:cNvPicPr>
-            <a:picLocks noChangeAspect="1"/>
-          </p:cNvPicPr>
-          <p:nvPr/>
-        </p:nvPicPr>
-        <p:blipFill>
-          <a:blip r:embed="rId11">
-            <a:extLst>
-              <a:ext uri="{28A0092B-C50C-407E-A947-70E740481C1C}">
-                <a14:useLocalDpi xmlns:a14="http://schemas.microsoft.com/office/drawing/2010/main" val="0"/>
-              </a:ext>
-            </a:extLst>
-          </a:blip>
-          <a:stretch>
-            <a:fillRect/>
-          </a:stretch>
-        </p:blipFill>
-        <p:spPr>
-          <a:xfrm>
-            <a:off x="2928505" y="4122624"/>
-            <a:ext cx="1993773" cy="1138225"/>
-          </a:xfrm>
-          <a:prstGeom prst="rect">
-            <a:avLst/>
-          </a:prstGeom>
-          <a:ln w="9525">
-            <a:solidFill>
-              <a:schemeClr val="tx1"/>
-            </a:solidFill>
-          </a:ln>
-        </p:spPr>
-      </p:pic>
-      <p:cxnSp>
-        <p:nvCxnSpPr>
-          <p:cNvPr id="1041" name="Straight Arrow Connector 1040">
-            <a:extLst>
-              <a:ext uri="{FF2B5EF4-FFF2-40B4-BE49-F238E27FC236}">
-                <a16:creationId xmlns:a16="http://schemas.microsoft.com/office/drawing/2014/main" id="{3FA1B850-5B64-1FA5-EB69-B673910050E5}"/>
-              </a:ext>
-            </a:extLst>
-          </p:cNvPr>
-          <p:cNvCxnSpPr>
-            <a:cxnSpLocks/>
-          </p:cNvCxnSpPr>
-          <p:nvPr/>
-        </p:nvCxnSpPr>
-        <p:spPr>
-          <a:xfrm>
-            <a:off x="2369194" y="4174579"/>
-            <a:ext cx="359322" cy="0"/>
-          </a:xfrm>
-          <a:prstGeom prst="straightConnector1">
-            <a:avLst/>
-          </a:prstGeom>
-          <a:ln w="28575">
-            <a:tailEnd type="triangle"/>
-          </a:ln>
-        </p:spPr>
-        <p:style>
-          <a:lnRef idx="2">
-            <a:schemeClr val="accent1"/>
-          </a:lnRef>
-          <a:fillRef idx="0">
-            <a:schemeClr val="accent1"/>
-          </a:fillRef>
-          <a:effectRef idx="1">
-            <a:schemeClr val="accent1"/>
-          </a:effectRef>
-          <a:fontRef idx="minor">
-            <a:schemeClr val="tx1"/>
-          </a:fontRef>
-        </p:style>
-      </p:cxnSp>
-      <p:sp>
-        <p:nvSpPr>
-          <p:cNvPr id="1043" name="TextBox 1042">
-            <a:extLst>
-              <a:ext uri="{FF2B5EF4-FFF2-40B4-BE49-F238E27FC236}">
-                <a16:creationId xmlns:a16="http://schemas.microsoft.com/office/drawing/2014/main" id="{B15EA8BE-029F-14A8-80A6-598A1B868AFA}"/>
-              </a:ext>
-            </a:extLst>
-          </p:cNvPr>
-          <p:cNvSpPr txBox="1"/>
-          <p:nvPr/>
-        </p:nvSpPr>
-        <p:spPr>
-          <a:xfrm>
-            <a:off x="2849678" y="2462295"/>
-            <a:ext cx="2234694" cy="338554"/>
-          </a:xfrm>
-          <a:prstGeom prst="rect">
-            <a:avLst/>
-          </a:prstGeom>
-          <a:noFill/>
-        </p:spPr>
-        <p:txBody>
-          <a:bodyPr wrap="square">
-            <a:spAutoFit/>
-          </a:bodyPr>
-          <a:lstStyle/>
-          <a:p>
-            <a:r>
-              <a:rPr lang="en-US" sz="1600" b="1" dirty="0">
-                <a:solidFill>
-                  <a:schemeClr val="accent2">
-                    <a:lumMod val="75000"/>
-                  </a:schemeClr>
-                </a:solidFill>
-              </a:rPr>
-              <a:t>Camera Web UI pages</a:t>
-            </a:r>
-            <a:endParaRPr lang="en-SG" sz="1600" b="1" dirty="0">
-              <a:solidFill>
-                <a:schemeClr val="accent2">
-                  <a:lumMod val="75000"/>
-                </a:schemeClr>
-              </a:solidFill>
-            </a:endParaRPr>
-          </a:p>
-        </p:txBody>
-      </p:sp>
-      <p:cxnSp>
-        <p:nvCxnSpPr>
-          <p:cNvPr id="1044" name="Straight Arrow Connector 1043">
-            <a:extLst>
-              <a:ext uri="{FF2B5EF4-FFF2-40B4-BE49-F238E27FC236}">
-                <a16:creationId xmlns:a16="http://schemas.microsoft.com/office/drawing/2014/main" id="{C84CBAAF-5262-F886-BB47-61B36AAC3788}"/>
-              </a:ext>
-            </a:extLst>
-          </p:cNvPr>
-          <p:cNvCxnSpPr>
-            <a:cxnSpLocks/>
-          </p:cNvCxnSpPr>
-          <p:nvPr/>
-        </p:nvCxnSpPr>
-        <p:spPr>
-          <a:xfrm>
-            <a:off x="4882768" y="3403948"/>
-            <a:ext cx="611189" cy="0"/>
-          </a:xfrm>
-          <a:prstGeom prst="straightConnector1">
-            <a:avLst/>
-          </a:prstGeom>
-          <a:ln w="28575">
-            <a:tailEnd type="triangle"/>
-          </a:ln>
-        </p:spPr>
-        <p:style>
-          <a:lnRef idx="2">
-            <a:schemeClr val="accent1"/>
-          </a:lnRef>
-          <a:fillRef idx="0">
-            <a:schemeClr val="accent1"/>
-          </a:fillRef>
-          <a:effectRef idx="1">
-            <a:schemeClr val="accent1"/>
-          </a:effectRef>
-          <a:fontRef idx="minor">
-            <a:schemeClr val="tx1"/>
-          </a:fontRef>
-        </p:style>
-      </p:cxnSp>
-      <p:cxnSp>
-        <p:nvCxnSpPr>
-          <p:cNvPr id="1046" name="Straight Arrow Connector 1045">
-            <a:extLst>
-              <a:ext uri="{FF2B5EF4-FFF2-40B4-BE49-F238E27FC236}">
-                <a16:creationId xmlns:a16="http://schemas.microsoft.com/office/drawing/2014/main" id="{996F13F8-D505-0519-0757-0A39657C1F8B}"/>
-              </a:ext>
-            </a:extLst>
-          </p:cNvPr>
-          <p:cNvCxnSpPr>
-            <a:cxnSpLocks/>
-          </p:cNvCxnSpPr>
-          <p:nvPr/>
-        </p:nvCxnSpPr>
-        <p:spPr>
-          <a:xfrm>
-            <a:off x="4930383" y="4627328"/>
-            <a:ext cx="611189" cy="0"/>
-          </a:xfrm>
-          <a:prstGeom prst="straightConnector1">
-            <a:avLst/>
-          </a:prstGeom>
-          <a:ln w="28575">
-            <a:tailEnd type="triangle"/>
-          </a:ln>
-        </p:spPr>
-        <p:style>
-          <a:lnRef idx="2">
-            <a:schemeClr val="accent1"/>
-          </a:lnRef>
-          <a:fillRef idx="0">
-            <a:schemeClr val="accent1"/>
-          </a:fillRef>
-          <a:effectRef idx="1">
-            <a:schemeClr val="accent1"/>
-          </a:effectRef>
-          <a:fontRef idx="minor">
-            <a:schemeClr val="tx1"/>
-          </a:fontRef>
-        </p:style>
-      </p:cxnSp>
-      <p:sp>
-        <p:nvSpPr>
-          <p:cNvPr id="1047" name="TextBox 1046">
-            <a:extLst>
-              <a:ext uri="{FF2B5EF4-FFF2-40B4-BE49-F238E27FC236}">
-                <a16:creationId xmlns:a16="http://schemas.microsoft.com/office/drawing/2014/main" id="{3F00CA10-D60A-3267-2070-9CBE2334443B}"/>
-              </a:ext>
-            </a:extLst>
-          </p:cNvPr>
-          <p:cNvSpPr txBox="1"/>
-          <p:nvPr/>
-        </p:nvSpPr>
-        <p:spPr>
-          <a:xfrm>
-            <a:off x="5505099" y="2313109"/>
-            <a:ext cx="3944395" cy="338554"/>
-          </a:xfrm>
-          <a:prstGeom prst="rect">
-            <a:avLst/>
-          </a:prstGeom>
-          <a:noFill/>
-        </p:spPr>
-        <p:txBody>
-          <a:bodyPr wrap="square">
-            <a:spAutoFit/>
-          </a:bodyPr>
-          <a:lstStyle/>
-          <a:p>
-            <a:r>
-              <a:rPr lang="en-US" sz="1600" b="1" dirty="0"/>
-              <a:t>Multi-Camera View Monitor Dashboard</a:t>
-            </a:r>
-            <a:endParaRPr lang="en-SG" sz="1600" b="1" dirty="0"/>
-          </a:p>
-        </p:txBody>
-      </p:sp>
     </p:spTree>
     <p:extLst>
       <p:ext uri="{BB962C8B-B14F-4D97-AF65-F5344CB8AC3E}">
-        <p14:creationId xmlns:p14="http://schemas.microsoft.com/office/powerpoint/2010/main" val="240756249"/>
+        <p14:creationId xmlns:p14="http://schemas.microsoft.com/office/powerpoint/2010/main" val="80695728"/>
       </p:ext>
     </p:extLst>
   </p:cSld>
@@ -4826,6 +3482,1481 @@
       </p:grpSpPr>
       <p:sp>
         <p:nvSpPr>
+          <p:cNvPr id="1038" name="Rectangle 1037">
+            <a:extLst>
+              <a:ext uri="{FF2B5EF4-FFF2-40B4-BE49-F238E27FC236}">
+                <a16:creationId xmlns:a16="http://schemas.microsoft.com/office/drawing/2014/main" id="{7A72A1C1-40DB-34C3-B7B6-E74702CE1591}"/>
+              </a:ext>
+            </a:extLst>
+          </p:cNvPr>
+          <p:cNvSpPr/>
+          <p:nvPr/>
+        </p:nvSpPr>
+        <p:spPr>
+          <a:xfrm>
+            <a:off x="2742502" y="2422633"/>
+            <a:ext cx="2487368" cy="2950135"/>
+          </a:xfrm>
+          <a:prstGeom prst="rect">
+            <a:avLst/>
+          </a:prstGeom>
+          <a:solidFill>
+            <a:schemeClr val="accent2">
+              <a:lumMod val="20000"/>
+              <a:lumOff val="80000"/>
+            </a:schemeClr>
+          </a:solidFill>
+        </p:spPr>
+        <p:style>
+          <a:lnRef idx="2">
+            <a:schemeClr val="accent1">
+              <a:shade val="15000"/>
+            </a:schemeClr>
+          </a:lnRef>
+          <a:fillRef idx="1">
+            <a:schemeClr val="accent1"/>
+          </a:fillRef>
+          <a:effectRef idx="0">
+            <a:schemeClr val="accent1"/>
+          </a:effectRef>
+          <a:fontRef idx="minor">
+            <a:schemeClr val="lt1"/>
+          </a:fontRef>
+        </p:style>
+        <p:txBody>
+          <a:bodyPr rtlCol="0" anchor="ctr"/>
+          <a:lstStyle/>
+          <a:p>
+            <a:pPr algn="ctr"/>
+            <a:endParaRPr lang="en-SG" dirty="0"/>
+          </a:p>
+        </p:txBody>
+      </p:sp>
+      <p:sp>
+        <p:nvSpPr>
+          <p:cNvPr id="13" name="Rectangle 12">
+            <a:extLst>
+              <a:ext uri="{FF2B5EF4-FFF2-40B4-BE49-F238E27FC236}">
+                <a16:creationId xmlns:a16="http://schemas.microsoft.com/office/drawing/2014/main" id="{8759375A-3526-252C-A754-BE057854A791}"/>
+              </a:ext>
+            </a:extLst>
+          </p:cNvPr>
+          <p:cNvSpPr/>
+          <p:nvPr/>
+        </p:nvSpPr>
+        <p:spPr>
+          <a:xfrm>
+            <a:off x="1121383" y="627614"/>
+            <a:ext cx="9325191" cy="1244506"/>
+          </a:xfrm>
+          <a:prstGeom prst="rect">
+            <a:avLst/>
+          </a:prstGeom>
+          <a:solidFill>
+            <a:schemeClr val="accent6">
+              <a:lumMod val="20000"/>
+              <a:lumOff val="80000"/>
+            </a:schemeClr>
+          </a:solidFill>
+        </p:spPr>
+        <p:style>
+          <a:lnRef idx="2">
+            <a:schemeClr val="accent1">
+              <a:shade val="15000"/>
+            </a:schemeClr>
+          </a:lnRef>
+          <a:fillRef idx="1">
+            <a:schemeClr val="accent1"/>
+          </a:fillRef>
+          <a:effectRef idx="0">
+            <a:schemeClr val="accent1"/>
+          </a:effectRef>
+          <a:fontRef idx="minor">
+            <a:schemeClr val="lt1"/>
+          </a:fontRef>
+        </p:style>
+        <p:txBody>
+          <a:bodyPr rtlCol="0" anchor="ctr"/>
+          <a:lstStyle/>
+          <a:p>
+            <a:pPr algn="ctr"/>
+            <a:endParaRPr lang="en-SG" dirty="0"/>
+          </a:p>
+        </p:txBody>
+      </p:sp>
+      <p:pic>
+        <p:nvPicPr>
+          <p:cNvPr id="1026" name="Picture 2" descr="Webcam - Free computer icons">
+            <a:extLst>
+              <a:ext uri="{FF2B5EF4-FFF2-40B4-BE49-F238E27FC236}">
+                <a16:creationId xmlns:a16="http://schemas.microsoft.com/office/drawing/2014/main" id="{1893017E-457B-DA61-73CD-5AF1C2D8E18B}"/>
+              </a:ext>
+            </a:extLst>
+          </p:cNvPr>
+          <p:cNvPicPr>
+            <a:picLocks noChangeAspect="1" noChangeArrowheads="1"/>
+          </p:cNvPicPr>
+          <p:nvPr/>
+        </p:nvPicPr>
+        <p:blipFill>
+          <a:blip r:embed="rId2">
+            <a:extLst>
+              <a:ext uri="{28A0092B-C50C-407E-A947-70E740481C1C}">
+                <a14:useLocalDpi xmlns:a14="http://schemas.microsoft.com/office/drawing/2010/main" val="0"/>
+              </a:ext>
+            </a:extLst>
+          </a:blip>
+          <a:srcRect/>
+          <a:stretch>
+            <a:fillRect/>
+          </a:stretch>
+        </p:blipFill>
+        <p:spPr bwMode="auto">
+          <a:xfrm>
+            <a:off x="1375875" y="1038236"/>
+            <a:ext cx="763929" cy="763929"/>
+          </a:xfrm>
+          <a:prstGeom prst="rect">
+            <a:avLst/>
+          </a:prstGeom>
+          <a:noFill/>
+          <a:extLst>
+            <a:ext uri="{909E8E84-426E-40DD-AFC4-6F175D3DCCD1}">
+              <a14:hiddenFill xmlns:a14="http://schemas.microsoft.com/office/drawing/2010/main">
+                <a:solidFill>
+                  <a:srgbClr val="FFFFFF"/>
+                </a:solidFill>
+              </a14:hiddenFill>
+            </a:ext>
+          </a:extLst>
+        </p:spPr>
+      </p:pic>
+      <p:sp>
+        <p:nvSpPr>
+          <p:cNvPr id="4" name="TextBox 3">
+            <a:extLst>
+              <a:ext uri="{FF2B5EF4-FFF2-40B4-BE49-F238E27FC236}">
+                <a16:creationId xmlns:a16="http://schemas.microsoft.com/office/drawing/2014/main" id="{CE539FF7-AF70-F40A-4FA9-5BE1ED00A1BF}"/>
+              </a:ext>
+            </a:extLst>
+          </p:cNvPr>
+          <p:cNvSpPr txBox="1"/>
+          <p:nvPr/>
+        </p:nvSpPr>
+        <p:spPr>
+          <a:xfrm>
+            <a:off x="1310816" y="694939"/>
+            <a:ext cx="1232810" cy="307777"/>
+          </a:xfrm>
+          <a:prstGeom prst="rect">
+            <a:avLst/>
+          </a:prstGeom>
+          <a:noFill/>
+        </p:spPr>
+        <p:txBody>
+          <a:bodyPr wrap="square">
+            <a:spAutoFit/>
+          </a:bodyPr>
+          <a:lstStyle/>
+          <a:p>
+            <a:r>
+              <a:rPr lang="en-US" sz="1400" b="1" dirty="0">
+                <a:solidFill>
+                  <a:schemeClr val="tx1">
+                    <a:lumMod val="75000"/>
+                    <a:lumOff val="25000"/>
+                  </a:schemeClr>
+                </a:solidFill>
+              </a:rPr>
+              <a:t>Real Camrea</a:t>
+            </a:r>
+            <a:endParaRPr lang="en-SG" sz="1400" b="1" dirty="0">
+              <a:solidFill>
+                <a:schemeClr val="tx1">
+                  <a:lumMod val="75000"/>
+                  <a:lumOff val="25000"/>
+                </a:schemeClr>
+              </a:solidFill>
+            </a:endParaRPr>
+          </a:p>
+        </p:txBody>
+      </p:sp>
+      <p:pic>
+        <p:nvPicPr>
+          <p:cNvPr id="6" name="Picture 5">
+            <a:extLst>
+              <a:ext uri="{FF2B5EF4-FFF2-40B4-BE49-F238E27FC236}">
+                <a16:creationId xmlns:a16="http://schemas.microsoft.com/office/drawing/2014/main" id="{D51FB2D0-AFF9-CDEF-7567-C197B48D4C90}"/>
+              </a:ext>
+            </a:extLst>
+          </p:cNvPr>
+          <p:cNvPicPr>
+            <a:picLocks noChangeAspect="1"/>
+          </p:cNvPicPr>
+          <p:nvPr/>
+        </p:nvPicPr>
+        <p:blipFill>
+          <a:blip r:embed="rId3"/>
+          <a:stretch>
+            <a:fillRect/>
+          </a:stretch>
+        </p:blipFill>
+        <p:spPr>
+          <a:xfrm>
+            <a:off x="3023900" y="1114405"/>
+            <a:ext cx="664252" cy="631449"/>
+          </a:xfrm>
+          <a:prstGeom prst="rect">
+            <a:avLst/>
+          </a:prstGeom>
+        </p:spPr>
+      </p:pic>
+      <p:sp>
+        <p:nvSpPr>
+          <p:cNvPr id="7" name="TextBox 6">
+            <a:extLst>
+              <a:ext uri="{FF2B5EF4-FFF2-40B4-BE49-F238E27FC236}">
+                <a16:creationId xmlns:a16="http://schemas.microsoft.com/office/drawing/2014/main" id="{B0C26ADD-BCF5-082F-67C0-8BC556475408}"/>
+              </a:ext>
+            </a:extLst>
+          </p:cNvPr>
+          <p:cNvSpPr txBox="1"/>
+          <p:nvPr/>
+        </p:nvSpPr>
+        <p:spPr>
+          <a:xfrm>
+            <a:off x="2733058" y="678099"/>
+            <a:ext cx="1668004" cy="307777"/>
+          </a:xfrm>
+          <a:prstGeom prst="rect">
+            <a:avLst/>
+          </a:prstGeom>
+          <a:noFill/>
+        </p:spPr>
+        <p:txBody>
+          <a:bodyPr wrap="square">
+            <a:spAutoFit/>
+          </a:bodyPr>
+          <a:lstStyle/>
+          <a:p>
+            <a:r>
+              <a:rPr lang="en-US" sz="1400" b="1" dirty="0">
+                <a:solidFill>
+                  <a:schemeClr val="tx1">
+                    <a:lumMod val="75000"/>
+                    <a:lumOff val="25000"/>
+                  </a:schemeClr>
+                </a:solidFill>
+              </a:rPr>
+              <a:t>RTSP Video server</a:t>
+            </a:r>
+            <a:endParaRPr lang="en-SG" sz="1400" b="1" dirty="0">
+              <a:solidFill>
+                <a:schemeClr val="tx1">
+                  <a:lumMod val="75000"/>
+                  <a:lumOff val="25000"/>
+                </a:schemeClr>
+              </a:solidFill>
+            </a:endParaRPr>
+          </a:p>
+        </p:txBody>
+      </p:sp>
+      <p:pic>
+        <p:nvPicPr>
+          <p:cNvPr id="1028" name="Picture 4" descr="Folder images Icon | Free Folder Iconpack | Iconshock">
+            <a:extLst>
+              <a:ext uri="{FF2B5EF4-FFF2-40B4-BE49-F238E27FC236}">
+                <a16:creationId xmlns:a16="http://schemas.microsoft.com/office/drawing/2014/main" id="{4F5F0147-7AAC-0DB1-F1A8-62C15B8B7ECA}"/>
+              </a:ext>
+            </a:extLst>
+          </p:cNvPr>
+          <p:cNvPicPr>
+            <a:picLocks noChangeAspect="1" noChangeArrowheads="1"/>
+          </p:cNvPicPr>
+          <p:nvPr/>
+        </p:nvPicPr>
+        <p:blipFill>
+          <a:blip r:embed="rId4">
+            <a:extLst>
+              <a:ext uri="{28A0092B-C50C-407E-A947-70E740481C1C}">
+                <a14:useLocalDpi xmlns:a14="http://schemas.microsoft.com/office/drawing/2010/main" val="0"/>
+              </a:ext>
+            </a:extLst>
+          </a:blip>
+          <a:srcRect/>
+          <a:stretch>
+            <a:fillRect/>
+          </a:stretch>
+        </p:blipFill>
+        <p:spPr bwMode="auto">
+          <a:xfrm>
+            <a:off x="4769026" y="1043421"/>
+            <a:ext cx="726204" cy="726204"/>
+          </a:xfrm>
+          <a:prstGeom prst="rect">
+            <a:avLst/>
+          </a:prstGeom>
+          <a:noFill/>
+          <a:extLst>
+            <a:ext uri="{909E8E84-426E-40DD-AFC4-6F175D3DCCD1}">
+              <a14:hiddenFill xmlns:a14="http://schemas.microsoft.com/office/drawing/2010/main">
+                <a:solidFill>
+                  <a:srgbClr val="FFFFFF"/>
+                </a:solidFill>
+              </a14:hiddenFill>
+            </a:ext>
+          </a:extLst>
+        </p:spPr>
+      </p:pic>
+      <p:sp>
+        <p:nvSpPr>
+          <p:cNvPr id="8" name="TextBox 7">
+            <a:extLst>
+              <a:ext uri="{FF2B5EF4-FFF2-40B4-BE49-F238E27FC236}">
+                <a16:creationId xmlns:a16="http://schemas.microsoft.com/office/drawing/2014/main" id="{9E24AF49-FC8A-1870-DC15-72F43AF37E84}"/>
+              </a:ext>
+            </a:extLst>
+          </p:cNvPr>
+          <p:cNvSpPr txBox="1"/>
+          <p:nvPr/>
+        </p:nvSpPr>
+        <p:spPr>
+          <a:xfrm>
+            <a:off x="4401062" y="698259"/>
+            <a:ext cx="1822486" cy="307777"/>
+          </a:xfrm>
+          <a:prstGeom prst="rect">
+            <a:avLst/>
+          </a:prstGeom>
+          <a:noFill/>
+        </p:spPr>
+        <p:txBody>
+          <a:bodyPr wrap="square">
+            <a:spAutoFit/>
+          </a:bodyPr>
+          <a:lstStyle/>
+          <a:p>
+            <a:r>
+              <a:rPr lang="en-US" sz="1400" b="1" dirty="0">
+                <a:solidFill>
+                  <a:schemeClr val="tx1">
+                    <a:lumMod val="75000"/>
+                    <a:lumOff val="25000"/>
+                  </a:schemeClr>
+                </a:solidFill>
+              </a:rPr>
+              <a:t>Pictures Data Set</a:t>
+            </a:r>
+            <a:endParaRPr lang="en-SG" sz="1400" b="1" dirty="0">
+              <a:solidFill>
+                <a:schemeClr val="tx1">
+                  <a:lumMod val="75000"/>
+                  <a:lumOff val="25000"/>
+                </a:schemeClr>
+              </a:solidFill>
+            </a:endParaRPr>
+          </a:p>
+        </p:txBody>
+      </p:sp>
+      <p:pic>
+        <p:nvPicPr>
+          <p:cNvPr id="10" name="Picture 9">
+            <a:extLst>
+              <a:ext uri="{FF2B5EF4-FFF2-40B4-BE49-F238E27FC236}">
+                <a16:creationId xmlns:a16="http://schemas.microsoft.com/office/drawing/2014/main" id="{EF14CECB-8E08-231D-2A36-E998D7F1FFA4}"/>
+              </a:ext>
+            </a:extLst>
+          </p:cNvPr>
+          <p:cNvPicPr>
+            <a:picLocks noChangeAspect="1"/>
+          </p:cNvPicPr>
+          <p:nvPr/>
+        </p:nvPicPr>
+        <p:blipFill>
+          <a:blip r:embed="rId5"/>
+          <a:stretch>
+            <a:fillRect/>
+          </a:stretch>
+        </p:blipFill>
+        <p:spPr>
+          <a:xfrm>
+            <a:off x="6576104" y="1118522"/>
+            <a:ext cx="789144" cy="627332"/>
+          </a:xfrm>
+          <a:prstGeom prst="rect">
+            <a:avLst/>
+          </a:prstGeom>
+        </p:spPr>
+      </p:pic>
+      <p:sp>
+        <p:nvSpPr>
+          <p:cNvPr id="11" name="TextBox 10">
+            <a:extLst>
+              <a:ext uri="{FF2B5EF4-FFF2-40B4-BE49-F238E27FC236}">
+                <a16:creationId xmlns:a16="http://schemas.microsoft.com/office/drawing/2014/main" id="{90DF4BB7-8192-D0A1-5917-163BBE054545}"/>
+              </a:ext>
+            </a:extLst>
+          </p:cNvPr>
+          <p:cNvSpPr txBox="1"/>
+          <p:nvPr/>
+        </p:nvSpPr>
+        <p:spPr>
+          <a:xfrm>
+            <a:off x="6093853" y="694939"/>
+            <a:ext cx="1942092" cy="307777"/>
+          </a:xfrm>
+          <a:prstGeom prst="rect">
+            <a:avLst/>
+          </a:prstGeom>
+          <a:noFill/>
+        </p:spPr>
+        <p:txBody>
+          <a:bodyPr wrap="square">
+            <a:spAutoFit/>
+          </a:bodyPr>
+          <a:lstStyle/>
+          <a:p>
+            <a:r>
+              <a:rPr lang="en-US" sz="1400" b="1" dirty="0">
+                <a:solidFill>
+                  <a:schemeClr val="tx1">
+                    <a:lumMod val="75000"/>
+                    <a:lumOff val="25000"/>
+                  </a:schemeClr>
+                </a:solidFill>
+              </a:rPr>
+              <a:t>Screen Recording</a:t>
+            </a:r>
+            <a:endParaRPr lang="en-SG" sz="1400" b="1" dirty="0">
+              <a:solidFill>
+                <a:schemeClr val="tx1">
+                  <a:lumMod val="75000"/>
+                  <a:lumOff val="25000"/>
+                </a:schemeClr>
+              </a:solidFill>
+            </a:endParaRPr>
+          </a:p>
+        </p:txBody>
+      </p:sp>
+      <p:pic>
+        <p:nvPicPr>
+          <p:cNvPr id="1030" name="Picture 6" descr="Application Flaticons Lineal Color icon | Freepik">
+            <a:extLst>
+              <a:ext uri="{FF2B5EF4-FFF2-40B4-BE49-F238E27FC236}">
+                <a16:creationId xmlns:a16="http://schemas.microsoft.com/office/drawing/2014/main" id="{D680763A-B9AE-32E3-9CDA-1D12A0EB1172}"/>
+              </a:ext>
+            </a:extLst>
+          </p:cNvPr>
+          <p:cNvPicPr>
+            <a:picLocks noChangeAspect="1" noChangeArrowheads="1"/>
+          </p:cNvPicPr>
+          <p:nvPr/>
+        </p:nvPicPr>
+        <p:blipFill>
+          <a:blip r:embed="rId6">
+            <a:extLst>
+              <a:ext uri="{28A0092B-C50C-407E-A947-70E740481C1C}">
+                <a14:useLocalDpi xmlns:a14="http://schemas.microsoft.com/office/drawing/2010/main" val="0"/>
+              </a:ext>
+            </a:extLst>
+          </a:blip>
+          <a:srcRect/>
+          <a:stretch>
+            <a:fillRect/>
+          </a:stretch>
+        </p:blipFill>
+        <p:spPr bwMode="auto">
+          <a:xfrm>
+            <a:off x="8313493" y="1161892"/>
+            <a:ext cx="629368" cy="629368"/>
+          </a:xfrm>
+          <a:prstGeom prst="rect">
+            <a:avLst/>
+          </a:prstGeom>
+          <a:noFill/>
+          <a:extLst>
+            <a:ext uri="{909E8E84-426E-40DD-AFC4-6F175D3DCCD1}">
+              <a14:hiddenFill xmlns:a14="http://schemas.microsoft.com/office/drawing/2010/main">
+                <a:solidFill>
+                  <a:srgbClr val="FFFFFF"/>
+                </a:solidFill>
+              </a14:hiddenFill>
+            </a:ext>
+          </a:extLst>
+        </p:spPr>
+      </p:pic>
+      <p:sp>
+        <p:nvSpPr>
+          <p:cNvPr id="12" name="TextBox 11">
+            <a:extLst>
+              <a:ext uri="{FF2B5EF4-FFF2-40B4-BE49-F238E27FC236}">
+                <a16:creationId xmlns:a16="http://schemas.microsoft.com/office/drawing/2014/main" id="{DAB31FAC-8E0F-A0CF-FC80-8934A7E4E9D2}"/>
+              </a:ext>
+            </a:extLst>
+          </p:cNvPr>
+          <p:cNvSpPr txBox="1"/>
+          <p:nvPr/>
+        </p:nvSpPr>
+        <p:spPr>
+          <a:xfrm>
+            <a:off x="7924440" y="678099"/>
+            <a:ext cx="1942092" cy="523220"/>
+          </a:xfrm>
+          <a:prstGeom prst="rect">
+            <a:avLst/>
+          </a:prstGeom>
+          <a:noFill/>
+        </p:spPr>
+        <p:txBody>
+          <a:bodyPr wrap="square">
+            <a:spAutoFit/>
+          </a:bodyPr>
+          <a:lstStyle/>
+          <a:p>
+            <a:r>
+              <a:rPr lang="en-US" sz="1400" b="1" dirty="0">
+                <a:solidFill>
+                  <a:schemeClr val="tx1">
+                    <a:lumMod val="75000"/>
+                    <a:lumOff val="25000"/>
+                  </a:schemeClr>
+                </a:solidFill>
+              </a:rPr>
+              <a:t>Application Window  Screen shot </a:t>
+            </a:r>
+            <a:endParaRPr lang="en-SG" sz="1400" b="1" dirty="0">
+              <a:solidFill>
+                <a:schemeClr val="tx1">
+                  <a:lumMod val="75000"/>
+                  <a:lumOff val="25000"/>
+                </a:schemeClr>
+              </a:solidFill>
+            </a:endParaRPr>
+          </a:p>
+        </p:txBody>
+      </p:sp>
+      <p:sp>
+        <p:nvSpPr>
+          <p:cNvPr id="14" name="TextBox 13">
+            <a:extLst>
+              <a:ext uri="{FF2B5EF4-FFF2-40B4-BE49-F238E27FC236}">
+                <a16:creationId xmlns:a16="http://schemas.microsoft.com/office/drawing/2014/main" id="{42228077-B29A-6297-80F2-58FCD95ADD78}"/>
+              </a:ext>
+            </a:extLst>
+          </p:cNvPr>
+          <p:cNvSpPr txBox="1"/>
+          <p:nvPr/>
+        </p:nvSpPr>
+        <p:spPr>
+          <a:xfrm>
+            <a:off x="9071264" y="1241413"/>
+            <a:ext cx="1553984" cy="584775"/>
+          </a:xfrm>
+          <a:prstGeom prst="rect">
+            <a:avLst/>
+          </a:prstGeom>
+          <a:noFill/>
+        </p:spPr>
+        <p:txBody>
+          <a:bodyPr wrap="square">
+            <a:spAutoFit/>
+          </a:bodyPr>
+          <a:lstStyle/>
+          <a:p>
+            <a:r>
+              <a:rPr lang="en-US" sz="1600" b="1" dirty="0">
+                <a:solidFill>
+                  <a:schemeClr val="accent6">
+                    <a:lumMod val="75000"/>
+                  </a:schemeClr>
+                </a:solidFill>
+              </a:rPr>
+              <a:t>5 Different Video Source</a:t>
+            </a:r>
+            <a:endParaRPr lang="en-SG" sz="1600" b="1" dirty="0">
+              <a:solidFill>
+                <a:schemeClr val="accent6">
+                  <a:lumMod val="75000"/>
+                </a:schemeClr>
+              </a:solidFill>
+            </a:endParaRPr>
+          </a:p>
+        </p:txBody>
+      </p:sp>
+      <p:pic>
+        <p:nvPicPr>
+          <p:cNvPr id="18" name="Graphic 17" descr="Web design with solid fill">
+            <a:extLst>
+              <a:ext uri="{FF2B5EF4-FFF2-40B4-BE49-F238E27FC236}">
+                <a16:creationId xmlns:a16="http://schemas.microsoft.com/office/drawing/2014/main" id="{77E0C4C9-D36F-C627-1554-3B240DB8A9AB}"/>
+              </a:ext>
+            </a:extLst>
+          </p:cNvPr>
+          <p:cNvPicPr>
+            <a:picLocks noChangeAspect="1"/>
+          </p:cNvPicPr>
+          <p:nvPr/>
+        </p:nvPicPr>
+        <p:blipFill>
+          <a:blip r:embed="rId7">
+            <a:extLst>
+              <a:ext uri="{96DAC541-7B7A-43D3-8B79-37D633B846F1}">
+                <asvg:svgBlip xmlns:asvg="http://schemas.microsoft.com/office/drawing/2016/SVG/main" r:embed="rId8"/>
+              </a:ext>
+            </a:extLst>
+          </a:blip>
+          <a:stretch>
+            <a:fillRect/>
+          </a:stretch>
+        </p:blipFill>
+        <p:spPr>
+          <a:xfrm>
+            <a:off x="1609952" y="2422633"/>
+            <a:ext cx="845350" cy="845350"/>
+          </a:xfrm>
+          <a:prstGeom prst="rect">
+            <a:avLst/>
+          </a:prstGeom>
+        </p:spPr>
+      </p:pic>
+      <p:cxnSp>
+        <p:nvCxnSpPr>
+          <p:cNvPr id="21" name="Straight Connector 20">
+            <a:extLst>
+              <a:ext uri="{FF2B5EF4-FFF2-40B4-BE49-F238E27FC236}">
+                <a16:creationId xmlns:a16="http://schemas.microsoft.com/office/drawing/2014/main" id="{271E2D5E-E190-237F-B206-6226603CF68D}"/>
+              </a:ext>
+            </a:extLst>
+          </p:cNvPr>
+          <p:cNvCxnSpPr>
+            <a:cxnSpLocks/>
+          </p:cNvCxnSpPr>
+          <p:nvPr/>
+        </p:nvCxnSpPr>
+        <p:spPr>
+          <a:xfrm flipV="1">
+            <a:off x="1745426" y="2182091"/>
+            <a:ext cx="6882751" cy="3"/>
+          </a:xfrm>
+          <a:prstGeom prst="line">
+            <a:avLst/>
+          </a:prstGeom>
+          <a:ln w="28575"/>
+        </p:spPr>
+        <p:style>
+          <a:lnRef idx="2">
+            <a:schemeClr val="accent1"/>
+          </a:lnRef>
+          <a:fillRef idx="0">
+            <a:schemeClr val="accent1"/>
+          </a:fillRef>
+          <a:effectRef idx="1">
+            <a:schemeClr val="accent1"/>
+          </a:effectRef>
+          <a:fontRef idx="minor">
+            <a:schemeClr val="tx1"/>
+          </a:fontRef>
+        </p:style>
+      </p:cxnSp>
+      <p:sp>
+        <p:nvSpPr>
+          <p:cNvPr id="37" name="TextBox 36">
+            <a:extLst>
+              <a:ext uri="{FF2B5EF4-FFF2-40B4-BE49-F238E27FC236}">
+                <a16:creationId xmlns:a16="http://schemas.microsoft.com/office/drawing/2014/main" id="{258E1831-CD12-30A2-D4B1-4CAA16AAF7E9}"/>
+              </a:ext>
+            </a:extLst>
+          </p:cNvPr>
+          <p:cNvSpPr txBox="1"/>
+          <p:nvPr/>
+        </p:nvSpPr>
+        <p:spPr>
+          <a:xfrm>
+            <a:off x="901983" y="2834918"/>
+            <a:ext cx="1368324" cy="830997"/>
+          </a:xfrm>
+          <a:prstGeom prst="rect">
+            <a:avLst/>
+          </a:prstGeom>
+          <a:noFill/>
+        </p:spPr>
+        <p:txBody>
+          <a:bodyPr wrap="square">
+            <a:spAutoFit/>
+          </a:bodyPr>
+          <a:lstStyle/>
+          <a:p>
+            <a:r>
+              <a:rPr lang="en-US" sz="1600" b="1" dirty="0"/>
+              <a:t>Virtual Camera Client Lib</a:t>
+            </a:r>
+            <a:endParaRPr lang="en-SG" sz="1600" b="1" dirty="0"/>
+          </a:p>
+        </p:txBody>
+      </p:sp>
+      <p:cxnSp>
+        <p:nvCxnSpPr>
+          <p:cNvPr id="38" name="Straight Arrow Connector 37">
+            <a:extLst>
+              <a:ext uri="{FF2B5EF4-FFF2-40B4-BE49-F238E27FC236}">
+                <a16:creationId xmlns:a16="http://schemas.microsoft.com/office/drawing/2014/main" id="{CD5C236A-5CBF-28A4-41E7-8B5167AFAC53}"/>
+              </a:ext>
+            </a:extLst>
+          </p:cNvPr>
+          <p:cNvCxnSpPr>
+            <a:cxnSpLocks/>
+            <a:stCxn id="1026" idx="2"/>
+          </p:cNvCxnSpPr>
+          <p:nvPr/>
+        </p:nvCxnSpPr>
+        <p:spPr>
+          <a:xfrm flipH="1">
+            <a:off x="1745426" y="1802165"/>
+            <a:ext cx="0" cy="379929"/>
+          </a:xfrm>
+          <a:prstGeom prst="straightConnector1">
+            <a:avLst/>
+          </a:prstGeom>
+          <a:ln>
+            <a:tailEnd type="triangle"/>
+          </a:ln>
+        </p:spPr>
+        <p:style>
+          <a:lnRef idx="2">
+            <a:schemeClr val="accent1"/>
+          </a:lnRef>
+          <a:fillRef idx="0">
+            <a:schemeClr val="accent1"/>
+          </a:fillRef>
+          <a:effectRef idx="1">
+            <a:schemeClr val="accent1"/>
+          </a:effectRef>
+          <a:fontRef idx="minor">
+            <a:schemeClr val="tx1"/>
+          </a:fontRef>
+        </p:style>
+      </p:cxnSp>
+      <p:pic>
+        <p:nvPicPr>
+          <p:cNvPr id="42" name="Picture 41" descr="A screenshot of a computer&#10;&#10;AI-generated content may be incorrect.">
+            <a:extLst>
+              <a:ext uri="{FF2B5EF4-FFF2-40B4-BE49-F238E27FC236}">
+                <a16:creationId xmlns:a16="http://schemas.microsoft.com/office/drawing/2014/main" id="{74329011-E43B-FF29-1A3E-D3C3484885C4}"/>
+              </a:ext>
+            </a:extLst>
+          </p:cNvPr>
+          <p:cNvPicPr>
+            <a:picLocks noChangeAspect="1"/>
+          </p:cNvPicPr>
+          <p:nvPr/>
+        </p:nvPicPr>
+        <p:blipFill>
+          <a:blip r:embed="rId9">
+            <a:extLst>
+              <a:ext uri="{28A0092B-C50C-407E-A947-70E740481C1C}">
+                <a14:useLocalDpi xmlns:a14="http://schemas.microsoft.com/office/drawing/2010/main" val="0"/>
+              </a:ext>
+            </a:extLst>
+          </a:blip>
+          <a:stretch>
+            <a:fillRect/>
+          </a:stretch>
+        </p:blipFill>
+        <p:spPr>
+          <a:xfrm>
+            <a:off x="5541572" y="2662385"/>
+            <a:ext cx="4825680" cy="2710384"/>
+          </a:xfrm>
+          <a:prstGeom prst="rect">
+            <a:avLst/>
+          </a:prstGeom>
+          <a:ln w="9525">
+            <a:solidFill>
+              <a:schemeClr val="tx1"/>
+            </a:solidFill>
+          </a:ln>
+        </p:spPr>
+      </p:pic>
+      <p:pic>
+        <p:nvPicPr>
+          <p:cNvPr id="49" name="Graphic 48" descr="Web design with solid fill">
+            <a:extLst>
+              <a:ext uri="{FF2B5EF4-FFF2-40B4-BE49-F238E27FC236}">
+                <a16:creationId xmlns:a16="http://schemas.microsoft.com/office/drawing/2014/main" id="{9373EFF3-C3CA-A8EC-F712-1E08228526A1}"/>
+              </a:ext>
+            </a:extLst>
+          </p:cNvPr>
+          <p:cNvPicPr>
+            <a:picLocks noChangeAspect="1"/>
+          </p:cNvPicPr>
+          <p:nvPr/>
+        </p:nvPicPr>
+        <p:blipFill>
+          <a:blip r:embed="rId7">
+            <a:extLst>
+              <a:ext uri="{96DAC541-7B7A-43D3-8B79-37D633B846F1}">
+                <asvg:svgBlip xmlns:asvg="http://schemas.microsoft.com/office/drawing/2016/SVG/main" r:embed="rId8"/>
+              </a:ext>
+            </a:extLst>
+          </a:blip>
+          <a:stretch>
+            <a:fillRect/>
+          </a:stretch>
+        </p:blipFill>
+        <p:spPr>
+          <a:xfrm>
+            <a:off x="1575427" y="3731053"/>
+            <a:ext cx="914400" cy="914400"/>
+          </a:xfrm>
+          <a:prstGeom prst="rect">
+            <a:avLst/>
+          </a:prstGeom>
+        </p:spPr>
+      </p:pic>
+      <p:cxnSp>
+        <p:nvCxnSpPr>
+          <p:cNvPr id="53" name="Straight Arrow Connector 52">
+            <a:extLst>
+              <a:ext uri="{FF2B5EF4-FFF2-40B4-BE49-F238E27FC236}">
+                <a16:creationId xmlns:a16="http://schemas.microsoft.com/office/drawing/2014/main" id="{C4EDD6BF-B996-C23E-95B9-A4031B65D19B}"/>
+              </a:ext>
+            </a:extLst>
+          </p:cNvPr>
+          <p:cNvCxnSpPr>
+            <a:cxnSpLocks/>
+          </p:cNvCxnSpPr>
+          <p:nvPr/>
+        </p:nvCxnSpPr>
+        <p:spPr>
+          <a:xfrm>
+            <a:off x="3279817" y="1769625"/>
+            <a:ext cx="0" cy="412469"/>
+          </a:xfrm>
+          <a:prstGeom prst="straightConnector1">
+            <a:avLst/>
+          </a:prstGeom>
+          <a:ln w="28575">
+            <a:tailEnd type="triangle"/>
+          </a:ln>
+        </p:spPr>
+        <p:style>
+          <a:lnRef idx="2">
+            <a:schemeClr val="accent1"/>
+          </a:lnRef>
+          <a:fillRef idx="0">
+            <a:schemeClr val="accent1"/>
+          </a:fillRef>
+          <a:effectRef idx="1">
+            <a:schemeClr val="accent1"/>
+          </a:effectRef>
+          <a:fontRef idx="minor">
+            <a:schemeClr val="tx1"/>
+          </a:fontRef>
+        </p:style>
+      </p:cxnSp>
+      <p:cxnSp>
+        <p:nvCxnSpPr>
+          <p:cNvPr id="59" name="Straight Arrow Connector 58">
+            <a:extLst>
+              <a:ext uri="{FF2B5EF4-FFF2-40B4-BE49-F238E27FC236}">
+                <a16:creationId xmlns:a16="http://schemas.microsoft.com/office/drawing/2014/main" id="{00B639C0-0151-BA37-B97B-3AA51DAC9CE2}"/>
+              </a:ext>
+            </a:extLst>
+          </p:cNvPr>
+          <p:cNvCxnSpPr>
+            <a:cxnSpLocks/>
+          </p:cNvCxnSpPr>
+          <p:nvPr/>
+        </p:nvCxnSpPr>
+        <p:spPr>
+          <a:xfrm>
+            <a:off x="1745426" y="1814634"/>
+            <a:ext cx="0" cy="367457"/>
+          </a:xfrm>
+          <a:prstGeom prst="straightConnector1">
+            <a:avLst/>
+          </a:prstGeom>
+          <a:ln w="28575">
+            <a:tailEnd type="triangle"/>
+          </a:ln>
+        </p:spPr>
+        <p:style>
+          <a:lnRef idx="2">
+            <a:schemeClr val="accent1"/>
+          </a:lnRef>
+          <a:fillRef idx="0">
+            <a:schemeClr val="accent1"/>
+          </a:fillRef>
+          <a:effectRef idx="1">
+            <a:schemeClr val="accent1"/>
+          </a:effectRef>
+          <a:fontRef idx="minor">
+            <a:schemeClr val="tx1"/>
+          </a:fontRef>
+        </p:style>
+      </p:cxnSp>
+      <p:cxnSp>
+        <p:nvCxnSpPr>
+          <p:cNvPr id="60" name="Straight Arrow Connector 59">
+            <a:extLst>
+              <a:ext uri="{FF2B5EF4-FFF2-40B4-BE49-F238E27FC236}">
+                <a16:creationId xmlns:a16="http://schemas.microsoft.com/office/drawing/2014/main" id="{D40D7555-136F-1B8A-5BE0-CFEEE888D221}"/>
+              </a:ext>
+            </a:extLst>
+          </p:cNvPr>
+          <p:cNvCxnSpPr>
+            <a:cxnSpLocks/>
+          </p:cNvCxnSpPr>
+          <p:nvPr/>
+        </p:nvCxnSpPr>
+        <p:spPr>
+          <a:xfrm>
+            <a:off x="5084372" y="1769625"/>
+            <a:ext cx="0" cy="412469"/>
+          </a:xfrm>
+          <a:prstGeom prst="straightConnector1">
+            <a:avLst/>
+          </a:prstGeom>
+          <a:ln w="28575">
+            <a:tailEnd type="triangle"/>
+          </a:ln>
+        </p:spPr>
+        <p:style>
+          <a:lnRef idx="2">
+            <a:schemeClr val="accent1"/>
+          </a:lnRef>
+          <a:fillRef idx="0">
+            <a:schemeClr val="accent1"/>
+          </a:fillRef>
+          <a:effectRef idx="1">
+            <a:schemeClr val="accent1"/>
+          </a:effectRef>
+          <a:fontRef idx="minor">
+            <a:schemeClr val="tx1"/>
+          </a:fontRef>
+        </p:style>
+      </p:cxnSp>
+      <p:cxnSp>
+        <p:nvCxnSpPr>
+          <p:cNvPr id="61" name="Straight Arrow Connector 60">
+            <a:extLst>
+              <a:ext uri="{FF2B5EF4-FFF2-40B4-BE49-F238E27FC236}">
+                <a16:creationId xmlns:a16="http://schemas.microsoft.com/office/drawing/2014/main" id="{5F0E1DAD-9B25-C0D2-5F4D-DDCC4FC7014E}"/>
+              </a:ext>
+            </a:extLst>
+          </p:cNvPr>
+          <p:cNvCxnSpPr>
+            <a:cxnSpLocks/>
+          </p:cNvCxnSpPr>
+          <p:nvPr/>
+        </p:nvCxnSpPr>
+        <p:spPr>
+          <a:xfrm>
+            <a:off x="6975517" y="1745854"/>
+            <a:ext cx="0" cy="412469"/>
+          </a:xfrm>
+          <a:prstGeom prst="straightConnector1">
+            <a:avLst/>
+          </a:prstGeom>
+          <a:ln w="28575">
+            <a:tailEnd type="triangle"/>
+          </a:ln>
+        </p:spPr>
+        <p:style>
+          <a:lnRef idx="2">
+            <a:schemeClr val="accent1"/>
+          </a:lnRef>
+          <a:fillRef idx="0">
+            <a:schemeClr val="accent1"/>
+          </a:fillRef>
+          <a:effectRef idx="1">
+            <a:schemeClr val="accent1"/>
+          </a:effectRef>
+          <a:fontRef idx="minor">
+            <a:schemeClr val="tx1"/>
+          </a:fontRef>
+        </p:style>
+      </p:cxnSp>
+      <p:cxnSp>
+        <p:nvCxnSpPr>
+          <p:cNvPr id="62" name="Straight Arrow Connector 61">
+            <a:extLst>
+              <a:ext uri="{FF2B5EF4-FFF2-40B4-BE49-F238E27FC236}">
+                <a16:creationId xmlns:a16="http://schemas.microsoft.com/office/drawing/2014/main" id="{C9C4C224-A813-99AB-6416-F0F0D647E5A4}"/>
+              </a:ext>
+            </a:extLst>
+          </p:cNvPr>
+          <p:cNvCxnSpPr>
+            <a:cxnSpLocks/>
+          </p:cNvCxnSpPr>
+          <p:nvPr/>
+        </p:nvCxnSpPr>
+        <p:spPr>
+          <a:xfrm>
+            <a:off x="8597005" y="1802165"/>
+            <a:ext cx="0" cy="412469"/>
+          </a:xfrm>
+          <a:prstGeom prst="straightConnector1">
+            <a:avLst/>
+          </a:prstGeom>
+          <a:ln w="28575">
+            <a:tailEnd type="triangle"/>
+          </a:ln>
+        </p:spPr>
+        <p:style>
+          <a:lnRef idx="2">
+            <a:schemeClr val="accent1"/>
+          </a:lnRef>
+          <a:fillRef idx="0">
+            <a:schemeClr val="accent1"/>
+          </a:fillRef>
+          <a:effectRef idx="1">
+            <a:schemeClr val="accent1"/>
+          </a:effectRef>
+          <a:fontRef idx="minor">
+            <a:schemeClr val="tx1"/>
+          </a:fontRef>
+        </p:style>
+      </p:cxnSp>
+      <p:cxnSp>
+        <p:nvCxnSpPr>
+          <p:cNvPr id="63" name="Straight Arrow Connector 62">
+            <a:extLst>
+              <a:ext uri="{FF2B5EF4-FFF2-40B4-BE49-F238E27FC236}">
+                <a16:creationId xmlns:a16="http://schemas.microsoft.com/office/drawing/2014/main" id="{939080D0-CEEF-9EF3-C1DA-2A9AFCA741E5}"/>
+              </a:ext>
+            </a:extLst>
+          </p:cNvPr>
+          <p:cNvCxnSpPr>
+            <a:cxnSpLocks/>
+          </p:cNvCxnSpPr>
+          <p:nvPr/>
+        </p:nvCxnSpPr>
+        <p:spPr>
+          <a:xfrm>
+            <a:off x="2032627" y="2182091"/>
+            <a:ext cx="0" cy="384464"/>
+          </a:xfrm>
+          <a:prstGeom prst="straightConnector1">
+            <a:avLst/>
+          </a:prstGeom>
+          <a:ln w="28575">
+            <a:tailEnd type="triangle"/>
+          </a:ln>
+        </p:spPr>
+        <p:style>
+          <a:lnRef idx="2">
+            <a:schemeClr val="accent1"/>
+          </a:lnRef>
+          <a:fillRef idx="0">
+            <a:schemeClr val="accent1"/>
+          </a:fillRef>
+          <a:effectRef idx="1">
+            <a:schemeClr val="accent1"/>
+          </a:effectRef>
+          <a:fontRef idx="minor">
+            <a:schemeClr val="tx1"/>
+          </a:fontRef>
+        </p:style>
+      </p:cxnSp>
+      <p:cxnSp>
+        <p:nvCxnSpPr>
+          <p:cNvPr id="1029" name="Straight Arrow Connector 1028">
+            <a:extLst>
+              <a:ext uri="{FF2B5EF4-FFF2-40B4-BE49-F238E27FC236}">
+                <a16:creationId xmlns:a16="http://schemas.microsoft.com/office/drawing/2014/main" id="{BC68FBBA-31E1-9472-5CD3-64E06949420B}"/>
+              </a:ext>
+            </a:extLst>
+          </p:cNvPr>
+          <p:cNvCxnSpPr>
+            <a:cxnSpLocks/>
+          </p:cNvCxnSpPr>
+          <p:nvPr/>
+        </p:nvCxnSpPr>
+        <p:spPr>
+          <a:xfrm>
+            <a:off x="2032627" y="3160026"/>
+            <a:ext cx="0" cy="736621"/>
+          </a:xfrm>
+          <a:prstGeom prst="straightConnector1">
+            <a:avLst/>
+          </a:prstGeom>
+          <a:ln w="28575">
+            <a:tailEnd type="triangle"/>
+          </a:ln>
+        </p:spPr>
+        <p:style>
+          <a:lnRef idx="2">
+            <a:schemeClr val="accent1"/>
+          </a:lnRef>
+          <a:fillRef idx="0">
+            <a:schemeClr val="accent1"/>
+          </a:fillRef>
+          <a:effectRef idx="1">
+            <a:schemeClr val="accent1"/>
+          </a:effectRef>
+          <a:fontRef idx="minor">
+            <a:schemeClr val="tx1"/>
+          </a:fontRef>
+        </p:style>
+      </p:cxnSp>
+      <p:sp>
+        <p:nvSpPr>
+          <p:cNvPr id="1033" name="TextBox 1032">
+            <a:extLst>
+              <a:ext uri="{FF2B5EF4-FFF2-40B4-BE49-F238E27FC236}">
+                <a16:creationId xmlns:a16="http://schemas.microsoft.com/office/drawing/2014/main" id="{5CEA3A56-428C-DFC3-3B44-1D49A8CDBFCE}"/>
+              </a:ext>
+            </a:extLst>
+          </p:cNvPr>
+          <p:cNvSpPr txBox="1"/>
+          <p:nvPr/>
+        </p:nvSpPr>
+        <p:spPr>
+          <a:xfrm>
+            <a:off x="1001241" y="4203185"/>
+            <a:ext cx="1340967" cy="830997"/>
+          </a:xfrm>
+          <a:prstGeom prst="rect">
+            <a:avLst/>
+          </a:prstGeom>
+          <a:noFill/>
+        </p:spPr>
+        <p:txBody>
+          <a:bodyPr wrap="square">
+            <a:spAutoFit/>
+          </a:bodyPr>
+          <a:lstStyle/>
+          <a:p>
+            <a:r>
+              <a:rPr lang="en-US" sz="1600" b="1" dirty="0"/>
+              <a:t>Flask Camera Web server</a:t>
+            </a:r>
+            <a:endParaRPr lang="en-SG" sz="1600" b="1" dirty="0"/>
+          </a:p>
+        </p:txBody>
+      </p:sp>
+      <p:pic>
+        <p:nvPicPr>
+          <p:cNvPr id="1035" name="Picture 1034" descr="A screenshot of a computer&#10;&#10;AI-generated content may be incorrect.">
+            <a:extLst>
+              <a:ext uri="{FF2B5EF4-FFF2-40B4-BE49-F238E27FC236}">
+                <a16:creationId xmlns:a16="http://schemas.microsoft.com/office/drawing/2014/main" id="{3F5ED33D-F215-496B-BD0A-08EBE4475A64}"/>
+              </a:ext>
+            </a:extLst>
+          </p:cNvPr>
+          <p:cNvPicPr>
+            <a:picLocks noChangeAspect="1"/>
+          </p:cNvPicPr>
+          <p:nvPr/>
+        </p:nvPicPr>
+        <p:blipFill>
+          <a:blip r:embed="rId10">
+            <a:extLst>
+              <a:ext uri="{28A0092B-C50C-407E-A947-70E740481C1C}">
+                <a14:useLocalDpi xmlns:a14="http://schemas.microsoft.com/office/drawing/2010/main" val="0"/>
+              </a:ext>
+            </a:extLst>
+          </a:blip>
+          <a:stretch>
+            <a:fillRect/>
+          </a:stretch>
+        </p:blipFill>
+        <p:spPr>
+          <a:xfrm>
+            <a:off x="2928505" y="2837786"/>
+            <a:ext cx="1942092" cy="1138227"/>
+          </a:xfrm>
+          <a:prstGeom prst="rect">
+            <a:avLst/>
+          </a:prstGeom>
+          <a:ln w="6350">
+            <a:solidFill>
+              <a:schemeClr val="tx1"/>
+            </a:solidFill>
+          </a:ln>
+        </p:spPr>
+      </p:pic>
+      <p:pic>
+        <p:nvPicPr>
+          <p:cNvPr id="1037" name="Picture 1036" descr="A screenshot of a video camera&#10;&#10;AI-generated content may be incorrect.">
+            <a:extLst>
+              <a:ext uri="{FF2B5EF4-FFF2-40B4-BE49-F238E27FC236}">
+                <a16:creationId xmlns:a16="http://schemas.microsoft.com/office/drawing/2014/main" id="{64210A98-AB0B-E091-A800-AC202E578395}"/>
+              </a:ext>
+            </a:extLst>
+          </p:cNvPr>
+          <p:cNvPicPr>
+            <a:picLocks noChangeAspect="1"/>
+          </p:cNvPicPr>
+          <p:nvPr/>
+        </p:nvPicPr>
+        <p:blipFill>
+          <a:blip r:embed="rId11">
+            <a:extLst>
+              <a:ext uri="{28A0092B-C50C-407E-A947-70E740481C1C}">
+                <a14:useLocalDpi xmlns:a14="http://schemas.microsoft.com/office/drawing/2010/main" val="0"/>
+              </a:ext>
+            </a:extLst>
+          </a:blip>
+          <a:stretch>
+            <a:fillRect/>
+          </a:stretch>
+        </p:blipFill>
+        <p:spPr>
+          <a:xfrm>
+            <a:off x="2928505" y="4122624"/>
+            <a:ext cx="1993773" cy="1138225"/>
+          </a:xfrm>
+          <a:prstGeom prst="rect">
+            <a:avLst/>
+          </a:prstGeom>
+          <a:ln w="9525">
+            <a:solidFill>
+              <a:schemeClr val="tx1"/>
+            </a:solidFill>
+          </a:ln>
+        </p:spPr>
+      </p:pic>
+      <p:cxnSp>
+        <p:nvCxnSpPr>
+          <p:cNvPr id="1041" name="Straight Arrow Connector 1040">
+            <a:extLst>
+              <a:ext uri="{FF2B5EF4-FFF2-40B4-BE49-F238E27FC236}">
+                <a16:creationId xmlns:a16="http://schemas.microsoft.com/office/drawing/2014/main" id="{3FA1B850-5B64-1FA5-EB69-B673910050E5}"/>
+              </a:ext>
+            </a:extLst>
+          </p:cNvPr>
+          <p:cNvCxnSpPr>
+            <a:cxnSpLocks/>
+          </p:cNvCxnSpPr>
+          <p:nvPr/>
+        </p:nvCxnSpPr>
+        <p:spPr>
+          <a:xfrm>
+            <a:off x="2369194" y="4174579"/>
+            <a:ext cx="359322" cy="0"/>
+          </a:xfrm>
+          <a:prstGeom prst="straightConnector1">
+            <a:avLst/>
+          </a:prstGeom>
+          <a:ln w="28575">
+            <a:tailEnd type="triangle"/>
+          </a:ln>
+        </p:spPr>
+        <p:style>
+          <a:lnRef idx="2">
+            <a:schemeClr val="accent1"/>
+          </a:lnRef>
+          <a:fillRef idx="0">
+            <a:schemeClr val="accent1"/>
+          </a:fillRef>
+          <a:effectRef idx="1">
+            <a:schemeClr val="accent1"/>
+          </a:effectRef>
+          <a:fontRef idx="minor">
+            <a:schemeClr val="tx1"/>
+          </a:fontRef>
+        </p:style>
+      </p:cxnSp>
+      <p:sp>
+        <p:nvSpPr>
+          <p:cNvPr id="1043" name="TextBox 1042">
+            <a:extLst>
+              <a:ext uri="{FF2B5EF4-FFF2-40B4-BE49-F238E27FC236}">
+                <a16:creationId xmlns:a16="http://schemas.microsoft.com/office/drawing/2014/main" id="{B15EA8BE-029F-14A8-80A6-598A1B868AFA}"/>
+              </a:ext>
+            </a:extLst>
+          </p:cNvPr>
+          <p:cNvSpPr txBox="1"/>
+          <p:nvPr/>
+        </p:nvSpPr>
+        <p:spPr>
+          <a:xfrm>
+            <a:off x="2849678" y="2462295"/>
+            <a:ext cx="2234694" cy="338554"/>
+          </a:xfrm>
+          <a:prstGeom prst="rect">
+            <a:avLst/>
+          </a:prstGeom>
+          <a:noFill/>
+        </p:spPr>
+        <p:txBody>
+          <a:bodyPr wrap="square">
+            <a:spAutoFit/>
+          </a:bodyPr>
+          <a:lstStyle/>
+          <a:p>
+            <a:r>
+              <a:rPr lang="en-US" sz="1600" b="1" dirty="0">
+                <a:solidFill>
+                  <a:schemeClr val="accent2">
+                    <a:lumMod val="75000"/>
+                  </a:schemeClr>
+                </a:solidFill>
+              </a:rPr>
+              <a:t>Camera Web UI pages</a:t>
+            </a:r>
+            <a:endParaRPr lang="en-SG" sz="1600" b="1" dirty="0">
+              <a:solidFill>
+                <a:schemeClr val="accent2">
+                  <a:lumMod val="75000"/>
+                </a:schemeClr>
+              </a:solidFill>
+            </a:endParaRPr>
+          </a:p>
+        </p:txBody>
+      </p:sp>
+      <p:cxnSp>
+        <p:nvCxnSpPr>
+          <p:cNvPr id="1044" name="Straight Arrow Connector 1043">
+            <a:extLst>
+              <a:ext uri="{FF2B5EF4-FFF2-40B4-BE49-F238E27FC236}">
+                <a16:creationId xmlns:a16="http://schemas.microsoft.com/office/drawing/2014/main" id="{C84CBAAF-5262-F886-BB47-61B36AAC3788}"/>
+              </a:ext>
+            </a:extLst>
+          </p:cNvPr>
+          <p:cNvCxnSpPr>
+            <a:cxnSpLocks/>
+          </p:cNvCxnSpPr>
+          <p:nvPr/>
+        </p:nvCxnSpPr>
+        <p:spPr>
+          <a:xfrm>
+            <a:off x="4882768" y="3403948"/>
+            <a:ext cx="611189" cy="0"/>
+          </a:xfrm>
+          <a:prstGeom prst="straightConnector1">
+            <a:avLst/>
+          </a:prstGeom>
+          <a:ln w="28575">
+            <a:tailEnd type="triangle"/>
+          </a:ln>
+        </p:spPr>
+        <p:style>
+          <a:lnRef idx="2">
+            <a:schemeClr val="accent1"/>
+          </a:lnRef>
+          <a:fillRef idx="0">
+            <a:schemeClr val="accent1"/>
+          </a:fillRef>
+          <a:effectRef idx="1">
+            <a:schemeClr val="accent1"/>
+          </a:effectRef>
+          <a:fontRef idx="minor">
+            <a:schemeClr val="tx1"/>
+          </a:fontRef>
+        </p:style>
+      </p:cxnSp>
+      <p:cxnSp>
+        <p:nvCxnSpPr>
+          <p:cNvPr id="1046" name="Straight Arrow Connector 1045">
+            <a:extLst>
+              <a:ext uri="{FF2B5EF4-FFF2-40B4-BE49-F238E27FC236}">
+                <a16:creationId xmlns:a16="http://schemas.microsoft.com/office/drawing/2014/main" id="{996F13F8-D505-0519-0757-0A39657C1F8B}"/>
+              </a:ext>
+            </a:extLst>
+          </p:cNvPr>
+          <p:cNvCxnSpPr>
+            <a:cxnSpLocks/>
+          </p:cNvCxnSpPr>
+          <p:nvPr/>
+        </p:nvCxnSpPr>
+        <p:spPr>
+          <a:xfrm>
+            <a:off x="4930383" y="4627328"/>
+            <a:ext cx="611189" cy="0"/>
+          </a:xfrm>
+          <a:prstGeom prst="straightConnector1">
+            <a:avLst/>
+          </a:prstGeom>
+          <a:ln w="28575">
+            <a:tailEnd type="triangle"/>
+          </a:ln>
+        </p:spPr>
+        <p:style>
+          <a:lnRef idx="2">
+            <a:schemeClr val="accent1"/>
+          </a:lnRef>
+          <a:fillRef idx="0">
+            <a:schemeClr val="accent1"/>
+          </a:fillRef>
+          <a:effectRef idx="1">
+            <a:schemeClr val="accent1"/>
+          </a:effectRef>
+          <a:fontRef idx="minor">
+            <a:schemeClr val="tx1"/>
+          </a:fontRef>
+        </p:style>
+      </p:cxnSp>
+      <p:sp>
+        <p:nvSpPr>
+          <p:cNvPr id="1047" name="TextBox 1046">
+            <a:extLst>
+              <a:ext uri="{FF2B5EF4-FFF2-40B4-BE49-F238E27FC236}">
+                <a16:creationId xmlns:a16="http://schemas.microsoft.com/office/drawing/2014/main" id="{3F00CA10-D60A-3267-2070-9CBE2334443B}"/>
+              </a:ext>
+            </a:extLst>
+          </p:cNvPr>
+          <p:cNvSpPr txBox="1"/>
+          <p:nvPr/>
+        </p:nvSpPr>
+        <p:spPr>
+          <a:xfrm>
+            <a:off x="5505099" y="2313109"/>
+            <a:ext cx="3944395" cy="338554"/>
+          </a:xfrm>
+          <a:prstGeom prst="rect">
+            <a:avLst/>
+          </a:prstGeom>
+          <a:noFill/>
+        </p:spPr>
+        <p:txBody>
+          <a:bodyPr wrap="square">
+            <a:spAutoFit/>
+          </a:bodyPr>
+          <a:lstStyle/>
+          <a:p>
+            <a:r>
+              <a:rPr lang="en-US" sz="1600" b="1" dirty="0"/>
+              <a:t>Multi-Camera View Monitor Dashboard</a:t>
+            </a:r>
+            <a:endParaRPr lang="en-SG" sz="1600" b="1" dirty="0"/>
+          </a:p>
+        </p:txBody>
+      </p:sp>
+    </p:spTree>
+    <p:extLst>
+      <p:ext uri="{BB962C8B-B14F-4D97-AF65-F5344CB8AC3E}">
+        <p14:creationId xmlns:p14="http://schemas.microsoft.com/office/powerpoint/2010/main" val="240756249"/>
+      </p:ext>
+    </p:extLst>
+  </p:cSld>
+  <p:clrMapOvr>
+    <a:masterClrMapping/>
+  </p:clrMapOvr>
+</p:sld>
+</file>
+
+<file path=ppt/slides/slide3.xml><?xml version="1.0" encoding="utf-8"?>
+<p:sld xmlns:a="http://schemas.openxmlformats.org/drawingml/2006/main" xmlns:r="http://schemas.openxmlformats.org/officeDocument/2006/relationships" xmlns:p="http://schemas.openxmlformats.org/presentationml/2006/main">
+  <p:cSld>
+    <p:spTree>
+      <p:nvGrpSpPr>
+        <p:cNvPr id="1" name=""/>
+        <p:cNvGrpSpPr/>
+        <p:nvPr/>
+      </p:nvGrpSpPr>
+      <p:grpSpPr>
+        <a:xfrm>
+          <a:off x="0" y="0"/>
+          <a:ext cx="0" cy="0"/>
+          <a:chOff x="0" y="0"/>
+          <a:chExt cx="0" cy="0"/>
+        </a:xfrm>
+      </p:grpSpPr>
+      <p:sp>
+        <p:nvSpPr>
           <p:cNvPr id="5" name="Rectangle 4">
             <a:extLst>
               <a:ext uri="{FF2B5EF4-FFF2-40B4-BE49-F238E27FC236}">
@@ -5749,7 +5880,7 @@
 </p:sld>
 </file>
 
-<file path=ppt/slides/slide3.xml><?xml version="1.0" encoding="utf-8"?>
+<file path=ppt/slides/slide4.xml><?xml version="1.0" encoding="utf-8"?>
 <p:sld xmlns:a="http://schemas.openxmlformats.org/drawingml/2006/main" xmlns:r="http://schemas.openxmlformats.org/officeDocument/2006/relationships" xmlns:p="http://schemas.openxmlformats.org/presentationml/2006/main">
   <p:cSld>
     <p:spTree>

</xml_diff>

<commit_message>
update the design document and overview image.
</commit_message>
<xml_diff>
--- a/doc/designDoc.pptx
+++ b/doc/designDoc.pptx
@@ -4,11 +4,15 @@
   <p:sldMasterIdLst>
     <p:sldMasterId id="2147483648" r:id="rId1"/>
   </p:sldMasterIdLst>
+  <p:notesMasterIdLst>
+    <p:notesMasterId r:id="rId7"/>
+  </p:notesMasterIdLst>
   <p:sldIdLst>
     <p:sldId id="259" r:id="rId2"/>
     <p:sldId id="256" r:id="rId3"/>
     <p:sldId id="257" r:id="rId4"/>
     <p:sldId id="258" r:id="rId5"/>
+    <p:sldId id="260" r:id="rId6"/>
   </p:sldIdLst>
   <p:sldSz cx="12192000" cy="6858000"/>
   <p:notesSz cx="6858000" cy="9144000"/>
@@ -115,6 +119,440 @@
 </p:presentation>
 </file>
 
+<file path=ppt/notesMasters/notesMaster1.xml><?xml version="1.0" encoding="utf-8"?>
+<p:notesMaster xmlns:a="http://schemas.openxmlformats.org/drawingml/2006/main" xmlns:r="http://schemas.openxmlformats.org/officeDocument/2006/relationships" xmlns:p="http://schemas.openxmlformats.org/presentationml/2006/main">
+  <p:cSld>
+    <p:bg>
+      <p:bgRef idx="1001">
+        <a:schemeClr val="bg1"/>
+      </p:bgRef>
+    </p:bg>
+    <p:spTree>
+      <p:nvGrpSpPr>
+        <p:cNvPr id="1" name=""/>
+        <p:cNvGrpSpPr/>
+        <p:nvPr/>
+      </p:nvGrpSpPr>
+      <p:grpSpPr>
+        <a:xfrm>
+          <a:off x="0" y="0"/>
+          <a:ext cx="0" cy="0"/>
+          <a:chOff x="0" y="0"/>
+          <a:chExt cx="0" cy="0"/>
+        </a:xfrm>
+      </p:grpSpPr>
+      <p:sp>
+        <p:nvSpPr>
+          <p:cNvPr id="2" name="Header Placeholder 1"/>
+          <p:cNvSpPr>
+            <a:spLocks noGrp="1"/>
+          </p:cNvSpPr>
+          <p:nvPr>
+            <p:ph type="hdr" sz="quarter"/>
+          </p:nvPr>
+        </p:nvSpPr>
+        <p:spPr>
+          <a:xfrm>
+            <a:off x="0" y="0"/>
+            <a:ext cx="2971800" cy="458788"/>
+          </a:xfrm>
+          <a:prstGeom prst="rect">
+            <a:avLst/>
+          </a:prstGeom>
+        </p:spPr>
+        <p:txBody>
+          <a:bodyPr vert="horz" lIns="91440" tIns="45720" rIns="91440" bIns="45720" rtlCol="0"/>
+          <a:lstStyle>
+            <a:lvl1pPr algn="l">
+              <a:defRPr sz="1200"/>
+            </a:lvl1pPr>
+          </a:lstStyle>
+          <a:p>
+            <a:endParaRPr lang="en-SG"/>
+          </a:p>
+        </p:txBody>
+      </p:sp>
+      <p:sp>
+        <p:nvSpPr>
+          <p:cNvPr id="3" name="Date Placeholder 2"/>
+          <p:cNvSpPr>
+            <a:spLocks noGrp="1"/>
+          </p:cNvSpPr>
+          <p:nvPr>
+            <p:ph type="dt" idx="1"/>
+          </p:nvPr>
+        </p:nvSpPr>
+        <p:spPr>
+          <a:xfrm>
+            <a:off x="3884613" y="0"/>
+            <a:ext cx="2971800" cy="458788"/>
+          </a:xfrm>
+          <a:prstGeom prst="rect">
+            <a:avLst/>
+          </a:prstGeom>
+        </p:spPr>
+        <p:txBody>
+          <a:bodyPr vert="horz" lIns="91440" tIns="45720" rIns="91440" bIns="45720" rtlCol="0"/>
+          <a:lstStyle>
+            <a:lvl1pPr algn="r">
+              <a:defRPr sz="1200"/>
+            </a:lvl1pPr>
+          </a:lstStyle>
+          <a:p>
+            <a:fld id="{331DA7F3-37F6-4775-B33A-057A4C6ECEA9}" type="datetimeFigureOut">
+              <a:rPr lang="en-SG" smtClean="0"/>
+              <a:t>7/11/2025</a:t>
+            </a:fld>
+            <a:endParaRPr lang="en-SG"/>
+          </a:p>
+        </p:txBody>
+      </p:sp>
+      <p:sp>
+        <p:nvSpPr>
+          <p:cNvPr id="4" name="Slide Image Placeholder 3"/>
+          <p:cNvSpPr>
+            <a:spLocks noGrp="1" noRot="1" noChangeAspect="1"/>
+          </p:cNvSpPr>
+          <p:nvPr>
+            <p:ph type="sldImg" idx="2"/>
+          </p:nvPr>
+        </p:nvSpPr>
+        <p:spPr>
+          <a:xfrm>
+            <a:off x="685800" y="1143000"/>
+            <a:ext cx="5486400" cy="3086100"/>
+          </a:xfrm>
+          <a:prstGeom prst="rect">
+            <a:avLst/>
+          </a:prstGeom>
+          <a:noFill/>
+          <a:ln w="12700">
+            <a:solidFill>
+              <a:prstClr val="black"/>
+            </a:solidFill>
+          </a:ln>
+        </p:spPr>
+        <p:txBody>
+          <a:bodyPr vert="horz" lIns="91440" tIns="45720" rIns="91440" bIns="45720" rtlCol="0" anchor="ctr"/>
+          <a:lstStyle/>
+          <a:p>
+            <a:endParaRPr lang="en-SG"/>
+          </a:p>
+        </p:txBody>
+      </p:sp>
+      <p:sp>
+        <p:nvSpPr>
+          <p:cNvPr id="5" name="Notes Placeholder 4"/>
+          <p:cNvSpPr>
+            <a:spLocks noGrp="1"/>
+          </p:cNvSpPr>
+          <p:nvPr>
+            <p:ph type="body" sz="quarter" idx="3"/>
+          </p:nvPr>
+        </p:nvSpPr>
+        <p:spPr>
+          <a:xfrm>
+            <a:off x="685800" y="4400550"/>
+            <a:ext cx="5486400" cy="3600450"/>
+          </a:xfrm>
+          <a:prstGeom prst="rect">
+            <a:avLst/>
+          </a:prstGeom>
+        </p:spPr>
+        <p:txBody>
+          <a:bodyPr vert="horz" lIns="91440" tIns="45720" rIns="91440" bIns="45720" rtlCol="0"/>
+          <a:lstStyle/>
+          <a:p>
+            <a:pPr lvl="0"/>
+            <a:r>
+              <a:rPr lang="en-US"/>
+              <a:t>Click to edit Master text styles</a:t>
+            </a:r>
+          </a:p>
+          <a:p>
+            <a:pPr lvl="1"/>
+            <a:r>
+              <a:rPr lang="en-US"/>
+              <a:t>Second level</a:t>
+            </a:r>
+          </a:p>
+          <a:p>
+            <a:pPr lvl="2"/>
+            <a:r>
+              <a:rPr lang="en-US"/>
+              <a:t>Third level</a:t>
+            </a:r>
+          </a:p>
+          <a:p>
+            <a:pPr lvl="3"/>
+            <a:r>
+              <a:rPr lang="en-US"/>
+              <a:t>Fourth level</a:t>
+            </a:r>
+          </a:p>
+          <a:p>
+            <a:pPr lvl="4"/>
+            <a:r>
+              <a:rPr lang="en-US"/>
+              <a:t>Fifth level</a:t>
+            </a:r>
+            <a:endParaRPr lang="en-SG"/>
+          </a:p>
+        </p:txBody>
+      </p:sp>
+      <p:sp>
+        <p:nvSpPr>
+          <p:cNvPr id="6" name="Footer Placeholder 5"/>
+          <p:cNvSpPr>
+            <a:spLocks noGrp="1"/>
+          </p:cNvSpPr>
+          <p:nvPr>
+            <p:ph type="ftr" sz="quarter" idx="4"/>
+          </p:nvPr>
+        </p:nvSpPr>
+        <p:spPr>
+          <a:xfrm>
+            <a:off x="0" y="8685213"/>
+            <a:ext cx="2971800" cy="458787"/>
+          </a:xfrm>
+          <a:prstGeom prst="rect">
+            <a:avLst/>
+          </a:prstGeom>
+        </p:spPr>
+        <p:txBody>
+          <a:bodyPr vert="horz" lIns="91440" tIns="45720" rIns="91440" bIns="45720" rtlCol="0" anchor="b"/>
+          <a:lstStyle>
+            <a:lvl1pPr algn="l">
+              <a:defRPr sz="1200"/>
+            </a:lvl1pPr>
+          </a:lstStyle>
+          <a:p>
+            <a:endParaRPr lang="en-SG"/>
+          </a:p>
+        </p:txBody>
+      </p:sp>
+      <p:sp>
+        <p:nvSpPr>
+          <p:cNvPr id="7" name="Slide Number Placeholder 6"/>
+          <p:cNvSpPr>
+            <a:spLocks noGrp="1"/>
+          </p:cNvSpPr>
+          <p:nvPr>
+            <p:ph type="sldNum" sz="quarter" idx="5"/>
+          </p:nvPr>
+        </p:nvSpPr>
+        <p:spPr>
+          <a:xfrm>
+            <a:off x="3884613" y="8685213"/>
+            <a:ext cx="2971800" cy="458787"/>
+          </a:xfrm>
+          <a:prstGeom prst="rect">
+            <a:avLst/>
+          </a:prstGeom>
+        </p:spPr>
+        <p:txBody>
+          <a:bodyPr vert="horz" lIns="91440" tIns="45720" rIns="91440" bIns="45720" rtlCol="0" anchor="b"/>
+          <a:lstStyle>
+            <a:lvl1pPr algn="r">
+              <a:defRPr sz="1200"/>
+            </a:lvl1pPr>
+          </a:lstStyle>
+          <a:p>
+            <a:fld id="{A19A0857-F9BC-425A-8965-650C0EAEF37B}" type="slidenum">
+              <a:rPr lang="en-SG" smtClean="0"/>
+              <a:t>‹#›</a:t>
+            </a:fld>
+            <a:endParaRPr lang="en-SG"/>
+          </a:p>
+        </p:txBody>
+      </p:sp>
+    </p:spTree>
+    <p:extLst>
+      <p:ext uri="{BB962C8B-B14F-4D97-AF65-F5344CB8AC3E}">
+        <p14:creationId xmlns:p14="http://schemas.microsoft.com/office/powerpoint/2010/main" val="2783787928"/>
+      </p:ext>
+    </p:extLst>
+  </p:cSld>
+  <p:clrMap bg1="lt1" tx1="dk1" bg2="lt2" tx2="dk2" accent1="accent1" accent2="accent2" accent3="accent3" accent4="accent4" accent5="accent5" accent6="accent6" hlink="hlink" folHlink="folHlink"/>
+  <p:notesStyle>
+    <a:lvl1pPr marL="0" algn="l" defTabSz="914400" rtl="0" eaLnBrk="1" latinLnBrk="0" hangingPunct="1">
+      <a:defRPr sz="1200" kern="1200">
+        <a:solidFill>
+          <a:schemeClr val="tx1"/>
+        </a:solidFill>
+        <a:latin typeface="+mn-lt"/>
+        <a:ea typeface="+mn-ea"/>
+        <a:cs typeface="+mn-cs"/>
+      </a:defRPr>
+    </a:lvl1pPr>
+    <a:lvl2pPr marL="457200" algn="l" defTabSz="914400" rtl="0" eaLnBrk="1" latinLnBrk="0" hangingPunct="1">
+      <a:defRPr sz="1200" kern="1200">
+        <a:solidFill>
+          <a:schemeClr val="tx1"/>
+        </a:solidFill>
+        <a:latin typeface="+mn-lt"/>
+        <a:ea typeface="+mn-ea"/>
+        <a:cs typeface="+mn-cs"/>
+      </a:defRPr>
+    </a:lvl2pPr>
+    <a:lvl3pPr marL="914400" algn="l" defTabSz="914400" rtl="0" eaLnBrk="1" latinLnBrk="0" hangingPunct="1">
+      <a:defRPr sz="1200" kern="1200">
+        <a:solidFill>
+          <a:schemeClr val="tx1"/>
+        </a:solidFill>
+        <a:latin typeface="+mn-lt"/>
+        <a:ea typeface="+mn-ea"/>
+        <a:cs typeface="+mn-cs"/>
+      </a:defRPr>
+    </a:lvl3pPr>
+    <a:lvl4pPr marL="1371600" algn="l" defTabSz="914400" rtl="0" eaLnBrk="1" latinLnBrk="0" hangingPunct="1">
+      <a:defRPr sz="1200" kern="1200">
+        <a:solidFill>
+          <a:schemeClr val="tx1"/>
+        </a:solidFill>
+        <a:latin typeface="+mn-lt"/>
+        <a:ea typeface="+mn-ea"/>
+        <a:cs typeface="+mn-cs"/>
+      </a:defRPr>
+    </a:lvl4pPr>
+    <a:lvl5pPr marL="1828800" algn="l" defTabSz="914400" rtl="0" eaLnBrk="1" latinLnBrk="0" hangingPunct="1">
+      <a:defRPr sz="1200" kern="1200">
+        <a:solidFill>
+          <a:schemeClr val="tx1"/>
+        </a:solidFill>
+        <a:latin typeface="+mn-lt"/>
+        <a:ea typeface="+mn-ea"/>
+        <a:cs typeface="+mn-cs"/>
+      </a:defRPr>
+    </a:lvl5pPr>
+    <a:lvl6pPr marL="2286000" algn="l" defTabSz="914400" rtl="0" eaLnBrk="1" latinLnBrk="0" hangingPunct="1">
+      <a:defRPr sz="1200" kern="1200">
+        <a:solidFill>
+          <a:schemeClr val="tx1"/>
+        </a:solidFill>
+        <a:latin typeface="+mn-lt"/>
+        <a:ea typeface="+mn-ea"/>
+        <a:cs typeface="+mn-cs"/>
+      </a:defRPr>
+    </a:lvl6pPr>
+    <a:lvl7pPr marL="2743200" algn="l" defTabSz="914400" rtl="0" eaLnBrk="1" latinLnBrk="0" hangingPunct="1">
+      <a:defRPr sz="1200" kern="1200">
+        <a:solidFill>
+          <a:schemeClr val="tx1"/>
+        </a:solidFill>
+        <a:latin typeface="+mn-lt"/>
+        <a:ea typeface="+mn-ea"/>
+        <a:cs typeface="+mn-cs"/>
+      </a:defRPr>
+    </a:lvl7pPr>
+    <a:lvl8pPr marL="3200400" algn="l" defTabSz="914400" rtl="0" eaLnBrk="1" latinLnBrk="0" hangingPunct="1">
+      <a:defRPr sz="1200" kern="1200">
+        <a:solidFill>
+          <a:schemeClr val="tx1"/>
+        </a:solidFill>
+        <a:latin typeface="+mn-lt"/>
+        <a:ea typeface="+mn-ea"/>
+        <a:cs typeface="+mn-cs"/>
+      </a:defRPr>
+    </a:lvl8pPr>
+    <a:lvl9pPr marL="3657600" algn="l" defTabSz="914400" rtl="0" eaLnBrk="1" latinLnBrk="0" hangingPunct="1">
+      <a:defRPr sz="1200" kern="1200">
+        <a:solidFill>
+          <a:schemeClr val="tx1"/>
+        </a:solidFill>
+        <a:latin typeface="+mn-lt"/>
+        <a:ea typeface="+mn-ea"/>
+        <a:cs typeface="+mn-cs"/>
+      </a:defRPr>
+    </a:lvl9pPr>
+  </p:notesStyle>
+</p:notesMaster>
+</file>
+
+<file path=ppt/notesSlides/notesSlide1.xml><?xml version="1.0" encoding="utf-8"?>
+<p:notes xmlns:a="http://schemas.openxmlformats.org/drawingml/2006/main" xmlns:r="http://schemas.openxmlformats.org/officeDocument/2006/relationships" xmlns:p="http://schemas.openxmlformats.org/presentationml/2006/main">
+  <p:cSld>
+    <p:spTree>
+      <p:nvGrpSpPr>
+        <p:cNvPr id="1" name=""/>
+        <p:cNvGrpSpPr/>
+        <p:nvPr/>
+      </p:nvGrpSpPr>
+      <p:grpSpPr>
+        <a:xfrm>
+          <a:off x="0" y="0"/>
+          <a:ext cx="0" cy="0"/>
+          <a:chOff x="0" y="0"/>
+          <a:chExt cx="0" cy="0"/>
+        </a:xfrm>
+      </p:grpSpPr>
+      <p:sp>
+        <p:nvSpPr>
+          <p:cNvPr id="2" name="Slide Image Placeholder 1"/>
+          <p:cNvSpPr>
+            <a:spLocks noGrp="1" noRot="1" noChangeAspect="1"/>
+          </p:cNvSpPr>
+          <p:nvPr>
+            <p:ph type="sldImg"/>
+          </p:nvPr>
+        </p:nvSpPr>
+        <p:spPr/>
+      </p:sp>
+      <p:sp>
+        <p:nvSpPr>
+          <p:cNvPr id="3" name="Notes Placeholder 2"/>
+          <p:cNvSpPr>
+            <a:spLocks noGrp="1"/>
+          </p:cNvSpPr>
+          <p:nvPr>
+            <p:ph type="body" idx="1"/>
+          </p:nvPr>
+        </p:nvSpPr>
+        <p:spPr/>
+        <p:txBody>
+          <a:bodyPr/>
+          <a:lstStyle/>
+          <a:p>
+            <a:endParaRPr lang="en-SG" dirty="0"/>
+          </a:p>
+        </p:txBody>
+      </p:sp>
+      <p:sp>
+        <p:nvSpPr>
+          <p:cNvPr id="4" name="Slide Number Placeholder 3"/>
+          <p:cNvSpPr>
+            <a:spLocks noGrp="1"/>
+          </p:cNvSpPr>
+          <p:nvPr>
+            <p:ph type="sldNum" sz="quarter" idx="5"/>
+          </p:nvPr>
+        </p:nvSpPr>
+        <p:spPr/>
+        <p:txBody>
+          <a:bodyPr/>
+          <a:lstStyle/>
+          <a:p>
+            <a:fld id="{A19A0857-F9BC-425A-8965-650C0EAEF37B}" type="slidenum">
+              <a:rPr lang="en-SG" smtClean="0"/>
+              <a:t>5</a:t>
+            </a:fld>
+            <a:endParaRPr lang="en-SG"/>
+          </a:p>
+        </p:txBody>
+      </p:sp>
+    </p:spTree>
+    <p:extLst>
+      <p:ext uri="{BB962C8B-B14F-4D97-AF65-F5344CB8AC3E}">
+        <p14:creationId xmlns:p14="http://schemas.microsoft.com/office/powerpoint/2010/main" val="3141026871"/>
+      </p:ext>
+    </p:extLst>
+  </p:cSld>
+  <p:clrMapOvr>
+    <a:masterClrMapping/>
+  </p:clrMapOvr>
+</p:notes>
+</file>
+
 <file path=ppt/slideLayouts/slideLayout1.xml><?xml version="1.0" encoding="utf-8"?>
 <p:sldLayout xmlns:a="http://schemas.openxmlformats.org/drawingml/2006/main" xmlns:r="http://schemas.openxmlformats.org/officeDocument/2006/relationships" xmlns:p="http://schemas.openxmlformats.org/presentationml/2006/main" type="title" preserve="1">
   <p:cSld name="Title Slide">
@@ -264,7 +702,7 @@
           <a:p>
             <a:fld id="{E61142BF-0A62-477F-BD0D-B122876D5D2E}" type="datetimeFigureOut">
               <a:rPr lang="en-SG" smtClean="0"/>
-              <a:t>5/11/2025</a:t>
+              <a:t>7/11/2025</a:t>
             </a:fld>
             <a:endParaRPr lang="en-SG"/>
           </a:p>
@@ -464,7 +902,7 @@
           <a:p>
             <a:fld id="{E61142BF-0A62-477F-BD0D-B122876D5D2E}" type="datetimeFigureOut">
               <a:rPr lang="en-SG" smtClean="0"/>
-              <a:t>5/11/2025</a:t>
+              <a:t>7/11/2025</a:t>
             </a:fld>
             <a:endParaRPr lang="en-SG"/>
           </a:p>
@@ -674,7 +1112,7 @@
           <a:p>
             <a:fld id="{E61142BF-0A62-477F-BD0D-B122876D5D2E}" type="datetimeFigureOut">
               <a:rPr lang="en-SG" smtClean="0"/>
-              <a:t>5/11/2025</a:t>
+              <a:t>7/11/2025</a:t>
             </a:fld>
             <a:endParaRPr lang="en-SG"/>
           </a:p>
@@ -874,7 +1312,7 @@
           <a:p>
             <a:fld id="{E61142BF-0A62-477F-BD0D-B122876D5D2E}" type="datetimeFigureOut">
               <a:rPr lang="en-SG" smtClean="0"/>
-              <a:t>5/11/2025</a:t>
+              <a:t>7/11/2025</a:t>
             </a:fld>
             <a:endParaRPr lang="en-SG"/>
           </a:p>
@@ -1150,7 +1588,7 @@
           <a:p>
             <a:fld id="{E61142BF-0A62-477F-BD0D-B122876D5D2E}" type="datetimeFigureOut">
               <a:rPr lang="en-SG" smtClean="0"/>
-              <a:t>5/11/2025</a:t>
+              <a:t>7/11/2025</a:t>
             </a:fld>
             <a:endParaRPr lang="en-SG"/>
           </a:p>
@@ -1418,7 +1856,7 @@
           <a:p>
             <a:fld id="{E61142BF-0A62-477F-BD0D-B122876D5D2E}" type="datetimeFigureOut">
               <a:rPr lang="en-SG" smtClean="0"/>
-              <a:t>5/11/2025</a:t>
+              <a:t>7/11/2025</a:t>
             </a:fld>
             <a:endParaRPr lang="en-SG"/>
           </a:p>
@@ -1833,7 +2271,7 @@
           <a:p>
             <a:fld id="{E61142BF-0A62-477F-BD0D-B122876D5D2E}" type="datetimeFigureOut">
               <a:rPr lang="en-SG" smtClean="0"/>
-              <a:t>5/11/2025</a:t>
+              <a:t>7/11/2025</a:t>
             </a:fld>
             <a:endParaRPr lang="en-SG"/>
           </a:p>
@@ -1975,7 +2413,7 @@
           <a:p>
             <a:fld id="{E61142BF-0A62-477F-BD0D-B122876D5D2E}" type="datetimeFigureOut">
               <a:rPr lang="en-SG" smtClean="0"/>
-              <a:t>5/11/2025</a:t>
+              <a:t>7/11/2025</a:t>
             </a:fld>
             <a:endParaRPr lang="en-SG"/>
           </a:p>
@@ -2088,7 +2526,7 @@
           <a:p>
             <a:fld id="{E61142BF-0A62-477F-BD0D-B122876D5D2E}" type="datetimeFigureOut">
               <a:rPr lang="en-SG" smtClean="0"/>
-              <a:t>5/11/2025</a:t>
+              <a:t>7/11/2025</a:t>
             </a:fld>
             <a:endParaRPr lang="en-SG"/>
           </a:p>
@@ -2401,7 +2839,7 @@
           <a:p>
             <a:fld id="{E61142BF-0A62-477F-BD0D-B122876D5D2E}" type="datetimeFigureOut">
               <a:rPr lang="en-SG" smtClean="0"/>
-              <a:t>5/11/2025</a:t>
+              <a:t>7/11/2025</a:t>
             </a:fld>
             <a:endParaRPr lang="en-SG"/>
           </a:p>
@@ -2690,7 +3128,7 @@
           <a:p>
             <a:fld id="{E61142BF-0A62-477F-BD0D-B122876D5D2E}" type="datetimeFigureOut">
               <a:rPr lang="en-SG" smtClean="0"/>
-              <a:t>5/11/2025</a:t>
+              <a:t>7/11/2025</a:t>
             </a:fld>
             <a:endParaRPr lang="en-SG"/>
           </a:p>
@@ -2933,7 +3371,7 @@
           <a:p>
             <a:fld id="{E61142BF-0A62-477F-BD0D-B122876D5D2E}" type="datetimeFigureOut">
               <a:rPr lang="en-SG" smtClean="0"/>
-              <a:t>5/11/2025</a:t>
+              <a:t>7/11/2025</a:t>
             </a:fld>
             <a:endParaRPr lang="en-SG"/>
           </a:p>
@@ -5553,7 +5991,7 @@
         <p:spPr>
           <a:xfrm>
             <a:off x="267695" y="2372513"/>
-            <a:ext cx="3339694" cy="307777"/>
+            <a:ext cx="3339694" cy="523220"/>
           </a:xfrm>
           <a:prstGeom prst="rect">
             <a:avLst/>
@@ -5568,7 +6006,7 @@
           <a:p>
             <a:r>
               <a:rPr lang="en-SG" sz="1400" b="1" dirty="0"/>
-              <a:t>Cyber Range Physical World Simulator </a:t>
+              <a:t>Cyber Range Physical World Simulator F</a:t>
             </a:r>
           </a:p>
         </p:txBody>
@@ -8106,6 +8544,2600 @@
     <p:extLst>
       <p:ext uri="{BB962C8B-B14F-4D97-AF65-F5344CB8AC3E}">
         <p14:creationId xmlns:p14="http://schemas.microsoft.com/office/powerpoint/2010/main" val="2543494670"/>
+      </p:ext>
+    </p:extLst>
+  </p:cSld>
+  <p:clrMapOvr>
+    <a:masterClrMapping/>
+  </p:clrMapOvr>
+</p:sld>
+</file>
+
+<file path=ppt/slides/slide5.xml><?xml version="1.0" encoding="utf-8"?>
+<p:sld xmlns:a="http://schemas.openxmlformats.org/drawingml/2006/main" xmlns:r="http://schemas.openxmlformats.org/officeDocument/2006/relationships" xmlns:p="http://schemas.openxmlformats.org/presentationml/2006/main">
+  <p:cSld>
+    <p:spTree>
+      <p:nvGrpSpPr>
+        <p:cNvPr id="1" name=""/>
+        <p:cNvGrpSpPr/>
+        <p:nvPr/>
+      </p:nvGrpSpPr>
+      <p:grpSpPr>
+        <a:xfrm>
+          <a:off x="0" y="0"/>
+          <a:ext cx="0" cy="0"/>
+          <a:chOff x="0" y="0"/>
+          <a:chExt cx="0" cy="0"/>
+        </a:xfrm>
+      </p:grpSpPr>
+      <p:sp>
+        <p:nvSpPr>
+          <p:cNvPr id="140" name="Rectangle 139">
+            <a:extLst>
+              <a:ext uri="{FF2B5EF4-FFF2-40B4-BE49-F238E27FC236}">
+                <a16:creationId xmlns:a16="http://schemas.microsoft.com/office/drawing/2014/main" id="{871B7375-EA3A-6508-5654-EA2205E4D31A}"/>
+              </a:ext>
+            </a:extLst>
+          </p:cNvPr>
+          <p:cNvSpPr/>
+          <p:nvPr/>
+        </p:nvSpPr>
+        <p:spPr>
+          <a:xfrm>
+            <a:off x="448056" y="338328"/>
+            <a:ext cx="11265408" cy="6236208"/>
+          </a:xfrm>
+          <a:prstGeom prst="rect">
+            <a:avLst/>
+          </a:prstGeom>
+          <a:noFill/>
+          <a:ln>
+            <a:prstDash val="sysDash"/>
+          </a:ln>
+        </p:spPr>
+        <p:style>
+          <a:lnRef idx="2">
+            <a:schemeClr val="accent1">
+              <a:shade val="15000"/>
+            </a:schemeClr>
+          </a:lnRef>
+          <a:fillRef idx="1">
+            <a:schemeClr val="accent1"/>
+          </a:fillRef>
+          <a:effectRef idx="0">
+            <a:schemeClr val="accent1"/>
+          </a:effectRef>
+          <a:fontRef idx="minor">
+            <a:schemeClr val="lt1"/>
+          </a:fontRef>
+        </p:style>
+        <p:txBody>
+          <a:bodyPr rtlCol="0" anchor="ctr"/>
+          <a:lstStyle/>
+          <a:p>
+            <a:pPr algn="ctr"/>
+            <a:endParaRPr lang="en-SG" dirty="0"/>
+          </a:p>
+        </p:txBody>
+      </p:sp>
+      <p:sp>
+        <p:nvSpPr>
+          <p:cNvPr id="83" name="Rectangle 82">
+            <a:extLst>
+              <a:ext uri="{FF2B5EF4-FFF2-40B4-BE49-F238E27FC236}">
+                <a16:creationId xmlns:a16="http://schemas.microsoft.com/office/drawing/2014/main" id="{F2A67E83-6D14-1631-5DD9-8CDB21121047}"/>
+              </a:ext>
+            </a:extLst>
+          </p:cNvPr>
+          <p:cNvSpPr/>
+          <p:nvPr/>
+        </p:nvSpPr>
+        <p:spPr>
+          <a:xfrm>
+            <a:off x="8233616" y="683362"/>
+            <a:ext cx="3252769" cy="5717436"/>
+          </a:xfrm>
+          <a:prstGeom prst="rect">
+            <a:avLst/>
+          </a:prstGeom>
+          <a:solidFill>
+            <a:schemeClr val="accent2">
+              <a:lumMod val="20000"/>
+              <a:lumOff val="80000"/>
+            </a:schemeClr>
+          </a:solidFill>
+        </p:spPr>
+        <p:style>
+          <a:lnRef idx="2">
+            <a:schemeClr val="accent1">
+              <a:shade val="15000"/>
+            </a:schemeClr>
+          </a:lnRef>
+          <a:fillRef idx="1">
+            <a:schemeClr val="accent1"/>
+          </a:fillRef>
+          <a:effectRef idx="0">
+            <a:schemeClr val="accent1"/>
+          </a:effectRef>
+          <a:fontRef idx="minor">
+            <a:schemeClr val="lt1"/>
+          </a:fontRef>
+        </p:style>
+        <p:txBody>
+          <a:bodyPr rtlCol="0" anchor="ctr"/>
+          <a:lstStyle/>
+          <a:p>
+            <a:pPr algn="ctr"/>
+            <a:endParaRPr lang="en-SG" dirty="0"/>
+          </a:p>
+        </p:txBody>
+      </p:sp>
+      <p:sp>
+        <p:nvSpPr>
+          <p:cNvPr id="4" name="Rectangle 3">
+            <a:extLst>
+              <a:ext uri="{FF2B5EF4-FFF2-40B4-BE49-F238E27FC236}">
+                <a16:creationId xmlns:a16="http://schemas.microsoft.com/office/drawing/2014/main" id="{1BECBAEC-1620-98C2-A527-9F427BA9FF62}"/>
+              </a:ext>
+            </a:extLst>
+          </p:cNvPr>
+          <p:cNvSpPr/>
+          <p:nvPr/>
+        </p:nvSpPr>
+        <p:spPr>
+          <a:xfrm>
+            <a:off x="4701073" y="2175861"/>
+            <a:ext cx="3045289" cy="2420592"/>
+          </a:xfrm>
+          <a:prstGeom prst="rect">
+            <a:avLst/>
+          </a:prstGeom>
+          <a:solidFill>
+            <a:schemeClr val="tx2">
+              <a:lumMod val="10000"/>
+              <a:lumOff val="90000"/>
+            </a:schemeClr>
+          </a:solidFill>
+        </p:spPr>
+        <p:style>
+          <a:lnRef idx="2">
+            <a:schemeClr val="accent1">
+              <a:shade val="15000"/>
+            </a:schemeClr>
+          </a:lnRef>
+          <a:fillRef idx="1">
+            <a:schemeClr val="accent1"/>
+          </a:fillRef>
+          <a:effectRef idx="0">
+            <a:schemeClr val="accent1"/>
+          </a:effectRef>
+          <a:fontRef idx="minor">
+            <a:schemeClr val="lt1"/>
+          </a:fontRef>
+        </p:style>
+        <p:txBody>
+          <a:bodyPr rtlCol="0" anchor="ctr"/>
+          <a:lstStyle/>
+          <a:p>
+            <a:pPr algn="ctr"/>
+            <a:endParaRPr lang="en-SG" dirty="0"/>
+          </a:p>
+        </p:txBody>
+      </p:sp>
+      <p:sp>
+        <p:nvSpPr>
+          <p:cNvPr id="5" name="Rectangle 4">
+            <a:extLst>
+              <a:ext uri="{FF2B5EF4-FFF2-40B4-BE49-F238E27FC236}">
+                <a16:creationId xmlns:a16="http://schemas.microsoft.com/office/drawing/2014/main" id="{BE3A276E-6B03-1C28-6C83-23B635782391}"/>
+              </a:ext>
+            </a:extLst>
+          </p:cNvPr>
+          <p:cNvSpPr/>
+          <p:nvPr/>
+        </p:nvSpPr>
+        <p:spPr>
+          <a:xfrm>
+            <a:off x="5860768" y="2949044"/>
+            <a:ext cx="1714048" cy="501471"/>
+          </a:xfrm>
+          <a:prstGeom prst="rect">
+            <a:avLst/>
+          </a:prstGeom>
+          <a:solidFill>
+            <a:schemeClr val="tx2">
+              <a:lumMod val="75000"/>
+              <a:lumOff val="25000"/>
+            </a:schemeClr>
+          </a:solidFill>
+          <a:ln>
+            <a:solidFill>
+              <a:schemeClr val="tx1"/>
+            </a:solidFill>
+          </a:ln>
+        </p:spPr>
+        <p:style>
+          <a:lnRef idx="2">
+            <a:schemeClr val="accent1">
+              <a:shade val="50000"/>
+            </a:schemeClr>
+          </a:lnRef>
+          <a:fillRef idx="1">
+            <a:schemeClr val="accent1"/>
+          </a:fillRef>
+          <a:effectRef idx="0">
+            <a:schemeClr val="accent1"/>
+          </a:effectRef>
+          <a:fontRef idx="minor">
+            <a:schemeClr val="lt1"/>
+          </a:fontRef>
+        </p:style>
+        <p:txBody>
+          <a:bodyPr rtlCol="0" anchor="ctr"/>
+          <a:lstStyle/>
+          <a:p>
+            <a:r>
+              <a:rPr lang="en-SG" sz="1200" b="1" dirty="0"/>
+              <a:t>User and Access  Management Module </a:t>
+            </a:r>
+          </a:p>
+        </p:txBody>
+      </p:sp>
+      <p:sp>
+        <p:nvSpPr>
+          <p:cNvPr id="6" name="TextBox 5">
+            <a:extLst>
+              <a:ext uri="{FF2B5EF4-FFF2-40B4-BE49-F238E27FC236}">
+                <a16:creationId xmlns:a16="http://schemas.microsoft.com/office/drawing/2014/main" id="{A46F4968-2575-2430-7DF0-BF5B1F1753A9}"/>
+              </a:ext>
+            </a:extLst>
+          </p:cNvPr>
+          <p:cNvSpPr txBox="1"/>
+          <p:nvPr/>
+        </p:nvSpPr>
+        <p:spPr>
+          <a:xfrm>
+            <a:off x="4681828" y="2135657"/>
+            <a:ext cx="2181328" cy="338554"/>
+          </a:xfrm>
+          <a:prstGeom prst="rect">
+            <a:avLst/>
+          </a:prstGeom>
+          <a:noFill/>
+        </p:spPr>
+        <p:txBody>
+          <a:bodyPr wrap="square" rtlCol="0">
+            <a:spAutoFit/>
+          </a:bodyPr>
+          <a:lstStyle/>
+          <a:p>
+            <a:r>
+              <a:rPr lang="en-US" sz="1600" b="1" dirty="0"/>
+              <a:t>Flask Camera Server</a:t>
+            </a:r>
+            <a:endParaRPr lang="en-SG" sz="1600" b="1" dirty="0"/>
+          </a:p>
+        </p:txBody>
+      </p:sp>
+      <p:sp>
+        <p:nvSpPr>
+          <p:cNvPr id="7" name="Cylinder 6">
+            <a:extLst>
+              <a:ext uri="{FF2B5EF4-FFF2-40B4-BE49-F238E27FC236}">
+                <a16:creationId xmlns:a16="http://schemas.microsoft.com/office/drawing/2014/main" id="{806DCC99-E033-3744-ABFD-A3684D8ABFCA}"/>
+              </a:ext>
+            </a:extLst>
+          </p:cNvPr>
+          <p:cNvSpPr/>
+          <p:nvPr/>
+        </p:nvSpPr>
+        <p:spPr>
+          <a:xfrm>
+            <a:off x="6794443" y="2242167"/>
+            <a:ext cx="696191" cy="519546"/>
+          </a:xfrm>
+          <a:prstGeom prst="can">
+            <a:avLst/>
+          </a:prstGeom>
+          <a:solidFill>
+            <a:schemeClr val="accent6">
+              <a:lumMod val="50000"/>
+            </a:schemeClr>
+          </a:solidFill>
+        </p:spPr>
+        <p:style>
+          <a:lnRef idx="2">
+            <a:schemeClr val="accent1">
+              <a:shade val="15000"/>
+            </a:schemeClr>
+          </a:lnRef>
+          <a:fillRef idx="1">
+            <a:schemeClr val="accent1"/>
+          </a:fillRef>
+          <a:effectRef idx="0">
+            <a:schemeClr val="accent1"/>
+          </a:effectRef>
+          <a:fontRef idx="minor">
+            <a:schemeClr val="lt1"/>
+          </a:fontRef>
+        </p:style>
+        <p:txBody>
+          <a:bodyPr rtlCol="0" anchor="ctr"/>
+          <a:lstStyle/>
+          <a:p>
+            <a:pPr algn="ctr"/>
+            <a:r>
+              <a:rPr lang="en-SG" sz="1200" b="1" dirty="0"/>
+              <a:t>User BD</a:t>
+            </a:r>
+          </a:p>
+        </p:txBody>
+      </p:sp>
+      <p:cxnSp>
+        <p:nvCxnSpPr>
+          <p:cNvPr id="8" name="Straight Arrow Connector 7">
+            <a:extLst>
+              <a:ext uri="{FF2B5EF4-FFF2-40B4-BE49-F238E27FC236}">
+                <a16:creationId xmlns:a16="http://schemas.microsoft.com/office/drawing/2014/main" id="{DFCA1D9E-2322-E331-6230-63A11F55EE23}"/>
+              </a:ext>
+            </a:extLst>
+          </p:cNvPr>
+          <p:cNvCxnSpPr>
+            <a:cxnSpLocks/>
+          </p:cNvCxnSpPr>
+          <p:nvPr/>
+        </p:nvCxnSpPr>
+        <p:spPr>
+          <a:xfrm flipH="1">
+            <a:off x="7134869" y="2761713"/>
+            <a:ext cx="0" cy="188554"/>
+          </a:xfrm>
+          <a:prstGeom prst="straightConnector1">
+            <a:avLst/>
+          </a:prstGeom>
+          <a:ln>
+            <a:tailEnd type="triangle"/>
+          </a:ln>
+        </p:spPr>
+        <p:style>
+          <a:lnRef idx="2">
+            <a:schemeClr val="accent1"/>
+          </a:lnRef>
+          <a:fillRef idx="0">
+            <a:schemeClr val="accent1"/>
+          </a:fillRef>
+          <a:effectRef idx="1">
+            <a:schemeClr val="accent1"/>
+          </a:effectRef>
+          <a:fontRef idx="minor">
+            <a:schemeClr val="tx1"/>
+          </a:fontRef>
+        </p:style>
+      </p:cxnSp>
+      <p:sp>
+        <p:nvSpPr>
+          <p:cNvPr id="9" name="Rectangle 8">
+            <a:extLst>
+              <a:ext uri="{FF2B5EF4-FFF2-40B4-BE49-F238E27FC236}">
+                <a16:creationId xmlns:a16="http://schemas.microsoft.com/office/drawing/2014/main" id="{23331518-879C-FA05-0419-17CC3CEE4066}"/>
+              </a:ext>
+            </a:extLst>
+          </p:cNvPr>
+          <p:cNvSpPr/>
+          <p:nvPr/>
+        </p:nvSpPr>
+        <p:spPr>
+          <a:xfrm>
+            <a:off x="4405310" y="3609959"/>
+            <a:ext cx="833444" cy="612982"/>
+          </a:xfrm>
+          <a:prstGeom prst="rect">
+            <a:avLst/>
+          </a:prstGeom>
+          <a:solidFill>
+            <a:schemeClr val="tx2">
+              <a:lumMod val="75000"/>
+              <a:lumOff val="25000"/>
+            </a:schemeClr>
+          </a:solidFill>
+          <a:ln>
+            <a:solidFill>
+              <a:schemeClr val="tx1"/>
+            </a:solidFill>
+          </a:ln>
+        </p:spPr>
+        <p:style>
+          <a:lnRef idx="2">
+            <a:schemeClr val="accent1">
+              <a:shade val="50000"/>
+            </a:schemeClr>
+          </a:lnRef>
+          <a:fillRef idx="1">
+            <a:schemeClr val="accent1"/>
+          </a:fillRef>
+          <a:effectRef idx="0">
+            <a:schemeClr val="accent1"/>
+          </a:effectRef>
+          <a:fontRef idx="minor">
+            <a:schemeClr val="lt1"/>
+          </a:fontRef>
+        </p:style>
+        <p:txBody>
+          <a:bodyPr rtlCol="0" anchor="ctr"/>
+          <a:lstStyle/>
+          <a:p>
+            <a:r>
+              <a:rPr lang="en-SG" sz="1200" b="1" dirty="0"/>
+              <a:t>Data Manager Module </a:t>
+            </a:r>
+          </a:p>
+        </p:txBody>
+      </p:sp>
+      <p:sp>
+        <p:nvSpPr>
+          <p:cNvPr id="10" name="Rectangle 9">
+            <a:extLst>
+              <a:ext uri="{FF2B5EF4-FFF2-40B4-BE49-F238E27FC236}">
+                <a16:creationId xmlns:a16="http://schemas.microsoft.com/office/drawing/2014/main" id="{0DD00CE0-4285-D188-BED9-893AA3F113F2}"/>
+              </a:ext>
+            </a:extLst>
+          </p:cNvPr>
+          <p:cNvSpPr/>
+          <p:nvPr/>
+        </p:nvSpPr>
+        <p:spPr>
+          <a:xfrm>
+            <a:off x="5460519" y="3657929"/>
+            <a:ext cx="2387762" cy="338554"/>
+          </a:xfrm>
+          <a:prstGeom prst="rect">
+            <a:avLst/>
+          </a:prstGeom>
+          <a:solidFill>
+            <a:schemeClr val="tx2">
+              <a:lumMod val="75000"/>
+              <a:lumOff val="25000"/>
+            </a:schemeClr>
+          </a:solidFill>
+          <a:ln>
+            <a:solidFill>
+              <a:schemeClr val="tx1"/>
+            </a:solidFill>
+          </a:ln>
+        </p:spPr>
+        <p:style>
+          <a:lnRef idx="2">
+            <a:schemeClr val="accent1">
+              <a:shade val="50000"/>
+            </a:schemeClr>
+          </a:lnRef>
+          <a:fillRef idx="1">
+            <a:schemeClr val="accent1"/>
+          </a:fillRef>
+          <a:effectRef idx="0">
+            <a:schemeClr val="accent1"/>
+          </a:effectRef>
+          <a:fontRef idx="minor">
+            <a:schemeClr val="lt1"/>
+          </a:fontRef>
+        </p:style>
+        <p:txBody>
+          <a:bodyPr rtlCol="0" anchor="ctr"/>
+          <a:lstStyle/>
+          <a:p>
+            <a:r>
+              <a:rPr lang="en-SG" sz="1200" b="1" dirty="0"/>
+              <a:t>Flask Web Service Module </a:t>
+            </a:r>
+          </a:p>
+        </p:txBody>
+      </p:sp>
+      <p:sp>
+        <p:nvSpPr>
+          <p:cNvPr id="11" name="Rectangle 10">
+            <a:extLst>
+              <a:ext uri="{FF2B5EF4-FFF2-40B4-BE49-F238E27FC236}">
+                <a16:creationId xmlns:a16="http://schemas.microsoft.com/office/drawing/2014/main" id="{F9D53FB2-F599-00F8-8267-1423DC3015AF}"/>
+              </a:ext>
+            </a:extLst>
+          </p:cNvPr>
+          <p:cNvSpPr/>
+          <p:nvPr/>
+        </p:nvSpPr>
+        <p:spPr>
+          <a:xfrm>
+            <a:off x="4415318" y="2452489"/>
+            <a:ext cx="2225821" cy="338554"/>
+          </a:xfrm>
+          <a:prstGeom prst="rect">
+            <a:avLst/>
+          </a:prstGeom>
+          <a:solidFill>
+            <a:schemeClr val="tx2">
+              <a:lumMod val="75000"/>
+              <a:lumOff val="25000"/>
+            </a:schemeClr>
+          </a:solidFill>
+          <a:ln>
+            <a:solidFill>
+              <a:schemeClr val="tx1"/>
+            </a:solidFill>
+          </a:ln>
+        </p:spPr>
+        <p:style>
+          <a:lnRef idx="2">
+            <a:schemeClr val="accent1">
+              <a:shade val="50000"/>
+            </a:schemeClr>
+          </a:lnRef>
+          <a:fillRef idx="1">
+            <a:schemeClr val="accent1"/>
+          </a:fillRef>
+          <a:effectRef idx="0">
+            <a:schemeClr val="accent1"/>
+          </a:effectRef>
+          <a:fontRef idx="minor">
+            <a:schemeClr val="lt1"/>
+          </a:fontRef>
+        </p:style>
+        <p:txBody>
+          <a:bodyPr rtlCol="0" anchor="ctr"/>
+          <a:lstStyle/>
+          <a:p>
+            <a:r>
+              <a:rPr lang="en-SG" sz="1200" b="1" dirty="0"/>
+              <a:t>Video Source Manger Module </a:t>
+            </a:r>
+          </a:p>
+        </p:txBody>
+      </p:sp>
+      <p:cxnSp>
+        <p:nvCxnSpPr>
+          <p:cNvPr id="12" name="Straight Arrow Connector 11">
+            <a:extLst>
+              <a:ext uri="{FF2B5EF4-FFF2-40B4-BE49-F238E27FC236}">
+                <a16:creationId xmlns:a16="http://schemas.microsoft.com/office/drawing/2014/main" id="{FA5F0344-E22E-E273-FDC6-0DF344EE4CBD}"/>
+              </a:ext>
+            </a:extLst>
+          </p:cNvPr>
+          <p:cNvCxnSpPr>
+            <a:cxnSpLocks/>
+          </p:cNvCxnSpPr>
+          <p:nvPr/>
+        </p:nvCxnSpPr>
+        <p:spPr>
+          <a:xfrm>
+            <a:off x="5589428" y="2769003"/>
+            <a:ext cx="0" cy="888926"/>
+          </a:xfrm>
+          <a:prstGeom prst="straightConnector1">
+            <a:avLst/>
+          </a:prstGeom>
+          <a:ln>
+            <a:tailEnd type="triangle"/>
+          </a:ln>
+        </p:spPr>
+        <p:style>
+          <a:lnRef idx="2">
+            <a:schemeClr val="accent1"/>
+          </a:lnRef>
+          <a:fillRef idx="0">
+            <a:schemeClr val="accent1"/>
+          </a:fillRef>
+          <a:effectRef idx="1">
+            <a:schemeClr val="accent1"/>
+          </a:effectRef>
+          <a:fontRef idx="minor">
+            <a:schemeClr val="tx1"/>
+          </a:fontRef>
+        </p:style>
+      </p:cxnSp>
+      <p:cxnSp>
+        <p:nvCxnSpPr>
+          <p:cNvPr id="14" name="Straight Arrow Connector 13">
+            <a:extLst>
+              <a:ext uri="{FF2B5EF4-FFF2-40B4-BE49-F238E27FC236}">
+                <a16:creationId xmlns:a16="http://schemas.microsoft.com/office/drawing/2014/main" id="{F058C508-CC32-6EC4-121A-EBD398E3F15C}"/>
+              </a:ext>
+            </a:extLst>
+          </p:cNvPr>
+          <p:cNvCxnSpPr>
+            <a:cxnSpLocks/>
+          </p:cNvCxnSpPr>
+          <p:nvPr/>
+        </p:nvCxnSpPr>
+        <p:spPr>
+          <a:xfrm>
+            <a:off x="3976802" y="3996483"/>
+            <a:ext cx="429352" cy="0"/>
+          </a:xfrm>
+          <a:prstGeom prst="straightConnector1">
+            <a:avLst/>
+          </a:prstGeom>
+          <a:ln w="28575">
+            <a:solidFill>
+              <a:schemeClr val="tx1"/>
+            </a:solidFill>
+            <a:tailEnd type="triangle"/>
+          </a:ln>
+        </p:spPr>
+        <p:style>
+          <a:lnRef idx="2">
+            <a:schemeClr val="accent1"/>
+          </a:lnRef>
+          <a:fillRef idx="0">
+            <a:schemeClr val="accent1"/>
+          </a:fillRef>
+          <a:effectRef idx="1">
+            <a:schemeClr val="accent1"/>
+          </a:effectRef>
+          <a:fontRef idx="minor">
+            <a:schemeClr val="tx1"/>
+          </a:fontRef>
+        </p:style>
+      </p:cxnSp>
+      <p:pic>
+        <p:nvPicPr>
+          <p:cNvPr id="15" name="Picture 14" descr="A computer screen shot of a runway&#10;&#10;AI-generated content may be incorrect.">
+            <a:extLst>
+              <a:ext uri="{FF2B5EF4-FFF2-40B4-BE49-F238E27FC236}">
+                <a16:creationId xmlns:a16="http://schemas.microsoft.com/office/drawing/2014/main" id="{46417502-CF3B-FD86-3646-F6C9A2794429}"/>
+              </a:ext>
+            </a:extLst>
+          </p:cNvPr>
+          <p:cNvPicPr>
+            <a:picLocks noChangeAspect="1"/>
+          </p:cNvPicPr>
+          <p:nvPr/>
+        </p:nvPicPr>
+        <p:blipFill>
+          <a:blip r:embed="rId3">
+            <a:extLst>
+              <a:ext uri="{28A0092B-C50C-407E-A947-70E740481C1C}">
+                <a14:useLocalDpi xmlns:a14="http://schemas.microsoft.com/office/drawing/2010/main" val="0"/>
+              </a:ext>
+            </a:extLst>
+          </a:blip>
+          <a:stretch>
+            <a:fillRect/>
+          </a:stretch>
+        </p:blipFill>
+        <p:spPr>
+          <a:xfrm>
+            <a:off x="724034" y="2848271"/>
+            <a:ext cx="3252768" cy="1781606"/>
+          </a:xfrm>
+          <a:prstGeom prst="rect">
+            <a:avLst/>
+          </a:prstGeom>
+          <a:ln w="9525">
+            <a:solidFill>
+              <a:schemeClr val="tx1"/>
+            </a:solidFill>
+          </a:ln>
+        </p:spPr>
+      </p:pic>
+      <p:cxnSp>
+        <p:nvCxnSpPr>
+          <p:cNvPr id="19" name="Straight Arrow Connector 18">
+            <a:extLst>
+              <a:ext uri="{FF2B5EF4-FFF2-40B4-BE49-F238E27FC236}">
+                <a16:creationId xmlns:a16="http://schemas.microsoft.com/office/drawing/2014/main" id="{2B3C3A35-7E0B-800D-17B6-A6F47FB24928}"/>
+              </a:ext>
+            </a:extLst>
+          </p:cNvPr>
+          <p:cNvCxnSpPr>
+            <a:cxnSpLocks/>
+            <a:stCxn id="10" idx="3"/>
+          </p:cNvCxnSpPr>
+          <p:nvPr/>
+        </p:nvCxnSpPr>
+        <p:spPr>
+          <a:xfrm>
+            <a:off x="7848281" y="3827206"/>
+            <a:ext cx="187490" cy="0"/>
+          </a:xfrm>
+          <a:prstGeom prst="straightConnector1">
+            <a:avLst/>
+          </a:prstGeom>
+          <a:ln w="28575">
+            <a:solidFill>
+              <a:schemeClr val="accent2">
+                <a:lumMod val="75000"/>
+              </a:schemeClr>
+            </a:solidFill>
+            <a:tailEnd type="triangle"/>
+          </a:ln>
+        </p:spPr>
+        <p:style>
+          <a:lnRef idx="2">
+            <a:schemeClr val="accent1"/>
+          </a:lnRef>
+          <a:fillRef idx="0">
+            <a:schemeClr val="accent1"/>
+          </a:fillRef>
+          <a:effectRef idx="1">
+            <a:schemeClr val="accent1"/>
+          </a:effectRef>
+          <a:fontRef idx="minor">
+            <a:schemeClr val="tx1"/>
+          </a:fontRef>
+        </p:style>
+      </p:cxnSp>
+      <p:pic>
+        <p:nvPicPr>
+          <p:cNvPr id="20" name="Picture 19">
+            <a:extLst>
+              <a:ext uri="{FF2B5EF4-FFF2-40B4-BE49-F238E27FC236}">
+                <a16:creationId xmlns:a16="http://schemas.microsoft.com/office/drawing/2014/main" id="{DD336189-D263-2824-AC9F-A4BA359198FB}"/>
+              </a:ext>
+            </a:extLst>
+          </p:cNvPr>
+          <p:cNvPicPr>
+            <a:picLocks noChangeAspect="1"/>
+          </p:cNvPicPr>
+          <p:nvPr/>
+        </p:nvPicPr>
+        <p:blipFill>
+          <a:blip r:embed="rId4"/>
+          <a:stretch>
+            <a:fillRect/>
+          </a:stretch>
+        </p:blipFill>
+        <p:spPr>
+          <a:xfrm>
+            <a:off x="8423245" y="1206581"/>
+            <a:ext cx="2885687" cy="1537245"/>
+          </a:xfrm>
+          <a:prstGeom prst="rect">
+            <a:avLst/>
+          </a:prstGeom>
+          <a:ln w="12700">
+            <a:solidFill>
+              <a:schemeClr val="tx1"/>
+            </a:solidFill>
+          </a:ln>
+        </p:spPr>
+      </p:pic>
+      <p:cxnSp>
+        <p:nvCxnSpPr>
+          <p:cNvPr id="21" name="Straight Arrow Connector 20">
+            <a:extLst>
+              <a:ext uri="{FF2B5EF4-FFF2-40B4-BE49-F238E27FC236}">
+                <a16:creationId xmlns:a16="http://schemas.microsoft.com/office/drawing/2014/main" id="{879DB34B-7875-772A-9B5A-F91E01368A39}"/>
+              </a:ext>
+            </a:extLst>
+          </p:cNvPr>
+          <p:cNvCxnSpPr>
+            <a:cxnSpLocks/>
+          </p:cNvCxnSpPr>
+          <p:nvPr/>
+        </p:nvCxnSpPr>
+        <p:spPr>
+          <a:xfrm flipH="1">
+            <a:off x="6717792" y="3469375"/>
+            <a:ext cx="0" cy="188554"/>
+          </a:xfrm>
+          <a:prstGeom prst="straightConnector1">
+            <a:avLst/>
+          </a:prstGeom>
+          <a:ln>
+            <a:tailEnd type="triangle"/>
+          </a:ln>
+        </p:spPr>
+        <p:style>
+          <a:lnRef idx="2">
+            <a:schemeClr val="accent1"/>
+          </a:lnRef>
+          <a:fillRef idx="0">
+            <a:schemeClr val="accent1"/>
+          </a:fillRef>
+          <a:effectRef idx="1">
+            <a:schemeClr val="accent1"/>
+          </a:effectRef>
+          <a:fontRef idx="minor">
+            <a:schemeClr val="tx1"/>
+          </a:fontRef>
+        </p:style>
+      </p:cxnSp>
+      <p:pic>
+        <p:nvPicPr>
+          <p:cNvPr id="22" name="Picture 21">
+            <a:extLst>
+              <a:ext uri="{FF2B5EF4-FFF2-40B4-BE49-F238E27FC236}">
+                <a16:creationId xmlns:a16="http://schemas.microsoft.com/office/drawing/2014/main" id="{8FD75856-405B-1DD7-D53E-7001D024A838}"/>
+              </a:ext>
+            </a:extLst>
+          </p:cNvPr>
+          <p:cNvPicPr>
+            <a:picLocks noChangeAspect="1"/>
+          </p:cNvPicPr>
+          <p:nvPr/>
+        </p:nvPicPr>
+        <p:blipFill>
+          <a:blip r:embed="rId5"/>
+          <a:stretch>
+            <a:fillRect/>
+          </a:stretch>
+        </p:blipFill>
+        <p:spPr>
+          <a:xfrm>
+            <a:off x="10874473" y="798783"/>
+            <a:ext cx="500932" cy="500932"/>
+          </a:xfrm>
+          <a:prstGeom prst="rect">
+            <a:avLst/>
+          </a:prstGeom>
+          <a:ln w="12700">
+            <a:solidFill>
+              <a:schemeClr val="tx1"/>
+            </a:solidFill>
+          </a:ln>
+        </p:spPr>
+      </p:pic>
+      <p:sp>
+        <p:nvSpPr>
+          <p:cNvPr id="23" name="TextBox 22">
+            <a:extLst>
+              <a:ext uri="{FF2B5EF4-FFF2-40B4-BE49-F238E27FC236}">
+                <a16:creationId xmlns:a16="http://schemas.microsoft.com/office/drawing/2014/main" id="{126DB273-778F-6EAE-EB2D-73F32881F3E0}"/>
+              </a:ext>
+            </a:extLst>
+          </p:cNvPr>
+          <p:cNvSpPr txBox="1"/>
+          <p:nvPr/>
+        </p:nvSpPr>
+        <p:spPr>
+          <a:xfrm>
+            <a:off x="8378185" y="800084"/>
+            <a:ext cx="2031653" cy="338554"/>
+          </a:xfrm>
+          <a:prstGeom prst="rect">
+            <a:avLst/>
+          </a:prstGeom>
+          <a:noFill/>
+        </p:spPr>
+        <p:txBody>
+          <a:bodyPr wrap="square" rtlCol="0">
+            <a:spAutoFit/>
+          </a:bodyPr>
+          <a:lstStyle/>
+          <a:p>
+            <a:r>
+              <a:rPr lang="en-SG" sz="1600" b="1" dirty="0"/>
+              <a:t>Web Browser View </a:t>
+            </a:r>
+          </a:p>
+        </p:txBody>
+      </p:sp>
+      <p:sp>
+        <p:nvSpPr>
+          <p:cNvPr id="43" name="Rectangle 42">
+            <a:extLst>
+              <a:ext uri="{FF2B5EF4-FFF2-40B4-BE49-F238E27FC236}">
+                <a16:creationId xmlns:a16="http://schemas.microsoft.com/office/drawing/2014/main" id="{F9DE50E0-4BDF-D59F-EF8C-252925595FE8}"/>
+              </a:ext>
+            </a:extLst>
+          </p:cNvPr>
+          <p:cNvSpPr/>
+          <p:nvPr/>
+        </p:nvSpPr>
+        <p:spPr>
+          <a:xfrm>
+            <a:off x="724034" y="1114742"/>
+            <a:ext cx="7189514" cy="710182"/>
+          </a:xfrm>
+          <a:prstGeom prst="rect">
+            <a:avLst/>
+          </a:prstGeom>
+          <a:solidFill>
+            <a:schemeClr val="accent6">
+              <a:lumMod val="20000"/>
+              <a:lumOff val="80000"/>
+            </a:schemeClr>
+          </a:solidFill>
+        </p:spPr>
+        <p:style>
+          <a:lnRef idx="2">
+            <a:schemeClr val="accent1">
+              <a:shade val="15000"/>
+            </a:schemeClr>
+          </a:lnRef>
+          <a:fillRef idx="1">
+            <a:schemeClr val="accent1"/>
+          </a:fillRef>
+          <a:effectRef idx="0">
+            <a:schemeClr val="accent1"/>
+          </a:effectRef>
+          <a:fontRef idx="minor">
+            <a:schemeClr val="lt1"/>
+          </a:fontRef>
+        </p:style>
+        <p:txBody>
+          <a:bodyPr rtlCol="0" anchor="ctr"/>
+          <a:lstStyle/>
+          <a:p>
+            <a:pPr algn="ctr"/>
+            <a:endParaRPr lang="en-SG" dirty="0"/>
+          </a:p>
+        </p:txBody>
+      </p:sp>
+      <p:pic>
+        <p:nvPicPr>
+          <p:cNvPr id="44" name="Picture 2" descr="Webcam - Free computer icons">
+            <a:extLst>
+              <a:ext uri="{FF2B5EF4-FFF2-40B4-BE49-F238E27FC236}">
+                <a16:creationId xmlns:a16="http://schemas.microsoft.com/office/drawing/2014/main" id="{5298D540-10E0-C308-A4AF-9F1B6B3683B8}"/>
+              </a:ext>
+            </a:extLst>
+          </p:cNvPr>
+          <p:cNvPicPr>
+            <a:picLocks noChangeAspect="1" noChangeArrowheads="1"/>
+          </p:cNvPicPr>
+          <p:nvPr/>
+        </p:nvPicPr>
+        <p:blipFill>
+          <a:blip r:embed="rId6">
+            <a:extLst>
+              <a:ext uri="{28A0092B-C50C-407E-A947-70E740481C1C}">
+                <a14:useLocalDpi xmlns:a14="http://schemas.microsoft.com/office/drawing/2010/main" val="0"/>
+              </a:ext>
+            </a:extLst>
+          </a:blip>
+          <a:srcRect/>
+          <a:stretch>
+            <a:fillRect/>
+          </a:stretch>
+        </p:blipFill>
+        <p:spPr bwMode="auto">
+          <a:xfrm>
+            <a:off x="787216" y="1178421"/>
+            <a:ext cx="567150" cy="567150"/>
+          </a:xfrm>
+          <a:prstGeom prst="rect">
+            <a:avLst/>
+          </a:prstGeom>
+          <a:noFill/>
+          <a:extLst>
+            <a:ext uri="{909E8E84-426E-40DD-AFC4-6F175D3DCCD1}">
+              <a14:hiddenFill xmlns:a14="http://schemas.microsoft.com/office/drawing/2010/main">
+                <a:solidFill>
+                  <a:srgbClr val="FFFFFF"/>
+                </a:solidFill>
+              </a14:hiddenFill>
+            </a:ext>
+          </a:extLst>
+        </p:spPr>
+      </p:pic>
+      <p:sp>
+        <p:nvSpPr>
+          <p:cNvPr id="45" name="TextBox 44">
+            <a:extLst>
+              <a:ext uri="{FF2B5EF4-FFF2-40B4-BE49-F238E27FC236}">
+                <a16:creationId xmlns:a16="http://schemas.microsoft.com/office/drawing/2014/main" id="{69334859-8A0E-E229-46D7-7F4578F69712}"/>
+              </a:ext>
+            </a:extLst>
+          </p:cNvPr>
+          <p:cNvSpPr txBox="1"/>
+          <p:nvPr/>
+        </p:nvSpPr>
+        <p:spPr>
+          <a:xfrm>
+            <a:off x="1326423" y="1254087"/>
+            <a:ext cx="1023995" cy="461665"/>
+          </a:xfrm>
+          <a:prstGeom prst="rect">
+            <a:avLst/>
+          </a:prstGeom>
+          <a:noFill/>
+        </p:spPr>
+        <p:txBody>
+          <a:bodyPr wrap="square">
+            <a:spAutoFit/>
+          </a:bodyPr>
+          <a:lstStyle/>
+          <a:p>
+            <a:r>
+              <a:rPr lang="en-US" sz="1200" b="1" dirty="0">
+                <a:solidFill>
+                  <a:schemeClr val="tx1">
+                    <a:lumMod val="75000"/>
+                    <a:lumOff val="25000"/>
+                  </a:schemeClr>
+                </a:solidFill>
+              </a:rPr>
+              <a:t>Real Camrea</a:t>
+            </a:r>
+            <a:endParaRPr lang="en-SG" sz="1200" b="1" dirty="0">
+              <a:solidFill>
+                <a:schemeClr val="tx1">
+                  <a:lumMod val="75000"/>
+                  <a:lumOff val="25000"/>
+                </a:schemeClr>
+              </a:solidFill>
+            </a:endParaRPr>
+          </a:p>
+        </p:txBody>
+      </p:sp>
+      <p:pic>
+        <p:nvPicPr>
+          <p:cNvPr id="46" name="Picture 45">
+            <a:extLst>
+              <a:ext uri="{FF2B5EF4-FFF2-40B4-BE49-F238E27FC236}">
+                <a16:creationId xmlns:a16="http://schemas.microsoft.com/office/drawing/2014/main" id="{BE72FC67-0B0D-4826-05A3-E6AF1FF86C6B}"/>
+              </a:ext>
+            </a:extLst>
+          </p:cNvPr>
+          <p:cNvPicPr>
+            <a:picLocks noChangeAspect="1"/>
+          </p:cNvPicPr>
+          <p:nvPr/>
+        </p:nvPicPr>
+        <p:blipFill>
+          <a:blip r:embed="rId7"/>
+          <a:stretch>
+            <a:fillRect/>
+          </a:stretch>
+        </p:blipFill>
+        <p:spPr>
+          <a:xfrm>
+            <a:off x="2127758" y="1219872"/>
+            <a:ext cx="567150" cy="539142"/>
+          </a:xfrm>
+          <a:prstGeom prst="rect">
+            <a:avLst/>
+          </a:prstGeom>
+        </p:spPr>
+      </p:pic>
+      <p:sp>
+        <p:nvSpPr>
+          <p:cNvPr id="47" name="TextBox 46">
+            <a:extLst>
+              <a:ext uri="{FF2B5EF4-FFF2-40B4-BE49-F238E27FC236}">
+                <a16:creationId xmlns:a16="http://schemas.microsoft.com/office/drawing/2014/main" id="{7364A0D7-DF7E-14DC-60B4-DEF95351CC1F}"/>
+              </a:ext>
+            </a:extLst>
+          </p:cNvPr>
+          <p:cNvSpPr txBox="1"/>
+          <p:nvPr/>
+        </p:nvSpPr>
+        <p:spPr>
+          <a:xfrm>
+            <a:off x="2696555" y="1202115"/>
+            <a:ext cx="930472" cy="646331"/>
+          </a:xfrm>
+          <a:prstGeom prst="rect">
+            <a:avLst/>
+          </a:prstGeom>
+          <a:noFill/>
+        </p:spPr>
+        <p:txBody>
+          <a:bodyPr wrap="square">
+            <a:spAutoFit/>
+          </a:bodyPr>
+          <a:lstStyle/>
+          <a:p>
+            <a:r>
+              <a:rPr lang="en-US" sz="1200" b="1" dirty="0">
+                <a:solidFill>
+                  <a:schemeClr val="tx1">
+                    <a:lumMod val="75000"/>
+                    <a:lumOff val="25000"/>
+                  </a:schemeClr>
+                </a:solidFill>
+              </a:rPr>
+              <a:t>RTSP Video Server</a:t>
+            </a:r>
+            <a:endParaRPr lang="en-SG" sz="1200" b="1" dirty="0">
+              <a:solidFill>
+                <a:schemeClr val="tx1">
+                  <a:lumMod val="75000"/>
+                  <a:lumOff val="25000"/>
+                </a:schemeClr>
+              </a:solidFill>
+            </a:endParaRPr>
+          </a:p>
+        </p:txBody>
+      </p:sp>
+      <p:pic>
+        <p:nvPicPr>
+          <p:cNvPr id="48" name="Picture 4" descr="Folder images Icon | Free Folder Iconpack | Iconshock">
+            <a:extLst>
+              <a:ext uri="{FF2B5EF4-FFF2-40B4-BE49-F238E27FC236}">
+                <a16:creationId xmlns:a16="http://schemas.microsoft.com/office/drawing/2014/main" id="{5C6F1B38-C571-CA25-03EF-14543C3789DE}"/>
+              </a:ext>
+            </a:extLst>
+          </p:cNvPr>
+          <p:cNvPicPr>
+            <a:picLocks noChangeAspect="1" noChangeArrowheads="1"/>
+          </p:cNvPicPr>
+          <p:nvPr/>
+        </p:nvPicPr>
+        <p:blipFill>
+          <a:blip r:embed="rId8">
+            <a:extLst>
+              <a:ext uri="{28A0092B-C50C-407E-A947-70E740481C1C}">
+                <a14:useLocalDpi xmlns:a14="http://schemas.microsoft.com/office/drawing/2010/main" val="0"/>
+              </a:ext>
+            </a:extLst>
+          </a:blip>
+          <a:srcRect/>
+          <a:stretch>
+            <a:fillRect/>
+          </a:stretch>
+        </p:blipFill>
+        <p:spPr bwMode="auto">
+          <a:xfrm>
+            <a:off x="3329554" y="1138264"/>
+            <a:ext cx="567150" cy="567150"/>
+          </a:xfrm>
+          <a:prstGeom prst="rect">
+            <a:avLst/>
+          </a:prstGeom>
+          <a:noFill/>
+          <a:extLst>
+            <a:ext uri="{909E8E84-426E-40DD-AFC4-6F175D3DCCD1}">
+              <a14:hiddenFill xmlns:a14="http://schemas.microsoft.com/office/drawing/2010/main">
+                <a:solidFill>
+                  <a:srgbClr val="FFFFFF"/>
+                </a:solidFill>
+              </a14:hiddenFill>
+            </a:ext>
+          </a:extLst>
+        </p:spPr>
+      </p:pic>
+      <p:sp>
+        <p:nvSpPr>
+          <p:cNvPr id="49" name="TextBox 48">
+            <a:extLst>
+              <a:ext uri="{FF2B5EF4-FFF2-40B4-BE49-F238E27FC236}">
+                <a16:creationId xmlns:a16="http://schemas.microsoft.com/office/drawing/2014/main" id="{49DD0A89-FD32-0839-7E6B-A4CB8BBFB7C8}"/>
+              </a:ext>
+            </a:extLst>
+          </p:cNvPr>
+          <p:cNvSpPr txBox="1"/>
+          <p:nvPr/>
+        </p:nvSpPr>
+        <p:spPr>
+          <a:xfrm>
+            <a:off x="3845227" y="1175966"/>
+            <a:ext cx="1232479" cy="461665"/>
+          </a:xfrm>
+          <a:prstGeom prst="rect">
+            <a:avLst/>
+          </a:prstGeom>
+          <a:noFill/>
+        </p:spPr>
+        <p:txBody>
+          <a:bodyPr wrap="square">
+            <a:spAutoFit/>
+          </a:bodyPr>
+          <a:lstStyle/>
+          <a:p>
+            <a:r>
+              <a:rPr lang="en-US" sz="1200" b="1" dirty="0">
+                <a:solidFill>
+                  <a:schemeClr val="tx1">
+                    <a:lumMod val="75000"/>
+                    <a:lumOff val="25000"/>
+                  </a:schemeClr>
+                </a:solidFill>
+              </a:rPr>
+              <a:t>Pictures Dataset</a:t>
+            </a:r>
+            <a:endParaRPr lang="en-SG" sz="1200" b="1" dirty="0">
+              <a:solidFill>
+                <a:schemeClr val="tx1">
+                  <a:lumMod val="75000"/>
+                  <a:lumOff val="25000"/>
+                </a:schemeClr>
+              </a:solidFill>
+            </a:endParaRPr>
+          </a:p>
+        </p:txBody>
+      </p:sp>
+      <p:pic>
+        <p:nvPicPr>
+          <p:cNvPr id="50" name="Picture 49">
+            <a:extLst>
+              <a:ext uri="{FF2B5EF4-FFF2-40B4-BE49-F238E27FC236}">
+                <a16:creationId xmlns:a16="http://schemas.microsoft.com/office/drawing/2014/main" id="{1A73D2E9-7AC5-13FB-C174-647C31EB858B}"/>
+              </a:ext>
+            </a:extLst>
+          </p:cNvPr>
+          <p:cNvPicPr>
+            <a:picLocks noChangeAspect="1"/>
+          </p:cNvPicPr>
+          <p:nvPr/>
+        </p:nvPicPr>
+        <p:blipFill>
+          <a:blip r:embed="rId9"/>
+          <a:stretch>
+            <a:fillRect/>
+          </a:stretch>
+        </p:blipFill>
+        <p:spPr>
+          <a:xfrm>
+            <a:off x="4710719" y="1190538"/>
+            <a:ext cx="636638" cy="506097"/>
+          </a:xfrm>
+          <a:prstGeom prst="rect">
+            <a:avLst/>
+          </a:prstGeom>
+        </p:spPr>
+      </p:pic>
+      <p:sp>
+        <p:nvSpPr>
+          <p:cNvPr id="51" name="TextBox 50">
+            <a:extLst>
+              <a:ext uri="{FF2B5EF4-FFF2-40B4-BE49-F238E27FC236}">
+                <a16:creationId xmlns:a16="http://schemas.microsoft.com/office/drawing/2014/main" id="{3835F191-51AA-9E3A-6FA8-B02B671E4A93}"/>
+              </a:ext>
+            </a:extLst>
+          </p:cNvPr>
+          <p:cNvSpPr txBox="1"/>
+          <p:nvPr/>
+        </p:nvSpPr>
+        <p:spPr>
+          <a:xfrm>
+            <a:off x="5295906" y="1201876"/>
+            <a:ext cx="1192834" cy="461665"/>
+          </a:xfrm>
+          <a:prstGeom prst="rect">
+            <a:avLst/>
+          </a:prstGeom>
+          <a:noFill/>
+        </p:spPr>
+        <p:txBody>
+          <a:bodyPr wrap="square">
+            <a:spAutoFit/>
+          </a:bodyPr>
+          <a:lstStyle/>
+          <a:p>
+            <a:r>
+              <a:rPr lang="en-US" sz="1200" b="1" dirty="0">
+                <a:solidFill>
+                  <a:schemeClr val="tx1">
+                    <a:lumMod val="75000"/>
+                    <a:lumOff val="25000"/>
+                  </a:schemeClr>
+                </a:solidFill>
+              </a:rPr>
+              <a:t>Screen Recording</a:t>
+            </a:r>
+            <a:endParaRPr lang="en-SG" sz="1200" b="1" dirty="0">
+              <a:solidFill>
+                <a:schemeClr val="tx1">
+                  <a:lumMod val="75000"/>
+                  <a:lumOff val="25000"/>
+                </a:schemeClr>
+              </a:solidFill>
+            </a:endParaRPr>
+          </a:p>
+        </p:txBody>
+      </p:sp>
+      <p:pic>
+        <p:nvPicPr>
+          <p:cNvPr id="52" name="Picture 6" descr="Application Flaticons Lineal Color icon | Freepik">
+            <a:extLst>
+              <a:ext uri="{FF2B5EF4-FFF2-40B4-BE49-F238E27FC236}">
+                <a16:creationId xmlns:a16="http://schemas.microsoft.com/office/drawing/2014/main" id="{A57E9B9D-FCF0-AA69-1E7B-A7CC76B779CE}"/>
+              </a:ext>
+            </a:extLst>
+          </p:cNvPr>
+          <p:cNvPicPr>
+            <a:picLocks noChangeAspect="1" noChangeArrowheads="1"/>
+          </p:cNvPicPr>
+          <p:nvPr/>
+        </p:nvPicPr>
+        <p:blipFill>
+          <a:blip r:embed="rId10">
+            <a:extLst>
+              <a:ext uri="{28A0092B-C50C-407E-A947-70E740481C1C}">
+                <a14:useLocalDpi xmlns:a14="http://schemas.microsoft.com/office/drawing/2010/main" val="0"/>
+              </a:ext>
+            </a:extLst>
+          </a:blip>
+          <a:srcRect/>
+          <a:stretch>
+            <a:fillRect/>
+          </a:stretch>
+        </p:blipFill>
+        <p:spPr bwMode="auto">
+          <a:xfrm>
+            <a:off x="6187539" y="1202099"/>
+            <a:ext cx="553033" cy="553033"/>
+          </a:xfrm>
+          <a:prstGeom prst="rect">
+            <a:avLst/>
+          </a:prstGeom>
+          <a:noFill/>
+          <a:extLst>
+            <a:ext uri="{909E8E84-426E-40DD-AFC4-6F175D3DCCD1}">
+              <a14:hiddenFill xmlns:a14="http://schemas.microsoft.com/office/drawing/2010/main">
+                <a:solidFill>
+                  <a:srgbClr val="FFFFFF"/>
+                </a:solidFill>
+              </a14:hiddenFill>
+            </a:ext>
+          </a:extLst>
+        </p:spPr>
+      </p:pic>
+      <p:sp>
+        <p:nvSpPr>
+          <p:cNvPr id="53" name="TextBox 52">
+            <a:extLst>
+              <a:ext uri="{FF2B5EF4-FFF2-40B4-BE49-F238E27FC236}">
+                <a16:creationId xmlns:a16="http://schemas.microsoft.com/office/drawing/2014/main" id="{B86FF3D3-62C3-4CAD-2831-BE535D3789A2}"/>
+              </a:ext>
+            </a:extLst>
+          </p:cNvPr>
+          <p:cNvSpPr txBox="1"/>
+          <p:nvPr/>
+        </p:nvSpPr>
+        <p:spPr>
+          <a:xfrm>
+            <a:off x="6789121" y="1111662"/>
+            <a:ext cx="1008096" cy="646331"/>
+          </a:xfrm>
+          <a:prstGeom prst="rect">
+            <a:avLst/>
+          </a:prstGeom>
+          <a:noFill/>
+        </p:spPr>
+        <p:txBody>
+          <a:bodyPr wrap="square">
+            <a:spAutoFit/>
+          </a:bodyPr>
+          <a:lstStyle/>
+          <a:p>
+            <a:r>
+              <a:rPr lang="en-US" sz="1200" b="1" dirty="0">
+                <a:solidFill>
+                  <a:schemeClr val="tx1">
+                    <a:lumMod val="75000"/>
+                    <a:lumOff val="25000"/>
+                  </a:schemeClr>
+                </a:solidFill>
+              </a:rPr>
+              <a:t>Application  Window  Screenshot </a:t>
+            </a:r>
+            <a:endParaRPr lang="en-SG" sz="1200" b="1" dirty="0">
+              <a:solidFill>
+                <a:schemeClr val="tx1">
+                  <a:lumMod val="75000"/>
+                  <a:lumOff val="25000"/>
+                </a:schemeClr>
+              </a:solidFill>
+            </a:endParaRPr>
+          </a:p>
+        </p:txBody>
+      </p:sp>
+      <p:cxnSp>
+        <p:nvCxnSpPr>
+          <p:cNvPr id="57" name="Straight Arrow Connector 56">
+            <a:extLst>
+              <a:ext uri="{FF2B5EF4-FFF2-40B4-BE49-F238E27FC236}">
+                <a16:creationId xmlns:a16="http://schemas.microsoft.com/office/drawing/2014/main" id="{EE681733-3245-3022-BDAE-FF9F3317A042}"/>
+              </a:ext>
+            </a:extLst>
+          </p:cNvPr>
+          <p:cNvCxnSpPr>
+            <a:cxnSpLocks/>
+          </p:cNvCxnSpPr>
+          <p:nvPr/>
+        </p:nvCxnSpPr>
+        <p:spPr>
+          <a:xfrm>
+            <a:off x="2413806" y="1721438"/>
+            <a:ext cx="0" cy="296824"/>
+          </a:xfrm>
+          <a:prstGeom prst="straightConnector1">
+            <a:avLst/>
+          </a:prstGeom>
+          <a:ln w="28575">
+            <a:solidFill>
+              <a:schemeClr val="accent6">
+                <a:lumMod val="75000"/>
+              </a:schemeClr>
+            </a:solidFill>
+            <a:tailEnd type="triangle"/>
+          </a:ln>
+        </p:spPr>
+        <p:style>
+          <a:lnRef idx="2">
+            <a:schemeClr val="accent1"/>
+          </a:lnRef>
+          <a:fillRef idx="0">
+            <a:schemeClr val="accent1"/>
+          </a:fillRef>
+          <a:effectRef idx="1">
+            <a:schemeClr val="accent1"/>
+          </a:effectRef>
+          <a:fontRef idx="minor">
+            <a:schemeClr val="tx1"/>
+          </a:fontRef>
+        </p:style>
+      </p:cxnSp>
+      <p:cxnSp>
+        <p:nvCxnSpPr>
+          <p:cNvPr id="58" name="Straight Arrow Connector 57">
+            <a:extLst>
+              <a:ext uri="{FF2B5EF4-FFF2-40B4-BE49-F238E27FC236}">
+                <a16:creationId xmlns:a16="http://schemas.microsoft.com/office/drawing/2014/main" id="{1DFFA36E-201D-A554-D833-3DC2A66C6284}"/>
+              </a:ext>
+            </a:extLst>
+          </p:cNvPr>
+          <p:cNvCxnSpPr>
+            <a:cxnSpLocks/>
+          </p:cNvCxnSpPr>
+          <p:nvPr/>
+        </p:nvCxnSpPr>
+        <p:spPr>
+          <a:xfrm>
+            <a:off x="1071029" y="1729912"/>
+            <a:ext cx="0" cy="263547"/>
+          </a:xfrm>
+          <a:prstGeom prst="straightConnector1">
+            <a:avLst/>
+          </a:prstGeom>
+          <a:ln w="28575">
+            <a:solidFill>
+              <a:schemeClr val="accent6">
+                <a:lumMod val="75000"/>
+              </a:schemeClr>
+            </a:solidFill>
+            <a:tailEnd type="triangle"/>
+          </a:ln>
+        </p:spPr>
+        <p:style>
+          <a:lnRef idx="2">
+            <a:schemeClr val="accent1"/>
+          </a:lnRef>
+          <a:fillRef idx="0">
+            <a:schemeClr val="accent1"/>
+          </a:fillRef>
+          <a:effectRef idx="1">
+            <a:schemeClr val="accent1"/>
+          </a:effectRef>
+          <a:fontRef idx="minor">
+            <a:schemeClr val="tx1"/>
+          </a:fontRef>
+        </p:style>
+      </p:cxnSp>
+      <p:cxnSp>
+        <p:nvCxnSpPr>
+          <p:cNvPr id="59" name="Straight Arrow Connector 58">
+            <a:extLst>
+              <a:ext uri="{FF2B5EF4-FFF2-40B4-BE49-F238E27FC236}">
+                <a16:creationId xmlns:a16="http://schemas.microsoft.com/office/drawing/2014/main" id="{5294CE04-4018-23B5-40AB-8FBCB4B5E805}"/>
+              </a:ext>
+            </a:extLst>
+          </p:cNvPr>
+          <p:cNvCxnSpPr>
+            <a:cxnSpLocks/>
+          </p:cNvCxnSpPr>
+          <p:nvPr/>
+        </p:nvCxnSpPr>
+        <p:spPr>
+          <a:xfrm>
+            <a:off x="3603621" y="1719378"/>
+            <a:ext cx="0" cy="263547"/>
+          </a:xfrm>
+          <a:prstGeom prst="straightConnector1">
+            <a:avLst/>
+          </a:prstGeom>
+          <a:ln w="28575">
+            <a:solidFill>
+              <a:schemeClr val="accent6">
+                <a:lumMod val="75000"/>
+              </a:schemeClr>
+            </a:solidFill>
+            <a:tailEnd type="triangle"/>
+          </a:ln>
+        </p:spPr>
+        <p:style>
+          <a:lnRef idx="2">
+            <a:schemeClr val="accent1"/>
+          </a:lnRef>
+          <a:fillRef idx="0">
+            <a:schemeClr val="accent1"/>
+          </a:fillRef>
+          <a:effectRef idx="1">
+            <a:schemeClr val="accent1"/>
+          </a:effectRef>
+          <a:fontRef idx="minor">
+            <a:schemeClr val="tx1"/>
+          </a:fontRef>
+        </p:style>
+      </p:cxnSp>
+      <p:cxnSp>
+        <p:nvCxnSpPr>
+          <p:cNvPr id="60" name="Straight Arrow Connector 59">
+            <a:extLst>
+              <a:ext uri="{FF2B5EF4-FFF2-40B4-BE49-F238E27FC236}">
+                <a16:creationId xmlns:a16="http://schemas.microsoft.com/office/drawing/2014/main" id="{1198B0D7-03DF-DE3D-8552-7146E2D04D56}"/>
+              </a:ext>
+            </a:extLst>
+          </p:cNvPr>
+          <p:cNvCxnSpPr>
+            <a:cxnSpLocks/>
+          </p:cNvCxnSpPr>
+          <p:nvPr/>
+        </p:nvCxnSpPr>
+        <p:spPr>
+          <a:xfrm>
+            <a:off x="4991790" y="1709823"/>
+            <a:ext cx="0" cy="263547"/>
+          </a:xfrm>
+          <a:prstGeom prst="straightConnector1">
+            <a:avLst/>
+          </a:prstGeom>
+          <a:ln w="28575">
+            <a:solidFill>
+              <a:schemeClr val="accent6">
+                <a:lumMod val="75000"/>
+              </a:schemeClr>
+            </a:solidFill>
+            <a:tailEnd type="triangle"/>
+          </a:ln>
+        </p:spPr>
+        <p:style>
+          <a:lnRef idx="2">
+            <a:schemeClr val="accent1"/>
+          </a:lnRef>
+          <a:fillRef idx="0">
+            <a:schemeClr val="accent1"/>
+          </a:fillRef>
+          <a:effectRef idx="1">
+            <a:schemeClr val="accent1"/>
+          </a:effectRef>
+          <a:fontRef idx="minor">
+            <a:schemeClr val="tx1"/>
+          </a:fontRef>
+        </p:style>
+      </p:cxnSp>
+      <p:sp>
+        <p:nvSpPr>
+          <p:cNvPr id="70" name="TextBox 69">
+            <a:extLst>
+              <a:ext uri="{FF2B5EF4-FFF2-40B4-BE49-F238E27FC236}">
+                <a16:creationId xmlns:a16="http://schemas.microsoft.com/office/drawing/2014/main" id="{48A123E3-5411-F417-77AF-2967130AA3A7}"/>
+              </a:ext>
+            </a:extLst>
+          </p:cNvPr>
+          <p:cNvSpPr txBox="1"/>
+          <p:nvPr/>
+        </p:nvSpPr>
+        <p:spPr>
+          <a:xfrm>
+            <a:off x="622430" y="2530504"/>
+            <a:ext cx="3938728" cy="338554"/>
+          </a:xfrm>
+          <a:prstGeom prst="rect">
+            <a:avLst/>
+          </a:prstGeom>
+          <a:noFill/>
+        </p:spPr>
+        <p:txBody>
+          <a:bodyPr wrap="square" rtlCol="0">
+            <a:spAutoFit/>
+          </a:bodyPr>
+          <a:lstStyle/>
+          <a:p>
+            <a:r>
+              <a:rPr lang="en-SG" sz="1600" b="1" dirty="0"/>
+              <a:t>Cyber Range Physical World Simulator </a:t>
+            </a:r>
+          </a:p>
+        </p:txBody>
+      </p:sp>
+      <p:cxnSp>
+        <p:nvCxnSpPr>
+          <p:cNvPr id="75" name="Straight Arrow Connector 74">
+            <a:extLst>
+              <a:ext uri="{FF2B5EF4-FFF2-40B4-BE49-F238E27FC236}">
+                <a16:creationId xmlns:a16="http://schemas.microsoft.com/office/drawing/2014/main" id="{0836C664-6101-AC9A-128A-0BE2B3F56B2D}"/>
+              </a:ext>
+            </a:extLst>
+          </p:cNvPr>
+          <p:cNvCxnSpPr>
+            <a:cxnSpLocks/>
+          </p:cNvCxnSpPr>
+          <p:nvPr/>
+        </p:nvCxnSpPr>
+        <p:spPr>
+          <a:xfrm>
+            <a:off x="6488740" y="1719378"/>
+            <a:ext cx="0" cy="263547"/>
+          </a:xfrm>
+          <a:prstGeom prst="straightConnector1">
+            <a:avLst/>
+          </a:prstGeom>
+          <a:ln w="28575">
+            <a:solidFill>
+              <a:schemeClr val="accent6">
+                <a:lumMod val="75000"/>
+              </a:schemeClr>
+            </a:solidFill>
+            <a:tailEnd type="triangle"/>
+          </a:ln>
+        </p:spPr>
+        <p:style>
+          <a:lnRef idx="2">
+            <a:schemeClr val="accent1"/>
+          </a:lnRef>
+          <a:fillRef idx="0">
+            <a:schemeClr val="accent1"/>
+          </a:fillRef>
+          <a:effectRef idx="1">
+            <a:schemeClr val="accent1"/>
+          </a:effectRef>
+          <a:fontRef idx="minor">
+            <a:schemeClr val="tx1"/>
+          </a:fontRef>
+        </p:style>
+      </p:cxnSp>
+      <p:cxnSp>
+        <p:nvCxnSpPr>
+          <p:cNvPr id="76" name="Straight Connector 75">
+            <a:extLst>
+              <a:ext uri="{FF2B5EF4-FFF2-40B4-BE49-F238E27FC236}">
+                <a16:creationId xmlns:a16="http://schemas.microsoft.com/office/drawing/2014/main" id="{60A87CAB-825E-7CFB-B817-C7F9A8C862E1}"/>
+              </a:ext>
+            </a:extLst>
+          </p:cNvPr>
+          <p:cNvCxnSpPr>
+            <a:cxnSpLocks/>
+          </p:cNvCxnSpPr>
+          <p:nvPr/>
+        </p:nvCxnSpPr>
+        <p:spPr>
+          <a:xfrm>
+            <a:off x="1052741" y="1994366"/>
+            <a:ext cx="5435999" cy="0"/>
+          </a:xfrm>
+          <a:prstGeom prst="line">
+            <a:avLst/>
+          </a:prstGeom>
+          <a:ln w="28575">
+            <a:solidFill>
+              <a:schemeClr val="accent6">
+                <a:lumMod val="75000"/>
+              </a:schemeClr>
+            </a:solidFill>
+          </a:ln>
+        </p:spPr>
+        <p:style>
+          <a:lnRef idx="2">
+            <a:schemeClr val="accent1"/>
+          </a:lnRef>
+          <a:fillRef idx="0">
+            <a:schemeClr val="accent1"/>
+          </a:fillRef>
+          <a:effectRef idx="1">
+            <a:schemeClr val="accent1"/>
+          </a:effectRef>
+          <a:fontRef idx="minor">
+            <a:schemeClr val="tx1"/>
+          </a:fontRef>
+        </p:style>
+      </p:cxnSp>
+      <p:sp>
+        <p:nvSpPr>
+          <p:cNvPr id="81" name="TextBox 80">
+            <a:extLst>
+              <a:ext uri="{FF2B5EF4-FFF2-40B4-BE49-F238E27FC236}">
+                <a16:creationId xmlns:a16="http://schemas.microsoft.com/office/drawing/2014/main" id="{5EE5B429-1FA5-6DD4-BCF7-38F4D3B5AF77}"/>
+              </a:ext>
+            </a:extLst>
+          </p:cNvPr>
+          <p:cNvSpPr txBox="1"/>
+          <p:nvPr/>
+        </p:nvSpPr>
+        <p:spPr>
+          <a:xfrm>
+            <a:off x="1387544" y="1982925"/>
+            <a:ext cx="2644925" cy="338554"/>
+          </a:xfrm>
+          <a:prstGeom prst="rect">
+            <a:avLst/>
+          </a:prstGeom>
+          <a:noFill/>
+        </p:spPr>
+        <p:txBody>
+          <a:bodyPr wrap="square">
+            <a:spAutoFit/>
+          </a:bodyPr>
+          <a:lstStyle/>
+          <a:p>
+            <a:r>
+              <a:rPr lang="en-US" sz="1600" b="1" dirty="0">
+                <a:solidFill>
+                  <a:schemeClr val="accent6">
+                    <a:lumMod val="75000"/>
+                  </a:schemeClr>
+                </a:solidFill>
+              </a:rPr>
+              <a:t>5 Different Video Source</a:t>
+            </a:r>
+            <a:endParaRPr lang="en-SG" sz="1600" b="1" dirty="0">
+              <a:solidFill>
+                <a:schemeClr val="accent6">
+                  <a:lumMod val="75000"/>
+                </a:schemeClr>
+              </a:solidFill>
+            </a:endParaRPr>
+          </a:p>
+        </p:txBody>
+      </p:sp>
+      <p:pic>
+        <p:nvPicPr>
+          <p:cNvPr id="82" name="Picture 81" descr="A screenshot of a video camera&#10;&#10;AI-generated content may be incorrect.">
+            <a:extLst>
+              <a:ext uri="{FF2B5EF4-FFF2-40B4-BE49-F238E27FC236}">
+                <a16:creationId xmlns:a16="http://schemas.microsoft.com/office/drawing/2014/main" id="{1657AE2C-97A5-2378-5F2F-B1076093F72E}"/>
+              </a:ext>
+            </a:extLst>
+          </p:cNvPr>
+          <p:cNvPicPr>
+            <a:picLocks noChangeAspect="1"/>
+          </p:cNvPicPr>
+          <p:nvPr/>
+        </p:nvPicPr>
+        <p:blipFill>
+          <a:blip r:embed="rId11">
+            <a:extLst>
+              <a:ext uri="{28A0092B-C50C-407E-A947-70E740481C1C}">
+                <a14:useLocalDpi xmlns:a14="http://schemas.microsoft.com/office/drawing/2010/main" val="0"/>
+              </a:ext>
+            </a:extLst>
+          </a:blip>
+          <a:stretch>
+            <a:fillRect/>
+          </a:stretch>
+        </p:blipFill>
+        <p:spPr>
+          <a:xfrm>
+            <a:off x="8417539" y="2949044"/>
+            <a:ext cx="2885687" cy="1647410"/>
+          </a:xfrm>
+          <a:prstGeom prst="rect">
+            <a:avLst/>
+          </a:prstGeom>
+          <a:ln w="9525">
+            <a:solidFill>
+              <a:schemeClr val="tx1"/>
+            </a:solidFill>
+          </a:ln>
+        </p:spPr>
+      </p:pic>
+      <p:pic>
+        <p:nvPicPr>
+          <p:cNvPr id="87" name="Picture 86" descr="A screenshot of a computer&#10;&#10;AI-generated content may be incorrect.">
+            <a:extLst>
+              <a:ext uri="{FF2B5EF4-FFF2-40B4-BE49-F238E27FC236}">
+                <a16:creationId xmlns:a16="http://schemas.microsoft.com/office/drawing/2014/main" id="{B56A244F-B55D-6C6C-9DE8-7587774460D0}"/>
+              </a:ext>
+            </a:extLst>
+          </p:cNvPr>
+          <p:cNvPicPr>
+            <a:picLocks noChangeAspect="1"/>
+          </p:cNvPicPr>
+          <p:nvPr/>
+        </p:nvPicPr>
+        <p:blipFill>
+          <a:blip r:embed="rId12">
+            <a:extLst>
+              <a:ext uri="{28A0092B-C50C-407E-A947-70E740481C1C}">
+                <a14:useLocalDpi xmlns:a14="http://schemas.microsoft.com/office/drawing/2010/main" val="0"/>
+              </a:ext>
+            </a:extLst>
+          </a:blip>
+          <a:stretch>
+            <a:fillRect/>
+          </a:stretch>
+        </p:blipFill>
+        <p:spPr>
+          <a:xfrm>
+            <a:off x="746438" y="5085793"/>
+            <a:ext cx="2272646" cy="1274392"/>
+          </a:xfrm>
+          <a:prstGeom prst="rect">
+            <a:avLst/>
+          </a:prstGeom>
+          <a:ln w="12700">
+            <a:solidFill>
+              <a:schemeClr val="tx1"/>
+            </a:solidFill>
+          </a:ln>
+        </p:spPr>
+      </p:pic>
+      <p:pic>
+        <p:nvPicPr>
+          <p:cNvPr id="88" name="Picture 87" descr="A screenshot of a computer&#10;&#10;AI-generated content may be incorrect.">
+            <a:extLst>
+              <a:ext uri="{FF2B5EF4-FFF2-40B4-BE49-F238E27FC236}">
+                <a16:creationId xmlns:a16="http://schemas.microsoft.com/office/drawing/2014/main" id="{C4F967FC-CCF6-0B05-680E-73EC74B41EB8}"/>
+              </a:ext>
+            </a:extLst>
+          </p:cNvPr>
+          <p:cNvPicPr>
+            <a:picLocks noChangeAspect="1"/>
+          </p:cNvPicPr>
+          <p:nvPr/>
+        </p:nvPicPr>
+        <p:blipFill>
+          <a:blip r:embed="rId13">
+            <a:extLst>
+              <a:ext uri="{28A0092B-C50C-407E-A947-70E740481C1C}">
+                <a14:useLocalDpi xmlns:a14="http://schemas.microsoft.com/office/drawing/2010/main" val="0"/>
+              </a:ext>
+            </a:extLst>
+          </a:blip>
+          <a:stretch>
+            <a:fillRect/>
+          </a:stretch>
+        </p:blipFill>
+        <p:spPr>
+          <a:xfrm>
+            <a:off x="3273387" y="5055695"/>
+            <a:ext cx="2376157" cy="1334589"/>
+          </a:xfrm>
+          <a:prstGeom prst="rect">
+            <a:avLst/>
+          </a:prstGeom>
+          <a:ln w="9525">
+            <a:solidFill>
+              <a:schemeClr val="tx1"/>
+            </a:solidFill>
+          </a:ln>
+        </p:spPr>
+      </p:pic>
+      <p:pic>
+        <p:nvPicPr>
+          <p:cNvPr id="95" name="Picture 94" descr="A screenshot of a computer&#10;&#10;AI-generated content may be incorrect.">
+            <a:extLst>
+              <a:ext uri="{FF2B5EF4-FFF2-40B4-BE49-F238E27FC236}">
+                <a16:creationId xmlns:a16="http://schemas.microsoft.com/office/drawing/2014/main" id="{4E5C4080-2D06-692C-A5E8-CF46BC1C5524}"/>
+              </a:ext>
+            </a:extLst>
+          </p:cNvPr>
+          <p:cNvPicPr>
+            <a:picLocks noChangeAspect="1"/>
+          </p:cNvPicPr>
+          <p:nvPr/>
+        </p:nvPicPr>
+        <p:blipFill>
+          <a:blip r:embed="rId14">
+            <a:extLst>
+              <a:ext uri="{28A0092B-C50C-407E-A947-70E740481C1C}">
+                <a14:useLocalDpi xmlns:a14="http://schemas.microsoft.com/office/drawing/2010/main" val="0"/>
+              </a:ext>
+            </a:extLst>
+          </a:blip>
+          <a:stretch>
+            <a:fillRect/>
+          </a:stretch>
+        </p:blipFill>
+        <p:spPr>
+          <a:xfrm>
+            <a:off x="8417539" y="4779067"/>
+            <a:ext cx="2885687" cy="1552814"/>
+          </a:xfrm>
+          <a:prstGeom prst="rect">
+            <a:avLst/>
+          </a:prstGeom>
+          <a:ln w="6350">
+            <a:solidFill>
+              <a:schemeClr val="tx1"/>
+            </a:solidFill>
+          </a:ln>
+        </p:spPr>
+      </p:pic>
+      <p:cxnSp>
+        <p:nvCxnSpPr>
+          <p:cNvPr id="97" name="Connector: Elbow 96">
+            <a:extLst>
+              <a:ext uri="{FF2B5EF4-FFF2-40B4-BE49-F238E27FC236}">
+                <a16:creationId xmlns:a16="http://schemas.microsoft.com/office/drawing/2014/main" id="{17897114-8D05-95A4-C209-9D5A622E92D3}"/>
+              </a:ext>
+            </a:extLst>
+          </p:cNvPr>
+          <p:cNvCxnSpPr>
+            <a:cxnSpLocks/>
+          </p:cNvCxnSpPr>
+          <p:nvPr/>
+        </p:nvCxnSpPr>
+        <p:spPr>
+          <a:xfrm rot="16200000" flipH="1">
+            <a:off x="3830531" y="2025295"/>
+            <a:ext cx="612982" cy="538264"/>
+          </a:xfrm>
+          <a:prstGeom prst="bentConnector2">
+            <a:avLst/>
+          </a:prstGeom>
+          <a:ln w="28575">
+            <a:solidFill>
+              <a:schemeClr val="accent6">
+                <a:lumMod val="75000"/>
+              </a:schemeClr>
+            </a:solidFill>
+            <a:tailEnd type="triangle"/>
+          </a:ln>
+        </p:spPr>
+        <p:style>
+          <a:lnRef idx="2">
+            <a:schemeClr val="accent1"/>
+          </a:lnRef>
+          <a:fillRef idx="0">
+            <a:schemeClr val="accent1"/>
+          </a:fillRef>
+          <a:effectRef idx="1">
+            <a:schemeClr val="accent1"/>
+          </a:effectRef>
+          <a:fontRef idx="minor">
+            <a:schemeClr val="tx1"/>
+          </a:fontRef>
+        </p:style>
+      </p:cxnSp>
+      <p:pic>
+        <p:nvPicPr>
+          <p:cNvPr id="107" name="Picture 106" descr="A large computer screen with multiple screens&#10;&#10;AI-generated content may be incorrect.">
+            <a:extLst>
+              <a:ext uri="{FF2B5EF4-FFF2-40B4-BE49-F238E27FC236}">
+                <a16:creationId xmlns:a16="http://schemas.microsoft.com/office/drawing/2014/main" id="{554C569B-7935-85B5-2506-AB1A9D91E9EF}"/>
+              </a:ext>
+            </a:extLst>
+          </p:cNvPr>
+          <p:cNvPicPr>
+            <a:picLocks noChangeAspect="1"/>
+          </p:cNvPicPr>
+          <p:nvPr/>
+        </p:nvPicPr>
+        <p:blipFill>
+          <a:blip r:embed="rId15">
+            <a:extLst>
+              <a:ext uri="{28A0092B-C50C-407E-A947-70E740481C1C}">
+                <a14:useLocalDpi xmlns:a14="http://schemas.microsoft.com/office/drawing/2010/main" val="0"/>
+              </a:ext>
+            </a:extLst>
+          </a:blip>
+          <a:stretch>
+            <a:fillRect/>
+          </a:stretch>
+        </p:blipFill>
+        <p:spPr>
+          <a:xfrm>
+            <a:off x="5876592" y="5054139"/>
+            <a:ext cx="2036956" cy="1359046"/>
+          </a:xfrm>
+          <a:prstGeom prst="rect">
+            <a:avLst/>
+          </a:prstGeom>
+          <a:ln w="6350">
+            <a:solidFill>
+              <a:schemeClr val="tx1"/>
+            </a:solidFill>
+          </a:ln>
+        </p:spPr>
+      </p:pic>
+      <p:cxnSp>
+        <p:nvCxnSpPr>
+          <p:cNvPr id="109" name="Connector: Elbow 108">
+            <a:extLst>
+              <a:ext uri="{FF2B5EF4-FFF2-40B4-BE49-F238E27FC236}">
+                <a16:creationId xmlns:a16="http://schemas.microsoft.com/office/drawing/2014/main" id="{2B766067-2509-A943-15FD-C78DF8285D5E}"/>
+              </a:ext>
+            </a:extLst>
+          </p:cNvPr>
+          <p:cNvCxnSpPr>
+            <a:cxnSpLocks/>
+            <a:stCxn id="9" idx="2"/>
+          </p:cNvCxnSpPr>
+          <p:nvPr/>
+        </p:nvCxnSpPr>
+        <p:spPr>
+          <a:xfrm rot="5400000" flipH="1" flipV="1">
+            <a:off x="5372147" y="3511962"/>
+            <a:ext cx="160864" cy="1261094"/>
+          </a:xfrm>
+          <a:prstGeom prst="bentConnector4">
+            <a:avLst>
+              <a:gd name="adj1" fmla="val -142108"/>
+              <a:gd name="adj2" fmla="val 100601"/>
+            </a:avLst>
+          </a:prstGeom>
+          <a:ln>
+            <a:tailEnd type="triangle"/>
+          </a:ln>
+        </p:spPr>
+        <p:style>
+          <a:lnRef idx="2">
+            <a:schemeClr val="accent1"/>
+          </a:lnRef>
+          <a:fillRef idx="0">
+            <a:schemeClr val="accent1"/>
+          </a:fillRef>
+          <a:effectRef idx="1">
+            <a:schemeClr val="accent1"/>
+          </a:effectRef>
+          <a:fontRef idx="minor">
+            <a:schemeClr val="tx1"/>
+          </a:fontRef>
+        </p:style>
+      </p:cxnSp>
+      <p:cxnSp>
+        <p:nvCxnSpPr>
+          <p:cNvPr id="119" name="Straight Arrow Connector 118">
+            <a:extLst>
+              <a:ext uri="{FF2B5EF4-FFF2-40B4-BE49-F238E27FC236}">
+                <a16:creationId xmlns:a16="http://schemas.microsoft.com/office/drawing/2014/main" id="{8E1244CC-5E23-D8FF-25F6-03B51536DCF7}"/>
+              </a:ext>
+            </a:extLst>
+          </p:cNvPr>
+          <p:cNvCxnSpPr>
+            <a:cxnSpLocks/>
+          </p:cNvCxnSpPr>
+          <p:nvPr/>
+        </p:nvCxnSpPr>
+        <p:spPr>
+          <a:xfrm>
+            <a:off x="6641139" y="3996483"/>
+            <a:ext cx="0" cy="782584"/>
+          </a:xfrm>
+          <a:prstGeom prst="straightConnector1">
+            <a:avLst/>
+          </a:prstGeom>
+          <a:ln w="28575">
+            <a:solidFill>
+              <a:schemeClr val="accent5">
+                <a:lumMod val="75000"/>
+              </a:schemeClr>
+            </a:solidFill>
+            <a:tailEnd type="triangle"/>
+          </a:ln>
+        </p:spPr>
+        <p:style>
+          <a:lnRef idx="2">
+            <a:schemeClr val="accent1"/>
+          </a:lnRef>
+          <a:fillRef idx="0">
+            <a:schemeClr val="accent1"/>
+          </a:fillRef>
+          <a:effectRef idx="1">
+            <a:schemeClr val="accent1"/>
+          </a:effectRef>
+          <a:fontRef idx="minor">
+            <a:schemeClr val="tx1"/>
+          </a:fontRef>
+        </p:style>
+      </p:cxnSp>
+      <p:cxnSp>
+        <p:nvCxnSpPr>
+          <p:cNvPr id="121" name="Straight Connector 120">
+            <a:extLst>
+              <a:ext uri="{FF2B5EF4-FFF2-40B4-BE49-F238E27FC236}">
+                <a16:creationId xmlns:a16="http://schemas.microsoft.com/office/drawing/2014/main" id="{242AA309-8363-2BC6-5E7E-19849DA5848F}"/>
+              </a:ext>
+            </a:extLst>
+          </p:cNvPr>
+          <p:cNvCxnSpPr>
+            <a:cxnSpLocks/>
+          </p:cNvCxnSpPr>
+          <p:nvPr/>
+        </p:nvCxnSpPr>
+        <p:spPr>
+          <a:xfrm>
+            <a:off x="1673753" y="4793303"/>
+            <a:ext cx="5249266" cy="0"/>
+          </a:xfrm>
+          <a:prstGeom prst="line">
+            <a:avLst/>
+          </a:prstGeom>
+          <a:ln w="28575">
+            <a:solidFill>
+              <a:schemeClr val="accent5">
+                <a:lumMod val="75000"/>
+              </a:schemeClr>
+            </a:solidFill>
+          </a:ln>
+        </p:spPr>
+        <p:style>
+          <a:lnRef idx="2">
+            <a:schemeClr val="accent1"/>
+          </a:lnRef>
+          <a:fillRef idx="0">
+            <a:schemeClr val="accent1"/>
+          </a:fillRef>
+          <a:effectRef idx="1">
+            <a:schemeClr val="accent1"/>
+          </a:effectRef>
+          <a:fontRef idx="minor">
+            <a:schemeClr val="tx1"/>
+          </a:fontRef>
+        </p:style>
+      </p:cxnSp>
+      <p:sp>
+        <p:nvSpPr>
+          <p:cNvPr id="123" name="TextBox 122">
+            <a:extLst>
+              <a:ext uri="{FF2B5EF4-FFF2-40B4-BE49-F238E27FC236}">
+                <a16:creationId xmlns:a16="http://schemas.microsoft.com/office/drawing/2014/main" id="{E8FF8F97-15BF-EDF1-C06F-15C0B8EBD3FB}"/>
+              </a:ext>
+            </a:extLst>
+          </p:cNvPr>
+          <p:cNvSpPr txBox="1"/>
+          <p:nvPr/>
+        </p:nvSpPr>
+        <p:spPr>
+          <a:xfrm>
+            <a:off x="6654400" y="4175709"/>
+            <a:ext cx="1232479" cy="276999"/>
+          </a:xfrm>
+          <a:prstGeom prst="rect">
+            <a:avLst/>
+          </a:prstGeom>
+          <a:noFill/>
+        </p:spPr>
+        <p:txBody>
+          <a:bodyPr wrap="square">
+            <a:spAutoFit/>
+          </a:bodyPr>
+          <a:lstStyle/>
+          <a:p>
+            <a:r>
+              <a:rPr lang="en-SG" sz="1200" b="1" dirty="0">
+                <a:solidFill>
+                  <a:schemeClr val="tx1">
+                    <a:lumMod val="75000"/>
+                    <a:lumOff val="25000"/>
+                  </a:schemeClr>
+                </a:solidFill>
+              </a:rPr>
+              <a:t>MJPEG API</a:t>
+            </a:r>
+          </a:p>
+        </p:txBody>
+      </p:sp>
+      <p:cxnSp>
+        <p:nvCxnSpPr>
+          <p:cNvPr id="124" name="Straight Arrow Connector 123">
+            <a:extLst>
+              <a:ext uri="{FF2B5EF4-FFF2-40B4-BE49-F238E27FC236}">
+                <a16:creationId xmlns:a16="http://schemas.microsoft.com/office/drawing/2014/main" id="{C29F0059-45A9-CBF9-E3F8-F52014531FBC}"/>
+              </a:ext>
+            </a:extLst>
+          </p:cNvPr>
+          <p:cNvCxnSpPr>
+            <a:cxnSpLocks/>
+          </p:cNvCxnSpPr>
+          <p:nvPr/>
+        </p:nvCxnSpPr>
+        <p:spPr>
+          <a:xfrm>
+            <a:off x="1661197" y="4779067"/>
+            <a:ext cx="0" cy="263547"/>
+          </a:xfrm>
+          <a:prstGeom prst="straightConnector1">
+            <a:avLst/>
+          </a:prstGeom>
+          <a:ln w="28575">
+            <a:solidFill>
+              <a:schemeClr val="accent5">
+                <a:lumMod val="75000"/>
+              </a:schemeClr>
+            </a:solidFill>
+            <a:tailEnd type="triangle"/>
+          </a:ln>
+        </p:spPr>
+        <p:style>
+          <a:lnRef idx="2">
+            <a:schemeClr val="accent1"/>
+          </a:lnRef>
+          <a:fillRef idx="0">
+            <a:schemeClr val="accent1"/>
+          </a:fillRef>
+          <a:effectRef idx="1">
+            <a:schemeClr val="accent1"/>
+          </a:effectRef>
+          <a:fontRef idx="minor">
+            <a:schemeClr val="tx1"/>
+          </a:fontRef>
+        </p:style>
+      </p:cxnSp>
+      <p:cxnSp>
+        <p:nvCxnSpPr>
+          <p:cNvPr id="125" name="Straight Arrow Connector 124">
+            <a:extLst>
+              <a:ext uri="{FF2B5EF4-FFF2-40B4-BE49-F238E27FC236}">
+                <a16:creationId xmlns:a16="http://schemas.microsoft.com/office/drawing/2014/main" id="{5EB54E9A-C865-2255-E564-95BB4851FC26}"/>
+              </a:ext>
+            </a:extLst>
+          </p:cNvPr>
+          <p:cNvCxnSpPr>
+            <a:cxnSpLocks/>
+          </p:cNvCxnSpPr>
+          <p:nvPr/>
+        </p:nvCxnSpPr>
+        <p:spPr>
+          <a:xfrm>
+            <a:off x="5446741" y="4793303"/>
+            <a:ext cx="0" cy="263547"/>
+          </a:xfrm>
+          <a:prstGeom prst="straightConnector1">
+            <a:avLst/>
+          </a:prstGeom>
+          <a:ln w="28575">
+            <a:solidFill>
+              <a:schemeClr val="accent5">
+                <a:lumMod val="75000"/>
+              </a:schemeClr>
+            </a:solidFill>
+            <a:tailEnd type="triangle"/>
+          </a:ln>
+        </p:spPr>
+        <p:style>
+          <a:lnRef idx="2">
+            <a:schemeClr val="accent1"/>
+          </a:lnRef>
+          <a:fillRef idx="0">
+            <a:schemeClr val="accent1"/>
+          </a:fillRef>
+          <a:effectRef idx="1">
+            <a:schemeClr val="accent1"/>
+          </a:effectRef>
+          <a:fontRef idx="minor">
+            <a:schemeClr val="tx1"/>
+          </a:fontRef>
+        </p:style>
+      </p:cxnSp>
+      <p:cxnSp>
+        <p:nvCxnSpPr>
+          <p:cNvPr id="126" name="Straight Arrow Connector 125">
+            <a:extLst>
+              <a:ext uri="{FF2B5EF4-FFF2-40B4-BE49-F238E27FC236}">
+                <a16:creationId xmlns:a16="http://schemas.microsoft.com/office/drawing/2014/main" id="{AEA373AB-6697-76A5-4B1B-9D19A34E5367}"/>
+              </a:ext>
+            </a:extLst>
+          </p:cNvPr>
+          <p:cNvCxnSpPr>
+            <a:cxnSpLocks/>
+          </p:cNvCxnSpPr>
+          <p:nvPr/>
+        </p:nvCxnSpPr>
+        <p:spPr>
+          <a:xfrm>
+            <a:off x="6923019" y="4790592"/>
+            <a:ext cx="0" cy="263547"/>
+          </a:xfrm>
+          <a:prstGeom prst="straightConnector1">
+            <a:avLst/>
+          </a:prstGeom>
+          <a:ln w="28575">
+            <a:solidFill>
+              <a:schemeClr val="accent5">
+                <a:lumMod val="75000"/>
+              </a:schemeClr>
+            </a:solidFill>
+            <a:tailEnd type="triangle"/>
+          </a:ln>
+        </p:spPr>
+        <p:style>
+          <a:lnRef idx="2">
+            <a:schemeClr val="accent1"/>
+          </a:lnRef>
+          <a:fillRef idx="0">
+            <a:schemeClr val="accent1"/>
+          </a:fillRef>
+          <a:effectRef idx="1">
+            <a:schemeClr val="accent1"/>
+          </a:effectRef>
+          <a:fontRef idx="minor">
+            <a:schemeClr val="tx1"/>
+          </a:fontRef>
+        </p:style>
+      </p:cxnSp>
+      <p:sp>
+        <p:nvSpPr>
+          <p:cNvPr id="128" name="TextBox 127">
+            <a:extLst>
+              <a:ext uri="{FF2B5EF4-FFF2-40B4-BE49-F238E27FC236}">
+                <a16:creationId xmlns:a16="http://schemas.microsoft.com/office/drawing/2014/main" id="{0A47FCE4-55CC-2787-5D87-BE39554B1C97}"/>
+              </a:ext>
+            </a:extLst>
+          </p:cNvPr>
+          <p:cNvSpPr txBox="1"/>
+          <p:nvPr/>
+        </p:nvSpPr>
+        <p:spPr>
+          <a:xfrm>
+            <a:off x="1720318" y="4753089"/>
+            <a:ext cx="3362559" cy="338554"/>
+          </a:xfrm>
+          <a:prstGeom prst="rect">
+            <a:avLst/>
+          </a:prstGeom>
+          <a:noFill/>
+        </p:spPr>
+        <p:txBody>
+          <a:bodyPr wrap="square" rtlCol="0">
+            <a:spAutoFit/>
+          </a:bodyPr>
+          <a:lstStyle/>
+          <a:p>
+            <a:r>
+              <a:rPr lang="en-SG" sz="1600" b="1" dirty="0"/>
+              <a:t>Multi-Cameras View Dashboards </a:t>
+            </a:r>
+          </a:p>
+        </p:txBody>
+      </p:sp>
+      <p:cxnSp>
+        <p:nvCxnSpPr>
+          <p:cNvPr id="130" name="Straight Connector 129">
+            <a:extLst>
+              <a:ext uri="{FF2B5EF4-FFF2-40B4-BE49-F238E27FC236}">
+                <a16:creationId xmlns:a16="http://schemas.microsoft.com/office/drawing/2014/main" id="{DB31B2A4-443E-4BB5-0844-B72D12BBB39D}"/>
+              </a:ext>
+            </a:extLst>
+          </p:cNvPr>
+          <p:cNvCxnSpPr>
+            <a:cxnSpLocks/>
+          </p:cNvCxnSpPr>
+          <p:nvPr/>
+        </p:nvCxnSpPr>
+        <p:spPr>
+          <a:xfrm flipH="1">
+            <a:off x="8040183" y="1966934"/>
+            <a:ext cx="3341" cy="3923461"/>
+          </a:xfrm>
+          <a:prstGeom prst="line">
+            <a:avLst/>
+          </a:prstGeom>
+          <a:ln w="28575">
+            <a:solidFill>
+              <a:schemeClr val="accent2">
+                <a:lumMod val="75000"/>
+              </a:schemeClr>
+            </a:solidFill>
+          </a:ln>
+        </p:spPr>
+        <p:style>
+          <a:lnRef idx="2">
+            <a:schemeClr val="accent1"/>
+          </a:lnRef>
+          <a:fillRef idx="0">
+            <a:schemeClr val="accent1"/>
+          </a:fillRef>
+          <a:effectRef idx="1">
+            <a:schemeClr val="accent1"/>
+          </a:effectRef>
+          <a:fontRef idx="minor">
+            <a:schemeClr val="tx1"/>
+          </a:fontRef>
+        </p:style>
+      </p:cxnSp>
+      <p:cxnSp>
+        <p:nvCxnSpPr>
+          <p:cNvPr id="134" name="Straight Arrow Connector 133">
+            <a:extLst>
+              <a:ext uri="{FF2B5EF4-FFF2-40B4-BE49-F238E27FC236}">
+                <a16:creationId xmlns:a16="http://schemas.microsoft.com/office/drawing/2014/main" id="{889C8A31-BD69-1A4F-A8E9-7BE0A26FA651}"/>
+              </a:ext>
+            </a:extLst>
+          </p:cNvPr>
+          <p:cNvCxnSpPr>
+            <a:cxnSpLocks/>
+          </p:cNvCxnSpPr>
+          <p:nvPr/>
+        </p:nvCxnSpPr>
+        <p:spPr>
+          <a:xfrm>
+            <a:off x="8038956" y="1973370"/>
+            <a:ext cx="330085" cy="0"/>
+          </a:xfrm>
+          <a:prstGeom prst="straightConnector1">
+            <a:avLst/>
+          </a:prstGeom>
+          <a:ln w="28575">
+            <a:solidFill>
+              <a:schemeClr val="accent2">
+                <a:lumMod val="75000"/>
+              </a:schemeClr>
+            </a:solidFill>
+            <a:tailEnd type="triangle"/>
+          </a:ln>
+        </p:spPr>
+        <p:style>
+          <a:lnRef idx="2">
+            <a:schemeClr val="accent1"/>
+          </a:lnRef>
+          <a:fillRef idx="0">
+            <a:schemeClr val="accent1"/>
+          </a:fillRef>
+          <a:effectRef idx="1">
+            <a:schemeClr val="accent1"/>
+          </a:effectRef>
+          <a:fontRef idx="minor">
+            <a:schemeClr val="tx1"/>
+          </a:fontRef>
+        </p:style>
+      </p:cxnSp>
+      <p:cxnSp>
+        <p:nvCxnSpPr>
+          <p:cNvPr id="137" name="Straight Arrow Connector 136">
+            <a:extLst>
+              <a:ext uri="{FF2B5EF4-FFF2-40B4-BE49-F238E27FC236}">
+                <a16:creationId xmlns:a16="http://schemas.microsoft.com/office/drawing/2014/main" id="{0D73B076-3069-5495-C783-73B19C71DEA9}"/>
+              </a:ext>
+            </a:extLst>
+          </p:cNvPr>
+          <p:cNvCxnSpPr>
+            <a:cxnSpLocks/>
+          </p:cNvCxnSpPr>
+          <p:nvPr/>
+        </p:nvCxnSpPr>
+        <p:spPr>
+          <a:xfrm>
+            <a:off x="8035771" y="3614321"/>
+            <a:ext cx="330085" cy="0"/>
+          </a:xfrm>
+          <a:prstGeom prst="straightConnector1">
+            <a:avLst/>
+          </a:prstGeom>
+          <a:ln w="28575">
+            <a:solidFill>
+              <a:schemeClr val="accent2">
+                <a:lumMod val="75000"/>
+              </a:schemeClr>
+            </a:solidFill>
+            <a:tailEnd type="triangle"/>
+          </a:ln>
+        </p:spPr>
+        <p:style>
+          <a:lnRef idx="2">
+            <a:schemeClr val="accent1"/>
+          </a:lnRef>
+          <a:fillRef idx="0">
+            <a:schemeClr val="accent1"/>
+          </a:fillRef>
+          <a:effectRef idx="1">
+            <a:schemeClr val="accent1"/>
+          </a:effectRef>
+          <a:fontRef idx="minor">
+            <a:schemeClr val="tx1"/>
+          </a:fontRef>
+        </p:style>
+      </p:cxnSp>
+      <p:cxnSp>
+        <p:nvCxnSpPr>
+          <p:cNvPr id="138" name="Straight Arrow Connector 137">
+            <a:extLst>
+              <a:ext uri="{FF2B5EF4-FFF2-40B4-BE49-F238E27FC236}">
+                <a16:creationId xmlns:a16="http://schemas.microsoft.com/office/drawing/2014/main" id="{2B8663B6-06CF-2EC0-3900-9F721863CA3C}"/>
+              </a:ext>
+            </a:extLst>
+          </p:cNvPr>
+          <p:cNvCxnSpPr>
+            <a:cxnSpLocks/>
+          </p:cNvCxnSpPr>
+          <p:nvPr/>
+        </p:nvCxnSpPr>
+        <p:spPr>
+          <a:xfrm>
+            <a:off x="8035770" y="5876469"/>
+            <a:ext cx="330085" cy="0"/>
+          </a:xfrm>
+          <a:prstGeom prst="straightConnector1">
+            <a:avLst/>
+          </a:prstGeom>
+          <a:ln w="28575">
+            <a:solidFill>
+              <a:schemeClr val="accent2">
+                <a:lumMod val="75000"/>
+              </a:schemeClr>
+            </a:solidFill>
+            <a:tailEnd type="triangle"/>
+          </a:ln>
+        </p:spPr>
+        <p:style>
+          <a:lnRef idx="2">
+            <a:schemeClr val="accent1"/>
+          </a:lnRef>
+          <a:fillRef idx="0">
+            <a:schemeClr val="accent1"/>
+          </a:fillRef>
+          <a:effectRef idx="1">
+            <a:schemeClr val="accent1"/>
+          </a:effectRef>
+          <a:fontRef idx="minor">
+            <a:schemeClr val="tx1"/>
+          </a:fontRef>
+        </p:style>
+      </p:cxnSp>
+      <p:sp>
+        <p:nvSpPr>
+          <p:cNvPr id="145" name="TextBox 144">
+            <a:extLst>
+              <a:ext uri="{FF2B5EF4-FFF2-40B4-BE49-F238E27FC236}">
+                <a16:creationId xmlns:a16="http://schemas.microsoft.com/office/drawing/2014/main" id="{6C1369B3-9BB5-AFDA-48B5-251AE80A3CE5}"/>
+              </a:ext>
+            </a:extLst>
+          </p:cNvPr>
+          <p:cNvSpPr txBox="1"/>
+          <p:nvPr/>
+        </p:nvSpPr>
+        <p:spPr>
+          <a:xfrm>
+            <a:off x="1475616" y="535676"/>
+            <a:ext cx="6560154" cy="461665"/>
+          </a:xfrm>
+          <a:prstGeom prst="rect">
+            <a:avLst/>
+          </a:prstGeom>
+          <a:noFill/>
+          <a:ln w="19050">
+            <a:solidFill>
+              <a:schemeClr val="tx1"/>
+            </a:solidFill>
+            <a:prstDash val="sysDash"/>
+          </a:ln>
+        </p:spPr>
+        <p:txBody>
+          <a:bodyPr wrap="square" rtlCol="0">
+            <a:spAutoFit/>
+          </a:bodyPr>
+          <a:lstStyle/>
+          <a:p>
+            <a:r>
+              <a:rPr lang="en-US" sz="2400" b="1" dirty="0"/>
+              <a:t>Python Virtual Motion-JPEG Camera Simulator</a:t>
+            </a:r>
+            <a:endParaRPr lang="en-SG" sz="2400" b="1" dirty="0"/>
+          </a:p>
+        </p:txBody>
+      </p:sp>
+      <p:pic>
+        <p:nvPicPr>
+          <p:cNvPr id="148" name="Picture 147" descr="A logo for a computer&#10;&#10;AI-generated content may be incorrect.">
+            <a:extLst>
+              <a:ext uri="{FF2B5EF4-FFF2-40B4-BE49-F238E27FC236}">
+                <a16:creationId xmlns:a16="http://schemas.microsoft.com/office/drawing/2014/main" id="{1694D07B-D88A-5AC3-0FA8-0F3E955E2419}"/>
+              </a:ext>
+            </a:extLst>
+          </p:cNvPr>
+          <p:cNvPicPr>
+            <a:picLocks noChangeAspect="1"/>
+          </p:cNvPicPr>
+          <p:nvPr/>
+        </p:nvPicPr>
+        <p:blipFill>
+          <a:blip r:embed="rId16">
+            <a:extLst>
+              <a:ext uri="{28A0092B-C50C-407E-A947-70E740481C1C}">
+                <a14:useLocalDpi xmlns:a14="http://schemas.microsoft.com/office/drawing/2010/main" val="0"/>
+              </a:ext>
+            </a:extLst>
+          </a:blip>
+          <a:stretch>
+            <a:fillRect/>
+          </a:stretch>
+        </p:blipFill>
+        <p:spPr>
+          <a:xfrm>
+            <a:off x="497432" y="499810"/>
+            <a:ext cx="928809" cy="529421"/>
+          </a:xfrm>
+          <a:prstGeom prst="rect">
+            <a:avLst/>
+          </a:prstGeom>
+        </p:spPr>
+      </p:pic>
+    </p:spTree>
+    <p:extLst>
+      <p:ext uri="{BB962C8B-B14F-4D97-AF65-F5344CB8AC3E}">
+        <p14:creationId xmlns:p14="http://schemas.microsoft.com/office/powerpoint/2010/main" val="254456563"/>
       </p:ext>
     </p:extLst>
   </p:cSld>
@@ -8428,4 +11460,319 @@
     </a:ext>
   </a:extLst>
 </a:theme>
+</file>
+
+<file path=ppt/theme/theme2.xml><?xml version="1.0" encoding="utf-8"?>
+<a:theme xmlns:a="http://schemas.openxmlformats.org/drawingml/2006/main" name="Office Theme">
+  <a:themeElements>
+    <a:clrScheme name="Office">
+      <a:dk1>
+        <a:sysClr val="windowText" lastClr="000000"/>
+      </a:dk1>
+      <a:lt1>
+        <a:sysClr val="window" lastClr="FFFFFF"/>
+      </a:lt1>
+      <a:dk2>
+        <a:srgbClr val="0E2841"/>
+      </a:dk2>
+      <a:lt2>
+        <a:srgbClr val="E8E8E8"/>
+      </a:lt2>
+      <a:accent1>
+        <a:srgbClr val="156082"/>
+      </a:accent1>
+      <a:accent2>
+        <a:srgbClr val="E97132"/>
+      </a:accent2>
+      <a:accent3>
+        <a:srgbClr val="196B24"/>
+      </a:accent3>
+      <a:accent4>
+        <a:srgbClr val="0F9ED5"/>
+      </a:accent4>
+      <a:accent5>
+        <a:srgbClr val="A02B93"/>
+      </a:accent5>
+      <a:accent6>
+        <a:srgbClr val="4EA72E"/>
+      </a:accent6>
+      <a:hlink>
+        <a:srgbClr val="467886"/>
+      </a:hlink>
+      <a:folHlink>
+        <a:srgbClr val="96607D"/>
+      </a:folHlink>
+    </a:clrScheme>
+    <a:fontScheme name="Office">
+      <a:majorFont>
+        <a:latin typeface="Aptos Display" panose="02110004020202020204"/>
+        <a:ea typeface=""/>
+        <a:cs typeface=""/>
+        <a:font script="Jpan" typeface="游ゴシック Light"/>
+        <a:font script="Hang" typeface="맑은 고딕"/>
+        <a:font script="Hans" typeface="等线 Light"/>
+        <a:font script="Hant" typeface="新細明體"/>
+        <a:font script="Arab" typeface="Times New Roman"/>
+        <a:font script="Hebr" typeface="Times New Roman"/>
+        <a:font script="Thai" typeface="Angsana New"/>
+        <a:font script="Ethi" typeface="Nyala"/>
+        <a:font script="Beng" typeface="Vrinda"/>
+        <a:font script="Gujr" typeface="Shruti"/>
+        <a:font script="Khmr" typeface="MoolBoran"/>
+        <a:font script="Knda" typeface="Tunga"/>
+        <a:font script="Guru" typeface="Raavi"/>
+        <a:font script="Cans" typeface="Euphemia"/>
+        <a:font script="Cher" typeface="Plantagenet Cherokee"/>
+        <a:font script="Yiii" typeface="Microsoft Yi Baiti"/>
+        <a:font script="Tibt" typeface="Microsoft Himalaya"/>
+        <a:font script="Thaa" typeface="MV Boli"/>
+        <a:font script="Deva" typeface="Mangal"/>
+        <a:font script="Telu" typeface="Gautami"/>
+        <a:font script="Taml" typeface="Latha"/>
+        <a:font script="Syrc" typeface="Estrangelo Edessa"/>
+        <a:font script="Orya" typeface="Kalinga"/>
+        <a:font script="Mlym" typeface="Kartika"/>
+        <a:font script="Laoo" typeface="DokChampa"/>
+        <a:font script="Sinh" typeface="Iskoola Pota"/>
+        <a:font script="Mong" typeface="Mongolian Baiti"/>
+        <a:font script="Viet" typeface="Times New Roman"/>
+        <a:font script="Uigh" typeface="Microsoft Uighur"/>
+        <a:font script="Geor" typeface="Sylfaen"/>
+        <a:font script="Armn" typeface="Arial"/>
+        <a:font script="Bugi" typeface="Leelawadee UI"/>
+        <a:font script="Bopo" typeface="Microsoft JhengHei"/>
+        <a:font script="Java" typeface="Javanese Text"/>
+        <a:font script="Lisu" typeface="Segoe UI"/>
+        <a:font script="Mymr" typeface="Myanmar Text"/>
+        <a:font script="Nkoo" typeface="Ebrima"/>
+        <a:font script="Olck" typeface="Nirmala UI"/>
+        <a:font script="Osma" typeface="Ebrima"/>
+        <a:font script="Phag" typeface="Phagspa"/>
+        <a:font script="Syrn" typeface="Estrangelo Edessa"/>
+        <a:font script="Syrj" typeface="Estrangelo Edessa"/>
+        <a:font script="Syre" typeface="Estrangelo Edessa"/>
+        <a:font script="Sora" typeface="Nirmala UI"/>
+        <a:font script="Tale" typeface="Microsoft Tai Le"/>
+        <a:font script="Talu" typeface="Microsoft New Tai Lue"/>
+        <a:font script="Tfng" typeface="Ebrima"/>
+      </a:majorFont>
+      <a:minorFont>
+        <a:latin typeface="Aptos" panose="02110004020202020204"/>
+        <a:ea typeface=""/>
+        <a:cs typeface=""/>
+        <a:font script="Jpan" typeface="游ゴシック"/>
+        <a:font script="Hang" typeface="맑은 고딕"/>
+        <a:font script="Hans" typeface="等线"/>
+        <a:font script="Hant" typeface="新細明體"/>
+        <a:font script="Arab" typeface="Arial"/>
+        <a:font script="Hebr" typeface="Arial"/>
+        <a:font script="Thai" typeface="Cordia New"/>
+        <a:font script="Ethi" typeface="Nyala"/>
+        <a:font script="Beng" typeface="Vrinda"/>
+        <a:font script="Gujr" typeface="Shruti"/>
+        <a:font script="Khmr" typeface="DaunPenh"/>
+        <a:font script="Knda" typeface="Tunga"/>
+        <a:font script="Guru" typeface="Raavi"/>
+        <a:font script="Cans" typeface="Euphemia"/>
+        <a:font script="Cher" typeface="Plantagenet Cherokee"/>
+        <a:font script="Yiii" typeface="Microsoft Yi Baiti"/>
+        <a:font script="Tibt" typeface="Microsoft Himalaya"/>
+        <a:font script="Thaa" typeface="MV Boli"/>
+        <a:font script="Deva" typeface="Mangal"/>
+        <a:font script="Telu" typeface="Gautami"/>
+        <a:font script="Taml" typeface="Latha"/>
+        <a:font script="Syrc" typeface="Estrangelo Edessa"/>
+        <a:font script="Orya" typeface="Kalinga"/>
+        <a:font script="Mlym" typeface="Kartika"/>
+        <a:font script="Laoo" typeface="DokChampa"/>
+        <a:font script="Sinh" typeface="Iskoola Pota"/>
+        <a:font script="Mong" typeface="Mongolian Baiti"/>
+        <a:font script="Viet" typeface="Arial"/>
+        <a:font script="Uigh" typeface="Microsoft Uighur"/>
+        <a:font script="Geor" typeface="Sylfaen"/>
+        <a:font script="Armn" typeface="Arial"/>
+        <a:font script="Bugi" typeface="Leelawadee UI"/>
+        <a:font script="Bopo" typeface="Microsoft JhengHei"/>
+        <a:font script="Java" typeface="Javanese Text"/>
+        <a:font script="Lisu" typeface="Segoe UI"/>
+        <a:font script="Mymr" typeface="Myanmar Text"/>
+        <a:font script="Nkoo" typeface="Ebrima"/>
+        <a:font script="Olck" typeface="Nirmala UI"/>
+        <a:font script="Osma" typeface="Ebrima"/>
+        <a:font script="Phag" typeface="Phagspa"/>
+        <a:font script="Syrn" typeface="Estrangelo Edessa"/>
+        <a:font script="Syrj" typeface="Estrangelo Edessa"/>
+        <a:font script="Syre" typeface="Estrangelo Edessa"/>
+        <a:font script="Sora" typeface="Nirmala UI"/>
+        <a:font script="Tale" typeface="Microsoft Tai Le"/>
+        <a:font script="Talu" typeface="Microsoft New Tai Lue"/>
+        <a:font script="Tfng" typeface="Ebrima"/>
+      </a:minorFont>
+    </a:fontScheme>
+    <a:fmtScheme name="Office">
+      <a:fillStyleLst>
+        <a:solidFill>
+          <a:schemeClr val="phClr"/>
+        </a:solidFill>
+        <a:gradFill rotWithShape="1">
+          <a:gsLst>
+            <a:gs pos="0">
+              <a:schemeClr val="phClr">
+                <a:lumMod val="110000"/>
+                <a:satMod val="105000"/>
+                <a:tint val="67000"/>
+              </a:schemeClr>
+            </a:gs>
+            <a:gs pos="50000">
+              <a:schemeClr val="phClr">
+                <a:lumMod val="105000"/>
+                <a:satMod val="103000"/>
+                <a:tint val="73000"/>
+              </a:schemeClr>
+            </a:gs>
+            <a:gs pos="100000">
+              <a:schemeClr val="phClr">
+                <a:lumMod val="105000"/>
+                <a:satMod val="109000"/>
+                <a:tint val="81000"/>
+              </a:schemeClr>
+            </a:gs>
+          </a:gsLst>
+          <a:lin ang="5400000" scaled="0"/>
+        </a:gradFill>
+        <a:gradFill rotWithShape="1">
+          <a:gsLst>
+            <a:gs pos="0">
+              <a:schemeClr val="phClr">
+                <a:satMod val="103000"/>
+                <a:lumMod val="102000"/>
+                <a:tint val="94000"/>
+              </a:schemeClr>
+            </a:gs>
+            <a:gs pos="50000">
+              <a:schemeClr val="phClr">
+                <a:satMod val="110000"/>
+                <a:lumMod val="100000"/>
+                <a:shade val="100000"/>
+              </a:schemeClr>
+            </a:gs>
+            <a:gs pos="100000">
+              <a:schemeClr val="phClr">
+                <a:lumMod val="99000"/>
+                <a:satMod val="120000"/>
+                <a:shade val="78000"/>
+              </a:schemeClr>
+            </a:gs>
+          </a:gsLst>
+          <a:lin ang="5400000" scaled="0"/>
+        </a:gradFill>
+      </a:fillStyleLst>
+      <a:lnStyleLst>
+        <a:ln w="12700" cap="flat" cmpd="sng" algn="ctr">
+          <a:solidFill>
+            <a:schemeClr val="phClr"/>
+          </a:solidFill>
+          <a:prstDash val="solid"/>
+          <a:miter lim="800000"/>
+        </a:ln>
+        <a:ln w="19050" cap="flat" cmpd="sng" algn="ctr">
+          <a:solidFill>
+            <a:schemeClr val="phClr"/>
+          </a:solidFill>
+          <a:prstDash val="solid"/>
+          <a:miter lim="800000"/>
+        </a:ln>
+        <a:ln w="25400" cap="flat" cmpd="sng" algn="ctr">
+          <a:solidFill>
+            <a:schemeClr val="phClr"/>
+          </a:solidFill>
+          <a:prstDash val="solid"/>
+          <a:miter lim="800000"/>
+        </a:ln>
+      </a:lnStyleLst>
+      <a:effectStyleLst>
+        <a:effectStyle>
+          <a:effectLst/>
+        </a:effectStyle>
+        <a:effectStyle>
+          <a:effectLst/>
+        </a:effectStyle>
+        <a:effectStyle>
+          <a:effectLst>
+            <a:outerShdw blurRad="57150" dist="19050" dir="5400000" algn="ctr" rotWithShape="0">
+              <a:srgbClr val="000000">
+                <a:alpha val="63000"/>
+              </a:srgbClr>
+            </a:outerShdw>
+          </a:effectLst>
+        </a:effectStyle>
+      </a:effectStyleLst>
+      <a:bgFillStyleLst>
+        <a:solidFill>
+          <a:schemeClr val="phClr"/>
+        </a:solidFill>
+        <a:solidFill>
+          <a:schemeClr val="phClr">
+            <a:tint val="95000"/>
+            <a:satMod val="170000"/>
+          </a:schemeClr>
+        </a:solidFill>
+        <a:gradFill rotWithShape="1">
+          <a:gsLst>
+            <a:gs pos="0">
+              <a:schemeClr val="phClr">
+                <a:tint val="93000"/>
+                <a:satMod val="150000"/>
+                <a:shade val="98000"/>
+                <a:lumMod val="102000"/>
+              </a:schemeClr>
+            </a:gs>
+            <a:gs pos="50000">
+              <a:schemeClr val="phClr">
+                <a:tint val="98000"/>
+                <a:satMod val="130000"/>
+                <a:shade val="90000"/>
+                <a:lumMod val="103000"/>
+              </a:schemeClr>
+            </a:gs>
+            <a:gs pos="100000">
+              <a:schemeClr val="phClr">
+                <a:shade val="63000"/>
+                <a:satMod val="120000"/>
+              </a:schemeClr>
+            </a:gs>
+          </a:gsLst>
+          <a:lin ang="5400000" scaled="0"/>
+        </a:gradFill>
+      </a:bgFillStyleLst>
+    </a:fmtScheme>
+  </a:themeElements>
+  <a:objectDefaults>
+    <a:lnDef>
+      <a:spPr/>
+      <a:bodyPr/>
+      <a:lstStyle/>
+      <a:style>
+        <a:lnRef idx="2">
+          <a:schemeClr val="accent1"/>
+        </a:lnRef>
+        <a:fillRef idx="0">
+          <a:schemeClr val="accent1"/>
+        </a:fillRef>
+        <a:effectRef idx="1">
+          <a:schemeClr val="accent1"/>
+        </a:effectRef>
+        <a:fontRef idx="minor">
+          <a:schemeClr val="tx1"/>
+        </a:fontRef>
+      </a:style>
+    </a:lnDef>
+  </a:objectDefaults>
+  <a:extraClrSchemeLst/>
+  <a:extLst>
+    <a:ext uri="{05A4C25C-085E-4340-85A3-A5531E510DB2}">
+      <thm15:themeFamily xmlns:thm15="http://schemas.microsoft.com/office/thememl/2012/main" name="Office Theme" id="{2E142A2C-CD16-42D6-873A-C26D2A0506FA}" vid="{1BDDFF52-6CD6-40A5-AB3C-68EB2F1E4D0A}"/>
+    </a:ext>
+  </a:extLst>
+</a:theme>
 </file>
</xml_diff>

<commit_message>
Update image, design document and fix typo error.
</commit_message>
<xml_diff>
--- a/doc/designDoc.pptx
+++ b/doc/designDoc.pptx
@@ -5,14 +5,15 @@
     <p:sldMasterId id="2147483648" r:id="rId1"/>
   </p:sldMasterIdLst>
   <p:notesMasterIdLst>
-    <p:notesMasterId r:id="rId7"/>
+    <p:notesMasterId r:id="rId8"/>
   </p:notesMasterIdLst>
   <p:sldIdLst>
     <p:sldId id="259" r:id="rId2"/>
-    <p:sldId id="256" r:id="rId3"/>
-    <p:sldId id="257" r:id="rId4"/>
-    <p:sldId id="258" r:id="rId5"/>
-    <p:sldId id="260" r:id="rId6"/>
+    <p:sldId id="261" r:id="rId3"/>
+    <p:sldId id="256" r:id="rId4"/>
+    <p:sldId id="257" r:id="rId5"/>
+    <p:sldId id="258" r:id="rId6"/>
+    <p:sldId id="260" r:id="rId7"/>
   </p:sldIdLst>
   <p:sldSz cx="12192000" cy="6858000"/>
   <p:notesSz cx="6858000" cy="9144000"/>
@@ -201,7 +202,7 @@
           <a:p>
             <a:fld id="{331DA7F3-37F6-4775-B33A-057A4C6ECEA9}" type="datetimeFigureOut">
               <a:rPr lang="en-SG" smtClean="0"/>
-              <a:t>7/11/2025</a:t>
+              <a:t>9/11/2025</a:t>
             </a:fld>
             <a:endParaRPr lang="en-SG"/>
           </a:p>
@@ -534,7 +535,7 @@
           <a:p>
             <a:fld id="{A19A0857-F9BC-425A-8965-650C0EAEF37B}" type="slidenum">
               <a:rPr lang="en-SG" smtClean="0"/>
-              <a:t>5</a:t>
+              <a:t>6</a:t>
             </a:fld>
             <a:endParaRPr lang="en-SG"/>
           </a:p>
@@ -702,7 +703,7 @@
           <a:p>
             <a:fld id="{E61142BF-0A62-477F-BD0D-B122876D5D2E}" type="datetimeFigureOut">
               <a:rPr lang="en-SG" smtClean="0"/>
-              <a:t>7/11/2025</a:t>
+              <a:t>9/11/2025</a:t>
             </a:fld>
             <a:endParaRPr lang="en-SG"/>
           </a:p>
@@ -902,7 +903,7 @@
           <a:p>
             <a:fld id="{E61142BF-0A62-477F-BD0D-B122876D5D2E}" type="datetimeFigureOut">
               <a:rPr lang="en-SG" smtClean="0"/>
-              <a:t>7/11/2025</a:t>
+              <a:t>9/11/2025</a:t>
             </a:fld>
             <a:endParaRPr lang="en-SG"/>
           </a:p>
@@ -1112,7 +1113,7 @@
           <a:p>
             <a:fld id="{E61142BF-0A62-477F-BD0D-B122876D5D2E}" type="datetimeFigureOut">
               <a:rPr lang="en-SG" smtClean="0"/>
-              <a:t>7/11/2025</a:t>
+              <a:t>9/11/2025</a:t>
             </a:fld>
             <a:endParaRPr lang="en-SG"/>
           </a:p>
@@ -1312,7 +1313,7 @@
           <a:p>
             <a:fld id="{E61142BF-0A62-477F-BD0D-B122876D5D2E}" type="datetimeFigureOut">
               <a:rPr lang="en-SG" smtClean="0"/>
-              <a:t>7/11/2025</a:t>
+              <a:t>9/11/2025</a:t>
             </a:fld>
             <a:endParaRPr lang="en-SG"/>
           </a:p>
@@ -1588,7 +1589,7 @@
           <a:p>
             <a:fld id="{E61142BF-0A62-477F-BD0D-B122876D5D2E}" type="datetimeFigureOut">
               <a:rPr lang="en-SG" smtClean="0"/>
-              <a:t>7/11/2025</a:t>
+              <a:t>9/11/2025</a:t>
             </a:fld>
             <a:endParaRPr lang="en-SG"/>
           </a:p>
@@ -1856,7 +1857,7 @@
           <a:p>
             <a:fld id="{E61142BF-0A62-477F-BD0D-B122876D5D2E}" type="datetimeFigureOut">
               <a:rPr lang="en-SG" smtClean="0"/>
-              <a:t>7/11/2025</a:t>
+              <a:t>9/11/2025</a:t>
             </a:fld>
             <a:endParaRPr lang="en-SG"/>
           </a:p>
@@ -2271,7 +2272,7 @@
           <a:p>
             <a:fld id="{E61142BF-0A62-477F-BD0D-B122876D5D2E}" type="datetimeFigureOut">
               <a:rPr lang="en-SG" smtClean="0"/>
-              <a:t>7/11/2025</a:t>
+              <a:t>9/11/2025</a:t>
             </a:fld>
             <a:endParaRPr lang="en-SG"/>
           </a:p>
@@ -2413,7 +2414,7 @@
           <a:p>
             <a:fld id="{E61142BF-0A62-477F-BD0D-B122876D5D2E}" type="datetimeFigureOut">
               <a:rPr lang="en-SG" smtClean="0"/>
-              <a:t>7/11/2025</a:t>
+              <a:t>9/11/2025</a:t>
             </a:fld>
             <a:endParaRPr lang="en-SG"/>
           </a:p>
@@ -2526,7 +2527,7 @@
           <a:p>
             <a:fld id="{E61142BF-0A62-477F-BD0D-B122876D5D2E}" type="datetimeFigureOut">
               <a:rPr lang="en-SG" smtClean="0"/>
-              <a:t>7/11/2025</a:t>
+              <a:t>9/11/2025</a:t>
             </a:fld>
             <a:endParaRPr lang="en-SG"/>
           </a:p>
@@ -2839,7 +2840,7 @@
           <a:p>
             <a:fld id="{E61142BF-0A62-477F-BD0D-B122876D5D2E}" type="datetimeFigureOut">
               <a:rPr lang="en-SG" smtClean="0"/>
-              <a:t>7/11/2025</a:t>
+              <a:t>9/11/2025</a:t>
             </a:fld>
             <a:endParaRPr lang="en-SG"/>
           </a:p>
@@ -3128,7 +3129,7 @@
           <a:p>
             <a:fld id="{E61142BF-0A62-477F-BD0D-B122876D5D2E}" type="datetimeFigureOut">
               <a:rPr lang="en-SG" smtClean="0"/>
-              <a:t>7/11/2025</a:t>
+              <a:t>9/11/2025</a:t>
             </a:fld>
             <a:endParaRPr lang="en-SG"/>
           </a:p>
@@ -3371,7 +3372,7 @@
           <a:p>
             <a:fld id="{E61142BF-0A62-477F-BD0D-B122876D5D2E}" type="datetimeFigureOut">
               <a:rPr lang="en-SG" smtClean="0"/>
-              <a:t>7/11/2025</a:t>
+              <a:t>9/11/2025</a:t>
             </a:fld>
             <a:endParaRPr lang="en-SG"/>
           </a:p>
@@ -3918,121 +3919,17 @@
           <a:chExt cx="0" cy="0"/>
         </a:xfrm>
       </p:grpSpPr>
-      <p:sp>
-        <p:nvSpPr>
-          <p:cNvPr id="1038" name="Rectangle 1037">
-            <a:extLst>
-              <a:ext uri="{FF2B5EF4-FFF2-40B4-BE49-F238E27FC236}">
-                <a16:creationId xmlns:a16="http://schemas.microsoft.com/office/drawing/2014/main" id="{7A72A1C1-40DB-34C3-B7B6-E74702CE1591}"/>
-              </a:ext>
-            </a:extLst>
-          </p:cNvPr>
-          <p:cNvSpPr/>
-          <p:nvPr/>
-        </p:nvSpPr>
-        <p:spPr>
-          <a:xfrm>
-            <a:off x="2742502" y="2422633"/>
-            <a:ext cx="2487368" cy="2950135"/>
-          </a:xfrm>
-          <a:prstGeom prst="rect">
-            <a:avLst/>
-          </a:prstGeom>
-          <a:solidFill>
-            <a:schemeClr val="accent2">
-              <a:lumMod val="20000"/>
-              <a:lumOff val="80000"/>
-            </a:schemeClr>
-          </a:solidFill>
-        </p:spPr>
-        <p:style>
-          <a:lnRef idx="2">
-            <a:schemeClr val="accent1">
-              <a:shade val="15000"/>
-            </a:schemeClr>
-          </a:lnRef>
-          <a:fillRef idx="1">
-            <a:schemeClr val="accent1"/>
-          </a:fillRef>
-          <a:effectRef idx="0">
-            <a:schemeClr val="accent1"/>
-          </a:effectRef>
-          <a:fontRef idx="minor">
-            <a:schemeClr val="lt1"/>
-          </a:fontRef>
-        </p:style>
-        <p:txBody>
-          <a:bodyPr rtlCol="0" anchor="ctr"/>
-          <a:lstStyle/>
-          <a:p>
-            <a:pPr algn="ctr"/>
-            <a:endParaRPr lang="en-SG" dirty="0"/>
-          </a:p>
-        </p:txBody>
-      </p:sp>
-      <p:sp>
-        <p:nvSpPr>
-          <p:cNvPr id="13" name="Rectangle 12">
-            <a:extLst>
-              <a:ext uri="{FF2B5EF4-FFF2-40B4-BE49-F238E27FC236}">
-                <a16:creationId xmlns:a16="http://schemas.microsoft.com/office/drawing/2014/main" id="{8759375A-3526-252C-A754-BE057854A791}"/>
-              </a:ext>
-            </a:extLst>
-          </p:cNvPr>
-          <p:cNvSpPr/>
-          <p:nvPr/>
-        </p:nvSpPr>
-        <p:spPr>
-          <a:xfrm>
-            <a:off x="1121383" y="627614"/>
-            <a:ext cx="9325191" cy="1244506"/>
-          </a:xfrm>
-          <a:prstGeom prst="rect">
-            <a:avLst/>
-          </a:prstGeom>
-          <a:solidFill>
-            <a:schemeClr val="accent6">
-              <a:lumMod val="20000"/>
-              <a:lumOff val="80000"/>
-            </a:schemeClr>
-          </a:solidFill>
-        </p:spPr>
-        <p:style>
-          <a:lnRef idx="2">
-            <a:schemeClr val="accent1">
-              <a:shade val="15000"/>
-            </a:schemeClr>
-          </a:lnRef>
-          <a:fillRef idx="1">
-            <a:schemeClr val="accent1"/>
-          </a:fillRef>
-          <a:effectRef idx="0">
-            <a:schemeClr val="accent1"/>
-          </a:effectRef>
-          <a:fontRef idx="minor">
-            <a:schemeClr val="lt1"/>
-          </a:fontRef>
-        </p:style>
-        <p:txBody>
-          <a:bodyPr rtlCol="0" anchor="ctr"/>
-          <a:lstStyle/>
-          <a:p>
-            <a:pPr algn="ctr"/>
-            <a:endParaRPr lang="en-SG" dirty="0"/>
-          </a:p>
-        </p:txBody>
-      </p:sp>
       <p:pic>
         <p:nvPicPr>
-          <p:cNvPr id="1026" name="Picture 2" descr="Webcam - Free computer icons">
-            <a:extLst>
-              <a:ext uri="{FF2B5EF4-FFF2-40B4-BE49-F238E27FC236}">
-                <a16:creationId xmlns:a16="http://schemas.microsoft.com/office/drawing/2014/main" id="{1893017E-457B-DA61-73CD-5AF1C2D8E18B}"/>
+          <p:cNvPr id="5" name="Picture 4" descr="A blue and white sign with black text&#10;&#10;AI-generated content may be incorrect.">
+            <a:extLst>
+              <a:ext uri="{FF2B5EF4-FFF2-40B4-BE49-F238E27FC236}">
+                <a16:creationId xmlns:a16="http://schemas.microsoft.com/office/drawing/2014/main" id="{B201AA71-0653-8E5D-3825-8A16E59BDD10}"/>
               </a:ext>
             </a:extLst>
           </p:cNvPr>
           <p:cNvPicPr>
-            <a:picLocks noChangeAspect="1" noChangeArrowheads="1"/>
+            <a:picLocks noChangeAspect="1"/>
           </p:cNvPicPr>
           <p:nvPr/>
         </p:nvPicPr>
@@ -4041,505 +3938,6 @@
             <a:extLst>
               <a:ext uri="{28A0092B-C50C-407E-A947-70E740481C1C}">
                 <a14:useLocalDpi xmlns:a14="http://schemas.microsoft.com/office/drawing/2010/main" val="0"/>
-              </a:ext>
-            </a:extLst>
-          </a:blip>
-          <a:srcRect/>
-          <a:stretch>
-            <a:fillRect/>
-          </a:stretch>
-        </p:blipFill>
-        <p:spPr bwMode="auto">
-          <a:xfrm>
-            <a:off x="1375875" y="1038236"/>
-            <a:ext cx="763929" cy="763929"/>
-          </a:xfrm>
-          <a:prstGeom prst="rect">
-            <a:avLst/>
-          </a:prstGeom>
-          <a:noFill/>
-          <a:extLst>
-            <a:ext uri="{909E8E84-426E-40DD-AFC4-6F175D3DCCD1}">
-              <a14:hiddenFill xmlns:a14="http://schemas.microsoft.com/office/drawing/2010/main">
-                <a:solidFill>
-                  <a:srgbClr val="FFFFFF"/>
-                </a:solidFill>
-              </a14:hiddenFill>
-            </a:ext>
-          </a:extLst>
-        </p:spPr>
-      </p:pic>
-      <p:sp>
-        <p:nvSpPr>
-          <p:cNvPr id="4" name="TextBox 3">
-            <a:extLst>
-              <a:ext uri="{FF2B5EF4-FFF2-40B4-BE49-F238E27FC236}">
-                <a16:creationId xmlns:a16="http://schemas.microsoft.com/office/drawing/2014/main" id="{CE539FF7-AF70-F40A-4FA9-5BE1ED00A1BF}"/>
-              </a:ext>
-            </a:extLst>
-          </p:cNvPr>
-          <p:cNvSpPr txBox="1"/>
-          <p:nvPr/>
-        </p:nvSpPr>
-        <p:spPr>
-          <a:xfrm>
-            <a:off x="1310816" y="694939"/>
-            <a:ext cx="1232810" cy="307777"/>
-          </a:xfrm>
-          <a:prstGeom prst="rect">
-            <a:avLst/>
-          </a:prstGeom>
-          <a:noFill/>
-        </p:spPr>
-        <p:txBody>
-          <a:bodyPr wrap="square">
-            <a:spAutoFit/>
-          </a:bodyPr>
-          <a:lstStyle/>
-          <a:p>
-            <a:r>
-              <a:rPr lang="en-US" sz="1400" b="1" dirty="0">
-                <a:solidFill>
-                  <a:schemeClr val="tx1">
-                    <a:lumMod val="75000"/>
-                    <a:lumOff val="25000"/>
-                  </a:schemeClr>
-                </a:solidFill>
-              </a:rPr>
-              <a:t>Real Camrea</a:t>
-            </a:r>
-            <a:endParaRPr lang="en-SG" sz="1400" b="1" dirty="0">
-              <a:solidFill>
-                <a:schemeClr val="tx1">
-                  <a:lumMod val="75000"/>
-                  <a:lumOff val="25000"/>
-                </a:schemeClr>
-              </a:solidFill>
-            </a:endParaRPr>
-          </a:p>
-        </p:txBody>
-      </p:sp>
-      <p:pic>
-        <p:nvPicPr>
-          <p:cNvPr id="6" name="Picture 5">
-            <a:extLst>
-              <a:ext uri="{FF2B5EF4-FFF2-40B4-BE49-F238E27FC236}">
-                <a16:creationId xmlns:a16="http://schemas.microsoft.com/office/drawing/2014/main" id="{D51FB2D0-AFF9-CDEF-7567-C197B48D4C90}"/>
-              </a:ext>
-            </a:extLst>
-          </p:cNvPr>
-          <p:cNvPicPr>
-            <a:picLocks noChangeAspect="1"/>
-          </p:cNvPicPr>
-          <p:nvPr/>
-        </p:nvPicPr>
-        <p:blipFill>
-          <a:blip r:embed="rId3"/>
-          <a:stretch>
-            <a:fillRect/>
-          </a:stretch>
-        </p:blipFill>
-        <p:spPr>
-          <a:xfrm>
-            <a:off x="3023900" y="1114405"/>
-            <a:ext cx="664252" cy="631449"/>
-          </a:xfrm>
-          <a:prstGeom prst="rect">
-            <a:avLst/>
-          </a:prstGeom>
-        </p:spPr>
-      </p:pic>
-      <p:sp>
-        <p:nvSpPr>
-          <p:cNvPr id="7" name="TextBox 6">
-            <a:extLst>
-              <a:ext uri="{FF2B5EF4-FFF2-40B4-BE49-F238E27FC236}">
-                <a16:creationId xmlns:a16="http://schemas.microsoft.com/office/drawing/2014/main" id="{B0C26ADD-BCF5-082F-67C0-8BC556475408}"/>
-              </a:ext>
-            </a:extLst>
-          </p:cNvPr>
-          <p:cNvSpPr txBox="1"/>
-          <p:nvPr/>
-        </p:nvSpPr>
-        <p:spPr>
-          <a:xfrm>
-            <a:off x="2733058" y="678099"/>
-            <a:ext cx="1668004" cy="307777"/>
-          </a:xfrm>
-          <a:prstGeom prst="rect">
-            <a:avLst/>
-          </a:prstGeom>
-          <a:noFill/>
-        </p:spPr>
-        <p:txBody>
-          <a:bodyPr wrap="square">
-            <a:spAutoFit/>
-          </a:bodyPr>
-          <a:lstStyle/>
-          <a:p>
-            <a:r>
-              <a:rPr lang="en-US" sz="1400" b="1" dirty="0">
-                <a:solidFill>
-                  <a:schemeClr val="tx1">
-                    <a:lumMod val="75000"/>
-                    <a:lumOff val="25000"/>
-                  </a:schemeClr>
-                </a:solidFill>
-              </a:rPr>
-              <a:t>RTSP Video server</a:t>
-            </a:r>
-            <a:endParaRPr lang="en-SG" sz="1400" b="1" dirty="0">
-              <a:solidFill>
-                <a:schemeClr val="tx1">
-                  <a:lumMod val="75000"/>
-                  <a:lumOff val="25000"/>
-                </a:schemeClr>
-              </a:solidFill>
-            </a:endParaRPr>
-          </a:p>
-        </p:txBody>
-      </p:sp>
-      <p:pic>
-        <p:nvPicPr>
-          <p:cNvPr id="1028" name="Picture 4" descr="Folder images Icon | Free Folder Iconpack | Iconshock">
-            <a:extLst>
-              <a:ext uri="{FF2B5EF4-FFF2-40B4-BE49-F238E27FC236}">
-                <a16:creationId xmlns:a16="http://schemas.microsoft.com/office/drawing/2014/main" id="{4F5F0147-7AAC-0DB1-F1A8-62C15B8B7ECA}"/>
-              </a:ext>
-            </a:extLst>
-          </p:cNvPr>
-          <p:cNvPicPr>
-            <a:picLocks noChangeAspect="1" noChangeArrowheads="1"/>
-          </p:cNvPicPr>
-          <p:nvPr/>
-        </p:nvPicPr>
-        <p:blipFill>
-          <a:blip r:embed="rId4">
-            <a:extLst>
-              <a:ext uri="{28A0092B-C50C-407E-A947-70E740481C1C}">
-                <a14:useLocalDpi xmlns:a14="http://schemas.microsoft.com/office/drawing/2010/main" val="0"/>
-              </a:ext>
-            </a:extLst>
-          </a:blip>
-          <a:srcRect/>
-          <a:stretch>
-            <a:fillRect/>
-          </a:stretch>
-        </p:blipFill>
-        <p:spPr bwMode="auto">
-          <a:xfrm>
-            <a:off x="4769026" y="1043421"/>
-            <a:ext cx="726204" cy="726204"/>
-          </a:xfrm>
-          <a:prstGeom prst="rect">
-            <a:avLst/>
-          </a:prstGeom>
-          <a:noFill/>
-          <a:extLst>
-            <a:ext uri="{909E8E84-426E-40DD-AFC4-6F175D3DCCD1}">
-              <a14:hiddenFill xmlns:a14="http://schemas.microsoft.com/office/drawing/2010/main">
-                <a:solidFill>
-                  <a:srgbClr val="FFFFFF"/>
-                </a:solidFill>
-              </a14:hiddenFill>
-            </a:ext>
-          </a:extLst>
-        </p:spPr>
-      </p:pic>
-      <p:sp>
-        <p:nvSpPr>
-          <p:cNvPr id="8" name="TextBox 7">
-            <a:extLst>
-              <a:ext uri="{FF2B5EF4-FFF2-40B4-BE49-F238E27FC236}">
-                <a16:creationId xmlns:a16="http://schemas.microsoft.com/office/drawing/2014/main" id="{9E24AF49-FC8A-1870-DC15-72F43AF37E84}"/>
-              </a:ext>
-            </a:extLst>
-          </p:cNvPr>
-          <p:cNvSpPr txBox="1"/>
-          <p:nvPr/>
-        </p:nvSpPr>
-        <p:spPr>
-          <a:xfrm>
-            <a:off x="4401062" y="698259"/>
-            <a:ext cx="1822486" cy="307777"/>
-          </a:xfrm>
-          <a:prstGeom prst="rect">
-            <a:avLst/>
-          </a:prstGeom>
-          <a:noFill/>
-        </p:spPr>
-        <p:txBody>
-          <a:bodyPr wrap="square">
-            <a:spAutoFit/>
-          </a:bodyPr>
-          <a:lstStyle/>
-          <a:p>
-            <a:r>
-              <a:rPr lang="en-US" sz="1400" b="1" dirty="0">
-                <a:solidFill>
-                  <a:schemeClr val="tx1">
-                    <a:lumMod val="75000"/>
-                    <a:lumOff val="25000"/>
-                  </a:schemeClr>
-                </a:solidFill>
-              </a:rPr>
-              <a:t>Pictures Data Set</a:t>
-            </a:r>
-            <a:endParaRPr lang="en-SG" sz="1400" b="1" dirty="0">
-              <a:solidFill>
-                <a:schemeClr val="tx1">
-                  <a:lumMod val="75000"/>
-                  <a:lumOff val="25000"/>
-                </a:schemeClr>
-              </a:solidFill>
-            </a:endParaRPr>
-          </a:p>
-        </p:txBody>
-      </p:sp>
-      <p:pic>
-        <p:nvPicPr>
-          <p:cNvPr id="10" name="Picture 9">
-            <a:extLst>
-              <a:ext uri="{FF2B5EF4-FFF2-40B4-BE49-F238E27FC236}">
-                <a16:creationId xmlns:a16="http://schemas.microsoft.com/office/drawing/2014/main" id="{EF14CECB-8E08-231D-2A36-E998D7F1FFA4}"/>
-              </a:ext>
-            </a:extLst>
-          </p:cNvPr>
-          <p:cNvPicPr>
-            <a:picLocks noChangeAspect="1"/>
-          </p:cNvPicPr>
-          <p:nvPr/>
-        </p:nvPicPr>
-        <p:blipFill>
-          <a:blip r:embed="rId5"/>
-          <a:stretch>
-            <a:fillRect/>
-          </a:stretch>
-        </p:blipFill>
-        <p:spPr>
-          <a:xfrm>
-            <a:off x="6576104" y="1118522"/>
-            <a:ext cx="789144" cy="627332"/>
-          </a:xfrm>
-          <a:prstGeom prst="rect">
-            <a:avLst/>
-          </a:prstGeom>
-        </p:spPr>
-      </p:pic>
-      <p:sp>
-        <p:nvSpPr>
-          <p:cNvPr id="11" name="TextBox 10">
-            <a:extLst>
-              <a:ext uri="{FF2B5EF4-FFF2-40B4-BE49-F238E27FC236}">
-                <a16:creationId xmlns:a16="http://schemas.microsoft.com/office/drawing/2014/main" id="{90DF4BB7-8192-D0A1-5917-163BBE054545}"/>
-              </a:ext>
-            </a:extLst>
-          </p:cNvPr>
-          <p:cNvSpPr txBox="1"/>
-          <p:nvPr/>
-        </p:nvSpPr>
-        <p:spPr>
-          <a:xfrm>
-            <a:off x="6093853" y="694939"/>
-            <a:ext cx="1942092" cy="307777"/>
-          </a:xfrm>
-          <a:prstGeom prst="rect">
-            <a:avLst/>
-          </a:prstGeom>
-          <a:noFill/>
-        </p:spPr>
-        <p:txBody>
-          <a:bodyPr wrap="square">
-            <a:spAutoFit/>
-          </a:bodyPr>
-          <a:lstStyle/>
-          <a:p>
-            <a:r>
-              <a:rPr lang="en-US" sz="1400" b="1" dirty="0">
-                <a:solidFill>
-                  <a:schemeClr val="tx1">
-                    <a:lumMod val="75000"/>
-                    <a:lumOff val="25000"/>
-                  </a:schemeClr>
-                </a:solidFill>
-              </a:rPr>
-              <a:t>Screen Recording</a:t>
-            </a:r>
-            <a:endParaRPr lang="en-SG" sz="1400" b="1" dirty="0">
-              <a:solidFill>
-                <a:schemeClr val="tx1">
-                  <a:lumMod val="75000"/>
-                  <a:lumOff val="25000"/>
-                </a:schemeClr>
-              </a:solidFill>
-            </a:endParaRPr>
-          </a:p>
-        </p:txBody>
-      </p:sp>
-      <p:pic>
-        <p:nvPicPr>
-          <p:cNvPr id="1030" name="Picture 6" descr="Application Flaticons Lineal Color icon | Freepik">
-            <a:extLst>
-              <a:ext uri="{FF2B5EF4-FFF2-40B4-BE49-F238E27FC236}">
-                <a16:creationId xmlns:a16="http://schemas.microsoft.com/office/drawing/2014/main" id="{D680763A-B9AE-32E3-9CDA-1D12A0EB1172}"/>
-              </a:ext>
-            </a:extLst>
-          </p:cNvPr>
-          <p:cNvPicPr>
-            <a:picLocks noChangeAspect="1" noChangeArrowheads="1"/>
-          </p:cNvPicPr>
-          <p:nvPr/>
-        </p:nvPicPr>
-        <p:blipFill>
-          <a:blip r:embed="rId6">
-            <a:extLst>
-              <a:ext uri="{28A0092B-C50C-407E-A947-70E740481C1C}">
-                <a14:useLocalDpi xmlns:a14="http://schemas.microsoft.com/office/drawing/2010/main" val="0"/>
-              </a:ext>
-            </a:extLst>
-          </a:blip>
-          <a:srcRect/>
-          <a:stretch>
-            <a:fillRect/>
-          </a:stretch>
-        </p:blipFill>
-        <p:spPr bwMode="auto">
-          <a:xfrm>
-            <a:off x="8313493" y="1161892"/>
-            <a:ext cx="629368" cy="629368"/>
-          </a:xfrm>
-          <a:prstGeom prst="rect">
-            <a:avLst/>
-          </a:prstGeom>
-          <a:noFill/>
-          <a:extLst>
-            <a:ext uri="{909E8E84-426E-40DD-AFC4-6F175D3DCCD1}">
-              <a14:hiddenFill xmlns:a14="http://schemas.microsoft.com/office/drawing/2010/main">
-                <a:solidFill>
-                  <a:srgbClr val="FFFFFF"/>
-                </a:solidFill>
-              </a14:hiddenFill>
-            </a:ext>
-          </a:extLst>
-        </p:spPr>
-      </p:pic>
-      <p:sp>
-        <p:nvSpPr>
-          <p:cNvPr id="12" name="TextBox 11">
-            <a:extLst>
-              <a:ext uri="{FF2B5EF4-FFF2-40B4-BE49-F238E27FC236}">
-                <a16:creationId xmlns:a16="http://schemas.microsoft.com/office/drawing/2014/main" id="{DAB31FAC-8E0F-A0CF-FC80-8934A7E4E9D2}"/>
-              </a:ext>
-            </a:extLst>
-          </p:cNvPr>
-          <p:cNvSpPr txBox="1"/>
-          <p:nvPr/>
-        </p:nvSpPr>
-        <p:spPr>
-          <a:xfrm>
-            <a:off x="7924440" y="678099"/>
-            <a:ext cx="1942092" cy="523220"/>
-          </a:xfrm>
-          <a:prstGeom prst="rect">
-            <a:avLst/>
-          </a:prstGeom>
-          <a:noFill/>
-        </p:spPr>
-        <p:txBody>
-          <a:bodyPr wrap="square">
-            <a:spAutoFit/>
-          </a:bodyPr>
-          <a:lstStyle/>
-          <a:p>
-            <a:r>
-              <a:rPr lang="en-US" sz="1400" b="1" dirty="0">
-                <a:solidFill>
-                  <a:schemeClr val="tx1">
-                    <a:lumMod val="75000"/>
-                    <a:lumOff val="25000"/>
-                  </a:schemeClr>
-                </a:solidFill>
-              </a:rPr>
-              <a:t>Application Window  Screen shot </a:t>
-            </a:r>
-            <a:endParaRPr lang="en-SG" sz="1400" b="1" dirty="0">
-              <a:solidFill>
-                <a:schemeClr val="tx1">
-                  <a:lumMod val="75000"/>
-                  <a:lumOff val="25000"/>
-                </a:schemeClr>
-              </a:solidFill>
-            </a:endParaRPr>
-          </a:p>
-        </p:txBody>
-      </p:sp>
-      <p:sp>
-        <p:nvSpPr>
-          <p:cNvPr id="14" name="TextBox 13">
-            <a:extLst>
-              <a:ext uri="{FF2B5EF4-FFF2-40B4-BE49-F238E27FC236}">
-                <a16:creationId xmlns:a16="http://schemas.microsoft.com/office/drawing/2014/main" id="{42228077-B29A-6297-80F2-58FCD95ADD78}"/>
-              </a:ext>
-            </a:extLst>
-          </p:cNvPr>
-          <p:cNvSpPr txBox="1"/>
-          <p:nvPr/>
-        </p:nvSpPr>
-        <p:spPr>
-          <a:xfrm>
-            <a:off x="9071264" y="1241413"/>
-            <a:ext cx="1553984" cy="584775"/>
-          </a:xfrm>
-          <a:prstGeom prst="rect">
-            <a:avLst/>
-          </a:prstGeom>
-          <a:noFill/>
-        </p:spPr>
-        <p:txBody>
-          <a:bodyPr wrap="square">
-            <a:spAutoFit/>
-          </a:bodyPr>
-          <a:lstStyle/>
-          <a:p>
-            <a:r>
-              <a:rPr lang="en-US" sz="1600" b="1" dirty="0">
-                <a:solidFill>
-                  <a:schemeClr val="accent6">
-                    <a:lumMod val="75000"/>
-                  </a:schemeClr>
-                </a:solidFill>
-              </a:rPr>
-              <a:t>5 Different Video Source</a:t>
-            </a:r>
-            <a:endParaRPr lang="en-SG" sz="1600" b="1" dirty="0">
-              <a:solidFill>
-                <a:schemeClr val="accent6">
-                  <a:lumMod val="75000"/>
-                </a:schemeClr>
-              </a:solidFill>
-            </a:endParaRPr>
-          </a:p>
-        </p:txBody>
-      </p:sp>
-      <p:pic>
-        <p:nvPicPr>
-          <p:cNvPr id="18" name="Graphic 17" descr="Web design with solid fill">
-            <a:extLst>
-              <a:ext uri="{FF2B5EF4-FFF2-40B4-BE49-F238E27FC236}">
-                <a16:creationId xmlns:a16="http://schemas.microsoft.com/office/drawing/2014/main" id="{77E0C4C9-D36F-C627-1554-3B240DB8A9AB}"/>
-              </a:ext>
-            </a:extLst>
-          </p:cNvPr>
-          <p:cNvPicPr>
-            <a:picLocks noChangeAspect="1"/>
-          </p:cNvPicPr>
-          <p:nvPr/>
-        </p:nvPicPr>
-        <p:blipFill>
-          <a:blip r:embed="rId7">
-            <a:extLst>
-              <a:ext uri="{96DAC541-7B7A-43D3-8B79-37D633B846F1}">
-                <asvg:svgBlip xmlns:asvg="http://schemas.microsoft.com/office/drawing/2016/SVG/main" r:embed="rId8"/>
               </a:ext>
             </a:extLst>
           </a:blip>
@@ -4549,824 +3947,18 @@
         </p:blipFill>
         <p:spPr>
           <a:xfrm>
-            <a:off x="1609952" y="2422633"/>
-            <a:ext cx="845350" cy="845350"/>
+            <a:off x="4191238" y="2343285"/>
+            <a:ext cx="3809524" cy="2171429"/>
           </a:xfrm>
           <a:prstGeom prst="rect">
             <a:avLst/>
           </a:prstGeom>
         </p:spPr>
       </p:pic>
-      <p:cxnSp>
-        <p:nvCxnSpPr>
-          <p:cNvPr id="21" name="Straight Connector 20">
-            <a:extLst>
-              <a:ext uri="{FF2B5EF4-FFF2-40B4-BE49-F238E27FC236}">
-                <a16:creationId xmlns:a16="http://schemas.microsoft.com/office/drawing/2014/main" id="{271E2D5E-E190-237F-B206-6226603CF68D}"/>
-              </a:ext>
-            </a:extLst>
-          </p:cNvPr>
-          <p:cNvCxnSpPr>
-            <a:cxnSpLocks/>
-          </p:cNvCxnSpPr>
-          <p:nvPr/>
-        </p:nvCxnSpPr>
-        <p:spPr>
-          <a:xfrm flipV="1">
-            <a:off x="1745426" y="2182091"/>
-            <a:ext cx="6882751" cy="3"/>
-          </a:xfrm>
-          <a:prstGeom prst="line">
-            <a:avLst/>
-          </a:prstGeom>
-          <a:ln w="28575"/>
-        </p:spPr>
-        <p:style>
-          <a:lnRef idx="2">
-            <a:schemeClr val="accent1"/>
-          </a:lnRef>
-          <a:fillRef idx="0">
-            <a:schemeClr val="accent1"/>
-          </a:fillRef>
-          <a:effectRef idx="1">
-            <a:schemeClr val="accent1"/>
-          </a:effectRef>
-          <a:fontRef idx="minor">
-            <a:schemeClr val="tx1"/>
-          </a:fontRef>
-        </p:style>
-      </p:cxnSp>
-      <p:sp>
-        <p:nvSpPr>
-          <p:cNvPr id="37" name="TextBox 36">
-            <a:extLst>
-              <a:ext uri="{FF2B5EF4-FFF2-40B4-BE49-F238E27FC236}">
-                <a16:creationId xmlns:a16="http://schemas.microsoft.com/office/drawing/2014/main" id="{258E1831-CD12-30A2-D4B1-4CAA16AAF7E9}"/>
-              </a:ext>
-            </a:extLst>
-          </p:cNvPr>
-          <p:cNvSpPr txBox="1"/>
-          <p:nvPr/>
-        </p:nvSpPr>
-        <p:spPr>
-          <a:xfrm>
-            <a:off x="901983" y="2834918"/>
-            <a:ext cx="1368324" cy="830997"/>
-          </a:xfrm>
-          <a:prstGeom prst="rect">
-            <a:avLst/>
-          </a:prstGeom>
-          <a:noFill/>
-        </p:spPr>
-        <p:txBody>
-          <a:bodyPr wrap="square">
-            <a:spAutoFit/>
-          </a:bodyPr>
-          <a:lstStyle/>
-          <a:p>
-            <a:r>
-              <a:rPr lang="en-US" sz="1600" b="1" dirty="0"/>
-              <a:t>Virtual Camera Client Lib</a:t>
-            </a:r>
-            <a:endParaRPr lang="en-SG" sz="1600" b="1" dirty="0"/>
-          </a:p>
-        </p:txBody>
-      </p:sp>
-      <p:cxnSp>
-        <p:nvCxnSpPr>
-          <p:cNvPr id="38" name="Straight Arrow Connector 37">
-            <a:extLst>
-              <a:ext uri="{FF2B5EF4-FFF2-40B4-BE49-F238E27FC236}">
-                <a16:creationId xmlns:a16="http://schemas.microsoft.com/office/drawing/2014/main" id="{CD5C236A-5CBF-28A4-41E7-8B5167AFAC53}"/>
-              </a:ext>
-            </a:extLst>
-          </p:cNvPr>
-          <p:cNvCxnSpPr>
-            <a:cxnSpLocks/>
-            <a:stCxn id="1026" idx="2"/>
-          </p:cNvCxnSpPr>
-          <p:nvPr/>
-        </p:nvCxnSpPr>
-        <p:spPr>
-          <a:xfrm flipH="1">
-            <a:off x="1745426" y="1802165"/>
-            <a:ext cx="0" cy="379929"/>
-          </a:xfrm>
-          <a:prstGeom prst="straightConnector1">
-            <a:avLst/>
-          </a:prstGeom>
-          <a:ln>
-            <a:tailEnd type="triangle"/>
-          </a:ln>
-        </p:spPr>
-        <p:style>
-          <a:lnRef idx="2">
-            <a:schemeClr val="accent1"/>
-          </a:lnRef>
-          <a:fillRef idx="0">
-            <a:schemeClr val="accent1"/>
-          </a:fillRef>
-          <a:effectRef idx="1">
-            <a:schemeClr val="accent1"/>
-          </a:effectRef>
-          <a:fontRef idx="minor">
-            <a:schemeClr val="tx1"/>
-          </a:fontRef>
-        </p:style>
-      </p:cxnSp>
-      <p:pic>
-        <p:nvPicPr>
-          <p:cNvPr id="42" name="Picture 41" descr="A screenshot of a computer&#10;&#10;AI-generated content may be incorrect.">
-            <a:extLst>
-              <a:ext uri="{FF2B5EF4-FFF2-40B4-BE49-F238E27FC236}">
-                <a16:creationId xmlns:a16="http://schemas.microsoft.com/office/drawing/2014/main" id="{74329011-E43B-FF29-1A3E-D3C3484885C4}"/>
-              </a:ext>
-            </a:extLst>
-          </p:cNvPr>
-          <p:cNvPicPr>
-            <a:picLocks noChangeAspect="1"/>
-          </p:cNvPicPr>
-          <p:nvPr/>
-        </p:nvPicPr>
-        <p:blipFill>
-          <a:blip r:embed="rId9">
-            <a:extLst>
-              <a:ext uri="{28A0092B-C50C-407E-A947-70E740481C1C}">
-                <a14:useLocalDpi xmlns:a14="http://schemas.microsoft.com/office/drawing/2010/main" val="0"/>
-              </a:ext>
-            </a:extLst>
-          </a:blip>
-          <a:stretch>
-            <a:fillRect/>
-          </a:stretch>
-        </p:blipFill>
-        <p:spPr>
-          <a:xfrm>
-            <a:off x="5541572" y="2662385"/>
-            <a:ext cx="4825680" cy="2710384"/>
-          </a:xfrm>
-          <a:prstGeom prst="rect">
-            <a:avLst/>
-          </a:prstGeom>
-          <a:ln w="9525">
-            <a:solidFill>
-              <a:schemeClr val="tx1"/>
-            </a:solidFill>
-          </a:ln>
-        </p:spPr>
-      </p:pic>
-      <p:pic>
-        <p:nvPicPr>
-          <p:cNvPr id="49" name="Graphic 48" descr="Web design with solid fill">
-            <a:extLst>
-              <a:ext uri="{FF2B5EF4-FFF2-40B4-BE49-F238E27FC236}">
-                <a16:creationId xmlns:a16="http://schemas.microsoft.com/office/drawing/2014/main" id="{9373EFF3-C3CA-A8EC-F712-1E08228526A1}"/>
-              </a:ext>
-            </a:extLst>
-          </p:cNvPr>
-          <p:cNvPicPr>
-            <a:picLocks noChangeAspect="1"/>
-          </p:cNvPicPr>
-          <p:nvPr/>
-        </p:nvPicPr>
-        <p:blipFill>
-          <a:blip r:embed="rId7">
-            <a:extLst>
-              <a:ext uri="{96DAC541-7B7A-43D3-8B79-37D633B846F1}">
-                <asvg:svgBlip xmlns:asvg="http://schemas.microsoft.com/office/drawing/2016/SVG/main" r:embed="rId8"/>
-              </a:ext>
-            </a:extLst>
-          </a:blip>
-          <a:stretch>
-            <a:fillRect/>
-          </a:stretch>
-        </p:blipFill>
-        <p:spPr>
-          <a:xfrm>
-            <a:off x="1575427" y="3731053"/>
-            <a:ext cx="914400" cy="914400"/>
-          </a:xfrm>
-          <a:prstGeom prst="rect">
-            <a:avLst/>
-          </a:prstGeom>
-        </p:spPr>
-      </p:pic>
-      <p:cxnSp>
-        <p:nvCxnSpPr>
-          <p:cNvPr id="53" name="Straight Arrow Connector 52">
-            <a:extLst>
-              <a:ext uri="{FF2B5EF4-FFF2-40B4-BE49-F238E27FC236}">
-                <a16:creationId xmlns:a16="http://schemas.microsoft.com/office/drawing/2014/main" id="{C4EDD6BF-B996-C23E-95B9-A4031B65D19B}"/>
-              </a:ext>
-            </a:extLst>
-          </p:cNvPr>
-          <p:cNvCxnSpPr>
-            <a:cxnSpLocks/>
-          </p:cNvCxnSpPr>
-          <p:nvPr/>
-        </p:nvCxnSpPr>
-        <p:spPr>
-          <a:xfrm>
-            <a:off x="3279817" y="1769625"/>
-            <a:ext cx="0" cy="412469"/>
-          </a:xfrm>
-          <a:prstGeom prst="straightConnector1">
-            <a:avLst/>
-          </a:prstGeom>
-          <a:ln w="28575">
-            <a:tailEnd type="triangle"/>
-          </a:ln>
-        </p:spPr>
-        <p:style>
-          <a:lnRef idx="2">
-            <a:schemeClr val="accent1"/>
-          </a:lnRef>
-          <a:fillRef idx="0">
-            <a:schemeClr val="accent1"/>
-          </a:fillRef>
-          <a:effectRef idx="1">
-            <a:schemeClr val="accent1"/>
-          </a:effectRef>
-          <a:fontRef idx="minor">
-            <a:schemeClr val="tx1"/>
-          </a:fontRef>
-        </p:style>
-      </p:cxnSp>
-      <p:cxnSp>
-        <p:nvCxnSpPr>
-          <p:cNvPr id="59" name="Straight Arrow Connector 58">
-            <a:extLst>
-              <a:ext uri="{FF2B5EF4-FFF2-40B4-BE49-F238E27FC236}">
-                <a16:creationId xmlns:a16="http://schemas.microsoft.com/office/drawing/2014/main" id="{00B639C0-0151-BA37-B97B-3AA51DAC9CE2}"/>
-              </a:ext>
-            </a:extLst>
-          </p:cNvPr>
-          <p:cNvCxnSpPr>
-            <a:cxnSpLocks/>
-          </p:cNvCxnSpPr>
-          <p:nvPr/>
-        </p:nvCxnSpPr>
-        <p:spPr>
-          <a:xfrm>
-            <a:off x="1745426" y="1814634"/>
-            <a:ext cx="0" cy="367457"/>
-          </a:xfrm>
-          <a:prstGeom prst="straightConnector1">
-            <a:avLst/>
-          </a:prstGeom>
-          <a:ln w="28575">
-            <a:tailEnd type="triangle"/>
-          </a:ln>
-        </p:spPr>
-        <p:style>
-          <a:lnRef idx="2">
-            <a:schemeClr val="accent1"/>
-          </a:lnRef>
-          <a:fillRef idx="0">
-            <a:schemeClr val="accent1"/>
-          </a:fillRef>
-          <a:effectRef idx="1">
-            <a:schemeClr val="accent1"/>
-          </a:effectRef>
-          <a:fontRef idx="minor">
-            <a:schemeClr val="tx1"/>
-          </a:fontRef>
-        </p:style>
-      </p:cxnSp>
-      <p:cxnSp>
-        <p:nvCxnSpPr>
-          <p:cNvPr id="60" name="Straight Arrow Connector 59">
-            <a:extLst>
-              <a:ext uri="{FF2B5EF4-FFF2-40B4-BE49-F238E27FC236}">
-                <a16:creationId xmlns:a16="http://schemas.microsoft.com/office/drawing/2014/main" id="{D40D7555-136F-1B8A-5BE0-CFEEE888D221}"/>
-              </a:ext>
-            </a:extLst>
-          </p:cNvPr>
-          <p:cNvCxnSpPr>
-            <a:cxnSpLocks/>
-          </p:cNvCxnSpPr>
-          <p:nvPr/>
-        </p:nvCxnSpPr>
-        <p:spPr>
-          <a:xfrm>
-            <a:off x="5084372" y="1769625"/>
-            <a:ext cx="0" cy="412469"/>
-          </a:xfrm>
-          <a:prstGeom prst="straightConnector1">
-            <a:avLst/>
-          </a:prstGeom>
-          <a:ln w="28575">
-            <a:tailEnd type="triangle"/>
-          </a:ln>
-        </p:spPr>
-        <p:style>
-          <a:lnRef idx="2">
-            <a:schemeClr val="accent1"/>
-          </a:lnRef>
-          <a:fillRef idx="0">
-            <a:schemeClr val="accent1"/>
-          </a:fillRef>
-          <a:effectRef idx="1">
-            <a:schemeClr val="accent1"/>
-          </a:effectRef>
-          <a:fontRef idx="minor">
-            <a:schemeClr val="tx1"/>
-          </a:fontRef>
-        </p:style>
-      </p:cxnSp>
-      <p:cxnSp>
-        <p:nvCxnSpPr>
-          <p:cNvPr id="61" name="Straight Arrow Connector 60">
-            <a:extLst>
-              <a:ext uri="{FF2B5EF4-FFF2-40B4-BE49-F238E27FC236}">
-                <a16:creationId xmlns:a16="http://schemas.microsoft.com/office/drawing/2014/main" id="{5F0E1DAD-9B25-C0D2-5F4D-DDCC4FC7014E}"/>
-              </a:ext>
-            </a:extLst>
-          </p:cNvPr>
-          <p:cNvCxnSpPr>
-            <a:cxnSpLocks/>
-          </p:cNvCxnSpPr>
-          <p:nvPr/>
-        </p:nvCxnSpPr>
-        <p:spPr>
-          <a:xfrm>
-            <a:off x="6975517" y="1745854"/>
-            <a:ext cx="0" cy="412469"/>
-          </a:xfrm>
-          <a:prstGeom prst="straightConnector1">
-            <a:avLst/>
-          </a:prstGeom>
-          <a:ln w="28575">
-            <a:tailEnd type="triangle"/>
-          </a:ln>
-        </p:spPr>
-        <p:style>
-          <a:lnRef idx="2">
-            <a:schemeClr val="accent1"/>
-          </a:lnRef>
-          <a:fillRef idx="0">
-            <a:schemeClr val="accent1"/>
-          </a:fillRef>
-          <a:effectRef idx="1">
-            <a:schemeClr val="accent1"/>
-          </a:effectRef>
-          <a:fontRef idx="minor">
-            <a:schemeClr val="tx1"/>
-          </a:fontRef>
-        </p:style>
-      </p:cxnSp>
-      <p:cxnSp>
-        <p:nvCxnSpPr>
-          <p:cNvPr id="62" name="Straight Arrow Connector 61">
-            <a:extLst>
-              <a:ext uri="{FF2B5EF4-FFF2-40B4-BE49-F238E27FC236}">
-                <a16:creationId xmlns:a16="http://schemas.microsoft.com/office/drawing/2014/main" id="{C9C4C224-A813-99AB-6416-F0F0D647E5A4}"/>
-              </a:ext>
-            </a:extLst>
-          </p:cNvPr>
-          <p:cNvCxnSpPr>
-            <a:cxnSpLocks/>
-          </p:cNvCxnSpPr>
-          <p:nvPr/>
-        </p:nvCxnSpPr>
-        <p:spPr>
-          <a:xfrm>
-            <a:off x="8597005" y="1802165"/>
-            <a:ext cx="0" cy="412469"/>
-          </a:xfrm>
-          <a:prstGeom prst="straightConnector1">
-            <a:avLst/>
-          </a:prstGeom>
-          <a:ln w="28575">
-            <a:tailEnd type="triangle"/>
-          </a:ln>
-        </p:spPr>
-        <p:style>
-          <a:lnRef idx="2">
-            <a:schemeClr val="accent1"/>
-          </a:lnRef>
-          <a:fillRef idx="0">
-            <a:schemeClr val="accent1"/>
-          </a:fillRef>
-          <a:effectRef idx="1">
-            <a:schemeClr val="accent1"/>
-          </a:effectRef>
-          <a:fontRef idx="minor">
-            <a:schemeClr val="tx1"/>
-          </a:fontRef>
-        </p:style>
-      </p:cxnSp>
-      <p:cxnSp>
-        <p:nvCxnSpPr>
-          <p:cNvPr id="63" name="Straight Arrow Connector 62">
-            <a:extLst>
-              <a:ext uri="{FF2B5EF4-FFF2-40B4-BE49-F238E27FC236}">
-                <a16:creationId xmlns:a16="http://schemas.microsoft.com/office/drawing/2014/main" id="{939080D0-CEEF-9EF3-C1DA-2A9AFCA741E5}"/>
-              </a:ext>
-            </a:extLst>
-          </p:cNvPr>
-          <p:cNvCxnSpPr>
-            <a:cxnSpLocks/>
-          </p:cNvCxnSpPr>
-          <p:nvPr/>
-        </p:nvCxnSpPr>
-        <p:spPr>
-          <a:xfrm>
-            <a:off x="2032627" y="2182091"/>
-            <a:ext cx="0" cy="384464"/>
-          </a:xfrm>
-          <a:prstGeom prst="straightConnector1">
-            <a:avLst/>
-          </a:prstGeom>
-          <a:ln w="28575">
-            <a:tailEnd type="triangle"/>
-          </a:ln>
-        </p:spPr>
-        <p:style>
-          <a:lnRef idx="2">
-            <a:schemeClr val="accent1"/>
-          </a:lnRef>
-          <a:fillRef idx="0">
-            <a:schemeClr val="accent1"/>
-          </a:fillRef>
-          <a:effectRef idx="1">
-            <a:schemeClr val="accent1"/>
-          </a:effectRef>
-          <a:fontRef idx="minor">
-            <a:schemeClr val="tx1"/>
-          </a:fontRef>
-        </p:style>
-      </p:cxnSp>
-      <p:cxnSp>
-        <p:nvCxnSpPr>
-          <p:cNvPr id="1029" name="Straight Arrow Connector 1028">
-            <a:extLst>
-              <a:ext uri="{FF2B5EF4-FFF2-40B4-BE49-F238E27FC236}">
-                <a16:creationId xmlns:a16="http://schemas.microsoft.com/office/drawing/2014/main" id="{BC68FBBA-31E1-9472-5CD3-64E06949420B}"/>
-              </a:ext>
-            </a:extLst>
-          </p:cNvPr>
-          <p:cNvCxnSpPr>
-            <a:cxnSpLocks/>
-          </p:cNvCxnSpPr>
-          <p:nvPr/>
-        </p:nvCxnSpPr>
-        <p:spPr>
-          <a:xfrm>
-            <a:off x="2032627" y="3160026"/>
-            <a:ext cx="0" cy="736621"/>
-          </a:xfrm>
-          <a:prstGeom prst="straightConnector1">
-            <a:avLst/>
-          </a:prstGeom>
-          <a:ln w="28575">
-            <a:tailEnd type="triangle"/>
-          </a:ln>
-        </p:spPr>
-        <p:style>
-          <a:lnRef idx="2">
-            <a:schemeClr val="accent1"/>
-          </a:lnRef>
-          <a:fillRef idx="0">
-            <a:schemeClr val="accent1"/>
-          </a:fillRef>
-          <a:effectRef idx="1">
-            <a:schemeClr val="accent1"/>
-          </a:effectRef>
-          <a:fontRef idx="minor">
-            <a:schemeClr val="tx1"/>
-          </a:fontRef>
-        </p:style>
-      </p:cxnSp>
-      <p:sp>
-        <p:nvSpPr>
-          <p:cNvPr id="1033" name="TextBox 1032">
-            <a:extLst>
-              <a:ext uri="{FF2B5EF4-FFF2-40B4-BE49-F238E27FC236}">
-                <a16:creationId xmlns:a16="http://schemas.microsoft.com/office/drawing/2014/main" id="{5CEA3A56-428C-DFC3-3B44-1D49A8CDBFCE}"/>
-              </a:ext>
-            </a:extLst>
-          </p:cNvPr>
-          <p:cNvSpPr txBox="1"/>
-          <p:nvPr/>
-        </p:nvSpPr>
-        <p:spPr>
-          <a:xfrm>
-            <a:off x="1001241" y="4203185"/>
-            <a:ext cx="1340967" cy="830997"/>
-          </a:xfrm>
-          <a:prstGeom prst="rect">
-            <a:avLst/>
-          </a:prstGeom>
-          <a:noFill/>
-        </p:spPr>
-        <p:txBody>
-          <a:bodyPr wrap="square">
-            <a:spAutoFit/>
-          </a:bodyPr>
-          <a:lstStyle/>
-          <a:p>
-            <a:r>
-              <a:rPr lang="en-US" sz="1600" b="1" dirty="0"/>
-              <a:t>Flask Camera Web server</a:t>
-            </a:r>
-            <a:endParaRPr lang="en-SG" sz="1600" b="1" dirty="0"/>
-          </a:p>
-        </p:txBody>
-      </p:sp>
-      <p:pic>
-        <p:nvPicPr>
-          <p:cNvPr id="1035" name="Picture 1034" descr="A screenshot of a computer&#10;&#10;AI-generated content may be incorrect.">
-            <a:extLst>
-              <a:ext uri="{FF2B5EF4-FFF2-40B4-BE49-F238E27FC236}">
-                <a16:creationId xmlns:a16="http://schemas.microsoft.com/office/drawing/2014/main" id="{3F5ED33D-F215-496B-BD0A-08EBE4475A64}"/>
-              </a:ext>
-            </a:extLst>
-          </p:cNvPr>
-          <p:cNvPicPr>
-            <a:picLocks noChangeAspect="1"/>
-          </p:cNvPicPr>
-          <p:nvPr/>
-        </p:nvPicPr>
-        <p:blipFill>
-          <a:blip r:embed="rId10">
-            <a:extLst>
-              <a:ext uri="{28A0092B-C50C-407E-A947-70E740481C1C}">
-                <a14:useLocalDpi xmlns:a14="http://schemas.microsoft.com/office/drawing/2010/main" val="0"/>
-              </a:ext>
-            </a:extLst>
-          </a:blip>
-          <a:stretch>
-            <a:fillRect/>
-          </a:stretch>
-        </p:blipFill>
-        <p:spPr>
-          <a:xfrm>
-            <a:off x="2928505" y="2837786"/>
-            <a:ext cx="1942092" cy="1138227"/>
-          </a:xfrm>
-          <a:prstGeom prst="rect">
-            <a:avLst/>
-          </a:prstGeom>
-          <a:ln w="6350">
-            <a:solidFill>
-              <a:schemeClr val="tx1"/>
-            </a:solidFill>
-          </a:ln>
-        </p:spPr>
-      </p:pic>
-      <p:pic>
-        <p:nvPicPr>
-          <p:cNvPr id="1037" name="Picture 1036" descr="A screenshot of a video camera&#10;&#10;AI-generated content may be incorrect.">
-            <a:extLst>
-              <a:ext uri="{FF2B5EF4-FFF2-40B4-BE49-F238E27FC236}">
-                <a16:creationId xmlns:a16="http://schemas.microsoft.com/office/drawing/2014/main" id="{64210A98-AB0B-E091-A800-AC202E578395}"/>
-              </a:ext>
-            </a:extLst>
-          </p:cNvPr>
-          <p:cNvPicPr>
-            <a:picLocks noChangeAspect="1"/>
-          </p:cNvPicPr>
-          <p:nvPr/>
-        </p:nvPicPr>
-        <p:blipFill>
-          <a:blip r:embed="rId11">
-            <a:extLst>
-              <a:ext uri="{28A0092B-C50C-407E-A947-70E740481C1C}">
-                <a14:useLocalDpi xmlns:a14="http://schemas.microsoft.com/office/drawing/2010/main" val="0"/>
-              </a:ext>
-            </a:extLst>
-          </a:blip>
-          <a:stretch>
-            <a:fillRect/>
-          </a:stretch>
-        </p:blipFill>
-        <p:spPr>
-          <a:xfrm>
-            <a:off x="2928505" y="4122624"/>
-            <a:ext cx="1993773" cy="1138225"/>
-          </a:xfrm>
-          <a:prstGeom prst="rect">
-            <a:avLst/>
-          </a:prstGeom>
-          <a:ln w="9525">
-            <a:solidFill>
-              <a:schemeClr val="tx1"/>
-            </a:solidFill>
-          </a:ln>
-        </p:spPr>
-      </p:pic>
-      <p:cxnSp>
-        <p:nvCxnSpPr>
-          <p:cNvPr id="1041" name="Straight Arrow Connector 1040">
-            <a:extLst>
-              <a:ext uri="{FF2B5EF4-FFF2-40B4-BE49-F238E27FC236}">
-                <a16:creationId xmlns:a16="http://schemas.microsoft.com/office/drawing/2014/main" id="{3FA1B850-5B64-1FA5-EB69-B673910050E5}"/>
-              </a:ext>
-            </a:extLst>
-          </p:cNvPr>
-          <p:cNvCxnSpPr>
-            <a:cxnSpLocks/>
-          </p:cNvCxnSpPr>
-          <p:nvPr/>
-        </p:nvCxnSpPr>
-        <p:spPr>
-          <a:xfrm>
-            <a:off x="2369194" y="4174579"/>
-            <a:ext cx="359322" cy="0"/>
-          </a:xfrm>
-          <a:prstGeom prst="straightConnector1">
-            <a:avLst/>
-          </a:prstGeom>
-          <a:ln w="28575">
-            <a:tailEnd type="triangle"/>
-          </a:ln>
-        </p:spPr>
-        <p:style>
-          <a:lnRef idx="2">
-            <a:schemeClr val="accent1"/>
-          </a:lnRef>
-          <a:fillRef idx="0">
-            <a:schemeClr val="accent1"/>
-          </a:fillRef>
-          <a:effectRef idx="1">
-            <a:schemeClr val="accent1"/>
-          </a:effectRef>
-          <a:fontRef idx="minor">
-            <a:schemeClr val="tx1"/>
-          </a:fontRef>
-        </p:style>
-      </p:cxnSp>
-      <p:sp>
-        <p:nvSpPr>
-          <p:cNvPr id="1043" name="TextBox 1042">
-            <a:extLst>
-              <a:ext uri="{FF2B5EF4-FFF2-40B4-BE49-F238E27FC236}">
-                <a16:creationId xmlns:a16="http://schemas.microsoft.com/office/drawing/2014/main" id="{B15EA8BE-029F-14A8-80A6-598A1B868AFA}"/>
-              </a:ext>
-            </a:extLst>
-          </p:cNvPr>
-          <p:cNvSpPr txBox="1"/>
-          <p:nvPr/>
-        </p:nvSpPr>
-        <p:spPr>
-          <a:xfrm>
-            <a:off x="2849678" y="2462295"/>
-            <a:ext cx="2234694" cy="338554"/>
-          </a:xfrm>
-          <a:prstGeom prst="rect">
-            <a:avLst/>
-          </a:prstGeom>
-          <a:noFill/>
-        </p:spPr>
-        <p:txBody>
-          <a:bodyPr wrap="square">
-            <a:spAutoFit/>
-          </a:bodyPr>
-          <a:lstStyle/>
-          <a:p>
-            <a:r>
-              <a:rPr lang="en-US" sz="1600" b="1" dirty="0">
-                <a:solidFill>
-                  <a:schemeClr val="accent2">
-                    <a:lumMod val="75000"/>
-                  </a:schemeClr>
-                </a:solidFill>
-              </a:rPr>
-              <a:t>Camera Web UI pages</a:t>
-            </a:r>
-            <a:endParaRPr lang="en-SG" sz="1600" b="1" dirty="0">
-              <a:solidFill>
-                <a:schemeClr val="accent2">
-                  <a:lumMod val="75000"/>
-                </a:schemeClr>
-              </a:solidFill>
-            </a:endParaRPr>
-          </a:p>
-        </p:txBody>
-      </p:sp>
-      <p:cxnSp>
-        <p:nvCxnSpPr>
-          <p:cNvPr id="1044" name="Straight Arrow Connector 1043">
-            <a:extLst>
-              <a:ext uri="{FF2B5EF4-FFF2-40B4-BE49-F238E27FC236}">
-                <a16:creationId xmlns:a16="http://schemas.microsoft.com/office/drawing/2014/main" id="{C84CBAAF-5262-F886-BB47-61B36AAC3788}"/>
-              </a:ext>
-            </a:extLst>
-          </p:cNvPr>
-          <p:cNvCxnSpPr>
-            <a:cxnSpLocks/>
-          </p:cNvCxnSpPr>
-          <p:nvPr/>
-        </p:nvCxnSpPr>
-        <p:spPr>
-          <a:xfrm>
-            <a:off x="4882768" y="3403948"/>
-            <a:ext cx="611189" cy="0"/>
-          </a:xfrm>
-          <a:prstGeom prst="straightConnector1">
-            <a:avLst/>
-          </a:prstGeom>
-          <a:ln w="28575">
-            <a:tailEnd type="triangle"/>
-          </a:ln>
-        </p:spPr>
-        <p:style>
-          <a:lnRef idx="2">
-            <a:schemeClr val="accent1"/>
-          </a:lnRef>
-          <a:fillRef idx="0">
-            <a:schemeClr val="accent1"/>
-          </a:fillRef>
-          <a:effectRef idx="1">
-            <a:schemeClr val="accent1"/>
-          </a:effectRef>
-          <a:fontRef idx="minor">
-            <a:schemeClr val="tx1"/>
-          </a:fontRef>
-        </p:style>
-      </p:cxnSp>
-      <p:cxnSp>
-        <p:nvCxnSpPr>
-          <p:cNvPr id="1046" name="Straight Arrow Connector 1045">
-            <a:extLst>
-              <a:ext uri="{FF2B5EF4-FFF2-40B4-BE49-F238E27FC236}">
-                <a16:creationId xmlns:a16="http://schemas.microsoft.com/office/drawing/2014/main" id="{996F13F8-D505-0519-0757-0A39657C1F8B}"/>
-              </a:ext>
-            </a:extLst>
-          </p:cNvPr>
-          <p:cNvCxnSpPr>
-            <a:cxnSpLocks/>
-          </p:cNvCxnSpPr>
-          <p:nvPr/>
-        </p:nvCxnSpPr>
-        <p:spPr>
-          <a:xfrm>
-            <a:off x="4930383" y="4627328"/>
-            <a:ext cx="611189" cy="0"/>
-          </a:xfrm>
-          <a:prstGeom prst="straightConnector1">
-            <a:avLst/>
-          </a:prstGeom>
-          <a:ln w="28575">
-            <a:tailEnd type="triangle"/>
-          </a:ln>
-        </p:spPr>
-        <p:style>
-          <a:lnRef idx="2">
-            <a:schemeClr val="accent1"/>
-          </a:lnRef>
-          <a:fillRef idx="0">
-            <a:schemeClr val="accent1"/>
-          </a:fillRef>
-          <a:effectRef idx="1">
-            <a:schemeClr val="accent1"/>
-          </a:effectRef>
-          <a:fontRef idx="minor">
-            <a:schemeClr val="tx1"/>
-          </a:fontRef>
-        </p:style>
-      </p:cxnSp>
-      <p:sp>
-        <p:nvSpPr>
-          <p:cNvPr id="1047" name="TextBox 1046">
-            <a:extLst>
-              <a:ext uri="{FF2B5EF4-FFF2-40B4-BE49-F238E27FC236}">
-                <a16:creationId xmlns:a16="http://schemas.microsoft.com/office/drawing/2014/main" id="{3F00CA10-D60A-3267-2070-9CBE2334443B}"/>
-              </a:ext>
-            </a:extLst>
-          </p:cNvPr>
-          <p:cNvSpPr txBox="1"/>
-          <p:nvPr/>
-        </p:nvSpPr>
-        <p:spPr>
-          <a:xfrm>
-            <a:off x="5505099" y="2313109"/>
-            <a:ext cx="3944395" cy="338554"/>
-          </a:xfrm>
-          <a:prstGeom prst="rect">
-            <a:avLst/>
-          </a:prstGeom>
-          <a:noFill/>
-        </p:spPr>
-        <p:txBody>
-          <a:bodyPr wrap="square">
-            <a:spAutoFit/>
-          </a:bodyPr>
-          <a:lstStyle/>
-          <a:p>
-            <a:r>
-              <a:rPr lang="en-US" sz="1600" b="1" dirty="0"/>
-              <a:t>Multi-Camera View Monitor Dashboard</a:t>
-            </a:r>
-            <a:endParaRPr lang="en-SG" sz="1600" b="1" dirty="0"/>
-          </a:p>
-        </p:txBody>
-      </p:sp>
     </p:spTree>
     <p:extLst>
       <p:ext uri="{BB962C8B-B14F-4D97-AF65-F5344CB8AC3E}">
-        <p14:creationId xmlns:p14="http://schemas.microsoft.com/office/powerpoint/2010/main" val="240756249"/>
+        <p14:creationId xmlns:p14="http://schemas.microsoft.com/office/powerpoint/2010/main" val="2040113549"/>
       </p:ext>
     </p:extLst>
   </p:cSld>
@@ -5395,10 +3987,10 @@
       </p:grpSpPr>
       <p:sp>
         <p:nvSpPr>
-          <p:cNvPr id="5" name="Rectangle 4">
-            <a:extLst>
-              <a:ext uri="{FF2B5EF4-FFF2-40B4-BE49-F238E27FC236}">
-                <a16:creationId xmlns:a16="http://schemas.microsoft.com/office/drawing/2014/main" id="{795BEA1A-7ACE-A084-E97E-EAB31DF9CD09}"/>
+          <p:cNvPr id="1038" name="Rectangle 1037">
+            <a:extLst>
+              <a:ext uri="{FF2B5EF4-FFF2-40B4-BE49-F238E27FC236}">
+                <a16:creationId xmlns:a16="http://schemas.microsoft.com/office/drawing/2014/main" id="{7A72A1C1-40DB-34C3-B7B6-E74702CE1591}"/>
               </a:ext>
             </a:extLst>
           </p:cNvPr>
@@ -5407,16 +3999,16 @@
         </p:nvSpPr>
         <p:spPr>
           <a:xfrm>
-            <a:off x="4079281" y="1558456"/>
-            <a:ext cx="3045289" cy="2836563"/>
+            <a:off x="2742502" y="2422633"/>
+            <a:ext cx="2487368" cy="2950135"/>
           </a:xfrm>
           <a:prstGeom prst="rect">
             <a:avLst/>
           </a:prstGeom>
           <a:solidFill>
-            <a:schemeClr val="tx2">
-              <a:lumMod val="10000"/>
-              <a:lumOff val="90000"/>
+            <a:schemeClr val="accent2">
+              <a:lumMod val="20000"/>
+              <a:lumOff val="80000"/>
             </a:schemeClr>
           </a:solidFill>
         </p:spPr>
@@ -5447,10 +4039,10 @@
       </p:sp>
       <p:sp>
         <p:nvSpPr>
-          <p:cNvPr id="4" name="Rectangle 3">
-            <a:extLst>
-              <a:ext uri="{FF2B5EF4-FFF2-40B4-BE49-F238E27FC236}">
-                <a16:creationId xmlns:a16="http://schemas.microsoft.com/office/drawing/2014/main" id="{9A640534-3FC6-9633-EF17-E19015883C71}"/>
+          <p:cNvPr id="13" name="Rectangle 12">
+            <a:extLst>
+              <a:ext uri="{FF2B5EF4-FFF2-40B4-BE49-F238E27FC236}">
+                <a16:creationId xmlns:a16="http://schemas.microsoft.com/office/drawing/2014/main" id="{8759375A-3526-252C-A754-BE057854A791}"/>
               </a:ext>
             </a:extLst>
           </p:cNvPr>
@@ -5459,110 +4051,16 @@
         </p:nvSpPr>
         <p:spPr>
           <a:xfrm>
-            <a:off x="5238976" y="2564996"/>
-            <a:ext cx="1714048" cy="501471"/>
+            <a:off x="1121383" y="627614"/>
+            <a:ext cx="9325191" cy="1244506"/>
           </a:xfrm>
           <a:prstGeom prst="rect">
-            <a:avLst/>
-          </a:prstGeom>
-          <a:solidFill>
-            <a:schemeClr val="tx2">
-              <a:lumMod val="75000"/>
-              <a:lumOff val="25000"/>
-            </a:schemeClr>
-          </a:solidFill>
-          <a:ln>
-            <a:solidFill>
-              <a:schemeClr val="tx1"/>
-            </a:solidFill>
-          </a:ln>
-        </p:spPr>
-        <p:style>
-          <a:lnRef idx="2">
-            <a:schemeClr val="accent1">
-              <a:shade val="50000"/>
-            </a:schemeClr>
-          </a:lnRef>
-          <a:fillRef idx="1">
-            <a:schemeClr val="accent1"/>
-          </a:fillRef>
-          <a:effectRef idx="0">
-            <a:schemeClr val="accent1"/>
-          </a:effectRef>
-          <a:fontRef idx="minor">
-            <a:schemeClr val="lt1"/>
-          </a:fontRef>
-        </p:style>
-        <p:txBody>
-          <a:bodyPr rtlCol="0" anchor="ctr"/>
-          <a:lstStyle/>
-          <a:p>
-            <a:r>
-              <a:rPr lang="en-SG" sz="1200" b="1" dirty="0"/>
-              <a:t>User and Access  Management Module </a:t>
-            </a:r>
-          </a:p>
-        </p:txBody>
-      </p:sp>
-      <p:sp>
-        <p:nvSpPr>
-          <p:cNvPr id="6" name="TextBox 5">
-            <a:extLst>
-              <a:ext uri="{FF2B5EF4-FFF2-40B4-BE49-F238E27FC236}">
-                <a16:creationId xmlns:a16="http://schemas.microsoft.com/office/drawing/2014/main" id="{7A70032D-F9A9-5DF3-348B-B60B4991CBC2}"/>
-              </a:ext>
-            </a:extLst>
-          </p:cNvPr>
-          <p:cNvSpPr txBox="1"/>
-          <p:nvPr/>
-        </p:nvSpPr>
-        <p:spPr>
-          <a:xfrm>
-            <a:off x="4048152" y="1622536"/>
-            <a:ext cx="2500148" cy="338554"/>
-          </a:xfrm>
-          <a:prstGeom prst="rect">
-            <a:avLst/>
-          </a:prstGeom>
-          <a:noFill/>
-        </p:spPr>
-        <p:txBody>
-          <a:bodyPr wrap="square" rtlCol="0">
-            <a:spAutoFit/>
-          </a:bodyPr>
-          <a:lstStyle/>
-          <a:p>
-            <a:r>
-              <a:rPr lang="en-US" sz="1600" b="1" dirty="0"/>
-              <a:t>Flask Camera Server</a:t>
-            </a:r>
-            <a:endParaRPr lang="en-SG" sz="1600" b="1" dirty="0"/>
-          </a:p>
-        </p:txBody>
-      </p:sp>
-      <p:sp>
-        <p:nvSpPr>
-          <p:cNvPr id="7" name="Cylinder 6">
-            <a:extLst>
-              <a:ext uri="{FF2B5EF4-FFF2-40B4-BE49-F238E27FC236}">
-                <a16:creationId xmlns:a16="http://schemas.microsoft.com/office/drawing/2014/main" id="{39FFC1E6-E8B7-E8F9-A757-519C2C7C8E73}"/>
-              </a:ext>
-            </a:extLst>
-          </p:cNvPr>
-          <p:cNvSpPr/>
-          <p:nvPr/>
-        </p:nvSpPr>
-        <p:spPr>
-          <a:xfrm>
-            <a:off x="6172651" y="1858119"/>
-            <a:ext cx="696191" cy="519546"/>
-          </a:xfrm>
-          <a:prstGeom prst="can">
             <a:avLst/>
           </a:prstGeom>
           <a:solidFill>
             <a:schemeClr val="accent6">
-              <a:lumMod val="50000"/>
+              <a:lumMod val="20000"/>
+              <a:lumOff val="80000"/>
             </a:schemeClr>
           </a:solidFill>
         </p:spPr>
@@ -5587,19 +4085,551 @@
           <a:lstStyle/>
           <a:p>
             <a:pPr algn="ctr"/>
-            <a:r>
-              <a:rPr lang="en-SG" sz="1200" b="1" dirty="0"/>
-              <a:t>User BD</a:t>
-            </a:r>
-          </a:p>
-        </p:txBody>
-      </p:sp>
+            <a:endParaRPr lang="en-SG" dirty="0"/>
+          </a:p>
+        </p:txBody>
+      </p:sp>
+      <p:pic>
+        <p:nvPicPr>
+          <p:cNvPr id="1026" name="Picture 2" descr="Webcam - Free computer icons">
+            <a:extLst>
+              <a:ext uri="{FF2B5EF4-FFF2-40B4-BE49-F238E27FC236}">
+                <a16:creationId xmlns:a16="http://schemas.microsoft.com/office/drawing/2014/main" id="{1893017E-457B-DA61-73CD-5AF1C2D8E18B}"/>
+              </a:ext>
+            </a:extLst>
+          </p:cNvPr>
+          <p:cNvPicPr>
+            <a:picLocks noChangeAspect="1" noChangeArrowheads="1"/>
+          </p:cNvPicPr>
+          <p:nvPr/>
+        </p:nvPicPr>
+        <p:blipFill>
+          <a:blip r:embed="rId2">
+            <a:extLst>
+              <a:ext uri="{28A0092B-C50C-407E-A947-70E740481C1C}">
+                <a14:useLocalDpi xmlns:a14="http://schemas.microsoft.com/office/drawing/2010/main" val="0"/>
+              </a:ext>
+            </a:extLst>
+          </a:blip>
+          <a:srcRect/>
+          <a:stretch>
+            <a:fillRect/>
+          </a:stretch>
+        </p:blipFill>
+        <p:spPr bwMode="auto">
+          <a:xfrm>
+            <a:off x="1375875" y="1038236"/>
+            <a:ext cx="763929" cy="763929"/>
+          </a:xfrm>
+          <a:prstGeom prst="rect">
+            <a:avLst/>
+          </a:prstGeom>
+          <a:noFill/>
+          <a:extLst>
+            <a:ext uri="{909E8E84-426E-40DD-AFC4-6F175D3DCCD1}">
+              <a14:hiddenFill xmlns:a14="http://schemas.microsoft.com/office/drawing/2010/main">
+                <a:solidFill>
+                  <a:srgbClr val="FFFFFF"/>
+                </a:solidFill>
+              </a14:hiddenFill>
+            </a:ext>
+          </a:extLst>
+        </p:spPr>
+      </p:pic>
+      <p:sp>
+        <p:nvSpPr>
+          <p:cNvPr id="4" name="TextBox 3">
+            <a:extLst>
+              <a:ext uri="{FF2B5EF4-FFF2-40B4-BE49-F238E27FC236}">
+                <a16:creationId xmlns:a16="http://schemas.microsoft.com/office/drawing/2014/main" id="{CE539FF7-AF70-F40A-4FA9-5BE1ED00A1BF}"/>
+              </a:ext>
+            </a:extLst>
+          </p:cNvPr>
+          <p:cNvSpPr txBox="1"/>
+          <p:nvPr/>
+        </p:nvSpPr>
+        <p:spPr>
+          <a:xfrm>
+            <a:off x="1310816" y="694939"/>
+            <a:ext cx="1232810" cy="307777"/>
+          </a:xfrm>
+          <a:prstGeom prst="rect">
+            <a:avLst/>
+          </a:prstGeom>
+          <a:noFill/>
+        </p:spPr>
+        <p:txBody>
+          <a:bodyPr wrap="square">
+            <a:spAutoFit/>
+          </a:bodyPr>
+          <a:lstStyle/>
+          <a:p>
+            <a:r>
+              <a:rPr lang="en-US" sz="1400" b="1" dirty="0">
+                <a:solidFill>
+                  <a:schemeClr val="tx1">
+                    <a:lumMod val="75000"/>
+                    <a:lumOff val="25000"/>
+                  </a:schemeClr>
+                </a:solidFill>
+              </a:rPr>
+              <a:t>Real Camrea</a:t>
+            </a:r>
+            <a:endParaRPr lang="en-SG" sz="1400" b="1" dirty="0">
+              <a:solidFill>
+                <a:schemeClr val="tx1">
+                  <a:lumMod val="75000"/>
+                  <a:lumOff val="25000"/>
+                </a:schemeClr>
+              </a:solidFill>
+            </a:endParaRPr>
+          </a:p>
+        </p:txBody>
+      </p:sp>
+      <p:pic>
+        <p:nvPicPr>
+          <p:cNvPr id="6" name="Picture 5">
+            <a:extLst>
+              <a:ext uri="{FF2B5EF4-FFF2-40B4-BE49-F238E27FC236}">
+                <a16:creationId xmlns:a16="http://schemas.microsoft.com/office/drawing/2014/main" id="{D51FB2D0-AFF9-CDEF-7567-C197B48D4C90}"/>
+              </a:ext>
+            </a:extLst>
+          </p:cNvPr>
+          <p:cNvPicPr>
+            <a:picLocks noChangeAspect="1"/>
+          </p:cNvPicPr>
+          <p:nvPr/>
+        </p:nvPicPr>
+        <p:blipFill>
+          <a:blip r:embed="rId3"/>
+          <a:stretch>
+            <a:fillRect/>
+          </a:stretch>
+        </p:blipFill>
+        <p:spPr>
+          <a:xfrm>
+            <a:off x="3023900" y="1114405"/>
+            <a:ext cx="664252" cy="631449"/>
+          </a:xfrm>
+          <a:prstGeom prst="rect">
+            <a:avLst/>
+          </a:prstGeom>
+        </p:spPr>
+      </p:pic>
+      <p:sp>
+        <p:nvSpPr>
+          <p:cNvPr id="7" name="TextBox 6">
+            <a:extLst>
+              <a:ext uri="{FF2B5EF4-FFF2-40B4-BE49-F238E27FC236}">
+                <a16:creationId xmlns:a16="http://schemas.microsoft.com/office/drawing/2014/main" id="{B0C26ADD-BCF5-082F-67C0-8BC556475408}"/>
+              </a:ext>
+            </a:extLst>
+          </p:cNvPr>
+          <p:cNvSpPr txBox="1"/>
+          <p:nvPr/>
+        </p:nvSpPr>
+        <p:spPr>
+          <a:xfrm>
+            <a:off x="2733058" y="678099"/>
+            <a:ext cx="1668004" cy="307777"/>
+          </a:xfrm>
+          <a:prstGeom prst="rect">
+            <a:avLst/>
+          </a:prstGeom>
+          <a:noFill/>
+        </p:spPr>
+        <p:txBody>
+          <a:bodyPr wrap="square">
+            <a:spAutoFit/>
+          </a:bodyPr>
+          <a:lstStyle/>
+          <a:p>
+            <a:r>
+              <a:rPr lang="en-US" sz="1400" b="1" dirty="0">
+                <a:solidFill>
+                  <a:schemeClr val="tx1">
+                    <a:lumMod val="75000"/>
+                    <a:lumOff val="25000"/>
+                  </a:schemeClr>
+                </a:solidFill>
+              </a:rPr>
+              <a:t>RTSP Video server</a:t>
+            </a:r>
+            <a:endParaRPr lang="en-SG" sz="1400" b="1" dirty="0">
+              <a:solidFill>
+                <a:schemeClr val="tx1">
+                  <a:lumMod val="75000"/>
+                  <a:lumOff val="25000"/>
+                </a:schemeClr>
+              </a:solidFill>
+            </a:endParaRPr>
+          </a:p>
+        </p:txBody>
+      </p:sp>
+      <p:pic>
+        <p:nvPicPr>
+          <p:cNvPr id="1028" name="Picture 4" descr="Folder images Icon | Free Folder Iconpack | Iconshock">
+            <a:extLst>
+              <a:ext uri="{FF2B5EF4-FFF2-40B4-BE49-F238E27FC236}">
+                <a16:creationId xmlns:a16="http://schemas.microsoft.com/office/drawing/2014/main" id="{4F5F0147-7AAC-0DB1-F1A8-62C15B8B7ECA}"/>
+              </a:ext>
+            </a:extLst>
+          </p:cNvPr>
+          <p:cNvPicPr>
+            <a:picLocks noChangeAspect="1" noChangeArrowheads="1"/>
+          </p:cNvPicPr>
+          <p:nvPr/>
+        </p:nvPicPr>
+        <p:blipFill>
+          <a:blip r:embed="rId4">
+            <a:extLst>
+              <a:ext uri="{28A0092B-C50C-407E-A947-70E740481C1C}">
+                <a14:useLocalDpi xmlns:a14="http://schemas.microsoft.com/office/drawing/2010/main" val="0"/>
+              </a:ext>
+            </a:extLst>
+          </a:blip>
+          <a:srcRect/>
+          <a:stretch>
+            <a:fillRect/>
+          </a:stretch>
+        </p:blipFill>
+        <p:spPr bwMode="auto">
+          <a:xfrm>
+            <a:off x="4769026" y="1043421"/>
+            <a:ext cx="726204" cy="726204"/>
+          </a:xfrm>
+          <a:prstGeom prst="rect">
+            <a:avLst/>
+          </a:prstGeom>
+          <a:noFill/>
+          <a:extLst>
+            <a:ext uri="{909E8E84-426E-40DD-AFC4-6F175D3DCCD1}">
+              <a14:hiddenFill xmlns:a14="http://schemas.microsoft.com/office/drawing/2010/main">
+                <a:solidFill>
+                  <a:srgbClr val="FFFFFF"/>
+                </a:solidFill>
+              </a14:hiddenFill>
+            </a:ext>
+          </a:extLst>
+        </p:spPr>
+      </p:pic>
+      <p:sp>
+        <p:nvSpPr>
+          <p:cNvPr id="8" name="TextBox 7">
+            <a:extLst>
+              <a:ext uri="{FF2B5EF4-FFF2-40B4-BE49-F238E27FC236}">
+                <a16:creationId xmlns:a16="http://schemas.microsoft.com/office/drawing/2014/main" id="{9E24AF49-FC8A-1870-DC15-72F43AF37E84}"/>
+              </a:ext>
+            </a:extLst>
+          </p:cNvPr>
+          <p:cNvSpPr txBox="1"/>
+          <p:nvPr/>
+        </p:nvSpPr>
+        <p:spPr>
+          <a:xfrm>
+            <a:off x="4401062" y="698259"/>
+            <a:ext cx="1822486" cy="307777"/>
+          </a:xfrm>
+          <a:prstGeom prst="rect">
+            <a:avLst/>
+          </a:prstGeom>
+          <a:noFill/>
+        </p:spPr>
+        <p:txBody>
+          <a:bodyPr wrap="square">
+            <a:spAutoFit/>
+          </a:bodyPr>
+          <a:lstStyle/>
+          <a:p>
+            <a:r>
+              <a:rPr lang="en-US" sz="1400" b="1" dirty="0">
+                <a:solidFill>
+                  <a:schemeClr val="tx1">
+                    <a:lumMod val="75000"/>
+                    <a:lumOff val="25000"/>
+                  </a:schemeClr>
+                </a:solidFill>
+              </a:rPr>
+              <a:t>Pictures Data Set</a:t>
+            </a:r>
+            <a:endParaRPr lang="en-SG" sz="1400" b="1" dirty="0">
+              <a:solidFill>
+                <a:schemeClr val="tx1">
+                  <a:lumMod val="75000"/>
+                  <a:lumOff val="25000"/>
+                </a:schemeClr>
+              </a:solidFill>
+            </a:endParaRPr>
+          </a:p>
+        </p:txBody>
+      </p:sp>
+      <p:pic>
+        <p:nvPicPr>
+          <p:cNvPr id="10" name="Picture 9">
+            <a:extLst>
+              <a:ext uri="{FF2B5EF4-FFF2-40B4-BE49-F238E27FC236}">
+                <a16:creationId xmlns:a16="http://schemas.microsoft.com/office/drawing/2014/main" id="{EF14CECB-8E08-231D-2A36-E998D7F1FFA4}"/>
+              </a:ext>
+            </a:extLst>
+          </p:cNvPr>
+          <p:cNvPicPr>
+            <a:picLocks noChangeAspect="1"/>
+          </p:cNvPicPr>
+          <p:nvPr/>
+        </p:nvPicPr>
+        <p:blipFill>
+          <a:blip r:embed="rId5"/>
+          <a:stretch>
+            <a:fillRect/>
+          </a:stretch>
+        </p:blipFill>
+        <p:spPr>
+          <a:xfrm>
+            <a:off x="6576104" y="1118522"/>
+            <a:ext cx="789144" cy="627332"/>
+          </a:xfrm>
+          <a:prstGeom prst="rect">
+            <a:avLst/>
+          </a:prstGeom>
+        </p:spPr>
+      </p:pic>
+      <p:sp>
+        <p:nvSpPr>
+          <p:cNvPr id="11" name="TextBox 10">
+            <a:extLst>
+              <a:ext uri="{FF2B5EF4-FFF2-40B4-BE49-F238E27FC236}">
+                <a16:creationId xmlns:a16="http://schemas.microsoft.com/office/drawing/2014/main" id="{90DF4BB7-8192-D0A1-5917-163BBE054545}"/>
+              </a:ext>
+            </a:extLst>
+          </p:cNvPr>
+          <p:cNvSpPr txBox="1"/>
+          <p:nvPr/>
+        </p:nvSpPr>
+        <p:spPr>
+          <a:xfrm>
+            <a:off x="6093853" y="694939"/>
+            <a:ext cx="1942092" cy="307777"/>
+          </a:xfrm>
+          <a:prstGeom prst="rect">
+            <a:avLst/>
+          </a:prstGeom>
+          <a:noFill/>
+        </p:spPr>
+        <p:txBody>
+          <a:bodyPr wrap="square">
+            <a:spAutoFit/>
+          </a:bodyPr>
+          <a:lstStyle/>
+          <a:p>
+            <a:r>
+              <a:rPr lang="en-US" sz="1400" b="1" dirty="0">
+                <a:solidFill>
+                  <a:schemeClr val="tx1">
+                    <a:lumMod val="75000"/>
+                    <a:lumOff val="25000"/>
+                  </a:schemeClr>
+                </a:solidFill>
+              </a:rPr>
+              <a:t>Screen Recording</a:t>
+            </a:r>
+            <a:endParaRPr lang="en-SG" sz="1400" b="1" dirty="0">
+              <a:solidFill>
+                <a:schemeClr val="tx1">
+                  <a:lumMod val="75000"/>
+                  <a:lumOff val="25000"/>
+                </a:schemeClr>
+              </a:solidFill>
+            </a:endParaRPr>
+          </a:p>
+        </p:txBody>
+      </p:sp>
+      <p:pic>
+        <p:nvPicPr>
+          <p:cNvPr id="1030" name="Picture 6" descr="Application Flaticons Lineal Color icon | Freepik">
+            <a:extLst>
+              <a:ext uri="{FF2B5EF4-FFF2-40B4-BE49-F238E27FC236}">
+                <a16:creationId xmlns:a16="http://schemas.microsoft.com/office/drawing/2014/main" id="{D680763A-B9AE-32E3-9CDA-1D12A0EB1172}"/>
+              </a:ext>
+            </a:extLst>
+          </p:cNvPr>
+          <p:cNvPicPr>
+            <a:picLocks noChangeAspect="1" noChangeArrowheads="1"/>
+          </p:cNvPicPr>
+          <p:nvPr/>
+        </p:nvPicPr>
+        <p:blipFill>
+          <a:blip r:embed="rId6">
+            <a:extLst>
+              <a:ext uri="{28A0092B-C50C-407E-A947-70E740481C1C}">
+                <a14:useLocalDpi xmlns:a14="http://schemas.microsoft.com/office/drawing/2010/main" val="0"/>
+              </a:ext>
+            </a:extLst>
+          </a:blip>
+          <a:srcRect/>
+          <a:stretch>
+            <a:fillRect/>
+          </a:stretch>
+        </p:blipFill>
+        <p:spPr bwMode="auto">
+          <a:xfrm>
+            <a:off x="8313493" y="1161892"/>
+            <a:ext cx="629368" cy="629368"/>
+          </a:xfrm>
+          <a:prstGeom prst="rect">
+            <a:avLst/>
+          </a:prstGeom>
+          <a:noFill/>
+          <a:extLst>
+            <a:ext uri="{909E8E84-426E-40DD-AFC4-6F175D3DCCD1}">
+              <a14:hiddenFill xmlns:a14="http://schemas.microsoft.com/office/drawing/2010/main">
+                <a:solidFill>
+                  <a:srgbClr val="FFFFFF"/>
+                </a:solidFill>
+              </a14:hiddenFill>
+            </a:ext>
+          </a:extLst>
+        </p:spPr>
+      </p:pic>
+      <p:sp>
+        <p:nvSpPr>
+          <p:cNvPr id="12" name="TextBox 11">
+            <a:extLst>
+              <a:ext uri="{FF2B5EF4-FFF2-40B4-BE49-F238E27FC236}">
+                <a16:creationId xmlns:a16="http://schemas.microsoft.com/office/drawing/2014/main" id="{DAB31FAC-8E0F-A0CF-FC80-8934A7E4E9D2}"/>
+              </a:ext>
+            </a:extLst>
+          </p:cNvPr>
+          <p:cNvSpPr txBox="1"/>
+          <p:nvPr/>
+        </p:nvSpPr>
+        <p:spPr>
+          <a:xfrm>
+            <a:off x="7924440" y="678099"/>
+            <a:ext cx="1942092" cy="523220"/>
+          </a:xfrm>
+          <a:prstGeom prst="rect">
+            <a:avLst/>
+          </a:prstGeom>
+          <a:noFill/>
+        </p:spPr>
+        <p:txBody>
+          <a:bodyPr wrap="square">
+            <a:spAutoFit/>
+          </a:bodyPr>
+          <a:lstStyle/>
+          <a:p>
+            <a:r>
+              <a:rPr lang="en-US" sz="1400" b="1" dirty="0">
+                <a:solidFill>
+                  <a:schemeClr val="tx1">
+                    <a:lumMod val="75000"/>
+                    <a:lumOff val="25000"/>
+                  </a:schemeClr>
+                </a:solidFill>
+              </a:rPr>
+              <a:t>Application Window  Screen shot </a:t>
+            </a:r>
+            <a:endParaRPr lang="en-SG" sz="1400" b="1" dirty="0">
+              <a:solidFill>
+                <a:schemeClr val="tx1">
+                  <a:lumMod val="75000"/>
+                  <a:lumOff val="25000"/>
+                </a:schemeClr>
+              </a:solidFill>
+            </a:endParaRPr>
+          </a:p>
+        </p:txBody>
+      </p:sp>
+      <p:sp>
+        <p:nvSpPr>
+          <p:cNvPr id="14" name="TextBox 13">
+            <a:extLst>
+              <a:ext uri="{FF2B5EF4-FFF2-40B4-BE49-F238E27FC236}">
+                <a16:creationId xmlns:a16="http://schemas.microsoft.com/office/drawing/2014/main" id="{42228077-B29A-6297-80F2-58FCD95ADD78}"/>
+              </a:ext>
+            </a:extLst>
+          </p:cNvPr>
+          <p:cNvSpPr txBox="1"/>
+          <p:nvPr/>
+        </p:nvSpPr>
+        <p:spPr>
+          <a:xfrm>
+            <a:off x="9071264" y="1241413"/>
+            <a:ext cx="1553984" cy="584775"/>
+          </a:xfrm>
+          <a:prstGeom prst="rect">
+            <a:avLst/>
+          </a:prstGeom>
+          <a:noFill/>
+        </p:spPr>
+        <p:txBody>
+          <a:bodyPr wrap="square">
+            <a:spAutoFit/>
+          </a:bodyPr>
+          <a:lstStyle/>
+          <a:p>
+            <a:r>
+              <a:rPr lang="en-US" sz="1600" b="1" dirty="0">
+                <a:solidFill>
+                  <a:schemeClr val="accent6">
+                    <a:lumMod val="75000"/>
+                  </a:schemeClr>
+                </a:solidFill>
+              </a:rPr>
+              <a:t>5 Different Video Source</a:t>
+            </a:r>
+            <a:endParaRPr lang="en-SG" sz="1600" b="1" dirty="0">
+              <a:solidFill>
+                <a:schemeClr val="accent6">
+                  <a:lumMod val="75000"/>
+                </a:schemeClr>
+              </a:solidFill>
+            </a:endParaRPr>
+          </a:p>
+        </p:txBody>
+      </p:sp>
+      <p:pic>
+        <p:nvPicPr>
+          <p:cNvPr id="18" name="Graphic 17" descr="Web design with solid fill">
+            <a:extLst>
+              <a:ext uri="{FF2B5EF4-FFF2-40B4-BE49-F238E27FC236}">
+                <a16:creationId xmlns:a16="http://schemas.microsoft.com/office/drawing/2014/main" id="{77E0C4C9-D36F-C627-1554-3B240DB8A9AB}"/>
+              </a:ext>
+            </a:extLst>
+          </p:cNvPr>
+          <p:cNvPicPr>
+            <a:picLocks noChangeAspect="1"/>
+          </p:cNvPicPr>
+          <p:nvPr/>
+        </p:nvPicPr>
+        <p:blipFill>
+          <a:blip r:embed="rId7">
+            <a:extLst>
+              <a:ext uri="{96DAC541-7B7A-43D3-8B79-37D633B846F1}">
+                <asvg:svgBlip xmlns:asvg="http://schemas.microsoft.com/office/drawing/2016/SVG/main" r:embed="rId8"/>
+              </a:ext>
+            </a:extLst>
+          </a:blip>
+          <a:stretch>
+            <a:fillRect/>
+          </a:stretch>
+        </p:blipFill>
+        <p:spPr>
+          <a:xfrm>
+            <a:off x="1609952" y="2422633"/>
+            <a:ext cx="845350" cy="845350"/>
+          </a:xfrm>
+          <a:prstGeom prst="rect">
+            <a:avLst/>
+          </a:prstGeom>
+        </p:spPr>
+      </p:pic>
       <p:cxnSp>
         <p:nvCxnSpPr>
-          <p:cNvPr id="9" name="Straight Arrow Connector 8">
-            <a:extLst>
-              <a:ext uri="{FF2B5EF4-FFF2-40B4-BE49-F238E27FC236}">
-                <a16:creationId xmlns:a16="http://schemas.microsoft.com/office/drawing/2014/main" id="{8AEE00F4-22BE-6C96-27EF-66E6AD06243A}"/>
+          <p:cNvPr id="21" name="Straight Connector 20">
+            <a:extLst>
+              <a:ext uri="{FF2B5EF4-FFF2-40B4-BE49-F238E27FC236}">
+                <a16:creationId xmlns:a16="http://schemas.microsoft.com/office/drawing/2014/main" id="{271E2D5E-E190-237F-B206-6226603CF68D}"/>
               </a:ext>
             </a:extLst>
           </p:cNvPr>
@@ -5609,16 +4639,14 @@
           <p:nvPr/>
         </p:nvCxnSpPr>
         <p:spPr>
-          <a:xfrm flipH="1">
-            <a:off x="6513077" y="2377665"/>
-            <a:ext cx="0" cy="188554"/>
-          </a:xfrm>
-          <a:prstGeom prst="straightConnector1">
-            <a:avLst/>
-          </a:prstGeom>
-          <a:ln>
-            <a:tailEnd type="triangle"/>
-          </a:ln>
+          <a:xfrm flipV="1">
+            <a:off x="1745426" y="2182091"/>
+            <a:ext cx="6882751" cy="3"/>
+          </a:xfrm>
+          <a:prstGeom prst="line">
+            <a:avLst/>
+          </a:prstGeom>
+          <a:ln w="28575"/>
         </p:spPr>
         <p:style>
           <a:lnRef idx="2">
@@ -5637,187 +4665,165 @@
       </p:cxnSp>
       <p:sp>
         <p:nvSpPr>
-          <p:cNvPr id="10" name="Rectangle 9">
-            <a:extLst>
-              <a:ext uri="{FF2B5EF4-FFF2-40B4-BE49-F238E27FC236}">
-                <a16:creationId xmlns:a16="http://schemas.microsoft.com/office/drawing/2014/main" id="{831EA590-ED1E-389D-C2EB-A578B654D40B}"/>
-              </a:ext>
-            </a:extLst>
-          </p:cNvPr>
-          <p:cNvSpPr/>
-          <p:nvPr/>
-        </p:nvSpPr>
-        <p:spPr>
-          <a:xfrm>
-            <a:off x="3869877" y="3838893"/>
-            <a:ext cx="1937698" cy="338554"/>
+          <p:cNvPr id="37" name="TextBox 36">
+            <a:extLst>
+              <a:ext uri="{FF2B5EF4-FFF2-40B4-BE49-F238E27FC236}">
+                <a16:creationId xmlns:a16="http://schemas.microsoft.com/office/drawing/2014/main" id="{258E1831-CD12-30A2-D4B1-4CAA16AAF7E9}"/>
+              </a:ext>
+            </a:extLst>
+          </p:cNvPr>
+          <p:cNvSpPr txBox="1"/>
+          <p:nvPr/>
+        </p:nvSpPr>
+        <p:spPr>
+          <a:xfrm>
+            <a:off x="901983" y="2834918"/>
+            <a:ext cx="1368324" cy="830997"/>
           </a:xfrm>
           <a:prstGeom prst="rect">
             <a:avLst/>
           </a:prstGeom>
-          <a:solidFill>
-            <a:schemeClr val="tx2">
-              <a:lumMod val="75000"/>
-              <a:lumOff val="25000"/>
-            </a:schemeClr>
-          </a:solidFill>
+          <a:noFill/>
+        </p:spPr>
+        <p:txBody>
+          <a:bodyPr wrap="square">
+            <a:spAutoFit/>
+          </a:bodyPr>
+          <a:lstStyle/>
+          <a:p>
+            <a:r>
+              <a:rPr lang="en-US" sz="1600" b="1" dirty="0"/>
+              <a:t>Virtual Camera Client Lib</a:t>
+            </a:r>
+            <a:endParaRPr lang="en-SG" sz="1600" b="1" dirty="0"/>
+          </a:p>
+        </p:txBody>
+      </p:sp>
+      <p:cxnSp>
+        <p:nvCxnSpPr>
+          <p:cNvPr id="38" name="Straight Arrow Connector 37">
+            <a:extLst>
+              <a:ext uri="{FF2B5EF4-FFF2-40B4-BE49-F238E27FC236}">
+                <a16:creationId xmlns:a16="http://schemas.microsoft.com/office/drawing/2014/main" id="{CD5C236A-5CBF-28A4-41E7-8B5167AFAC53}"/>
+              </a:ext>
+            </a:extLst>
+          </p:cNvPr>
+          <p:cNvCxnSpPr>
+            <a:cxnSpLocks/>
+            <a:stCxn id="1026" idx="2"/>
+          </p:cNvCxnSpPr>
+          <p:nvPr/>
+        </p:nvCxnSpPr>
+        <p:spPr>
+          <a:xfrm flipH="1">
+            <a:off x="1745426" y="1802165"/>
+            <a:ext cx="0" cy="379929"/>
+          </a:xfrm>
+          <a:prstGeom prst="straightConnector1">
+            <a:avLst/>
+          </a:prstGeom>
           <a:ln>
+            <a:tailEnd type="triangle"/>
+          </a:ln>
+        </p:spPr>
+        <p:style>
+          <a:lnRef idx="2">
+            <a:schemeClr val="accent1"/>
+          </a:lnRef>
+          <a:fillRef idx="0">
+            <a:schemeClr val="accent1"/>
+          </a:fillRef>
+          <a:effectRef idx="1">
+            <a:schemeClr val="accent1"/>
+          </a:effectRef>
+          <a:fontRef idx="minor">
+            <a:schemeClr val="tx1"/>
+          </a:fontRef>
+        </p:style>
+      </p:cxnSp>
+      <p:pic>
+        <p:nvPicPr>
+          <p:cNvPr id="42" name="Picture 41" descr="A screenshot of a computer&#10;&#10;AI-generated content may be incorrect.">
+            <a:extLst>
+              <a:ext uri="{FF2B5EF4-FFF2-40B4-BE49-F238E27FC236}">
+                <a16:creationId xmlns:a16="http://schemas.microsoft.com/office/drawing/2014/main" id="{74329011-E43B-FF29-1A3E-D3C3484885C4}"/>
+              </a:ext>
+            </a:extLst>
+          </p:cNvPr>
+          <p:cNvPicPr>
+            <a:picLocks noChangeAspect="1"/>
+          </p:cNvPicPr>
+          <p:nvPr/>
+        </p:nvPicPr>
+        <p:blipFill>
+          <a:blip r:embed="rId9">
+            <a:extLst>
+              <a:ext uri="{28A0092B-C50C-407E-A947-70E740481C1C}">
+                <a14:useLocalDpi xmlns:a14="http://schemas.microsoft.com/office/drawing/2010/main" val="0"/>
+              </a:ext>
+            </a:extLst>
+          </a:blip>
+          <a:stretch>
+            <a:fillRect/>
+          </a:stretch>
+        </p:blipFill>
+        <p:spPr>
+          <a:xfrm>
+            <a:off x="5541572" y="2662385"/>
+            <a:ext cx="4825680" cy="2710384"/>
+          </a:xfrm>
+          <a:prstGeom prst="rect">
+            <a:avLst/>
+          </a:prstGeom>
+          <a:ln w="9525">
             <a:solidFill>
               <a:schemeClr val="tx1"/>
             </a:solidFill>
           </a:ln>
         </p:spPr>
-        <p:style>
-          <a:lnRef idx="2">
-            <a:schemeClr val="accent1">
-              <a:shade val="50000"/>
-            </a:schemeClr>
-          </a:lnRef>
-          <a:fillRef idx="1">
-            <a:schemeClr val="accent1"/>
-          </a:fillRef>
-          <a:effectRef idx="0">
-            <a:schemeClr val="accent1"/>
-          </a:effectRef>
-          <a:fontRef idx="minor">
-            <a:schemeClr val="lt1"/>
-          </a:fontRef>
-        </p:style>
-        <p:txBody>
-          <a:bodyPr rtlCol="0" anchor="ctr"/>
-          <a:lstStyle/>
-          <a:p>
-            <a:r>
-              <a:rPr lang="en-SG" sz="1200" b="1" dirty="0"/>
-              <a:t>Data Manager Module </a:t>
-            </a:r>
-          </a:p>
-        </p:txBody>
-      </p:sp>
-      <p:sp>
-        <p:nvSpPr>
-          <p:cNvPr id="11" name="Rectangle 10">
-            <a:extLst>
-              <a:ext uri="{FF2B5EF4-FFF2-40B4-BE49-F238E27FC236}">
-                <a16:creationId xmlns:a16="http://schemas.microsoft.com/office/drawing/2014/main" id="{43212530-F0D6-978A-DF0D-A3A8FB1D596F}"/>
-              </a:ext>
-            </a:extLst>
-          </p:cNvPr>
-          <p:cNvSpPr/>
-          <p:nvPr/>
-        </p:nvSpPr>
-        <p:spPr>
-          <a:xfrm>
-            <a:off x="4838727" y="3273881"/>
-            <a:ext cx="2387762" cy="338554"/>
+      </p:pic>
+      <p:pic>
+        <p:nvPicPr>
+          <p:cNvPr id="49" name="Graphic 48" descr="Web design with solid fill">
+            <a:extLst>
+              <a:ext uri="{FF2B5EF4-FFF2-40B4-BE49-F238E27FC236}">
+                <a16:creationId xmlns:a16="http://schemas.microsoft.com/office/drawing/2014/main" id="{9373EFF3-C3CA-A8EC-F712-1E08228526A1}"/>
+              </a:ext>
+            </a:extLst>
+          </p:cNvPr>
+          <p:cNvPicPr>
+            <a:picLocks noChangeAspect="1"/>
+          </p:cNvPicPr>
+          <p:nvPr/>
+        </p:nvPicPr>
+        <p:blipFill>
+          <a:blip r:embed="rId7">
+            <a:extLst>
+              <a:ext uri="{96DAC541-7B7A-43D3-8B79-37D633B846F1}">
+                <asvg:svgBlip xmlns:asvg="http://schemas.microsoft.com/office/drawing/2016/SVG/main" r:embed="rId8"/>
+              </a:ext>
+            </a:extLst>
+          </a:blip>
+          <a:stretch>
+            <a:fillRect/>
+          </a:stretch>
+        </p:blipFill>
+        <p:spPr>
+          <a:xfrm>
+            <a:off x="1575427" y="3731053"/>
+            <a:ext cx="914400" cy="914400"/>
           </a:xfrm>
           <a:prstGeom prst="rect">
             <a:avLst/>
           </a:prstGeom>
-          <a:solidFill>
-            <a:schemeClr val="tx2">
-              <a:lumMod val="75000"/>
-              <a:lumOff val="25000"/>
-            </a:schemeClr>
-          </a:solidFill>
-          <a:ln>
-            <a:solidFill>
-              <a:schemeClr val="tx1"/>
-            </a:solidFill>
-          </a:ln>
-        </p:spPr>
-        <p:style>
-          <a:lnRef idx="2">
-            <a:schemeClr val="accent1">
-              <a:shade val="50000"/>
-            </a:schemeClr>
-          </a:lnRef>
-          <a:fillRef idx="1">
-            <a:schemeClr val="accent1"/>
-          </a:fillRef>
-          <a:effectRef idx="0">
-            <a:schemeClr val="accent1"/>
-          </a:effectRef>
-          <a:fontRef idx="minor">
-            <a:schemeClr val="lt1"/>
-          </a:fontRef>
-        </p:style>
-        <p:txBody>
-          <a:bodyPr rtlCol="0" anchor="ctr"/>
-          <a:lstStyle/>
-          <a:p>
-            <a:r>
-              <a:rPr lang="en-SG" sz="1200" b="1" dirty="0"/>
-              <a:t>Flask Web Service Module </a:t>
-            </a:r>
-          </a:p>
-        </p:txBody>
-      </p:sp>
-      <p:sp>
-        <p:nvSpPr>
-          <p:cNvPr id="12" name="Rectangle 11">
-            <a:extLst>
-              <a:ext uri="{FF2B5EF4-FFF2-40B4-BE49-F238E27FC236}">
-                <a16:creationId xmlns:a16="http://schemas.microsoft.com/office/drawing/2014/main" id="{E167F503-53D7-03EF-F5BE-4400BC086F8F}"/>
-              </a:ext>
-            </a:extLst>
-          </p:cNvPr>
-          <p:cNvSpPr/>
-          <p:nvPr/>
-        </p:nvSpPr>
-        <p:spPr>
-          <a:xfrm>
-            <a:off x="3793526" y="2068441"/>
-            <a:ext cx="2225821" cy="338554"/>
-          </a:xfrm>
-          <a:prstGeom prst="rect">
-            <a:avLst/>
-          </a:prstGeom>
-          <a:solidFill>
-            <a:schemeClr val="tx2">
-              <a:lumMod val="75000"/>
-              <a:lumOff val="25000"/>
-            </a:schemeClr>
-          </a:solidFill>
-          <a:ln>
-            <a:solidFill>
-              <a:schemeClr val="tx1"/>
-            </a:solidFill>
-          </a:ln>
-        </p:spPr>
-        <p:style>
-          <a:lnRef idx="2">
-            <a:schemeClr val="accent1">
-              <a:shade val="50000"/>
-            </a:schemeClr>
-          </a:lnRef>
-          <a:fillRef idx="1">
-            <a:schemeClr val="accent1"/>
-          </a:fillRef>
-          <a:effectRef idx="0">
-            <a:schemeClr val="accent1"/>
-          </a:effectRef>
-          <a:fontRef idx="minor">
-            <a:schemeClr val="lt1"/>
-          </a:fontRef>
-        </p:style>
-        <p:txBody>
-          <a:bodyPr rtlCol="0" anchor="ctr"/>
-          <a:lstStyle/>
-          <a:p>
-            <a:r>
-              <a:rPr lang="en-SG" sz="1200" b="1" dirty="0"/>
-              <a:t>Video Source Manger Module </a:t>
-            </a:r>
-          </a:p>
-        </p:txBody>
-      </p:sp>
+        </p:spPr>
+      </p:pic>
       <p:cxnSp>
         <p:nvCxnSpPr>
-          <p:cNvPr id="16" name="Straight Arrow Connector 15">
-            <a:extLst>
-              <a:ext uri="{FF2B5EF4-FFF2-40B4-BE49-F238E27FC236}">
-                <a16:creationId xmlns:a16="http://schemas.microsoft.com/office/drawing/2014/main" id="{4912AC03-8DA6-D8CA-0ED4-A562424A4FD8}"/>
+          <p:cNvPr id="53" name="Straight Arrow Connector 52">
+            <a:extLst>
+              <a:ext uri="{FF2B5EF4-FFF2-40B4-BE49-F238E27FC236}">
+                <a16:creationId xmlns:a16="http://schemas.microsoft.com/office/drawing/2014/main" id="{C4EDD6BF-B996-C23E-95B9-A4031B65D19B}"/>
               </a:ext>
             </a:extLst>
           </p:cNvPr>
@@ -5828,13 +4834,13 @@
         </p:nvCxnSpPr>
         <p:spPr>
           <a:xfrm>
-            <a:off x="4967636" y="2384955"/>
-            <a:ext cx="0" cy="888926"/>
+            <a:off x="3279817" y="1769625"/>
+            <a:ext cx="0" cy="412469"/>
           </a:xfrm>
           <a:prstGeom prst="straightConnector1">
             <a:avLst/>
           </a:prstGeom>
-          <a:ln>
+          <a:ln w="28575">
             <a:tailEnd type="triangle"/>
           </a:ln>
         </p:spPr>
@@ -5855,10 +4861,10 @@
       </p:cxnSp>
       <p:cxnSp>
         <p:nvCxnSpPr>
-          <p:cNvPr id="18" name="Straight Arrow Connector 17">
-            <a:extLst>
-              <a:ext uri="{FF2B5EF4-FFF2-40B4-BE49-F238E27FC236}">
-                <a16:creationId xmlns:a16="http://schemas.microsoft.com/office/drawing/2014/main" id="{2F6E7933-5D6D-5174-082D-DC4208989B30}"/>
+          <p:cNvPr id="59" name="Straight Arrow Connector 58">
+            <a:extLst>
+              <a:ext uri="{FF2B5EF4-FFF2-40B4-BE49-F238E27FC236}">
+                <a16:creationId xmlns:a16="http://schemas.microsoft.com/office/drawing/2014/main" id="{00B639C0-0151-BA37-B97B-3AA51DAC9CE2}"/>
               </a:ext>
             </a:extLst>
           </p:cNvPr>
@@ -5868,14 +4874,14 @@
           <p:nvPr/>
         </p:nvCxnSpPr>
         <p:spPr>
-          <a:xfrm flipV="1">
-            <a:off x="4965513" y="3612435"/>
-            <a:ext cx="0" cy="219055"/>
+          <a:xfrm>
+            <a:off x="1745426" y="1814634"/>
+            <a:ext cx="0" cy="367457"/>
           </a:xfrm>
           <a:prstGeom prst="straightConnector1">
             <a:avLst/>
           </a:prstGeom>
-          <a:ln>
+          <a:ln w="28575">
             <a:tailEnd type="triangle"/>
           </a:ln>
         </p:spPr>
@@ -5896,10 +4902,10 @@
       </p:cxnSp>
       <p:cxnSp>
         <p:nvCxnSpPr>
-          <p:cNvPr id="26" name="Straight Arrow Connector 25">
-            <a:extLst>
-              <a:ext uri="{FF2B5EF4-FFF2-40B4-BE49-F238E27FC236}">
-                <a16:creationId xmlns:a16="http://schemas.microsoft.com/office/drawing/2014/main" id="{F679CB73-DBB5-9E76-3B51-8023C411BC91}"/>
+          <p:cNvPr id="60" name="Straight Arrow Connector 59">
+            <a:extLst>
+              <a:ext uri="{FF2B5EF4-FFF2-40B4-BE49-F238E27FC236}">
+                <a16:creationId xmlns:a16="http://schemas.microsoft.com/office/drawing/2014/main" id="{D40D7555-136F-1B8A-5BE0-CFEEE888D221}"/>
               </a:ext>
             </a:extLst>
           </p:cNvPr>
@@ -5910,195 +4916,13 @@
         </p:nvCxnSpPr>
         <p:spPr>
           <a:xfrm>
-            <a:off x="3579684" y="4000155"/>
-            <a:ext cx="290193" cy="0"/>
+            <a:off x="5084372" y="1769625"/>
+            <a:ext cx="0" cy="412469"/>
           </a:xfrm>
           <a:prstGeom prst="straightConnector1">
             <a:avLst/>
           </a:prstGeom>
-          <a:ln>
-            <a:tailEnd type="triangle"/>
-          </a:ln>
-        </p:spPr>
-        <p:style>
-          <a:lnRef idx="2">
-            <a:schemeClr val="accent1"/>
-          </a:lnRef>
-          <a:fillRef idx="0">
-            <a:schemeClr val="accent1"/>
-          </a:fillRef>
-          <a:effectRef idx="1">
-            <a:schemeClr val="accent1"/>
-          </a:effectRef>
-          <a:fontRef idx="minor">
-            <a:schemeClr val="tx1"/>
-          </a:fontRef>
-        </p:style>
-      </p:cxnSp>
-      <p:pic>
-        <p:nvPicPr>
-          <p:cNvPr id="21" name="Picture 20" descr="A computer screen shot of a runway&#10;&#10;AI-generated content may be incorrect.">
-            <a:extLst>
-              <a:ext uri="{FF2B5EF4-FFF2-40B4-BE49-F238E27FC236}">
-                <a16:creationId xmlns:a16="http://schemas.microsoft.com/office/drawing/2014/main" id="{A5A68227-F3E4-A5D8-E5BE-F49D0AF99408}"/>
-              </a:ext>
-            </a:extLst>
-          </p:cNvPr>
-          <p:cNvPicPr>
-            <a:picLocks noChangeAspect="1"/>
-          </p:cNvPicPr>
-          <p:nvPr/>
-        </p:nvPicPr>
-        <p:blipFill>
-          <a:blip r:embed="rId2">
-            <a:extLst>
-              <a:ext uri="{28A0092B-C50C-407E-A947-70E740481C1C}">
-                <a14:useLocalDpi xmlns:a14="http://schemas.microsoft.com/office/drawing/2010/main" val="0"/>
-              </a:ext>
-            </a:extLst>
-          </a:blip>
-          <a:stretch>
-            <a:fillRect/>
-          </a:stretch>
-        </p:blipFill>
-        <p:spPr>
-          <a:xfrm>
-            <a:off x="396148" y="2685683"/>
-            <a:ext cx="3175137" cy="1739086"/>
-          </a:xfrm>
-          <a:prstGeom prst="rect">
-            <a:avLst/>
-          </a:prstGeom>
-          <a:ln w="9525">
-            <a:solidFill>
-              <a:schemeClr val="tx1"/>
-            </a:solidFill>
-          </a:ln>
-        </p:spPr>
-      </p:pic>
-      <p:sp>
-        <p:nvSpPr>
-          <p:cNvPr id="29" name="TextBox 28">
-            <a:extLst>
-              <a:ext uri="{FF2B5EF4-FFF2-40B4-BE49-F238E27FC236}">
-                <a16:creationId xmlns:a16="http://schemas.microsoft.com/office/drawing/2014/main" id="{2D6FEFEC-0A21-437D-3206-81C9C8C59D79}"/>
-              </a:ext>
-            </a:extLst>
-          </p:cNvPr>
-          <p:cNvSpPr txBox="1"/>
-          <p:nvPr/>
-        </p:nvSpPr>
-        <p:spPr>
-          <a:xfrm>
-            <a:off x="267695" y="2372513"/>
-            <a:ext cx="3339694" cy="523220"/>
-          </a:xfrm>
-          <a:prstGeom prst="rect">
-            <a:avLst/>
-          </a:prstGeom>
-          <a:noFill/>
-        </p:spPr>
-        <p:txBody>
-          <a:bodyPr wrap="square" rtlCol="0">
-            <a:spAutoFit/>
-          </a:bodyPr>
-          <a:lstStyle/>
-          <a:p>
-            <a:r>
-              <a:rPr lang="en-SG" sz="1400" b="1" dirty="0"/>
-              <a:t>Cyber Range Physical World Simulator F</a:t>
-            </a:r>
-          </a:p>
-        </p:txBody>
-      </p:sp>
-      <p:pic>
-        <p:nvPicPr>
-          <p:cNvPr id="31" name="Picture 30">
-            <a:extLst>
-              <a:ext uri="{FF2B5EF4-FFF2-40B4-BE49-F238E27FC236}">
-                <a16:creationId xmlns:a16="http://schemas.microsoft.com/office/drawing/2014/main" id="{0127D3F8-A57E-20C1-8EF0-5AE80F4191B5}"/>
-              </a:ext>
-            </a:extLst>
-          </p:cNvPr>
-          <p:cNvPicPr>
-            <a:picLocks noChangeAspect="1"/>
-          </p:cNvPicPr>
-          <p:nvPr/>
-        </p:nvPicPr>
-        <p:blipFill>
-          <a:blip r:embed="rId3"/>
-          <a:stretch>
-            <a:fillRect/>
-          </a:stretch>
-        </p:blipFill>
-        <p:spPr>
-          <a:xfrm>
-            <a:off x="360046" y="1786598"/>
-            <a:ext cx="3247343" cy="478983"/>
-          </a:xfrm>
-          <a:prstGeom prst="rect">
-            <a:avLst/>
-          </a:prstGeom>
-        </p:spPr>
-      </p:pic>
-      <p:sp>
-        <p:nvSpPr>
-          <p:cNvPr id="32" name="TextBox 31">
-            <a:extLst>
-              <a:ext uri="{FF2B5EF4-FFF2-40B4-BE49-F238E27FC236}">
-                <a16:creationId xmlns:a16="http://schemas.microsoft.com/office/drawing/2014/main" id="{6AF2A4BE-9C38-88B7-208B-94F3BD0C9369}"/>
-              </a:ext>
-            </a:extLst>
-          </p:cNvPr>
-          <p:cNvSpPr txBox="1"/>
-          <p:nvPr/>
-        </p:nvSpPr>
-        <p:spPr>
-          <a:xfrm>
-            <a:off x="360046" y="1408370"/>
-            <a:ext cx="2023197" cy="307777"/>
-          </a:xfrm>
-          <a:prstGeom prst="rect">
-            <a:avLst/>
-          </a:prstGeom>
-          <a:noFill/>
-        </p:spPr>
-        <p:txBody>
-          <a:bodyPr wrap="square" rtlCol="0">
-            <a:spAutoFit/>
-          </a:bodyPr>
-          <a:lstStyle/>
-          <a:p>
-            <a:r>
-              <a:rPr lang="en-SG" sz="1400" b="1" dirty="0"/>
-              <a:t>Video Stream Source </a:t>
-            </a:r>
-          </a:p>
-        </p:txBody>
-      </p:sp>
-      <p:cxnSp>
-        <p:nvCxnSpPr>
-          <p:cNvPr id="33" name="Straight Arrow Connector 32">
-            <a:extLst>
-              <a:ext uri="{FF2B5EF4-FFF2-40B4-BE49-F238E27FC236}">
-                <a16:creationId xmlns:a16="http://schemas.microsoft.com/office/drawing/2014/main" id="{AEE6FBF7-A397-B5F6-8C2B-7BFB0872A311}"/>
-              </a:ext>
-            </a:extLst>
-          </p:cNvPr>
-          <p:cNvCxnSpPr>
-            <a:cxnSpLocks/>
-          </p:cNvCxnSpPr>
-          <p:nvPr/>
-        </p:nvCxnSpPr>
-        <p:spPr>
-          <a:xfrm>
-            <a:off x="3579684" y="2202315"/>
-            <a:ext cx="213842" cy="0"/>
-          </a:xfrm>
-          <a:prstGeom prst="straightConnector1">
-            <a:avLst/>
-          </a:prstGeom>
-          <a:ln>
+          <a:ln w="28575">
             <a:tailEnd type="triangle"/>
           </a:ln>
         </p:spPr>
@@ -6119,28 +4943,27 @@
       </p:cxnSp>
       <p:cxnSp>
         <p:nvCxnSpPr>
-          <p:cNvPr id="35" name="Straight Arrow Connector 34">
-            <a:extLst>
-              <a:ext uri="{FF2B5EF4-FFF2-40B4-BE49-F238E27FC236}">
-                <a16:creationId xmlns:a16="http://schemas.microsoft.com/office/drawing/2014/main" id="{C69B1288-537A-E9AB-1560-BAE1CB70103D}"/>
+          <p:cNvPr id="61" name="Straight Arrow Connector 60">
+            <a:extLst>
+              <a:ext uri="{FF2B5EF4-FFF2-40B4-BE49-F238E27FC236}">
+                <a16:creationId xmlns:a16="http://schemas.microsoft.com/office/drawing/2014/main" id="{5F0E1DAD-9B25-C0D2-5F4D-DDCC4FC7014E}"/>
               </a:ext>
             </a:extLst>
           </p:cNvPr>
           <p:cNvCxnSpPr>
             <a:cxnSpLocks/>
-            <a:stCxn id="11" idx="3"/>
           </p:cNvCxnSpPr>
           <p:nvPr/>
         </p:nvCxnSpPr>
         <p:spPr>
           <a:xfrm>
-            <a:off x="7226489" y="3443158"/>
-            <a:ext cx="311348" cy="0"/>
+            <a:off x="6975517" y="1745854"/>
+            <a:ext cx="0" cy="412469"/>
           </a:xfrm>
           <a:prstGeom prst="straightConnector1">
             <a:avLst/>
           </a:prstGeom>
-          <a:ln>
+          <a:ln w="28575">
             <a:tailEnd type="triangle"/>
           </a:ln>
         </p:spPr>
@@ -6159,47 +4982,12 @@
           </a:fontRef>
         </p:style>
       </p:cxnSp>
-      <p:pic>
-        <p:nvPicPr>
-          <p:cNvPr id="39" name="Picture 38">
-            <a:extLst>
-              <a:ext uri="{FF2B5EF4-FFF2-40B4-BE49-F238E27FC236}">
-                <a16:creationId xmlns:a16="http://schemas.microsoft.com/office/drawing/2014/main" id="{57E62C6C-7D80-AC36-A313-A707018E0058}"/>
-              </a:ext>
-            </a:extLst>
-          </p:cNvPr>
-          <p:cNvPicPr>
-            <a:picLocks noChangeAspect="1"/>
-          </p:cNvPicPr>
-          <p:nvPr/>
-        </p:nvPicPr>
-        <p:blipFill>
-          <a:blip r:embed="rId4"/>
-          <a:stretch>
-            <a:fillRect/>
-          </a:stretch>
-        </p:blipFill>
-        <p:spPr>
-          <a:xfrm>
-            <a:off x="7537837" y="1791813"/>
-            <a:ext cx="3882607" cy="2603206"/>
-          </a:xfrm>
-          <a:prstGeom prst="rect">
-            <a:avLst/>
-          </a:prstGeom>
-          <a:ln w="12700">
-            <a:solidFill>
-              <a:schemeClr val="tx1"/>
-            </a:solidFill>
-          </a:ln>
-        </p:spPr>
-      </p:pic>
       <p:cxnSp>
         <p:nvCxnSpPr>
-          <p:cNvPr id="44" name="Straight Arrow Connector 43">
-            <a:extLst>
-              <a:ext uri="{FF2B5EF4-FFF2-40B4-BE49-F238E27FC236}">
-                <a16:creationId xmlns:a16="http://schemas.microsoft.com/office/drawing/2014/main" id="{1C313551-14B2-8300-1EDF-9C31D34374FF}"/>
+          <p:cNvPr id="62" name="Straight Arrow Connector 61">
+            <a:extLst>
+              <a:ext uri="{FF2B5EF4-FFF2-40B4-BE49-F238E27FC236}">
+                <a16:creationId xmlns:a16="http://schemas.microsoft.com/office/drawing/2014/main" id="{C9C4C224-A813-99AB-6416-F0F0D647E5A4}"/>
               </a:ext>
             </a:extLst>
           </p:cNvPr>
@@ -6209,14 +4997,14 @@
           <p:nvPr/>
         </p:nvCxnSpPr>
         <p:spPr>
-          <a:xfrm flipH="1">
-            <a:off x="6096000" y="3085327"/>
-            <a:ext cx="0" cy="188554"/>
+          <a:xfrm>
+            <a:off x="8597005" y="1802165"/>
+            <a:ext cx="0" cy="412469"/>
           </a:xfrm>
           <a:prstGeom prst="straightConnector1">
             <a:avLst/>
           </a:prstGeom>
-          <a:ln>
+          <a:ln w="28575">
             <a:tailEnd type="triangle"/>
           </a:ln>
         </p:spPr>
@@ -6235,12 +5023,130 @@
           </a:fontRef>
         </p:style>
       </p:cxnSp>
+      <p:cxnSp>
+        <p:nvCxnSpPr>
+          <p:cNvPr id="63" name="Straight Arrow Connector 62">
+            <a:extLst>
+              <a:ext uri="{FF2B5EF4-FFF2-40B4-BE49-F238E27FC236}">
+                <a16:creationId xmlns:a16="http://schemas.microsoft.com/office/drawing/2014/main" id="{939080D0-CEEF-9EF3-C1DA-2A9AFCA741E5}"/>
+              </a:ext>
+            </a:extLst>
+          </p:cNvPr>
+          <p:cNvCxnSpPr>
+            <a:cxnSpLocks/>
+          </p:cNvCxnSpPr>
+          <p:nvPr/>
+        </p:nvCxnSpPr>
+        <p:spPr>
+          <a:xfrm>
+            <a:off x="2032627" y="2182091"/>
+            <a:ext cx="0" cy="384464"/>
+          </a:xfrm>
+          <a:prstGeom prst="straightConnector1">
+            <a:avLst/>
+          </a:prstGeom>
+          <a:ln w="28575">
+            <a:tailEnd type="triangle"/>
+          </a:ln>
+        </p:spPr>
+        <p:style>
+          <a:lnRef idx="2">
+            <a:schemeClr val="accent1"/>
+          </a:lnRef>
+          <a:fillRef idx="0">
+            <a:schemeClr val="accent1"/>
+          </a:fillRef>
+          <a:effectRef idx="1">
+            <a:schemeClr val="accent1"/>
+          </a:effectRef>
+          <a:fontRef idx="minor">
+            <a:schemeClr val="tx1"/>
+          </a:fontRef>
+        </p:style>
+      </p:cxnSp>
+      <p:cxnSp>
+        <p:nvCxnSpPr>
+          <p:cNvPr id="1029" name="Straight Arrow Connector 1028">
+            <a:extLst>
+              <a:ext uri="{FF2B5EF4-FFF2-40B4-BE49-F238E27FC236}">
+                <a16:creationId xmlns:a16="http://schemas.microsoft.com/office/drawing/2014/main" id="{BC68FBBA-31E1-9472-5CD3-64E06949420B}"/>
+              </a:ext>
+            </a:extLst>
+          </p:cNvPr>
+          <p:cNvCxnSpPr>
+            <a:cxnSpLocks/>
+          </p:cNvCxnSpPr>
+          <p:nvPr/>
+        </p:nvCxnSpPr>
+        <p:spPr>
+          <a:xfrm>
+            <a:off x="2032627" y="3160026"/>
+            <a:ext cx="0" cy="736621"/>
+          </a:xfrm>
+          <a:prstGeom prst="straightConnector1">
+            <a:avLst/>
+          </a:prstGeom>
+          <a:ln w="28575">
+            <a:tailEnd type="triangle"/>
+          </a:ln>
+        </p:spPr>
+        <p:style>
+          <a:lnRef idx="2">
+            <a:schemeClr val="accent1"/>
+          </a:lnRef>
+          <a:fillRef idx="0">
+            <a:schemeClr val="accent1"/>
+          </a:fillRef>
+          <a:effectRef idx="1">
+            <a:schemeClr val="accent1"/>
+          </a:effectRef>
+          <a:fontRef idx="minor">
+            <a:schemeClr val="tx1"/>
+          </a:fontRef>
+        </p:style>
+      </p:cxnSp>
+      <p:sp>
+        <p:nvSpPr>
+          <p:cNvPr id="1033" name="TextBox 1032">
+            <a:extLst>
+              <a:ext uri="{FF2B5EF4-FFF2-40B4-BE49-F238E27FC236}">
+                <a16:creationId xmlns:a16="http://schemas.microsoft.com/office/drawing/2014/main" id="{5CEA3A56-428C-DFC3-3B44-1D49A8CDBFCE}"/>
+              </a:ext>
+            </a:extLst>
+          </p:cNvPr>
+          <p:cNvSpPr txBox="1"/>
+          <p:nvPr/>
+        </p:nvSpPr>
+        <p:spPr>
+          <a:xfrm>
+            <a:off x="1001241" y="4203185"/>
+            <a:ext cx="1340967" cy="830997"/>
+          </a:xfrm>
+          <a:prstGeom prst="rect">
+            <a:avLst/>
+          </a:prstGeom>
+          <a:noFill/>
+        </p:spPr>
+        <p:txBody>
+          <a:bodyPr wrap="square">
+            <a:spAutoFit/>
+          </a:bodyPr>
+          <a:lstStyle/>
+          <a:p>
+            <a:r>
+              <a:rPr lang="en-US" sz="1600" b="1" dirty="0"/>
+              <a:t>Flask Camera Web server</a:t>
+            </a:r>
+            <a:endParaRPr lang="en-SG" sz="1600" b="1" dirty="0"/>
+          </a:p>
+        </p:txBody>
+      </p:sp>
       <p:pic>
         <p:nvPicPr>
-          <p:cNvPr id="50" name="Picture 49">
-            <a:extLst>
-              <a:ext uri="{FF2B5EF4-FFF2-40B4-BE49-F238E27FC236}">
-                <a16:creationId xmlns:a16="http://schemas.microsoft.com/office/drawing/2014/main" id="{9A8651CE-65DD-B836-7E28-1CE96DDDD95B}"/>
+          <p:cNvPr id="1035" name="Picture 1034" descr="A screenshot of a computer&#10;&#10;AI-generated content may be incorrect.">
+            <a:extLst>
+              <a:ext uri="{FF2B5EF4-FFF2-40B4-BE49-F238E27FC236}">
+                <a16:creationId xmlns:a16="http://schemas.microsoft.com/office/drawing/2014/main" id="{3F5ED33D-F215-496B-BD0A-08EBE4475A64}"/>
               </a:ext>
             </a:extLst>
           </p:cNvPr>
@@ -6250,32 +5156,120 @@
           <p:nvPr/>
         </p:nvPicPr>
         <p:blipFill>
-          <a:blip r:embed="rId5"/>
+          <a:blip r:embed="rId10">
+            <a:extLst>
+              <a:ext uri="{28A0092B-C50C-407E-A947-70E740481C1C}">
+                <a14:useLocalDpi xmlns:a14="http://schemas.microsoft.com/office/drawing/2010/main" val="0"/>
+              </a:ext>
+            </a:extLst>
+          </a:blip>
           <a:stretch>
             <a:fillRect/>
           </a:stretch>
         </p:blipFill>
         <p:spPr>
           <a:xfrm>
-            <a:off x="7537837" y="1554709"/>
-            <a:ext cx="500932" cy="500932"/>
+            <a:off x="2928505" y="2837786"/>
+            <a:ext cx="1942092" cy="1138227"/>
           </a:xfrm>
           <a:prstGeom prst="rect">
             <a:avLst/>
           </a:prstGeom>
-          <a:ln w="12700">
+          <a:ln w="6350">
             <a:solidFill>
               <a:schemeClr val="tx1"/>
             </a:solidFill>
           </a:ln>
         </p:spPr>
       </p:pic>
-      <p:sp>
-        <p:nvSpPr>
-          <p:cNvPr id="51" name="TextBox 50">
-            <a:extLst>
-              <a:ext uri="{FF2B5EF4-FFF2-40B4-BE49-F238E27FC236}">
-                <a16:creationId xmlns:a16="http://schemas.microsoft.com/office/drawing/2014/main" id="{0A243121-01E1-4584-A4D1-C0D1180EA244}"/>
+      <p:pic>
+        <p:nvPicPr>
+          <p:cNvPr id="1037" name="Picture 1036" descr="A screenshot of a video camera&#10;&#10;AI-generated content may be incorrect.">
+            <a:extLst>
+              <a:ext uri="{FF2B5EF4-FFF2-40B4-BE49-F238E27FC236}">
+                <a16:creationId xmlns:a16="http://schemas.microsoft.com/office/drawing/2014/main" id="{64210A98-AB0B-E091-A800-AC202E578395}"/>
+              </a:ext>
+            </a:extLst>
+          </p:cNvPr>
+          <p:cNvPicPr>
+            <a:picLocks noChangeAspect="1"/>
+          </p:cNvPicPr>
+          <p:nvPr/>
+        </p:nvPicPr>
+        <p:blipFill>
+          <a:blip r:embed="rId11">
+            <a:extLst>
+              <a:ext uri="{28A0092B-C50C-407E-A947-70E740481C1C}">
+                <a14:useLocalDpi xmlns:a14="http://schemas.microsoft.com/office/drawing/2010/main" val="0"/>
+              </a:ext>
+            </a:extLst>
+          </a:blip>
+          <a:stretch>
+            <a:fillRect/>
+          </a:stretch>
+        </p:blipFill>
+        <p:spPr>
+          <a:xfrm>
+            <a:off x="2928505" y="4122624"/>
+            <a:ext cx="1993773" cy="1138225"/>
+          </a:xfrm>
+          <a:prstGeom prst="rect">
+            <a:avLst/>
+          </a:prstGeom>
+          <a:ln w="9525">
+            <a:solidFill>
+              <a:schemeClr val="tx1"/>
+            </a:solidFill>
+          </a:ln>
+        </p:spPr>
+      </p:pic>
+      <p:cxnSp>
+        <p:nvCxnSpPr>
+          <p:cNvPr id="1041" name="Straight Arrow Connector 1040">
+            <a:extLst>
+              <a:ext uri="{FF2B5EF4-FFF2-40B4-BE49-F238E27FC236}">
+                <a16:creationId xmlns:a16="http://schemas.microsoft.com/office/drawing/2014/main" id="{3FA1B850-5B64-1FA5-EB69-B673910050E5}"/>
+              </a:ext>
+            </a:extLst>
+          </p:cNvPr>
+          <p:cNvCxnSpPr>
+            <a:cxnSpLocks/>
+          </p:cNvCxnSpPr>
+          <p:nvPr/>
+        </p:nvCxnSpPr>
+        <p:spPr>
+          <a:xfrm>
+            <a:off x="2369194" y="4174579"/>
+            <a:ext cx="359322" cy="0"/>
+          </a:xfrm>
+          <a:prstGeom prst="straightConnector1">
+            <a:avLst/>
+          </a:prstGeom>
+          <a:ln w="28575">
+            <a:tailEnd type="triangle"/>
+          </a:ln>
+        </p:spPr>
+        <p:style>
+          <a:lnRef idx="2">
+            <a:schemeClr val="accent1"/>
+          </a:lnRef>
+          <a:fillRef idx="0">
+            <a:schemeClr val="accent1"/>
+          </a:fillRef>
+          <a:effectRef idx="1">
+            <a:schemeClr val="accent1"/>
+          </a:effectRef>
+          <a:fontRef idx="minor">
+            <a:schemeClr val="tx1"/>
+          </a:fontRef>
+        </p:style>
+      </p:cxnSp>
+      <p:sp>
+        <p:nvSpPr>
+          <p:cNvPr id="1043" name="TextBox 1042">
+            <a:extLst>
+              <a:ext uri="{FF2B5EF4-FFF2-40B4-BE49-F238E27FC236}">
+                <a16:creationId xmlns:a16="http://schemas.microsoft.com/office/drawing/2014/main" id="{B15EA8BE-029F-14A8-80A6-598A1B868AFA}"/>
               </a:ext>
             </a:extLst>
           </p:cNvPr>
@@ -6284,8 +5278,8 @@
         </p:nvSpPr>
         <p:spPr>
           <a:xfrm>
-            <a:off x="8017230" y="1519373"/>
-            <a:ext cx="1586698" cy="307777"/>
+            <a:off x="2849678" y="2462295"/>
+            <a:ext cx="2234694" cy="338554"/>
           </a:xfrm>
           <a:prstGeom prst="rect">
             <a:avLst/>
@@ -6293,22 +5287,153 @@
           <a:noFill/>
         </p:spPr>
         <p:txBody>
-          <a:bodyPr wrap="square" rtlCol="0">
+          <a:bodyPr wrap="square">
             <a:spAutoFit/>
           </a:bodyPr>
           <a:lstStyle/>
           <a:p>
             <a:r>
-              <a:rPr lang="en-SG" sz="1400" b="1" dirty="0"/>
-              <a:t>Web Browser </a:t>
-            </a:r>
+              <a:rPr lang="en-US" sz="1600" b="1" dirty="0">
+                <a:solidFill>
+                  <a:schemeClr val="accent2">
+                    <a:lumMod val="75000"/>
+                  </a:schemeClr>
+                </a:solidFill>
+              </a:rPr>
+              <a:t>Camera Web UI pages</a:t>
+            </a:r>
+            <a:endParaRPr lang="en-SG" sz="1600" b="1" dirty="0">
+              <a:solidFill>
+                <a:schemeClr val="accent2">
+                  <a:lumMod val="75000"/>
+                </a:schemeClr>
+              </a:solidFill>
+            </a:endParaRPr>
+          </a:p>
+        </p:txBody>
+      </p:sp>
+      <p:cxnSp>
+        <p:nvCxnSpPr>
+          <p:cNvPr id="1044" name="Straight Arrow Connector 1043">
+            <a:extLst>
+              <a:ext uri="{FF2B5EF4-FFF2-40B4-BE49-F238E27FC236}">
+                <a16:creationId xmlns:a16="http://schemas.microsoft.com/office/drawing/2014/main" id="{C84CBAAF-5262-F886-BB47-61B36AAC3788}"/>
+              </a:ext>
+            </a:extLst>
+          </p:cNvPr>
+          <p:cNvCxnSpPr>
+            <a:cxnSpLocks/>
+          </p:cNvCxnSpPr>
+          <p:nvPr/>
+        </p:nvCxnSpPr>
+        <p:spPr>
+          <a:xfrm>
+            <a:off x="4882768" y="3403948"/>
+            <a:ext cx="611189" cy="0"/>
+          </a:xfrm>
+          <a:prstGeom prst="straightConnector1">
+            <a:avLst/>
+          </a:prstGeom>
+          <a:ln w="28575">
+            <a:tailEnd type="triangle"/>
+          </a:ln>
+        </p:spPr>
+        <p:style>
+          <a:lnRef idx="2">
+            <a:schemeClr val="accent1"/>
+          </a:lnRef>
+          <a:fillRef idx="0">
+            <a:schemeClr val="accent1"/>
+          </a:fillRef>
+          <a:effectRef idx="1">
+            <a:schemeClr val="accent1"/>
+          </a:effectRef>
+          <a:fontRef idx="minor">
+            <a:schemeClr val="tx1"/>
+          </a:fontRef>
+        </p:style>
+      </p:cxnSp>
+      <p:cxnSp>
+        <p:nvCxnSpPr>
+          <p:cNvPr id="1046" name="Straight Arrow Connector 1045">
+            <a:extLst>
+              <a:ext uri="{FF2B5EF4-FFF2-40B4-BE49-F238E27FC236}">
+                <a16:creationId xmlns:a16="http://schemas.microsoft.com/office/drawing/2014/main" id="{996F13F8-D505-0519-0757-0A39657C1F8B}"/>
+              </a:ext>
+            </a:extLst>
+          </p:cNvPr>
+          <p:cNvCxnSpPr>
+            <a:cxnSpLocks/>
+          </p:cNvCxnSpPr>
+          <p:nvPr/>
+        </p:nvCxnSpPr>
+        <p:spPr>
+          <a:xfrm>
+            <a:off x="4930383" y="4627328"/>
+            <a:ext cx="611189" cy="0"/>
+          </a:xfrm>
+          <a:prstGeom prst="straightConnector1">
+            <a:avLst/>
+          </a:prstGeom>
+          <a:ln w="28575">
+            <a:tailEnd type="triangle"/>
+          </a:ln>
+        </p:spPr>
+        <p:style>
+          <a:lnRef idx="2">
+            <a:schemeClr val="accent1"/>
+          </a:lnRef>
+          <a:fillRef idx="0">
+            <a:schemeClr val="accent1"/>
+          </a:fillRef>
+          <a:effectRef idx="1">
+            <a:schemeClr val="accent1"/>
+          </a:effectRef>
+          <a:fontRef idx="minor">
+            <a:schemeClr val="tx1"/>
+          </a:fontRef>
+        </p:style>
+      </p:cxnSp>
+      <p:sp>
+        <p:nvSpPr>
+          <p:cNvPr id="1047" name="TextBox 1046">
+            <a:extLst>
+              <a:ext uri="{FF2B5EF4-FFF2-40B4-BE49-F238E27FC236}">
+                <a16:creationId xmlns:a16="http://schemas.microsoft.com/office/drawing/2014/main" id="{3F00CA10-D60A-3267-2070-9CBE2334443B}"/>
+              </a:ext>
+            </a:extLst>
+          </p:cNvPr>
+          <p:cNvSpPr txBox="1"/>
+          <p:nvPr/>
+        </p:nvSpPr>
+        <p:spPr>
+          <a:xfrm>
+            <a:off x="5505099" y="2313109"/>
+            <a:ext cx="3944395" cy="338554"/>
+          </a:xfrm>
+          <a:prstGeom prst="rect">
+            <a:avLst/>
+          </a:prstGeom>
+          <a:noFill/>
+        </p:spPr>
+        <p:txBody>
+          <a:bodyPr wrap="square">
+            <a:spAutoFit/>
+          </a:bodyPr>
+          <a:lstStyle/>
+          <a:p>
+            <a:r>
+              <a:rPr lang="en-US" sz="1600" b="1" dirty="0"/>
+              <a:t>Multi-Camera View Monitor Dashboard</a:t>
+            </a:r>
+            <a:endParaRPr lang="en-SG" sz="1600" b="1" dirty="0"/>
           </a:p>
         </p:txBody>
       </p:sp>
     </p:spTree>
     <p:extLst>
       <p:ext uri="{BB962C8B-B14F-4D97-AF65-F5344CB8AC3E}">
-        <p14:creationId xmlns:p14="http://schemas.microsoft.com/office/powerpoint/2010/main" val="3681641428"/>
+        <p14:creationId xmlns:p14="http://schemas.microsoft.com/office/powerpoint/2010/main" val="240756249"/>
       </p:ext>
     </p:extLst>
   </p:cSld>
@@ -6335,6 +5460,948 @@
           <a:chExt cx="0" cy="0"/>
         </a:xfrm>
       </p:grpSpPr>
+      <p:sp>
+        <p:nvSpPr>
+          <p:cNvPr id="5" name="Rectangle 4">
+            <a:extLst>
+              <a:ext uri="{FF2B5EF4-FFF2-40B4-BE49-F238E27FC236}">
+                <a16:creationId xmlns:a16="http://schemas.microsoft.com/office/drawing/2014/main" id="{795BEA1A-7ACE-A084-E97E-EAB31DF9CD09}"/>
+              </a:ext>
+            </a:extLst>
+          </p:cNvPr>
+          <p:cNvSpPr/>
+          <p:nvPr/>
+        </p:nvSpPr>
+        <p:spPr>
+          <a:xfrm>
+            <a:off x="4079281" y="1558456"/>
+            <a:ext cx="3045289" cy="2836563"/>
+          </a:xfrm>
+          <a:prstGeom prst="rect">
+            <a:avLst/>
+          </a:prstGeom>
+          <a:solidFill>
+            <a:schemeClr val="tx2">
+              <a:lumMod val="10000"/>
+              <a:lumOff val="90000"/>
+            </a:schemeClr>
+          </a:solidFill>
+        </p:spPr>
+        <p:style>
+          <a:lnRef idx="2">
+            <a:schemeClr val="accent1">
+              <a:shade val="15000"/>
+            </a:schemeClr>
+          </a:lnRef>
+          <a:fillRef idx="1">
+            <a:schemeClr val="accent1"/>
+          </a:fillRef>
+          <a:effectRef idx="0">
+            <a:schemeClr val="accent1"/>
+          </a:effectRef>
+          <a:fontRef idx="minor">
+            <a:schemeClr val="lt1"/>
+          </a:fontRef>
+        </p:style>
+        <p:txBody>
+          <a:bodyPr rtlCol="0" anchor="ctr"/>
+          <a:lstStyle/>
+          <a:p>
+            <a:pPr algn="ctr"/>
+            <a:endParaRPr lang="en-SG" dirty="0"/>
+          </a:p>
+        </p:txBody>
+      </p:sp>
+      <p:sp>
+        <p:nvSpPr>
+          <p:cNvPr id="4" name="Rectangle 3">
+            <a:extLst>
+              <a:ext uri="{FF2B5EF4-FFF2-40B4-BE49-F238E27FC236}">
+                <a16:creationId xmlns:a16="http://schemas.microsoft.com/office/drawing/2014/main" id="{9A640534-3FC6-9633-EF17-E19015883C71}"/>
+              </a:ext>
+            </a:extLst>
+          </p:cNvPr>
+          <p:cNvSpPr/>
+          <p:nvPr/>
+        </p:nvSpPr>
+        <p:spPr>
+          <a:xfrm>
+            <a:off x="5238976" y="2564996"/>
+            <a:ext cx="1714048" cy="501471"/>
+          </a:xfrm>
+          <a:prstGeom prst="rect">
+            <a:avLst/>
+          </a:prstGeom>
+          <a:solidFill>
+            <a:schemeClr val="tx2">
+              <a:lumMod val="75000"/>
+              <a:lumOff val="25000"/>
+            </a:schemeClr>
+          </a:solidFill>
+          <a:ln>
+            <a:solidFill>
+              <a:schemeClr val="tx1"/>
+            </a:solidFill>
+          </a:ln>
+        </p:spPr>
+        <p:style>
+          <a:lnRef idx="2">
+            <a:schemeClr val="accent1">
+              <a:shade val="50000"/>
+            </a:schemeClr>
+          </a:lnRef>
+          <a:fillRef idx="1">
+            <a:schemeClr val="accent1"/>
+          </a:fillRef>
+          <a:effectRef idx="0">
+            <a:schemeClr val="accent1"/>
+          </a:effectRef>
+          <a:fontRef idx="minor">
+            <a:schemeClr val="lt1"/>
+          </a:fontRef>
+        </p:style>
+        <p:txBody>
+          <a:bodyPr rtlCol="0" anchor="ctr"/>
+          <a:lstStyle/>
+          <a:p>
+            <a:r>
+              <a:rPr lang="en-SG" sz="1200" b="1" dirty="0"/>
+              <a:t>User and Access  Management Module </a:t>
+            </a:r>
+          </a:p>
+        </p:txBody>
+      </p:sp>
+      <p:sp>
+        <p:nvSpPr>
+          <p:cNvPr id="6" name="TextBox 5">
+            <a:extLst>
+              <a:ext uri="{FF2B5EF4-FFF2-40B4-BE49-F238E27FC236}">
+                <a16:creationId xmlns:a16="http://schemas.microsoft.com/office/drawing/2014/main" id="{7A70032D-F9A9-5DF3-348B-B60B4991CBC2}"/>
+              </a:ext>
+            </a:extLst>
+          </p:cNvPr>
+          <p:cNvSpPr txBox="1"/>
+          <p:nvPr/>
+        </p:nvSpPr>
+        <p:spPr>
+          <a:xfrm>
+            <a:off x="4048152" y="1622536"/>
+            <a:ext cx="2500148" cy="338554"/>
+          </a:xfrm>
+          <a:prstGeom prst="rect">
+            <a:avLst/>
+          </a:prstGeom>
+          <a:noFill/>
+        </p:spPr>
+        <p:txBody>
+          <a:bodyPr wrap="square" rtlCol="0">
+            <a:spAutoFit/>
+          </a:bodyPr>
+          <a:lstStyle/>
+          <a:p>
+            <a:r>
+              <a:rPr lang="en-US" sz="1600" b="1" dirty="0"/>
+              <a:t>Flask Camera Server</a:t>
+            </a:r>
+            <a:endParaRPr lang="en-SG" sz="1600" b="1" dirty="0"/>
+          </a:p>
+        </p:txBody>
+      </p:sp>
+      <p:sp>
+        <p:nvSpPr>
+          <p:cNvPr id="7" name="Cylinder 6">
+            <a:extLst>
+              <a:ext uri="{FF2B5EF4-FFF2-40B4-BE49-F238E27FC236}">
+                <a16:creationId xmlns:a16="http://schemas.microsoft.com/office/drawing/2014/main" id="{39FFC1E6-E8B7-E8F9-A757-519C2C7C8E73}"/>
+              </a:ext>
+            </a:extLst>
+          </p:cNvPr>
+          <p:cNvSpPr/>
+          <p:nvPr/>
+        </p:nvSpPr>
+        <p:spPr>
+          <a:xfrm>
+            <a:off x="6172651" y="1858119"/>
+            <a:ext cx="696191" cy="519546"/>
+          </a:xfrm>
+          <a:prstGeom prst="can">
+            <a:avLst/>
+          </a:prstGeom>
+          <a:solidFill>
+            <a:schemeClr val="accent6">
+              <a:lumMod val="50000"/>
+            </a:schemeClr>
+          </a:solidFill>
+        </p:spPr>
+        <p:style>
+          <a:lnRef idx="2">
+            <a:schemeClr val="accent1">
+              <a:shade val="15000"/>
+            </a:schemeClr>
+          </a:lnRef>
+          <a:fillRef idx="1">
+            <a:schemeClr val="accent1"/>
+          </a:fillRef>
+          <a:effectRef idx="0">
+            <a:schemeClr val="accent1"/>
+          </a:effectRef>
+          <a:fontRef idx="minor">
+            <a:schemeClr val="lt1"/>
+          </a:fontRef>
+        </p:style>
+        <p:txBody>
+          <a:bodyPr rtlCol="0" anchor="ctr"/>
+          <a:lstStyle/>
+          <a:p>
+            <a:pPr algn="ctr"/>
+            <a:r>
+              <a:rPr lang="en-SG" sz="1200" b="1" dirty="0"/>
+              <a:t>User BD</a:t>
+            </a:r>
+          </a:p>
+        </p:txBody>
+      </p:sp>
+      <p:cxnSp>
+        <p:nvCxnSpPr>
+          <p:cNvPr id="9" name="Straight Arrow Connector 8">
+            <a:extLst>
+              <a:ext uri="{FF2B5EF4-FFF2-40B4-BE49-F238E27FC236}">
+                <a16:creationId xmlns:a16="http://schemas.microsoft.com/office/drawing/2014/main" id="{8AEE00F4-22BE-6C96-27EF-66E6AD06243A}"/>
+              </a:ext>
+            </a:extLst>
+          </p:cNvPr>
+          <p:cNvCxnSpPr>
+            <a:cxnSpLocks/>
+          </p:cNvCxnSpPr>
+          <p:nvPr/>
+        </p:nvCxnSpPr>
+        <p:spPr>
+          <a:xfrm flipH="1">
+            <a:off x="6513077" y="2377665"/>
+            <a:ext cx="0" cy="188554"/>
+          </a:xfrm>
+          <a:prstGeom prst="straightConnector1">
+            <a:avLst/>
+          </a:prstGeom>
+          <a:ln>
+            <a:tailEnd type="triangle"/>
+          </a:ln>
+        </p:spPr>
+        <p:style>
+          <a:lnRef idx="2">
+            <a:schemeClr val="accent1"/>
+          </a:lnRef>
+          <a:fillRef idx="0">
+            <a:schemeClr val="accent1"/>
+          </a:fillRef>
+          <a:effectRef idx="1">
+            <a:schemeClr val="accent1"/>
+          </a:effectRef>
+          <a:fontRef idx="minor">
+            <a:schemeClr val="tx1"/>
+          </a:fontRef>
+        </p:style>
+      </p:cxnSp>
+      <p:sp>
+        <p:nvSpPr>
+          <p:cNvPr id="10" name="Rectangle 9">
+            <a:extLst>
+              <a:ext uri="{FF2B5EF4-FFF2-40B4-BE49-F238E27FC236}">
+                <a16:creationId xmlns:a16="http://schemas.microsoft.com/office/drawing/2014/main" id="{831EA590-ED1E-389D-C2EB-A578B654D40B}"/>
+              </a:ext>
+            </a:extLst>
+          </p:cNvPr>
+          <p:cNvSpPr/>
+          <p:nvPr/>
+        </p:nvSpPr>
+        <p:spPr>
+          <a:xfrm>
+            <a:off x="3869877" y="3838893"/>
+            <a:ext cx="1937698" cy="338554"/>
+          </a:xfrm>
+          <a:prstGeom prst="rect">
+            <a:avLst/>
+          </a:prstGeom>
+          <a:solidFill>
+            <a:schemeClr val="tx2">
+              <a:lumMod val="75000"/>
+              <a:lumOff val="25000"/>
+            </a:schemeClr>
+          </a:solidFill>
+          <a:ln>
+            <a:solidFill>
+              <a:schemeClr val="tx1"/>
+            </a:solidFill>
+          </a:ln>
+        </p:spPr>
+        <p:style>
+          <a:lnRef idx="2">
+            <a:schemeClr val="accent1">
+              <a:shade val="50000"/>
+            </a:schemeClr>
+          </a:lnRef>
+          <a:fillRef idx="1">
+            <a:schemeClr val="accent1"/>
+          </a:fillRef>
+          <a:effectRef idx="0">
+            <a:schemeClr val="accent1"/>
+          </a:effectRef>
+          <a:fontRef idx="minor">
+            <a:schemeClr val="lt1"/>
+          </a:fontRef>
+        </p:style>
+        <p:txBody>
+          <a:bodyPr rtlCol="0" anchor="ctr"/>
+          <a:lstStyle/>
+          <a:p>
+            <a:r>
+              <a:rPr lang="en-SG" sz="1200" b="1" dirty="0"/>
+              <a:t>Data Manager Module </a:t>
+            </a:r>
+          </a:p>
+        </p:txBody>
+      </p:sp>
+      <p:sp>
+        <p:nvSpPr>
+          <p:cNvPr id="11" name="Rectangle 10">
+            <a:extLst>
+              <a:ext uri="{FF2B5EF4-FFF2-40B4-BE49-F238E27FC236}">
+                <a16:creationId xmlns:a16="http://schemas.microsoft.com/office/drawing/2014/main" id="{43212530-F0D6-978A-DF0D-A3A8FB1D596F}"/>
+              </a:ext>
+            </a:extLst>
+          </p:cNvPr>
+          <p:cNvSpPr/>
+          <p:nvPr/>
+        </p:nvSpPr>
+        <p:spPr>
+          <a:xfrm>
+            <a:off x="4838727" y="3273881"/>
+            <a:ext cx="2387762" cy="338554"/>
+          </a:xfrm>
+          <a:prstGeom prst="rect">
+            <a:avLst/>
+          </a:prstGeom>
+          <a:solidFill>
+            <a:schemeClr val="tx2">
+              <a:lumMod val="75000"/>
+              <a:lumOff val="25000"/>
+            </a:schemeClr>
+          </a:solidFill>
+          <a:ln>
+            <a:solidFill>
+              <a:schemeClr val="tx1"/>
+            </a:solidFill>
+          </a:ln>
+        </p:spPr>
+        <p:style>
+          <a:lnRef idx="2">
+            <a:schemeClr val="accent1">
+              <a:shade val="50000"/>
+            </a:schemeClr>
+          </a:lnRef>
+          <a:fillRef idx="1">
+            <a:schemeClr val="accent1"/>
+          </a:fillRef>
+          <a:effectRef idx="0">
+            <a:schemeClr val="accent1"/>
+          </a:effectRef>
+          <a:fontRef idx="minor">
+            <a:schemeClr val="lt1"/>
+          </a:fontRef>
+        </p:style>
+        <p:txBody>
+          <a:bodyPr rtlCol="0" anchor="ctr"/>
+          <a:lstStyle/>
+          <a:p>
+            <a:r>
+              <a:rPr lang="en-SG" sz="1200" b="1" dirty="0"/>
+              <a:t>Flask Web Service Module </a:t>
+            </a:r>
+          </a:p>
+        </p:txBody>
+      </p:sp>
+      <p:sp>
+        <p:nvSpPr>
+          <p:cNvPr id="12" name="Rectangle 11">
+            <a:extLst>
+              <a:ext uri="{FF2B5EF4-FFF2-40B4-BE49-F238E27FC236}">
+                <a16:creationId xmlns:a16="http://schemas.microsoft.com/office/drawing/2014/main" id="{E167F503-53D7-03EF-F5BE-4400BC086F8F}"/>
+              </a:ext>
+            </a:extLst>
+          </p:cNvPr>
+          <p:cNvSpPr/>
+          <p:nvPr/>
+        </p:nvSpPr>
+        <p:spPr>
+          <a:xfrm>
+            <a:off x="3793526" y="2068441"/>
+            <a:ext cx="2225821" cy="338554"/>
+          </a:xfrm>
+          <a:prstGeom prst="rect">
+            <a:avLst/>
+          </a:prstGeom>
+          <a:solidFill>
+            <a:schemeClr val="tx2">
+              <a:lumMod val="75000"/>
+              <a:lumOff val="25000"/>
+            </a:schemeClr>
+          </a:solidFill>
+          <a:ln>
+            <a:solidFill>
+              <a:schemeClr val="tx1"/>
+            </a:solidFill>
+          </a:ln>
+        </p:spPr>
+        <p:style>
+          <a:lnRef idx="2">
+            <a:schemeClr val="accent1">
+              <a:shade val="50000"/>
+            </a:schemeClr>
+          </a:lnRef>
+          <a:fillRef idx="1">
+            <a:schemeClr val="accent1"/>
+          </a:fillRef>
+          <a:effectRef idx="0">
+            <a:schemeClr val="accent1"/>
+          </a:effectRef>
+          <a:fontRef idx="minor">
+            <a:schemeClr val="lt1"/>
+          </a:fontRef>
+        </p:style>
+        <p:txBody>
+          <a:bodyPr rtlCol="0" anchor="ctr"/>
+          <a:lstStyle/>
+          <a:p>
+            <a:r>
+              <a:rPr lang="en-SG" sz="1200" b="1" dirty="0"/>
+              <a:t>Video Source Manger Module </a:t>
+            </a:r>
+          </a:p>
+        </p:txBody>
+      </p:sp>
+      <p:cxnSp>
+        <p:nvCxnSpPr>
+          <p:cNvPr id="16" name="Straight Arrow Connector 15">
+            <a:extLst>
+              <a:ext uri="{FF2B5EF4-FFF2-40B4-BE49-F238E27FC236}">
+                <a16:creationId xmlns:a16="http://schemas.microsoft.com/office/drawing/2014/main" id="{4912AC03-8DA6-D8CA-0ED4-A562424A4FD8}"/>
+              </a:ext>
+            </a:extLst>
+          </p:cNvPr>
+          <p:cNvCxnSpPr>
+            <a:cxnSpLocks/>
+          </p:cNvCxnSpPr>
+          <p:nvPr/>
+        </p:nvCxnSpPr>
+        <p:spPr>
+          <a:xfrm>
+            <a:off x="4967636" y="2384955"/>
+            <a:ext cx="0" cy="888926"/>
+          </a:xfrm>
+          <a:prstGeom prst="straightConnector1">
+            <a:avLst/>
+          </a:prstGeom>
+          <a:ln>
+            <a:tailEnd type="triangle"/>
+          </a:ln>
+        </p:spPr>
+        <p:style>
+          <a:lnRef idx="2">
+            <a:schemeClr val="accent1"/>
+          </a:lnRef>
+          <a:fillRef idx="0">
+            <a:schemeClr val="accent1"/>
+          </a:fillRef>
+          <a:effectRef idx="1">
+            <a:schemeClr val="accent1"/>
+          </a:effectRef>
+          <a:fontRef idx="minor">
+            <a:schemeClr val="tx1"/>
+          </a:fontRef>
+        </p:style>
+      </p:cxnSp>
+      <p:cxnSp>
+        <p:nvCxnSpPr>
+          <p:cNvPr id="18" name="Straight Arrow Connector 17">
+            <a:extLst>
+              <a:ext uri="{FF2B5EF4-FFF2-40B4-BE49-F238E27FC236}">
+                <a16:creationId xmlns:a16="http://schemas.microsoft.com/office/drawing/2014/main" id="{2F6E7933-5D6D-5174-082D-DC4208989B30}"/>
+              </a:ext>
+            </a:extLst>
+          </p:cNvPr>
+          <p:cNvCxnSpPr>
+            <a:cxnSpLocks/>
+          </p:cNvCxnSpPr>
+          <p:nvPr/>
+        </p:nvCxnSpPr>
+        <p:spPr>
+          <a:xfrm flipV="1">
+            <a:off x="4965513" y="3612435"/>
+            <a:ext cx="0" cy="219055"/>
+          </a:xfrm>
+          <a:prstGeom prst="straightConnector1">
+            <a:avLst/>
+          </a:prstGeom>
+          <a:ln>
+            <a:tailEnd type="triangle"/>
+          </a:ln>
+        </p:spPr>
+        <p:style>
+          <a:lnRef idx="2">
+            <a:schemeClr val="accent1"/>
+          </a:lnRef>
+          <a:fillRef idx="0">
+            <a:schemeClr val="accent1"/>
+          </a:fillRef>
+          <a:effectRef idx="1">
+            <a:schemeClr val="accent1"/>
+          </a:effectRef>
+          <a:fontRef idx="minor">
+            <a:schemeClr val="tx1"/>
+          </a:fontRef>
+        </p:style>
+      </p:cxnSp>
+      <p:cxnSp>
+        <p:nvCxnSpPr>
+          <p:cNvPr id="26" name="Straight Arrow Connector 25">
+            <a:extLst>
+              <a:ext uri="{FF2B5EF4-FFF2-40B4-BE49-F238E27FC236}">
+                <a16:creationId xmlns:a16="http://schemas.microsoft.com/office/drawing/2014/main" id="{F679CB73-DBB5-9E76-3B51-8023C411BC91}"/>
+              </a:ext>
+            </a:extLst>
+          </p:cNvPr>
+          <p:cNvCxnSpPr>
+            <a:cxnSpLocks/>
+          </p:cNvCxnSpPr>
+          <p:nvPr/>
+        </p:nvCxnSpPr>
+        <p:spPr>
+          <a:xfrm>
+            <a:off x="3579684" y="4000155"/>
+            <a:ext cx="290193" cy="0"/>
+          </a:xfrm>
+          <a:prstGeom prst="straightConnector1">
+            <a:avLst/>
+          </a:prstGeom>
+          <a:ln>
+            <a:tailEnd type="triangle"/>
+          </a:ln>
+        </p:spPr>
+        <p:style>
+          <a:lnRef idx="2">
+            <a:schemeClr val="accent1"/>
+          </a:lnRef>
+          <a:fillRef idx="0">
+            <a:schemeClr val="accent1"/>
+          </a:fillRef>
+          <a:effectRef idx="1">
+            <a:schemeClr val="accent1"/>
+          </a:effectRef>
+          <a:fontRef idx="minor">
+            <a:schemeClr val="tx1"/>
+          </a:fontRef>
+        </p:style>
+      </p:cxnSp>
+      <p:pic>
+        <p:nvPicPr>
+          <p:cNvPr id="21" name="Picture 20" descr="A computer screen shot of a runway&#10;&#10;AI-generated content may be incorrect.">
+            <a:extLst>
+              <a:ext uri="{FF2B5EF4-FFF2-40B4-BE49-F238E27FC236}">
+                <a16:creationId xmlns:a16="http://schemas.microsoft.com/office/drawing/2014/main" id="{A5A68227-F3E4-A5D8-E5BE-F49D0AF99408}"/>
+              </a:ext>
+            </a:extLst>
+          </p:cNvPr>
+          <p:cNvPicPr>
+            <a:picLocks noChangeAspect="1"/>
+          </p:cNvPicPr>
+          <p:nvPr/>
+        </p:nvPicPr>
+        <p:blipFill>
+          <a:blip r:embed="rId2">
+            <a:extLst>
+              <a:ext uri="{28A0092B-C50C-407E-A947-70E740481C1C}">
+                <a14:useLocalDpi xmlns:a14="http://schemas.microsoft.com/office/drawing/2010/main" val="0"/>
+              </a:ext>
+            </a:extLst>
+          </a:blip>
+          <a:stretch>
+            <a:fillRect/>
+          </a:stretch>
+        </p:blipFill>
+        <p:spPr>
+          <a:xfrm>
+            <a:off x="396148" y="2685683"/>
+            <a:ext cx="3175137" cy="1739086"/>
+          </a:xfrm>
+          <a:prstGeom prst="rect">
+            <a:avLst/>
+          </a:prstGeom>
+          <a:ln w="9525">
+            <a:solidFill>
+              <a:schemeClr val="tx1"/>
+            </a:solidFill>
+          </a:ln>
+        </p:spPr>
+      </p:pic>
+      <p:sp>
+        <p:nvSpPr>
+          <p:cNvPr id="29" name="TextBox 28">
+            <a:extLst>
+              <a:ext uri="{FF2B5EF4-FFF2-40B4-BE49-F238E27FC236}">
+                <a16:creationId xmlns:a16="http://schemas.microsoft.com/office/drawing/2014/main" id="{2D6FEFEC-0A21-437D-3206-81C9C8C59D79}"/>
+              </a:ext>
+            </a:extLst>
+          </p:cNvPr>
+          <p:cNvSpPr txBox="1"/>
+          <p:nvPr/>
+        </p:nvSpPr>
+        <p:spPr>
+          <a:xfrm>
+            <a:off x="267695" y="2372513"/>
+            <a:ext cx="3339694" cy="523220"/>
+          </a:xfrm>
+          <a:prstGeom prst="rect">
+            <a:avLst/>
+          </a:prstGeom>
+          <a:noFill/>
+        </p:spPr>
+        <p:txBody>
+          <a:bodyPr wrap="square" rtlCol="0">
+            <a:spAutoFit/>
+          </a:bodyPr>
+          <a:lstStyle/>
+          <a:p>
+            <a:r>
+              <a:rPr lang="en-SG" sz="1400" b="1" dirty="0"/>
+              <a:t>Cyber Range Physical World Simulator F</a:t>
+            </a:r>
+          </a:p>
+        </p:txBody>
+      </p:sp>
+      <p:pic>
+        <p:nvPicPr>
+          <p:cNvPr id="31" name="Picture 30">
+            <a:extLst>
+              <a:ext uri="{FF2B5EF4-FFF2-40B4-BE49-F238E27FC236}">
+                <a16:creationId xmlns:a16="http://schemas.microsoft.com/office/drawing/2014/main" id="{0127D3F8-A57E-20C1-8EF0-5AE80F4191B5}"/>
+              </a:ext>
+            </a:extLst>
+          </p:cNvPr>
+          <p:cNvPicPr>
+            <a:picLocks noChangeAspect="1"/>
+          </p:cNvPicPr>
+          <p:nvPr/>
+        </p:nvPicPr>
+        <p:blipFill>
+          <a:blip r:embed="rId3"/>
+          <a:stretch>
+            <a:fillRect/>
+          </a:stretch>
+        </p:blipFill>
+        <p:spPr>
+          <a:xfrm>
+            <a:off x="360046" y="1786598"/>
+            <a:ext cx="3247343" cy="478983"/>
+          </a:xfrm>
+          <a:prstGeom prst="rect">
+            <a:avLst/>
+          </a:prstGeom>
+        </p:spPr>
+      </p:pic>
+      <p:sp>
+        <p:nvSpPr>
+          <p:cNvPr id="32" name="TextBox 31">
+            <a:extLst>
+              <a:ext uri="{FF2B5EF4-FFF2-40B4-BE49-F238E27FC236}">
+                <a16:creationId xmlns:a16="http://schemas.microsoft.com/office/drawing/2014/main" id="{6AF2A4BE-9C38-88B7-208B-94F3BD0C9369}"/>
+              </a:ext>
+            </a:extLst>
+          </p:cNvPr>
+          <p:cNvSpPr txBox="1"/>
+          <p:nvPr/>
+        </p:nvSpPr>
+        <p:spPr>
+          <a:xfrm>
+            <a:off x="360046" y="1408370"/>
+            <a:ext cx="2023197" cy="307777"/>
+          </a:xfrm>
+          <a:prstGeom prst="rect">
+            <a:avLst/>
+          </a:prstGeom>
+          <a:noFill/>
+        </p:spPr>
+        <p:txBody>
+          <a:bodyPr wrap="square" rtlCol="0">
+            <a:spAutoFit/>
+          </a:bodyPr>
+          <a:lstStyle/>
+          <a:p>
+            <a:r>
+              <a:rPr lang="en-SG" sz="1400" b="1" dirty="0"/>
+              <a:t>Video Stream Source </a:t>
+            </a:r>
+          </a:p>
+        </p:txBody>
+      </p:sp>
+      <p:cxnSp>
+        <p:nvCxnSpPr>
+          <p:cNvPr id="33" name="Straight Arrow Connector 32">
+            <a:extLst>
+              <a:ext uri="{FF2B5EF4-FFF2-40B4-BE49-F238E27FC236}">
+                <a16:creationId xmlns:a16="http://schemas.microsoft.com/office/drawing/2014/main" id="{AEE6FBF7-A397-B5F6-8C2B-7BFB0872A311}"/>
+              </a:ext>
+            </a:extLst>
+          </p:cNvPr>
+          <p:cNvCxnSpPr>
+            <a:cxnSpLocks/>
+          </p:cNvCxnSpPr>
+          <p:nvPr/>
+        </p:nvCxnSpPr>
+        <p:spPr>
+          <a:xfrm>
+            <a:off x="3579684" y="2202315"/>
+            <a:ext cx="213842" cy="0"/>
+          </a:xfrm>
+          <a:prstGeom prst="straightConnector1">
+            <a:avLst/>
+          </a:prstGeom>
+          <a:ln>
+            <a:tailEnd type="triangle"/>
+          </a:ln>
+        </p:spPr>
+        <p:style>
+          <a:lnRef idx="2">
+            <a:schemeClr val="accent1"/>
+          </a:lnRef>
+          <a:fillRef idx="0">
+            <a:schemeClr val="accent1"/>
+          </a:fillRef>
+          <a:effectRef idx="1">
+            <a:schemeClr val="accent1"/>
+          </a:effectRef>
+          <a:fontRef idx="minor">
+            <a:schemeClr val="tx1"/>
+          </a:fontRef>
+        </p:style>
+      </p:cxnSp>
+      <p:cxnSp>
+        <p:nvCxnSpPr>
+          <p:cNvPr id="35" name="Straight Arrow Connector 34">
+            <a:extLst>
+              <a:ext uri="{FF2B5EF4-FFF2-40B4-BE49-F238E27FC236}">
+                <a16:creationId xmlns:a16="http://schemas.microsoft.com/office/drawing/2014/main" id="{C69B1288-537A-E9AB-1560-BAE1CB70103D}"/>
+              </a:ext>
+            </a:extLst>
+          </p:cNvPr>
+          <p:cNvCxnSpPr>
+            <a:cxnSpLocks/>
+            <a:stCxn id="11" idx="3"/>
+          </p:cNvCxnSpPr>
+          <p:nvPr/>
+        </p:nvCxnSpPr>
+        <p:spPr>
+          <a:xfrm>
+            <a:off x="7226489" y="3443158"/>
+            <a:ext cx="311348" cy="0"/>
+          </a:xfrm>
+          <a:prstGeom prst="straightConnector1">
+            <a:avLst/>
+          </a:prstGeom>
+          <a:ln>
+            <a:tailEnd type="triangle"/>
+          </a:ln>
+        </p:spPr>
+        <p:style>
+          <a:lnRef idx="2">
+            <a:schemeClr val="accent1"/>
+          </a:lnRef>
+          <a:fillRef idx="0">
+            <a:schemeClr val="accent1"/>
+          </a:fillRef>
+          <a:effectRef idx="1">
+            <a:schemeClr val="accent1"/>
+          </a:effectRef>
+          <a:fontRef idx="minor">
+            <a:schemeClr val="tx1"/>
+          </a:fontRef>
+        </p:style>
+      </p:cxnSp>
+      <p:pic>
+        <p:nvPicPr>
+          <p:cNvPr id="39" name="Picture 38">
+            <a:extLst>
+              <a:ext uri="{FF2B5EF4-FFF2-40B4-BE49-F238E27FC236}">
+                <a16:creationId xmlns:a16="http://schemas.microsoft.com/office/drawing/2014/main" id="{57E62C6C-7D80-AC36-A313-A707018E0058}"/>
+              </a:ext>
+            </a:extLst>
+          </p:cNvPr>
+          <p:cNvPicPr>
+            <a:picLocks noChangeAspect="1"/>
+          </p:cNvPicPr>
+          <p:nvPr/>
+        </p:nvPicPr>
+        <p:blipFill>
+          <a:blip r:embed="rId4"/>
+          <a:stretch>
+            <a:fillRect/>
+          </a:stretch>
+        </p:blipFill>
+        <p:spPr>
+          <a:xfrm>
+            <a:off x="7537837" y="1791813"/>
+            <a:ext cx="3882607" cy="2603206"/>
+          </a:xfrm>
+          <a:prstGeom prst="rect">
+            <a:avLst/>
+          </a:prstGeom>
+          <a:ln w="12700">
+            <a:solidFill>
+              <a:schemeClr val="tx1"/>
+            </a:solidFill>
+          </a:ln>
+        </p:spPr>
+      </p:pic>
+      <p:cxnSp>
+        <p:nvCxnSpPr>
+          <p:cNvPr id="44" name="Straight Arrow Connector 43">
+            <a:extLst>
+              <a:ext uri="{FF2B5EF4-FFF2-40B4-BE49-F238E27FC236}">
+                <a16:creationId xmlns:a16="http://schemas.microsoft.com/office/drawing/2014/main" id="{1C313551-14B2-8300-1EDF-9C31D34374FF}"/>
+              </a:ext>
+            </a:extLst>
+          </p:cNvPr>
+          <p:cNvCxnSpPr>
+            <a:cxnSpLocks/>
+          </p:cNvCxnSpPr>
+          <p:nvPr/>
+        </p:nvCxnSpPr>
+        <p:spPr>
+          <a:xfrm flipH="1">
+            <a:off x="6096000" y="3085327"/>
+            <a:ext cx="0" cy="188554"/>
+          </a:xfrm>
+          <a:prstGeom prst="straightConnector1">
+            <a:avLst/>
+          </a:prstGeom>
+          <a:ln>
+            <a:tailEnd type="triangle"/>
+          </a:ln>
+        </p:spPr>
+        <p:style>
+          <a:lnRef idx="2">
+            <a:schemeClr val="accent1"/>
+          </a:lnRef>
+          <a:fillRef idx="0">
+            <a:schemeClr val="accent1"/>
+          </a:fillRef>
+          <a:effectRef idx="1">
+            <a:schemeClr val="accent1"/>
+          </a:effectRef>
+          <a:fontRef idx="minor">
+            <a:schemeClr val="tx1"/>
+          </a:fontRef>
+        </p:style>
+      </p:cxnSp>
+      <p:pic>
+        <p:nvPicPr>
+          <p:cNvPr id="50" name="Picture 49">
+            <a:extLst>
+              <a:ext uri="{FF2B5EF4-FFF2-40B4-BE49-F238E27FC236}">
+                <a16:creationId xmlns:a16="http://schemas.microsoft.com/office/drawing/2014/main" id="{9A8651CE-65DD-B836-7E28-1CE96DDDD95B}"/>
+              </a:ext>
+            </a:extLst>
+          </p:cNvPr>
+          <p:cNvPicPr>
+            <a:picLocks noChangeAspect="1"/>
+          </p:cNvPicPr>
+          <p:nvPr/>
+        </p:nvPicPr>
+        <p:blipFill>
+          <a:blip r:embed="rId5"/>
+          <a:stretch>
+            <a:fillRect/>
+          </a:stretch>
+        </p:blipFill>
+        <p:spPr>
+          <a:xfrm>
+            <a:off x="7537837" y="1554709"/>
+            <a:ext cx="500932" cy="500932"/>
+          </a:xfrm>
+          <a:prstGeom prst="rect">
+            <a:avLst/>
+          </a:prstGeom>
+          <a:ln w="12700">
+            <a:solidFill>
+              <a:schemeClr val="tx1"/>
+            </a:solidFill>
+          </a:ln>
+        </p:spPr>
+      </p:pic>
+      <p:sp>
+        <p:nvSpPr>
+          <p:cNvPr id="51" name="TextBox 50">
+            <a:extLst>
+              <a:ext uri="{FF2B5EF4-FFF2-40B4-BE49-F238E27FC236}">
+                <a16:creationId xmlns:a16="http://schemas.microsoft.com/office/drawing/2014/main" id="{0A243121-01E1-4584-A4D1-C0D1180EA244}"/>
+              </a:ext>
+            </a:extLst>
+          </p:cNvPr>
+          <p:cNvSpPr txBox="1"/>
+          <p:nvPr/>
+        </p:nvSpPr>
+        <p:spPr>
+          <a:xfrm>
+            <a:off x="8017230" y="1519373"/>
+            <a:ext cx="1586698" cy="307777"/>
+          </a:xfrm>
+          <a:prstGeom prst="rect">
+            <a:avLst/>
+          </a:prstGeom>
+          <a:noFill/>
+        </p:spPr>
+        <p:txBody>
+          <a:bodyPr wrap="square" rtlCol="0">
+            <a:spAutoFit/>
+          </a:bodyPr>
+          <a:lstStyle/>
+          <a:p>
+            <a:r>
+              <a:rPr lang="en-SG" sz="1400" b="1" dirty="0"/>
+              <a:t>Web Browser </a:t>
+            </a:r>
+          </a:p>
+        </p:txBody>
+      </p:sp>
+    </p:spTree>
+    <p:extLst>
+      <p:ext uri="{BB962C8B-B14F-4D97-AF65-F5344CB8AC3E}">
+        <p14:creationId xmlns:p14="http://schemas.microsoft.com/office/powerpoint/2010/main" val="3681641428"/>
+      </p:ext>
+    </p:extLst>
+  </p:cSld>
+  <p:clrMapOvr>
+    <a:masterClrMapping/>
+  </p:clrMapOvr>
+</p:sld>
+</file>
+
+<file path=ppt/slides/slide5.xml><?xml version="1.0" encoding="utf-8"?>
+<p:sld xmlns:a="http://schemas.openxmlformats.org/drawingml/2006/main" xmlns:r="http://schemas.openxmlformats.org/officeDocument/2006/relationships" xmlns:p="http://schemas.openxmlformats.org/presentationml/2006/main">
+  <p:cSld>
+    <p:spTree>
+      <p:nvGrpSpPr>
+        <p:cNvPr id="1" name=""/>
+        <p:cNvGrpSpPr/>
+        <p:nvPr/>
+      </p:nvGrpSpPr>
+      <p:grpSpPr>
+        <a:xfrm>
+          <a:off x="0" y="0"/>
+          <a:ext cx="0" cy="0"/>
+          <a:chOff x="0" y="0"/>
+          <a:chExt cx="0" cy="0"/>
+        </a:xfrm>
+      </p:grpSpPr>
       <p:pic>
         <p:nvPicPr>
           <p:cNvPr id="4" name="Picture 3">
@@ -8553,7 +8620,7 @@
 </p:sld>
 </file>
 
-<file path=ppt/slides/slide5.xml><?xml version="1.0" encoding="utf-8"?>
+<file path=ppt/slides/slide6.xml><?xml version="1.0" encoding="utf-8"?>
 <p:sld xmlns:a="http://schemas.openxmlformats.org/drawingml/2006/main" xmlns:r="http://schemas.openxmlformats.org/officeDocument/2006/relationships" xmlns:p="http://schemas.openxmlformats.org/presentationml/2006/main">
   <p:cSld>
     <p:spTree>

</xml_diff>